<commit_message>
feat(presentation): presentacion ejecutiva completa con historia de Alamos, IA, desglose por juego y estrategia de Fan Club
</commit_message>
<xml_diff>
--- a/Drinks_and_Wins_Presentacion_Ejecutiva.pptx
+++ b/Drinks_and_Wins_Presentacion_Ejecutiva.pptx
@@ -3122,7 +3122,7 @@
             <a:avLst/>
           </a:prstGeom>
           <a:solidFill>
-            <a:srgbClr val="161C2A"/>
+            <a:srgbClr val="141A26"/>
           </a:solidFill>
           <a:ln w="19050">
             <a:solidFill>
@@ -3168,7 +3168,7 @@
         </p:blipFill>
         <p:spPr>
           <a:xfrm>
-            <a:off x="1188720" y="1371600"/>
+            <a:off x="1188720" y="1280160"/>
             <a:ext cx="850821" cy="1097280"/>
           </a:xfrm>
           <a:prstGeom prst="rect">
@@ -3184,8 +3184,8 @@
         </p:nvSpPr>
         <p:spPr>
           <a:xfrm>
-            <a:off x="1188720" y="2651760"/>
-            <a:ext cx="9601200" cy="2926080"/>
+            <a:off x="1188720" y="2560320"/>
+            <a:ext cx="9601200" cy="3108960"/>
           </a:xfrm>
           <a:prstGeom prst="rect">
             <a:avLst/>
@@ -3200,23 +3200,23 @@
           <a:p>
             <a:pPr>
               <a:spcAft>
+                <a:spcPts val="600"/>
+              </a:spcAft>
+              <a:defRPr sz="1200" b="1">
+                <a:solidFill>
+                  <a:srgbClr val="FFB612"/>
+                </a:solidFill>
+              </a:defRPr>
+            </a:pPr>
+            <a:r>
+              <a:t>EXPERIENCIA DIGITAL EN MESA • VALIDADA EN BARRA</a:t>
+            </a:r>
+          </a:p>
+          <a:p>
+            <a:pPr>
+              <a:spcAft>
                 <a:spcPts val="800"/>
               </a:spcAft>
-              <a:defRPr sz="1300" b="1">
-                <a:solidFill>
-                  <a:srgbClr val="FFB612"/>
-                </a:solidFill>
-              </a:defRPr>
-            </a:pPr>
-            <a:r>
-              <a:t>EXPERIENCIA DIGITAL EN MESA</a:t>
-            </a:r>
-          </a:p>
-          <a:p>
-            <a:pPr>
-              <a:spcAft>
-                <a:spcPts val="1000"/>
-              </a:spcAft>
               <a:defRPr sz="4400" b="1">
                 <a:solidFill>
                   <a:srgbClr val="FFFFFF"/>
@@ -3230,16 +3230,16 @@
           <a:p>
             <a:pPr>
               <a:spcAft>
-                <a:spcPts val="2400"/>
-              </a:spcAft>
-              <a:defRPr sz="2000">
+                <a:spcPts val="2000"/>
+              </a:spcAft>
+              <a:defRPr sz="1900">
                 <a:solidFill>
                   <a:srgbClr val="FFD100"/>
                 </a:solidFill>
               </a:defRPr>
             </a:pPr>
             <a:r>
-              <a:t>La Plataforma de Gamificación Deportiva que Convierte Comensales en Fanáticos Recurrentes</a:t>
+              <a:t>La Plataforma Deportiva que Convierte Comensales en Fanáticos Recurrentes</a:t>
             </a:r>
           </a:p>
           <a:p>
@@ -3251,7 +3251,7 @@
               </a:defRPr>
             </a:pPr>
             <a:r>
-              <a:t>Presentación Estratégica para Dirección General, Dueños de Marca y Gerencia Operativa</a:t>
+              <a:t>De la Barra de Álamos a la Escala de Marca • Presentación para Dirección y Gerencia General</a:t>
             </a:r>
           </a:p>
         </p:txBody>
@@ -3290,7 +3290,7 @@
         </p:nvSpPr>
         <p:spPr>
           <a:xfrm>
-            <a:off x="731520" y="457200"/>
+            <a:off x="731520" y="411480"/>
             <a:ext cx="10698480" cy="1005840"/>
           </a:xfrm>
           <a:prstGeom prst="rect">
@@ -3306,28 +3306,28 @@
           <a:p>
             <a:pPr>
               <a:spcAft>
-                <a:spcPts val="400"/>
-              </a:spcAft>
-              <a:defRPr sz="1100" b="1">
+                <a:spcPts val="300"/>
+              </a:spcAft>
+              <a:defRPr sz="1050" b="1">
                 <a:solidFill>
                   <a:srgbClr val="FFB612"/>
                 </a:solidFill>
               </a:defRPr>
             </a:pPr>
             <a:r>
-              <a:t>DRINKS &amp; WINS • PLATAFORMA DE GAMIFICACIÓN</a:t>
-            </a:r>
-          </a:p>
-          <a:p>
-            <a:pPr>
-              <a:defRPr sz="2600" b="1">
+              <a:t>EQUIPO DE SERVICIO</a:t>
+            </a:r>
+          </a:p>
+          <a:p>
+            <a:pPr>
+              <a:defRPr sz="2400" b="1">
                 <a:solidFill>
                   <a:srgbClr val="FFFFFF"/>
                 </a:solidFill>
               </a:defRPr>
             </a:pPr>
             <a:r>
-              <a:t>Gamificación para el Equipo: Meseros como Embajadores</a:t>
+              <a:t>Gamificación del Personal: Meseros como Embajadores</a:t>
             </a:r>
           </a:p>
         </p:txBody>
@@ -3340,18 +3340,18 @@
         </p:nvSpPr>
         <p:spPr>
           <a:xfrm>
-            <a:off x="731520" y="1737360"/>
-            <a:ext cx="10728655" cy="4480560"/>
+            <a:off x="731520" y="1645920"/>
+            <a:ext cx="6858000" cy="4572000"/>
           </a:xfrm>
           <a:prstGeom prst="roundRect">
             <a:avLst/>
           </a:prstGeom>
           <a:solidFill>
-            <a:srgbClr val="161C2A"/>
+            <a:srgbClr val="141A26"/>
           </a:solidFill>
           <a:ln w="19050">
             <a:solidFill>
-              <a:srgbClr val="2D374B"/>
+              <a:srgbClr val="283246"/>
             </a:solidFill>
           </a:ln>
         </p:spPr>
@@ -3385,8 +3385,8 @@
         </p:nvSpPr>
         <p:spPr>
           <a:xfrm>
-            <a:off x="1097280" y="2011680"/>
-            <a:ext cx="9966960" cy="3931920"/>
+            <a:off x="1005840" y="1828800"/>
+            <a:ext cx="6309360" cy="4114800"/>
           </a:xfrm>
           <a:prstGeom prst="rect">
             <a:avLst/>
@@ -3403,14 +3403,14 @@
               <a:spcAft>
                 <a:spcPts val="200"/>
               </a:spcAft>
-              <a:defRPr sz="1500" b="1">
+              <a:defRPr sz="1400" b="1">
                 <a:solidFill>
                   <a:srgbClr val="FFB612"/>
                 </a:solidFill>
               </a:defRPr>
             </a:pPr>
             <a:r>
-              <a:t>🙋 Atribución Transparente en Cada Registro</a:t>
+              <a:t>🙋 Atribución Clara en Cada Mesa</a:t>
             </a:r>
           </a:p>
           <a:p>
@@ -3418,14 +3418,14 @@
               <a:spcAft>
                 <a:spcPts val="1000"/>
               </a:spcAft>
-              <a:defRPr sz="1200">
+              <a:defRPr sz="1150">
                 <a:solidFill>
                   <a:srgbClr val="FFFFFF"/>
                 </a:solidFill>
               </a:defRPr>
             </a:pPr>
             <a:r>
-              <a:t>Al entrar a la quiniela, el cliente selecciona el nombre de su mesero en un menú desplegable. Esto permite saber qué colaborador está invitando activamente a las mesas.</a:t>
+              <a:t>Al registrar sus pronósticos, el cliente selecciona el nombre de su mesero en la lista. La gerencia sabe con métricas exactas qué meseros están invitando activamente y cuáles no.</a:t>
             </a:r>
           </a:p>
           <a:p>
@@ -3433,14 +3433,14 @@
               <a:spcAft>
                 <a:spcPts val="200"/>
               </a:spcAft>
-              <a:defRPr sz="1500" b="1">
+              <a:defRPr sz="1400" b="1">
                 <a:solidFill>
                   <a:srgbClr val="FFB612"/>
                 </a:solidFill>
               </a:defRPr>
             </a:pPr>
             <a:r>
-              <a:t>💰 Mayor Tiempo de Mesa = Mayor Ticket = Más Propina</a:t>
+              <a:t>💰 Incentivo Económico Directo (Más Propina)</a:t>
             </a:r>
           </a:p>
           <a:p>
@@ -3448,14 +3448,14 @@
               <a:spcAft>
                 <a:spcPts val="1000"/>
               </a:spcAft>
-              <a:defRPr sz="1200">
+              <a:defRPr sz="1150">
                 <a:solidFill>
                   <a:srgbClr val="FFFFFF"/>
                 </a:solidFill>
               </a:defRPr>
             </a:pPr>
             <a:r>
-              <a:t>Los meseros entienden el beneficio directo: si la mesa se queda viendo el partido para ver si gana su quiniela, pedirán más rondas de cerveza y comida, aumentando la cuenta y la propina final.</a:t>
+              <a:t>Los meseros comprenden la fórmula de inmediato: Si la mesa se queda 3 horas compitiendo, consumirá más rondas de cerveza, hamburguesas y alitas, lo que elevará el total de la cuenta y su propina.</a:t>
             </a:r>
           </a:p>
           <a:p>
@@ -3463,14 +3463,14 @@
               <a:spcAft>
                 <a:spcPts val="200"/>
               </a:spcAft>
-              <a:defRPr sz="1500" b="1">
+              <a:defRPr sz="1400" b="1">
                 <a:solidFill>
                   <a:srgbClr val="FFB612"/>
                 </a:solidFill>
               </a:defRPr>
             </a:pPr>
             <a:r>
-              <a:t>🏆 Competencia Interna del Personal</a:t>
+              <a:t>💬 Rompehielos Natural de Venta Sugerida</a:t>
             </a:r>
           </a:p>
           <a:p>
@@ -3478,14 +3478,14 @@
               <a:spcAft>
                 <a:spcPts val="1000"/>
               </a:spcAft>
-              <a:defRPr sz="1200">
+              <a:defRPr sz="1150">
                 <a:solidFill>
                   <a:srgbClr val="FFFFFF"/>
                 </a:solidFill>
               </a:defRPr>
             </a:pPr>
             <a:r>
-              <a:t>El restaurante puede premiar al mesero con más comensales registrados en la semana (ej. bono simbólico, turno preferencial, reconocimiento en junta de servicio).</a:t>
+              <a:t>En lugar del genérico '¿Se les ofrece algo más?', el mesero llega sonriendo: '¿Ya metieron su quiniela de hoy con mi nombre? Si ganan, ¡la casa les invita unas alitas!'.</a:t>
             </a:r>
           </a:p>
           <a:p>
@@ -3493,14 +3493,14 @@
               <a:spcAft>
                 <a:spcPts val="200"/>
               </a:spcAft>
-              <a:defRPr sz="1500" b="1">
+              <a:defRPr sz="1400" b="1">
                 <a:solidFill>
                   <a:srgbClr val="FFB612"/>
                 </a:solidFill>
               </a:defRPr>
             </a:pPr>
             <a:r>
-              <a:t>💬 Rompehielos Natural en Mesa</a:t>
+              <a:t>🏆 Competencia Interna del Equipo</a:t>
             </a:r>
           </a:p>
           <a:p>
@@ -3508,18 +3508,42 @@
               <a:spcAft>
                 <a:spcPts val="1000"/>
               </a:spcAft>
-              <a:defRPr sz="1200">
+              <a:defRPr sz="1150">
                 <a:solidFill>
                   <a:srgbClr val="FFFFFF"/>
                 </a:solidFill>
               </a:defRPr>
             </a:pPr>
             <a:r>
-              <a:t>En lugar del clásico '¿Se les ofrece algo más?', el mesero pregunta: '¿Ya metieron su quiniela gratis para ganarse unas alitas hoy?'. Crea conexión inmediata.</a:t>
-            </a:r>
-          </a:p>
-        </p:txBody>
-      </p:sp>
+              <a:t>Se puede premiar al mesero con más comensales registrados en la semana con turnos preferenciales o un reconocimiento en la junta semanal.</a:t>
+            </a:r>
+          </a:p>
+        </p:txBody>
+      </p:sp>
+      <p:pic>
+        <p:nvPicPr>
+          <p:cNvPr id="5" name="Picture 4" descr="screenshot_admin_player.png"/>
+          <p:cNvPicPr>
+            <a:picLocks noChangeAspect="1"/>
+          </p:cNvPicPr>
+          <p:nvPr/>
+        </p:nvPicPr>
+        <p:blipFill>
+          <a:blip r:embed="rId2"/>
+          <a:stretch>
+            <a:fillRect/>
+          </a:stretch>
+        </p:blipFill>
+        <p:spPr>
+          <a:xfrm>
+            <a:off x="7863840" y="1828800"/>
+            <a:ext cx="3566160" cy="1308612"/>
+          </a:xfrm>
+          <a:prstGeom prst="rect">
+            <a:avLst/>
+          </a:prstGeom>
+        </p:spPr>
+      </p:pic>
     </p:spTree>
   </p:cSld>
   <p:clrMapOvr>
@@ -3554,7 +3578,7 @@
         </p:nvSpPr>
         <p:spPr>
           <a:xfrm>
-            <a:off x="731520" y="457200"/>
+            <a:off x="731520" y="411480"/>
             <a:ext cx="10698480" cy="1005840"/>
           </a:xfrm>
           <a:prstGeom prst="rect">
@@ -3570,28 +3594,28 @@
           <a:p>
             <a:pPr>
               <a:spcAft>
-                <a:spcPts val="400"/>
-              </a:spcAft>
-              <a:defRPr sz="1100" b="1">
+                <a:spcPts val="300"/>
+              </a:spcAft>
+              <a:defRPr sz="1050" b="1">
                 <a:solidFill>
                   <a:srgbClr val="FFB612"/>
                 </a:solidFill>
               </a:defRPr>
             </a:pPr>
             <a:r>
-              <a:t>DRINKS &amp; WINS • PLATAFORMA DE GAMIFICACIÓN</a:t>
-            </a:r>
-          </a:p>
-          <a:p>
-            <a:pPr>
-              <a:defRPr sz="2600" b="1">
+              <a:t>RETORNO DE INVERSIÓN</a:t>
+            </a:r>
+          </a:p>
+          <a:p>
+            <a:pPr>
+              <a:defRPr sz="2400" b="1">
                 <a:solidFill>
                   <a:srgbClr val="FFFFFF"/>
                 </a:solidFill>
               </a:defRPr>
             </a:pPr>
             <a:r>
-              <a:t>Métricas Clave de Negocio (KPIs y Retorno)</a:t>
+              <a:t>Métricas Clave de Negocio (KPIs y Rentabilidad)</a:t>
             </a:r>
           </a:p>
         </p:txBody>
@@ -3604,18 +3628,18 @@
         </p:nvSpPr>
         <p:spPr>
           <a:xfrm>
-            <a:off x="731520" y="1737360"/>
-            <a:ext cx="2499055" cy="4297680"/>
+            <a:off x="731520" y="1645920"/>
+            <a:ext cx="2499055" cy="4572000"/>
           </a:xfrm>
           <a:prstGeom prst="roundRect">
             <a:avLst/>
           </a:prstGeom>
           <a:solidFill>
-            <a:srgbClr val="161C2A"/>
+            <a:srgbClr val="141A26"/>
           </a:solidFill>
           <a:ln w="19050">
             <a:solidFill>
-              <a:srgbClr val="2D374B"/>
+              <a:srgbClr val="283246"/>
             </a:solidFill>
           </a:ln>
         </p:spPr>
@@ -3649,8 +3673,8 @@
         </p:nvSpPr>
         <p:spPr>
           <a:xfrm>
-            <a:off x="914400" y="2011680"/>
-            <a:ext cx="2133295" cy="3749039"/>
+            <a:off x="914400" y="1920240"/>
+            <a:ext cx="2133295" cy="4023360"/>
           </a:xfrm>
           <a:prstGeom prst="rect">
             <a:avLst/>
@@ -3689,19 +3713,19 @@
               </a:defRPr>
             </a:pPr>
             <a:r>
-              <a:t>TIEMPO DE ESTANCIA</a:t>
+              <a:t>PERMANENCIA (DWELL TIME)</a:t>
             </a:r>
           </a:p>
           <a:p>
             <a:pPr algn="ctr">
-              <a:defRPr sz="1100">
+              <a:defRPr sz="1150">
                 <a:solidFill>
                   <a:srgbClr val="94A3B8"/>
                 </a:solidFill>
               </a:defRPr>
             </a:pPr>
             <a:r>
-              <a:t>Los clientes permanecen durante todo el evento deportivo en lugar de pedir la cuenta al medio tiempo.</a:t>
+              <a:t>Las mesas se quedan hasta el silbatazo final para ver si ganan su quiniela.</a:t>
             </a:r>
           </a:p>
         </p:txBody>
@@ -3714,18 +3738,18 @@
         </p:nvSpPr>
         <p:spPr>
           <a:xfrm>
-            <a:off x="3474720" y="1737360"/>
-            <a:ext cx="2499055" cy="4297680"/>
+            <a:off x="3474720" y="1645920"/>
+            <a:ext cx="2499055" cy="4572000"/>
           </a:xfrm>
           <a:prstGeom prst="roundRect">
             <a:avLst/>
           </a:prstGeom>
           <a:solidFill>
-            <a:srgbClr val="161C2A"/>
+            <a:srgbClr val="141A26"/>
           </a:solidFill>
           <a:ln w="19050">
             <a:solidFill>
-              <a:srgbClr val="2D374B"/>
+              <a:srgbClr val="283246"/>
             </a:solidFill>
           </a:ln>
         </p:spPr>
@@ -3759,8 +3783,8 @@
         </p:nvSpPr>
         <p:spPr>
           <a:xfrm>
-            <a:off x="3657600" y="2011680"/>
-            <a:ext cx="2133295" cy="3749039"/>
+            <a:off x="3657600" y="1920240"/>
+            <a:ext cx="2133295" cy="4023360"/>
           </a:xfrm>
           <a:prstGeom prst="rect">
             <a:avLst/>
@@ -3804,14 +3828,14 @@
           </a:p>
           <a:p>
             <a:pPr algn="ctr">
-              <a:defRPr sz="1100">
+              <a:defRPr sz="1150">
                 <a:solidFill>
                   <a:srgbClr val="94A3B8"/>
                 </a:solidFill>
               </a:defRPr>
             </a:pPr>
             <a:r>
-              <a:t>El ambiente competitivo estimula pedidos repetidos de bebidas y snacks durante las fases finales del juego.</a:t>
+              <a:t>El ambiente competitivo estimula pedidos repetidos de cerveza y botanas.</a:t>
             </a:r>
           </a:p>
         </p:txBody>
@@ -3824,18 +3848,18 @@
         </p:nvSpPr>
         <p:spPr>
           <a:xfrm>
-            <a:off x="6217920" y="1737360"/>
-            <a:ext cx="2499055" cy="4297680"/>
+            <a:off x="6217920" y="1645920"/>
+            <a:ext cx="2499055" cy="4572000"/>
           </a:xfrm>
           <a:prstGeom prst="roundRect">
             <a:avLst/>
           </a:prstGeom>
           <a:solidFill>
-            <a:srgbClr val="161C2A"/>
+            <a:srgbClr val="141A26"/>
           </a:solidFill>
           <a:ln w="19050">
             <a:solidFill>
-              <a:srgbClr val="2D374B"/>
+              <a:srgbClr val="283246"/>
             </a:solidFill>
           </a:ln>
         </p:spPr>
@@ -3869,8 +3893,8 @@
         </p:nvSpPr>
         <p:spPr>
           <a:xfrm>
-            <a:off x="6400800" y="2011680"/>
-            <a:ext cx="2133295" cy="3749039"/>
+            <a:off x="6400800" y="1920240"/>
+            <a:ext cx="2133295" cy="4023360"/>
           </a:xfrm>
           <a:prstGeom prst="rect">
             <a:avLst/>
@@ -3909,19 +3933,19 @@
               </a:defRPr>
             </a:pPr>
             <a:r>
-              <a:t>RETENCIÓN SEMANAL</a:t>
+              <a:t>RETENCIÓN Y LEALTAD</a:t>
             </a:r>
           </a:p>
           <a:p>
             <a:pPr algn="ctr">
-              <a:defRPr sz="1100">
+              <a:defRPr sz="1150">
                 <a:solidFill>
                   <a:srgbClr val="94A3B8"/>
                 </a:solidFill>
               </a:defRPr>
             </a:pPr>
             <a:r>
-              <a:t>El fanático regresa la semana siguiente para defender su posición en la tabla de la temporada.</a:t>
+              <a:t>El comensal regresa jornada tras jornada para defender su posición en la tabla.</a:t>
             </a:r>
           </a:p>
         </p:txBody>
@@ -3934,18 +3958,18 @@
         </p:nvSpPr>
         <p:spPr>
           <a:xfrm>
-            <a:off x="8961120" y="1737360"/>
-            <a:ext cx="2499055" cy="4297680"/>
+            <a:off x="8961120" y="1645920"/>
+            <a:ext cx="2499055" cy="4572000"/>
           </a:xfrm>
           <a:prstGeom prst="roundRect">
             <a:avLst/>
           </a:prstGeom>
           <a:solidFill>
-            <a:srgbClr val="161C2A"/>
+            <a:srgbClr val="141A26"/>
           </a:solidFill>
           <a:ln w="19050">
             <a:solidFill>
-              <a:srgbClr val="2D374B"/>
+              <a:srgbClr val="283246"/>
             </a:solidFill>
           </a:ln>
         </p:spPr>
@@ -3979,8 +4003,8 @@
         </p:nvSpPr>
         <p:spPr>
           <a:xfrm>
-            <a:off x="9144000" y="2011680"/>
-            <a:ext cx="2133295" cy="3749039"/>
+            <a:off x="9144000" y="1920240"/>
+            <a:ext cx="2133295" cy="4023360"/>
           </a:xfrm>
           <a:prstGeom prst="rect">
             <a:avLst/>
@@ -4024,14 +4048,14 @@
           </a:p>
           <a:p>
             <a:pPr algn="ctr">
-              <a:defRPr sz="1100">
+              <a:defRPr sz="1150">
                 <a:solidFill>
                   <a:srgbClr val="94A3B8"/>
                 </a:solidFill>
               </a:defRPr>
             </a:pPr>
             <a:r>
-              <a:t>Eliminación absoluta de papeletas impresas, plumas extraviadas y conteos manuales con margen de error.</a:t>
+              <a:t>Eliminación total de impresiones, papeletas extraviadas y errores de conteo.</a:t>
             </a:r>
           </a:p>
         </p:txBody>
@@ -4070,7 +4094,7 @@
         </p:nvSpPr>
         <p:spPr>
           <a:xfrm>
-            <a:off x="731520" y="457200"/>
+            <a:off x="731520" y="411480"/>
             <a:ext cx="10698480" cy="1005840"/>
           </a:xfrm>
           <a:prstGeom prst="rect">
@@ -4086,28 +4110,28 @@
           <a:p>
             <a:pPr>
               <a:spcAft>
-                <a:spcPts val="400"/>
-              </a:spcAft>
-              <a:defRPr sz="1100" b="1">
+                <a:spcPts val="300"/>
+              </a:spcAft>
+              <a:defRPr sz="1050" b="1">
                 <a:solidFill>
                   <a:srgbClr val="FFB612"/>
                 </a:solidFill>
               </a:defRPr>
             </a:pPr>
             <a:r>
-              <a:t>DRINKS &amp; WINS • PLATAFORMA DE GAMIFICACIÓN</a:t>
-            </a:r>
-          </a:p>
-          <a:p>
-            <a:pPr>
-              <a:defRPr sz="2600" b="1">
+              <a:t>PRÓXIMOS PASOS</a:t>
+            </a:r>
+          </a:p>
+          <a:p>
+            <a:pPr>
+              <a:defRPr sz="2400" b="1">
                 <a:solidFill>
                   <a:srgbClr val="FFFFFF"/>
                 </a:solidFill>
               </a:defRPr>
             </a:pPr>
             <a:r>
-              <a:t>Próximos Pasos: Lanzamiento Rápido en Sucursal</a:t>
+              <a:t>Plan de Acción: Lanzamiento Piloto en Querétaro</a:t>
             </a:r>
           </a:p>
         </p:txBody>
@@ -4120,18 +4144,18 @@
         </p:nvSpPr>
         <p:spPr>
           <a:xfrm>
-            <a:off x="731520" y="1737360"/>
-            <a:ext cx="10728655" cy="4480560"/>
+            <a:off x="731520" y="1645920"/>
+            <a:ext cx="10728655" cy="4572000"/>
           </a:xfrm>
           <a:prstGeom prst="roundRect">
             <a:avLst/>
           </a:prstGeom>
           <a:solidFill>
-            <a:srgbClr val="161C2A"/>
+            <a:srgbClr val="141A26"/>
           </a:solidFill>
           <a:ln w="19050">
             <a:solidFill>
-              <a:srgbClr val="2D374B"/>
+              <a:srgbClr val="283246"/>
             </a:solidFill>
           </a:ln>
         </p:spPr>
@@ -4165,8 +4189,8 @@
         </p:nvSpPr>
         <p:spPr>
           <a:xfrm>
-            <a:off x="1097280" y="2011680"/>
-            <a:ext cx="9966960" cy="3931920"/>
+            <a:off x="1097280" y="1920240"/>
+            <a:ext cx="9966960" cy="4023360"/>
           </a:xfrm>
           <a:prstGeom prst="rect">
             <a:avLst/>
@@ -4183,20 +4207,20 @@
               <a:spcAft>
                 <a:spcPts val="200"/>
               </a:spcAft>
-              <a:defRPr sz="1500" b="1">
+              <a:defRPr sz="1450" b="1">
                 <a:solidFill>
                   <a:srgbClr val="FFB612"/>
                 </a:solidFill>
               </a:defRPr>
             </a:pPr>
             <a:r>
-              <a:t>Fase 1: Material en Mesas (Día 1)</a:t>
-            </a:r>
-          </a:p>
-          <a:p>
-            <a:pPr>
-              <a:spcAft>
-                <a:spcPts val="1200"/>
+              <a:t>Paso 1: Colocación de Material POP en Mesas (Día 1)</a:t>
+            </a:r>
+          </a:p>
+          <a:p>
+            <a:pPr>
+              <a:spcAft>
+                <a:spcPts val="1000"/>
               </a:spcAft>
               <a:defRPr sz="1200">
                 <a:solidFill>
@@ -4205,7 +4229,7 @@
               </a:defRPr>
             </a:pPr>
             <a:r>
-              <a:t>Colocación de códigos QR en acrílicos de mesa y banners de bienvenida en pantallas de bar.</a:t>
+              <a:t>Acrílicos de mesa con código QR directo y bienvenida en pantallas del restaurante.</a:t>
             </a:r>
           </a:p>
           <a:p>
@@ -4213,20 +4237,20 @@
               <a:spcAft>
                 <a:spcPts val="200"/>
               </a:spcAft>
-              <a:defRPr sz="1500" b="1">
+              <a:defRPr sz="1450" b="1">
                 <a:solidFill>
                   <a:srgbClr val="FFB612"/>
                 </a:solidFill>
               </a:defRPr>
             </a:pPr>
             <a:r>
-              <a:t>Fase 2: Capacitación Express de 15 Minutos (Día 2)</a:t>
-            </a:r>
-          </a:p>
-          <a:p>
-            <a:pPr>
-              <a:spcAft>
-                <a:spcPts val="1200"/>
+              <a:t>Paso 2: Capacitación Express de 15 Minutos (Día 2)</a:t>
+            </a:r>
+          </a:p>
+          <a:p>
+            <a:pPr>
+              <a:spcAft>
+                <a:spcPts val="1000"/>
               </a:spcAft>
               <a:defRPr sz="1200">
                 <a:solidFill>
@@ -4235,7 +4259,7 @@
               </a:defRPr>
             </a:pPr>
             <a:r>
-              <a:t>Demostración rápida al equipo de gerencia y meseros: cómo invitar al cliente y cómo verificar ganadores.</a:t>
+              <a:t>Demostración rápida al equipo de meseros y capitanes: cómo invitar a la mesa y cómo verificar al ganador.</a:t>
             </a:r>
           </a:p>
           <a:p>
@@ -4243,20 +4267,20 @@
               <a:spcAft>
                 <a:spcPts val="200"/>
               </a:spcAft>
-              <a:defRPr sz="1500" b="1">
+              <a:defRPr sz="1450" b="1">
                 <a:solidFill>
                   <a:srgbClr val="FFB612"/>
                 </a:solidFill>
               </a:defRPr>
             </a:pPr>
             <a:r>
-              <a:t>Fase 3: Jornada Piloto de Estreno (Fin de Semana)</a:t>
-            </a:r>
-          </a:p>
-          <a:p>
-            <a:pPr>
-              <a:spcAft>
-                <a:spcPts val="1200"/>
+              <a:t>Paso 3: Activación Piloto con Fan Club (Fin de Semana)</a:t>
+            </a:r>
+          </a:p>
+          <a:p>
+            <a:pPr>
+              <a:spcAft>
+                <a:spcPts val="1000"/>
               </a:spcAft>
               <a:defRPr sz="1200">
                 <a:solidFill>
@@ -4265,7 +4289,7 @@
               </a:defRPr>
             </a:pPr>
             <a:r>
-              <a:t>Lanzamiento oficial en el partido estelar de la semana (ej. Domingo de NFL o Clásico de Liga MX).</a:t>
+              <a:t>Lanzamiento con la comunidad de Steelers Nation Querétaro en el partido estelar de la semana.</a:t>
             </a:r>
           </a:p>
           <a:p>
@@ -4273,20 +4297,20 @@
               <a:spcAft>
                 <a:spcPts val="200"/>
               </a:spcAft>
-              <a:defRPr sz="1500" b="1">
+              <a:defRPr sz="1450" b="1">
                 <a:solidFill>
                   <a:srgbClr val="FFB612"/>
                 </a:solidFill>
               </a:defRPr>
             </a:pPr>
             <a:r>
-              <a:t>Fase 4: Evaluación de Resultados y Expansión</a:t>
-            </a:r>
-          </a:p>
-          <a:p>
-            <a:pPr>
-              <a:spcAft>
-                <a:spcPts val="1200"/>
+              <a:t>Paso 4: Evaluación de Resultados y Expansión a Otras Sucursales</a:t>
+            </a:r>
+          </a:p>
+          <a:p>
+            <a:pPr>
+              <a:spcAft>
+                <a:spcPts val="1000"/>
               </a:spcAft>
               <a:defRPr sz="1200">
                 <a:solidFill>
@@ -4295,7 +4319,7 @@
               </a:defRPr>
             </a:pPr>
             <a:r>
-              <a:t>Revisión con gerencia de mesas participantes, consumo generado y retroalimentación para afinar premios.</a:t>
+              <a:t>Revisión con dueños y gerencia de consumo generado, mesas participantes y lealtad para escalarlo.</a:t>
             </a:r>
           </a:p>
         </p:txBody>
@@ -4334,7 +4358,7 @@
         </p:nvSpPr>
         <p:spPr>
           <a:xfrm>
-            <a:off x="731520" y="457200"/>
+            <a:off x="731520" y="411480"/>
             <a:ext cx="10698480" cy="1005840"/>
           </a:xfrm>
           <a:prstGeom prst="rect">
@@ -4350,28 +4374,28 @@
           <a:p>
             <a:pPr>
               <a:spcAft>
-                <a:spcPts val="400"/>
-              </a:spcAft>
-              <a:defRPr sz="1100" b="1">
+                <a:spcPts val="300"/>
+              </a:spcAft>
+              <a:defRPr sz="1050" b="1">
                 <a:solidFill>
                   <a:srgbClr val="FFB612"/>
                 </a:solidFill>
               </a:defRPr>
             </a:pPr>
             <a:r>
-              <a:t>DRINKS &amp; WINS • PLATAFORMA DE GAMIFICACIÓN</a:t>
-            </a:r>
-          </a:p>
-          <a:p>
-            <a:pPr>
-              <a:defRPr sz="2600" b="1">
+              <a:t>VALIDACIÓN ORGÁNICA • HISTORIA DE ÉXITO</a:t>
+            </a:r>
+          </a:p>
+          <a:p>
+            <a:pPr>
+              <a:defRPr sz="2400" b="1">
                 <a:solidFill>
                   <a:srgbClr val="FFFFFF"/>
                 </a:solidFill>
               </a:defRPr>
             </a:pPr>
             <a:r>
-              <a:t>El Reto en el Restaurante: ¿Qué pasa durante los partidos?</a:t>
+              <a:t>Nacido en Barra: Una Idea Probada con Clientes Reales</a:t>
             </a:r>
           </a:p>
         </p:txBody>
@@ -4384,18 +4408,18 @@
         </p:nvSpPr>
         <p:spPr>
           <a:xfrm>
-            <a:off x="731520" y="1737360"/>
-            <a:ext cx="3413455" cy="4297680"/>
+            <a:off x="731520" y="1645920"/>
+            <a:ext cx="10728655" cy="4572000"/>
           </a:xfrm>
           <a:prstGeom prst="roundRect">
             <a:avLst/>
           </a:prstGeom>
           <a:solidFill>
-            <a:srgbClr val="161C2A"/>
+            <a:srgbClr val="141A26"/>
           </a:solidFill>
           <a:ln w="19050">
             <a:solidFill>
-              <a:srgbClr val="2D374B"/>
+              <a:srgbClr val="283246"/>
             </a:solidFill>
           </a:ln>
         </p:spPr>
@@ -4429,8 +4453,8 @@
         </p:nvSpPr>
         <p:spPr>
           <a:xfrm>
-            <a:off x="1005840" y="2011680"/>
-            <a:ext cx="2864815" cy="3749039"/>
+            <a:off x="1097280" y="1920240"/>
+            <a:ext cx="9966960" cy="4023360"/>
           </a:xfrm>
           <a:prstGeom prst="rect">
             <a:avLst/>
@@ -4445,218 +4469,106 @@
           <a:p>
             <a:pPr>
               <a:spcAft>
-                <a:spcPts val="1600"/>
+                <a:spcPts val="1400"/>
               </a:spcAft>
               <a:defRPr sz="1800" b="1">
                 <a:solidFill>
-                  <a:srgbClr val="FF5722"/>
-                </a:solidFill>
-              </a:defRPr>
-            </a:pPr>
-            <a:r>
-              <a:t>⏳ Tiempos Muertos y Rotación Lenta</a:t>
-            </a:r>
-          </a:p>
-          <a:p>
-            <a:pPr>
-              <a:defRPr sz="1400">
+                  <a:srgbClr val="FFB612"/>
+                </a:solidFill>
+              </a:defRPr>
+            </a:pPr>
+            <a:r>
+              <a:t>💬 «Beto, ¿qué onda? ¿Para cuándo la próxima quiniela o trivia?»</a:t>
+            </a:r>
+          </a:p>
+          <a:p>
+            <a:pPr>
+              <a:spcAft>
+                <a:spcPts val="200"/>
+              </a:spcAft>
+              <a:defRPr sz="1450" b="1">
+                <a:solidFill>
+                  <a:srgbClr val="FFD100"/>
+                </a:solidFill>
+              </a:defRPr>
+            </a:pPr>
+            <a:r>
+              <a:t>🍺 El Origen en Álamos</a:t>
+            </a:r>
+          </a:p>
+          <a:p>
+            <a:pPr>
+              <a:spcAft>
+                <a:spcPts val="1200"/>
+              </a:spcAft>
+              <a:defRPr sz="1200">
                 <a:solidFill>
                   <a:srgbClr val="FFFFFF"/>
                 </a:solidFill>
               </a:defRPr>
             </a:pPr>
             <a:r>
-              <a:t>Durante un partido de 3 horas de NFL o 90 min de fútbol, hay largos lapsos pasivos (medios tiempos, pausas comerciales, revisiones de jugadas). Los comensales pierden dinamismo y baja la frecuencia de pedidos.</a:t>
-            </a:r>
-          </a:p>
-        </p:txBody>
-      </p:sp>
-      <p:sp>
-        <p:nvSpPr>
-          <p:cNvPr id="5" name="Rounded Rectangle 4"/>
-          <p:cNvSpPr/>
-          <p:nvPr/>
-        </p:nvSpPr>
-        <p:spPr>
-          <a:xfrm>
-            <a:off x="4389120" y="1737360"/>
-            <a:ext cx="3413455" cy="4297680"/>
-          </a:xfrm>
-          <a:prstGeom prst="roundRect">
-            <a:avLst/>
-          </a:prstGeom>
-          <a:solidFill>
-            <a:srgbClr val="161C2A"/>
-          </a:solidFill>
-          <a:ln w="19050">
-            <a:solidFill>
-              <a:srgbClr val="2D374B"/>
-            </a:solidFill>
-          </a:ln>
-        </p:spPr>
-        <p:style>
-          <a:lnRef idx="1">
-            <a:schemeClr val="accent1"/>
-          </a:lnRef>
-          <a:fillRef idx="3">
-            <a:schemeClr val="accent1"/>
-          </a:fillRef>
-          <a:effectRef idx="2">
-            <a:schemeClr val="accent1"/>
-          </a:effectRef>
-          <a:fontRef idx="minor">
-            <a:schemeClr val="lt1"/>
-          </a:fontRef>
-        </p:style>
-        <p:txBody>
-          <a:bodyPr rtlCol="0" anchor="ctr"/>
-          <a:lstStyle/>
-          <a:p>
-            <a:pPr algn="ctr"/>
-          </a:p>
-        </p:txBody>
-      </p:sp>
-      <p:sp>
-        <p:nvSpPr>
-          <p:cNvPr id="6" name="TextBox 5"/>
-          <p:cNvSpPr txBox="1"/>
-          <p:nvPr/>
-        </p:nvSpPr>
-        <p:spPr>
-          <a:xfrm>
-            <a:off x="4663440" y="2011680"/>
-            <a:ext cx="2864815" cy="3749039"/>
-          </a:xfrm>
-          <a:prstGeom prst="rect">
-            <a:avLst/>
-          </a:prstGeom>
-          <a:noFill/>
-        </p:spPr>
-        <p:txBody>
-          <a:bodyPr wrap="square">
-            <a:spAutoFit/>
-          </a:bodyPr>
-          <a:lstStyle/>
-          <a:p>
-            <a:pPr>
-              <a:spcAft>
-                <a:spcPts val="1600"/>
-              </a:spcAft>
-              <a:defRPr sz="1800" b="1">
-                <a:solidFill>
-                  <a:srgbClr val="FFB612"/>
-                </a:solidFill>
-              </a:defRPr>
-            </a:pPr>
-            <a:r>
-              <a:t>📱 Distracción Aislada en el Celular</a:t>
-            </a:r>
-          </a:p>
-          <a:p>
-            <a:pPr>
-              <a:defRPr sz="1400">
+              <a:t>Drinks &amp; Wins no nació como una teoría de oficina. Nació directamente en la barra de Álamos, donde Beto empezó a organizar quinielas y trivias entre las mesas de forma orgánica. La respuesta de los comensales fue abrumadora: las mesas competían, consumían más y se quedaban hasta el final del partido.</a:t>
+            </a:r>
+          </a:p>
+          <a:p>
+            <a:pPr>
+              <a:spcAft>
+                <a:spcPts val="200"/>
+              </a:spcAft>
+              <a:defRPr sz="1450" b="1">
+                <a:solidFill>
+                  <a:srgbClr val="FFD100"/>
+                </a:solidFill>
+              </a:defRPr>
+            </a:pPr>
+            <a:r>
+              <a:t>🤝 Creación de Clientes Frecuentes y Leales</a:t>
+            </a:r>
+          </a:p>
+          <a:p>
+            <a:pPr>
+              <a:spcAft>
+                <a:spcPts val="1200"/>
+              </a:spcAft>
+              <a:defRPr sz="1200">
                 <a:solidFill>
                   <a:srgbClr val="FFFFFF"/>
                 </a:solidFill>
               </a:defRPr>
             </a:pPr>
             <a:r>
-              <a:t>El cliente mira su teléfono para chatear o revisar redes ajenas al restaurante. No existe una experiencia interactiva que vincule la pantalla de televisión del bar con la mesa del cliente.</a:t>
-            </a:r>
-          </a:p>
-        </p:txBody>
-      </p:sp>
-      <p:sp>
-        <p:nvSpPr>
-          <p:cNvPr id="7" name="Rounded Rectangle 6"/>
-          <p:cNvSpPr/>
-          <p:nvPr/>
-        </p:nvSpPr>
-        <p:spPr>
-          <a:xfrm>
-            <a:off x="8046720" y="1737360"/>
-            <a:ext cx="3413455" cy="4297680"/>
-          </a:xfrm>
-          <a:prstGeom prst="roundRect">
-            <a:avLst/>
-          </a:prstGeom>
-          <a:solidFill>
-            <a:srgbClr val="161C2A"/>
-          </a:solidFill>
-          <a:ln w="19050">
-            <a:solidFill>
-              <a:srgbClr val="2D374B"/>
-            </a:solidFill>
-          </a:ln>
-        </p:spPr>
-        <p:style>
-          <a:lnRef idx="1">
-            <a:schemeClr val="accent1"/>
-          </a:lnRef>
-          <a:fillRef idx="3">
-            <a:schemeClr val="accent1"/>
-          </a:fillRef>
-          <a:effectRef idx="2">
-            <a:schemeClr val="accent1"/>
-          </a:effectRef>
-          <a:fontRef idx="minor">
-            <a:schemeClr val="lt1"/>
-          </a:fontRef>
-        </p:style>
-        <p:txBody>
-          <a:bodyPr rtlCol="0" anchor="ctr"/>
-          <a:lstStyle/>
-          <a:p>
-            <a:pPr algn="ctr"/>
-          </a:p>
-        </p:txBody>
-      </p:sp>
-      <p:sp>
-        <p:nvSpPr>
-          <p:cNvPr id="8" name="TextBox 7"/>
-          <p:cNvSpPr txBox="1"/>
-          <p:nvPr/>
-        </p:nvSpPr>
-        <p:spPr>
-          <a:xfrm>
-            <a:off x="8321040" y="2011680"/>
-            <a:ext cx="2864815" cy="3749039"/>
-          </a:xfrm>
-          <a:prstGeom prst="rect">
-            <a:avLst/>
-          </a:prstGeom>
-          <a:noFill/>
-        </p:spPr>
-        <p:txBody>
-          <a:bodyPr wrap="square">
-            <a:spAutoFit/>
-          </a:bodyPr>
-          <a:lstStyle/>
-          <a:p>
-            <a:pPr>
-              <a:spcAft>
-                <a:spcPts val="1600"/>
-              </a:spcAft>
-              <a:defRPr sz="1800" b="1">
-                <a:solidFill>
-                  <a:srgbClr val="00E676"/>
-                </a:solidFill>
-              </a:defRPr>
-            </a:pPr>
-            <a:r>
-              <a:t>💵 Pérdida de Potencial de Consumo</a:t>
-            </a:r>
-          </a:p>
-          <a:p>
-            <a:pPr>
-              <a:defRPr sz="1400">
+              <a:t>Esa dinámica creó una comunidad fiel que no solo llenaba el restaurante en días de juego, sino que hoy en día, cuando ven a Beto en la calle en Querétaro, lo reconocen y le preguntan entusiasmados por la siguiente fecha.</a:t>
+            </a:r>
+          </a:p>
+          <a:p>
+            <a:pPr>
+              <a:spcAft>
+                <a:spcPts val="200"/>
+              </a:spcAft>
+              <a:defRPr sz="1450" b="1">
+                <a:solidFill>
+                  <a:srgbClr val="FFD100"/>
+                </a:solidFill>
+              </a:defRPr>
+            </a:pPr>
+            <a:r>
+              <a:t>🚀 De la Libreta de Papel a la Tecnología PWA con IA</a:t>
+            </a:r>
+          </a:p>
+          <a:p>
+            <a:pPr>
+              <a:spcAft>
+                <a:spcPts val="1200"/>
+              </a:spcAft>
+              <a:defRPr sz="1200">
                 <a:solidFill>
                   <a:srgbClr val="FFFFFF"/>
                 </a:solidFill>
               </a:defRPr>
             </a:pPr>
             <a:r>
-              <a:t>Una mesa entretenida y compitiendo amistosamente consume más bebidas, alitas y botanas. Sin dinamismo, el ticket promedio se estanca tras el primer pedido inicial.</a:t>
+              <a:t>Lo que antes se hacía con hojas de papel, plumas perdidas y conteos manuales agotadores, ahora está digitalizado al 100% en la nube, con conexión oficial a ESPN e Inteligencia Artificial para crear jornadas en segundos.</a:t>
             </a:r>
           </a:p>
         </p:txBody>
@@ -4695,7 +4607,7 @@
         </p:nvSpPr>
         <p:spPr>
           <a:xfrm>
-            <a:off x="731520" y="457200"/>
+            <a:off x="731520" y="411480"/>
             <a:ext cx="10698480" cy="1005840"/>
           </a:xfrm>
           <a:prstGeom prst="rect">
@@ -4711,28 +4623,28 @@
           <a:p>
             <a:pPr>
               <a:spcAft>
-                <a:spcPts val="400"/>
-              </a:spcAft>
-              <a:defRPr sz="1100" b="1">
+                <a:spcPts val="300"/>
+              </a:spcAft>
+              <a:defRPr sz="1050" b="1">
                 <a:solidFill>
                   <a:srgbClr val="FFB612"/>
                 </a:solidFill>
               </a:defRPr>
             </a:pPr>
             <a:r>
-              <a:t>DRINKS &amp; WINS • PLATAFORMA DE GAMIFICACIÓN</a:t>
-            </a:r>
-          </a:p>
-          <a:p>
-            <a:pPr>
-              <a:defRPr sz="2600" b="1">
+              <a:t>ESTRATEGIA COMERCIAL INTELIGENTE</a:t>
+            </a:r>
+          </a:p>
+          <a:p>
+            <a:pPr>
+              <a:defRPr sz="2400" b="1">
                 <a:solidFill>
                   <a:srgbClr val="FFFFFF"/>
                 </a:solidFill>
               </a:defRPr>
             </a:pPr>
             <a:r>
-              <a:t>La Solución: Gamificación en Mesa sin Fricción</a:t>
+              <a:t>Estrategia Gradual y Punta de Lanza con Fan Clubs</a:t>
             </a:r>
           </a:p>
         </p:txBody>
@@ -4745,18 +4657,18 @@
         </p:nvSpPr>
         <p:spPr>
           <a:xfrm>
-            <a:off x="731520" y="1737360"/>
-            <a:ext cx="6583680" cy="4480560"/>
+            <a:off x="731520" y="1645920"/>
+            <a:ext cx="5212080" cy="4572000"/>
           </a:xfrm>
           <a:prstGeom prst="roundRect">
             <a:avLst/>
           </a:prstGeom>
           <a:solidFill>
-            <a:srgbClr val="161C2A"/>
+            <a:srgbClr val="141A26"/>
           </a:solidFill>
           <a:ln w="19050">
             <a:solidFill>
-              <a:srgbClr val="2D374B"/>
+              <a:srgbClr val="283246"/>
             </a:solidFill>
           </a:ln>
         </p:spPr>
@@ -4790,8 +4702,8 @@
         </p:nvSpPr>
         <p:spPr>
           <a:xfrm>
-            <a:off x="1097280" y="2011680"/>
-            <a:ext cx="5852160" cy="3931920"/>
+            <a:off x="1005840" y="1920240"/>
+            <a:ext cx="4663440" cy="4023360"/>
           </a:xfrm>
           <a:prstGeom prst="rect">
             <a:avLst/>
@@ -4806,149 +4718,313 @@
           <a:p>
             <a:pPr>
               <a:spcAft>
-                <a:spcPts val="200"/>
-              </a:spcAft>
-              <a:defRPr sz="1500" b="1">
+                <a:spcPts val="1000"/>
+              </a:spcAft>
+              <a:defRPr sz="1700" b="1">
                 <a:solidFill>
                   <a:srgbClr val="FFB612"/>
                 </a:solidFill>
               </a:defRPr>
             </a:pPr>
             <a:r>
-              <a:t>📲 100% Web (Sin Descargas)</a:t>
-            </a:r>
-          </a:p>
-          <a:p>
-            <a:pPr>
-              <a:spcAft>
-                <a:spcPts val="1200"/>
-              </a:spcAft>
-              <a:defRPr sz="1200">
+              <a:t>🎯 No Saturar: El Juego Indicado en el Día Indicado</a:t>
+            </a:r>
+          </a:p>
+          <a:p>
+            <a:pPr>
+              <a:spcAft>
+                <a:spcPts val="100"/>
+              </a:spcAft>
+              <a:defRPr sz="1300" b="1">
+                <a:solidFill>
+                  <a:srgbClr val="FF5722"/>
+                </a:solidFill>
+              </a:defRPr>
+            </a:pPr>
+            <a:r>
+              <a:t>📅 Selección Quirúrgica de Fechas</a:t>
+            </a:r>
+          </a:p>
+          <a:p>
+            <a:pPr>
+              <a:spcAft>
+                <a:spcPts val="800"/>
+              </a:spcAft>
+              <a:defRPr sz="1100">
                 <a:solidFill>
                   <a:srgbClr val="FFFFFF"/>
                 </a:solidFill>
               </a:defRPr>
             </a:pPr>
             <a:r>
-              <a:t>El cliente escanea el código QR de su mesa y entra directo desde su navegador en 3 segundos. Cero descargas pesadas de App Store o Play Store.</a:t>
-            </a:r>
-          </a:p>
-          <a:p>
-            <a:pPr>
-              <a:spcAft>
-                <a:spcPts val="200"/>
-              </a:spcAft>
-              <a:defRPr sz="1500" b="1">
-                <a:solidFill>
-                  <a:srgbClr val="FFB612"/>
-                </a:solidFill>
-              </a:defRPr>
-            </a:pPr>
-            <a:r>
-              <a:t>🏆 Emoción Deportiva en Vivo</a:t>
-            </a:r>
-          </a:p>
-          <a:p>
-            <a:pPr>
-              <a:spcAft>
-                <a:spcPts val="1200"/>
-              </a:spcAft>
-              <a:defRPr sz="1200">
+              <a:t>No se tienen que jugar todos los juegos todos los días. Saturar al cliente cansa. La clave es activar dinámicas exclusivamente en partidos estelares:</a:t>
+            </a:r>
+          </a:p>
+          <a:p>
+            <a:pPr>
+              <a:spcAft>
+                <a:spcPts val="100"/>
+              </a:spcAft>
+              <a:defRPr sz="1300" b="1">
+                <a:solidFill>
+                  <a:srgbClr val="FF5722"/>
+                </a:solidFill>
+              </a:defRPr>
+            </a:pPr>
+            <a:r>
+              <a:t>🏈 Jueves, Domingos y Lunes</a:t>
+            </a:r>
+          </a:p>
+          <a:p>
+            <a:pPr>
+              <a:spcAft>
+                <a:spcPts val="800"/>
+              </a:spcAft>
+              <a:defRPr sz="1100">
                 <a:solidFill>
                   <a:srgbClr val="FFFFFF"/>
                 </a:solidFill>
               </a:defRPr>
             </a:pPr>
             <a:r>
-              <a:t>Pronósticos, quinielas y trivias conectadas en tiempo real a los marcadores oficiales de ESPN. Cada anotación en la TV cambia la tabla en su celular.</a:t>
-            </a:r>
-          </a:p>
-          <a:p>
-            <a:pPr>
-              <a:spcAft>
-                <a:spcPts val="200"/>
-              </a:spcAft>
-              <a:defRPr sz="1500" b="1">
-                <a:solidFill>
-                  <a:srgbClr val="FFB612"/>
-                </a:solidFill>
-              </a:defRPr>
-            </a:pPr>
-            <a:r>
-              <a:t>🍻 Recompensas Reales del Restaurante</a:t>
-            </a:r>
-          </a:p>
-          <a:p>
-            <a:pPr>
-              <a:spcAft>
-                <a:spcPts val="1200"/>
-              </a:spcAft>
-              <a:defRPr sz="1200">
+              <a:t>Quinielas y Grids de NFL durante transmisiones estelares.</a:t>
+            </a:r>
+          </a:p>
+          <a:p>
+            <a:pPr>
+              <a:spcAft>
+                <a:spcPts val="100"/>
+              </a:spcAft>
+              <a:defRPr sz="1300" b="1">
+                <a:solidFill>
+                  <a:srgbClr val="FF5722"/>
+                </a:solidFill>
+              </a:defRPr>
+            </a:pPr>
+            <a:r>
+              <a:t>⚽ Viernes a Domingo</a:t>
+            </a:r>
+          </a:p>
+          <a:p>
+            <a:pPr>
+              <a:spcAft>
+                <a:spcPts val="800"/>
+              </a:spcAft>
+              <a:defRPr sz="1100">
                 <a:solidFill>
                   <a:srgbClr val="FFFFFF"/>
                 </a:solidFill>
               </a:defRPr>
             </a:pPr>
             <a:r>
-              <a:t>Los ganadores reciben premios del bar (cervezas, alitas, descuentos en su próxima visita). El premio incentiva la permanencia y el retorno.</a:t>
-            </a:r>
-          </a:p>
-          <a:p>
-            <a:pPr>
-              <a:spcAft>
-                <a:spcPts val="200"/>
-              </a:spcAft>
-              <a:defRPr sz="1500" b="1">
-                <a:solidFill>
-                  <a:srgbClr val="FFB612"/>
-                </a:solidFill>
-              </a:defRPr>
-            </a:pPr>
-            <a:r>
-              <a:t>👨‍🍳 Conexión con el Personal (Meseros)</a:t>
-            </a:r>
-          </a:p>
-          <a:p>
-            <a:pPr>
-              <a:spcAft>
-                <a:spcPts val="1200"/>
-              </a:spcAft>
-              <a:defRPr sz="1200">
+              <a:t>Quinielas de Liga MX, First Striker y Clásicos de fútbol.</a:t>
+            </a:r>
+          </a:p>
+          <a:p>
+            <a:pPr>
+              <a:spcAft>
+                <a:spcPts val="100"/>
+              </a:spcAft>
+              <a:defRPr sz="1300" b="1">
+                <a:solidFill>
+                  <a:srgbClr val="FF5722"/>
+                </a:solidFill>
+              </a:defRPr>
+            </a:pPr>
+            <a:r>
+              <a:t>🧠 Medios Tiempos Selectos</a:t>
+            </a:r>
+          </a:p>
+          <a:p>
+            <a:pPr>
+              <a:spcAft>
+                <a:spcPts val="800"/>
+              </a:spcAft>
+              <a:defRPr sz="1100">
                 <a:solidFill>
                   <a:srgbClr val="FFFFFF"/>
                 </a:solidFill>
               </a:defRPr>
             </a:pPr>
             <a:r>
-              <a:t>Cada comensal asocia su participación a su mesero. Los meseros se convierten en embajadores del juego y aumentan sus propinas por mayor consumo.</a:t>
-            </a:r>
-          </a:p>
-        </p:txBody>
-      </p:sp>
-      <p:pic>
-        <p:nvPicPr>
-          <p:cNvPr id="5" name="Picture 4" descr="tarjeta_1_que_es_drinks_and_wins.png"/>
-          <p:cNvPicPr>
-            <a:picLocks noChangeAspect="1"/>
-          </p:cNvPicPr>
+              <a:t>Trivias rápidas de 10 min para reactivar consumo en la pausa.</a:t>
+            </a:r>
+          </a:p>
+        </p:txBody>
+      </p:sp>
+      <p:sp>
+        <p:nvSpPr>
+          <p:cNvPr id="5" name="Rounded Rectangle 4"/>
+          <p:cNvSpPr/>
           <p:nvPr/>
-        </p:nvPicPr>
-        <p:blipFill>
-          <a:blip r:embed="rId2"/>
-          <a:stretch>
-            <a:fillRect/>
-          </a:stretch>
-        </p:blipFill>
-        <p:spPr>
-          <a:xfrm>
-            <a:off x="7680960" y="1737360"/>
-            <a:ext cx="2520315" cy="4480560"/>
+        </p:nvSpPr>
+        <p:spPr>
+          <a:xfrm>
+            <a:off x="6217920" y="1645920"/>
+            <a:ext cx="5212080" cy="4572000"/>
+          </a:xfrm>
+          <a:prstGeom prst="roundRect">
+            <a:avLst/>
+          </a:prstGeom>
+          <a:solidFill>
+            <a:srgbClr val="141A26"/>
+          </a:solidFill>
+          <a:ln w="19050">
+            <a:solidFill>
+              <a:srgbClr val="283246"/>
+            </a:solidFill>
+          </a:ln>
+        </p:spPr>
+        <p:style>
+          <a:lnRef idx="1">
+            <a:schemeClr val="accent1"/>
+          </a:lnRef>
+          <a:fillRef idx="3">
+            <a:schemeClr val="accent1"/>
+          </a:fillRef>
+          <a:effectRef idx="2">
+            <a:schemeClr val="accent1"/>
+          </a:effectRef>
+          <a:fontRef idx="minor">
+            <a:schemeClr val="lt1"/>
+          </a:fontRef>
+        </p:style>
+        <p:txBody>
+          <a:bodyPr rtlCol="0" anchor="ctr"/>
+          <a:lstStyle/>
+          <a:p>
+            <a:pPr algn="ctr"/>
+          </a:p>
+        </p:txBody>
+      </p:sp>
+      <p:sp>
+        <p:nvSpPr>
+          <p:cNvPr id="6" name="TextBox 5"/>
+          <p:cNvSpPr txBox="1"/>
+          <p:nvPr/>
+        </p:nvSpPr>
+        <p:spPr>
+          <a:xfrm>
+            <a:off x="6492240" y="1920240"/>
+            <a:ext cx="4663440" cy="4023360"/>
           </a:xfrm>
           <a:prstGeom prst="rect">
             <a:avLst/>
           </a:prstGeom>
-        </p:spPr>
-      </p:pic>
+          <a:noFill/>
+        </p:spPr>
+        <p:txBody>
+          <a:bodyPr wrap="square">
+            <a:spAutoFit/>
+          </a:bodyPr>
+          <a:lstStyle/>
+          <a:p>
+            <a:pPr>
+              <a:spcAft>
+                <a:spcPts val="1000"/>
+              </a:spcAft>
+              <a:defRPr sz="1700" b="1">
+                <a:solidFill>
+                  <a:srgbClr val="00E676"/>
+                </a:solidFill>
+              </a:defRPr>
+            </a:pPr>
+            <a:r>
+              <a:t>🛡️ Punta de Lanza: Steelers Nation QRO (71+ Fans)</a:t>
+            </a:r>
+          </a:p>
+          <a:p>
+            <a:pPr>
+              <a:spcAft>
+                <a:spcPts val="100"/>
+              </a:spcAft>
+              <a:defRPr sz="1300" b="1">
+                <a:solidFill>
+                  <a:srgbClr val="FFD100"/>
+                </a:solidFill>
+              </a:defRPr>
+            </a:pPr>
+            <a:r>
+              <a:t>💳 Audiencia Cautiva y Lista</a:t>
+            </a:r>
+          </a:p>
+          <a:p>
+            <a:pPr>
+              <a:spcAft>
+                <a:spcPts val="800"/>
+              </a:spcAft>
+              <a:defRPr sz="1100">
+                <a:solidFill>
+                  <a:srgbClr val="FFFFFF"/>
+                </a:solidFill>
+              </a:defRPr>
+            </a:pPr>
+            <a:r>
+              <a:t>En Querétaro ya contamos con más de 71 fanáticos registrados en la app oficial de Steelers Fan Club, con su credencial digital PWA activa en sus celulares.</a:t>
+            </a:r>
+          </a:p>
+          <a:p>
+            <a:pPr>
+              <a:spcAft>
+                <a:spcPts val="100"/>
+              </a:spcAft>
+              <a:defRPr sz="1300" b="1">
+                <a:solidFill>
+                  <a:srgbClr val="FFD100"/>
+                </a:solidFill>
+              </a:defRPr>
+            </a:pPr>
+            <a:r>
+              <a:t>📲 Botón Directo Integrado</a:t>
+            </a:r>
+          </a:p>
+          <a:p>
+            <a:pPr>
+              <a:spcAft>
+                <a:spcPts val="800"/>
+              </a:spcAft>
+              <a:defRPr sz="1100">
+                <a:solidFill>
+                  <a:srgbClr val="FFFFFF"/>
+                </a:solidFill>
+              </a:defRPr>
+            </a:pPr>
+            <a:r>
+              <a:t>Su credencial ya incluye el botón especial que los enlaza directamente a Drinks &amp; Wins para participar en las dinámicas de cada partido.</a:t>
+            </a:r>
+          </a:p>
+          <a:p>
+            <a:pPr>
+              <a:spcAft>
+                <a:spcPts val="100"/>
+              </a:spcAft>
+              <a:defRPr sz="1300" b="1">
+                <a:solidFill>
+                  <a:srgbClr val="FFD100"/>
+                </a:solidFill>
+              </a:defRPr>
+            </a:pPr>
+            <a:r>
+              <a:t>🍻 Asistencia Garantizada</a:t>
+            </a:r>
+          </a:p>
+          <a:p>
+            <a:pPr>
+              <a:spcAft>
+                <a:spcPts val="800"/>
+              </a:spcAft>
+              <a:defRPr sz="1100">
+                <a:solidFill>
+                  <a:srgbClr val="FFFFFF"/>
+                </a:solidFill>
+              </a:defRPr>
+            </a:pPr>
+            <a:r>
+              <a:t>Este grupo ya llena mesas, pide rondas continuas y consume activamente alitas y cerveza semana a semana. Es la base perfecta para arrancar con éxito probado.</a:t>
+            </a:r>
+          </a:p>
+        </p:txBody>
+      </p:sp>
     </p:spTree>
   </p:cSld>
   <p:clrMapOvr>
@@ -4983,7 +5059,7 @@
         </p:nvSpPr>
         <p:spPr>
           <a:xfrm>
-            <a:off x="731520" y="457200"/>
+            <a:off x="731520" y="411480"/>
             <a:ext cx="10698480" cy="1005840"/>
           </a:xfrm>
           <a:prstGeom prst="rect">
@@ -4999,28 +5075,28 @@
           <a:p>
             <a:pPr>
               <a:spcAft>
-                <a:spcPts val="400"/>
-              </a:spcAft>
-              <a:defRPr sz="1100" b="1">
+                <a:spcPts val="300"/>
+              </a:spcAft>
+              <a:defRPr sz="1050" b="1">
                 <a:solidFill>
                   <a:srgbClr val="FFB612"/>
                 </a:solidFill>
               </a:defRPr>
             </a:pPr>
             <a:r>
-              <a:t>DRINKS &amp; WINS • PLATAFORMA DE GAMIFICACIÓN</a:t>
-            </a:r>
-          </a:p>
-          <a:p>
-            <a:pPr>
-              <a:defRPr sz="2600" b="1">
+              <a:t>EFICIENCIA OPERATIVA</a:t>
+            </a:r>
+          </a:p>
+          <a:p>
+            <a:pPr>
+              <a:defRPr sz="2400" b="1">
                 <a:solidFill>
                   <a:srgbClr val="FFFFFF"/>
                 </a:solidFill>
               </a:defRPr>
             </a:pPr>
             <a:r>
-              <a:t>6 Juegos Diseñados para Cada Deporte y Momento</a:t>
+              <a:t>Inteligencia Artificial y Automatización: Cero Carga para el Gerente</a:t>
             </a:r>
           </a:p>
         </p:txBody>
@@ -5033,18 +5109,18 @@
         </p:nvSpPr>
         <p:spPr>
           <a:xfrm>
-            <a:off x="731520" y="1737360"/>
-            <a:ext cx="3413455" cy="2011680"/>
+            <a:off x="731520" y="1645920"/>
+            <a:ext cx="3413455" cy="4572000"/>
           </a:xfrm>
           <a:prstGeom prst="roundRect">
             <a:avLst/>
           </a:prstGeom>
           <a:solidFill>
-            <a:srgbClr val="161C2A"/>
+            <a:srgbClr val="141A26"/>
           </a:solidFill>
           <a:ln w="19050">
             <a:solidFill>
-              <a:srgbClr val="2D374B"/>
+              <a:srgbClr val="283246"/>
             </a:solidFill>
           </a:ln>
         </p:spPr>
@@ -5070,40 +5146,16 @@
           </a:p>
         </p:txBody>
       </p:sp>
-      <p:pic>
-        <p:nvPicPr>
-          <p:cNvPr id="4" name="Picture 3" descr="badge_quiniela.png"/>
-          <p:cNvPicPr>
-            <a:picLocks noChangeAspect="1"/>
-          </p:cNvPicPr>
-          <p:nvPr/>
-        </p:nvPicPr>
-        <p:blipFill>
-          <a:blip r:embed="rId2"/>
-          <a:stretch>
-            <a:fillRect/>
-          </a:stretch>
-        </p:blipFill>
-        <p:spPr>
-          <a:xfrm>
-            <a:off x="914400" y="2011680"/>
-            <a:ext cx="727492" cy="548640"/>
-          </a:xfrm>
-          <a:prstGeom prst="rect">
-            <a:avLst/>
-          </a:prstGeom>
-        </p:spPr>
-      </p:pic>
-      <p:sp>
-        <p:nvSpPr>
-          <p:cNvPr id="5" name="TextBox 4"/>
+      <p:sp>
+        <p:nvSpPr>
+          <p:cNvPr id="4" name="TextBox 3"/>
           <p:cNvSpPr txBox="1"/>
           <p:nvPr/>
         </p:nvSpPr>
         <p:spPr>
           <a:xfrm>
-            <a:off x="1554480" y="1965960"/>
-            <a:ext cx="2377440" cy="1554480"/>
+            <a:off x="1005840" y="1920240"/>
+            <a:ext cx="2864815" cy="4023360"/>
           </a:xfrm>
           <a:prstGeom prst="rect">
             <a:avLst/>
@@ -5117,65 +5169,57 @@
           <a:lstStyle/>
           <a:p>
             <a:pPr>
-              <a:defRPr sz="1400" b="1">
+              <a:spcAft>
+                <a:spcPts val="1400"/>
+              </a:spcAft>
+              <a:defRPr sz="1650" b="1">
                 <a:solidFill>
                   <a:srgbClr val="FFB612"/>
                 </a:solidFill>
               </a:defRPr>
             </a:pPr>
             <a:r>
-              <a:t>🏈 Quinielas Pick'em</a:t>
-            </a:r>
-          </a:p>
-          <a:p>
-            <a:pPr>
-              <a:spcAft>
-                <a:spcPts val="400"/>
-              </a:spcAft>
-              <a:defRPr sz="950" b="1">
-                <a:solidFill>
-                  <a:srgbClr val="FF5722"/>
-                </a:solidFill>
-              </a:defRPr>
-            </a:pPr>
-            <a:r>
-              <a:t>NFL &amp; LIGA MX</a:t>
-            </a:r>
-          </a:p>
-          <a:p>
-            <a:pPr>
-              <a:defRPr sz="1100">
-                <a:solidFill>
-                  <a:srgbClr val="94A3B8"/>
-                </a:solidFill>
-              </a:defRPr>
-            </a:pPr>
-            <a:r>
-              <a:t>Pronósticos de ganadores y marcadores exactos con ranking en vivo.</a:t>
-            </a:r>
-          </a:p>
-        </p:txBody>
-      </p:sp>
-      <p:sp>
-        <p:nvSpPr>
-          <p:cNvPr id="6" name="Rounded Rectangle 5"/>
+              <a:t>⚡ Creación de Jornadas en Segundos</a:t>
+            </a:r>
+          </a:p>
+          <a:p>
+            <a:pPr>
+              <a:defRPr sz="1300">
+                <a:solidFill>
+                  <a:srgbClr val="FFFFFF"/>
+                </a:solidFill>
+              </a:defRPr>
+            </a:pPr>
+            <a:r>
+              <a:t>Antes: Un gerente tardaba hasta 2 horas buscando partidos en internet, armando tablas en Excel e imprimiendo hojas.</a:t>
+            </a:r>
+            <a:br/>
+            <a:r>
+              <a:t>Hoy: Conexión directa a ESPN y algoritmos que importan partidos oficiales, horarios y escudos con un solo clic.</a:t>
+            </a:r>
+          </a:p>
+        </p:txBody>
+      </p:sp>
+      <p:sp>
+        <p:nvSpPr>
+          <p:cNvPr id="5" name="Rounded Rectangle 4"/>
           <p:cNvSpPr/>
           <p:nvPr/>
         </p:nvSpPr>
         <p:spPr>
           <a:xfrm>
-            <a:off x="4389120" y="1737360"/>
-            <a:ext cx="3413455" cy="2011680"/>
+            <a:off x="4389120" y="1645920"/>
+            <a:ext cx="3413455" cy="4572000"/>
           </a:xfrm>
           <a:prstGeom prst="roundRect">
             <a:avLst/>
           </a:prstGeom>
           <a:solidFill>
-            <a:srgbClr val="161C2A"/>
+            <a:srgbClr val="141A26"/>
           </a:solidFill>
           <a:ln w="19050">
             <a:solidFill>
-              <a:srgbClr val="2D374B"/>
+              <a:srgbClr val="283246"/>
             </a:solidFill>
           </a:ln>
         </p:spPr>
@@ -5201,40 +5245,16 @@
           </a:p>
         </p:txBody>
       </p:sp>
-      <p:pic>
-        <p:nvPicPr>
-          <p:cNvPr id="7" name="Picture 6" descr="badge_grids.png"/>
-          <p:cNvPicPr>
-            <a:picLocks noChangeAspect="1"/>
-          </p:cNvPicPr>
-          <p:nvPr/>
-        </p:nvPicPr>
-        <p:blipFill>
-          <a:blip r:embed="rId3"/>
-          <a:stretch>
-            <a:fillRect/>
-          </a:stretch>
-        </p:blipFill>
-        <p:spPr>
-          <a:xfrm>
-            <a:off x="4572000" y="2011680"/>
-            <a:ext cx="667265" cy="548640"/>
-          </a:xfrm>
-          <a:prstGeom prst="rect">
-            <a:avLst/>
-          </a:prstGeom>
-        </p:spPr>
-      </p:pic>
-      <p:sp>
-        <p:nvSpPr>
-          <p:cNvPr id="8" name="TextBox 7"/>
+      <p:sp>
+        <p:nvSpPr>
+          <p:cNvPr id="6" name="TextBox 5"/>
           <p:cNvSpPr txBox="1"/>
           <p:nvPr/>
         </p:nvSpPr>
         <p:spPr>
           <a:xfrm>
-            <a:off x="5212080" y="1965960"/>
-            <a:ext cx="2377440" cy="1554480"/>
+            <a:off x="4663440" y="1920240"/>
+            <a:ext cx="2864815" cy="4023360"/>
           </a:xfrm>
           <a:prstGeom prst="rect">
             <a:avLst/>
@@ -5248,65 +5268,53 @@
           <a:lstStyle/>
           <a:p>
             <a:pPr>
-              <a:defRPr sz="1400" b="1">
-                <a:solidFill>
-                  <a:srgbClr val="FFB612"/>
-                </a:solidFill>
-              </a:defRPr>
-            </a:pPr>
-            <a:r>
-              <a:t>🏁 Football Grids</a:t>
-            </a:r>
-          </a:p>
-          <a:p>
-            <a:pPr>
-              <a:spcAft>
-                <a:spcPts val="400"/>
-              </a:spcAft>
-              <a:defRPr sz="950" b="1">
+              <a:spcAft>
+                <a:spcPts val="1400"/>
+              </a:spcAft>
+              <a:defRPr sz="1650" b="1">
                 <a:solidFill>
                   <a:srgbClr val="FF5722"/>
                 </a:solidFill>
               </a:defRPr>
             </a:pPr>
             <a:r>
-              <a:t>NFL ESPECIAL</a:t>
-            </a:r>
-          </a:p>
-          <a:p>
-            <a:pPr>
-              <a:defRPr sz="1100">
-                <a:solidFill>
-                  <a:srgbClr val="94A3B8"/>
-                </a:solidFill>
-              </a:defRPr>
-            </a:pPr>
-            <a:r>
-              <a:t>Cuadrícula digital de 100 casillas con ganadores por cada cuarto.</a:t>
-            </a:r>
-          </a:p>
-        </p:txBody>
-      </p:sp>
-      <p:sp>
-        <p:nvSpPr>
-          <p:cNvPr id="9" name="Rounded Rectangle 8"/>
+              <a:t>🧠 Generación de Trivias Deportivas con IA</a:t>
+            </a:r>
+          </a:p>
+          <a:p>
+            <a:pPr>
+              <a:defRPr sz="1300">
+                <a:solidFill>
+                  <a:srgbClr val="FFFFFF"/>
+                </a:solidFill>
+              </a:defRPr>
+            </a:pPr>
+            <a:r>
+              <a:t>La Inteligencia Artificial genera sets completos de preguntas deportivas temáticas (NFL, Liga MX, datos curiosos de Steelers) adaptadas al partido del día en menos de 10 segundos, listas para proyectar en TV.</a:t>
+            </a:r>
+          </a:p>
+        </p:txBody>
+      </p:sp>
+      <p:sp>
+        <p:nvSpPr>
+          <p:cNvPr id="7" name="Rounded Rectangle 6"/>
           <p:cNvSpPr/>
           <p:nvPr/>
         </p:nvSpPr>
         <p:spPr>
           <a:xfrm>
-            <a:off x="8046720" y="1737360"/>
-            <a:ext cx="3413455" cy="2011680"/>
+            <a:off x="8046720" y="1645920"/>
+            <a:ext cx="3413455" cy="4572000"/>
           </a:xfrm>
           <a:prstGeom prst="roundRect">
             <a:avLst/>
           </a:prstGeom>
           <a:solidFill>
-            <a:srgbClr val="161C2A"/>
+            <a:srgbClr val="141A26"/>
           </a:solidFill>
           <a:ln w="19050">
             <a:solidFill>
-              <a:srgbClr val="2D374B"/>
+              <a:srgbClr val="283246"/>
             </a:solidFill>
           </a:ln>
         </p:spPr>
@@ -5332,40 +5340,16 @@
           </a:p>
         </p:txBody>
       </p:sp>
-      <p:pic>
-        <p:nvPicPr>
-          <p:cNvPr id="10" name="Picture 9" descr="badge_survivor.png"/>
-          <p:cNvPicPr>
-            <a:picLocks noChangeAspect="1"/>
-          </p:cNvPicPr>
-          <p:nvPr/>
-        </p:nvPicPr>
-        <p:blipFill>
-          <a:blip r:embed="rId4"/>
-          <a:stretch>
-            <a:fillRect/>
-          </a:stretch>
-        </p:blipFill>
-        <p:spPr>
-          <a:xfrm>
-            <a:off x="8229600" y="2011680"/>
-            <a:ext cx="753301" cy="548640"/>
-          </a:xfrm>
-          <a:prstGeom prst="rect">
-            <a:avLst/>
-          </a:prstGeom>
-        </p:spPr>
-      </p:pic>
-      <p:sp>
-        <p:nvSpPr>
-          <p:cNvPr id="11" name="TextBox 10"/>
+      <p:sp>
+        <p:nvSpPr>
+          <p:cNvPr id="8" name="TextBox 7"/>
           <p:cNvSpPr txBox="1"/>
           <p:nvPr/>
         </p:nvSpPr>
         <p:spPr>
           <a:xfrm>
-            <a:off x="8869680" y="1965960"/>
-            <a:ext cx="2377440" cy="1554480"/>
+            <a:off x="8321040" y="1920240"/>
+            <a:ext cx="2864815" cy="4023360"/>
           </a:xfrm>
           <a:prstGeom prst="rect">
             <a:avLst/>
@@ -5379,434 +5363,29 @@
           <a:lstStyle/>
           <a:p>
             <a:pPr>
-              <a:defRPr sz="1400" b="1">
-                <a:solidFill>
-                  <a:srgbClr val="FFB612"/>
-                </a:solidFill>
-              </a:defRPr>
-            </a:pPr>
-            <a:r>
-              <a:t>🛡️ Survivor NFL</a:t>
-            </a:r>
-          </a:p>
-          <a:p>
-            <a:pPr>
-              <a:spcAft>
-                <a:spcPts val="400"/>
-              </a:spcAft>
-              <a:defRPr sz="950" b="1">
-                <a:solidFill>
-                  <a:srgbClr val="FF5722"/>
-                </a:solidFill>
-              </a:defRPr>
-            </a:pPr>
-            <a:r>
-              <a:t>SEMANA A SEMANA</a:t>
-            </a:r>
-          </a:p>
-          <a:p>
-            <a:pPr>
-              <a:defRPr sz="1100">
-                <a:solidFill>
-                  <a:srgbClr val="94A3B8"/>
-                </a:solidFill>
-              </a:defRPr>
-            </a:pPr>
-            <a:r>
-              <a:t>Elige 1 equipo ganador por semana sin repetir. El último en pie gana.</a:t>
-            </a:r>
-          </a:p>
-        </p:txBody>
-      </p:sp>
-      <p:sp>
-        <p:nvSpPr>
-          <p:cNvPr id="12" name="Rounded Rectangle 11"/>
-          <p:cNvSpPr/>
-          <p:nvPr/>
-        </p:nvSpPr>
-        <p:spPr>
-          <a:xfrm>
-            <a:off x="731520" y="4023360"/>
-            <a:ext cx="3413455" cy="2011680"/>
-          </a:xfrm>
-          <a:prstGeom prst="roundRect">
-            <a:avLst/>
-          </a:prstGeom>
-          <a:solidFill>
-            <a:srgbClr val="161C2A"/>
-          </a:solidFill>
-          <a:ln w="19050">
-            <a:solidFill>
-              <a:srgbClr val="2D374B"/>
-            </a:solidFill>
-          </a:ln>
-        </p:spPr>
-        <p:style>
-          <a:lnRef idx="1">
-            <a:schemeClr val="accent1"/>
-          </a:lnRef>
-          <a:fillRef idx="3">
-            <a:schemeClr val="accent1"/>
-          </a:fillRef>
-          <a:effectRef idx="2">
-            <a:schemeClr val="accent1"/>
-          </a:effectRef>
-          <a:fontRef idx="minor">
-            <a:schemeClr val="lt1"/>
-          </a:fontRef>
-        </p:style>
-        <p:txBody>
-          <a:bodyPr rtlCol="0" anchor="ctr"/>
-          <a:lstStyle/>
-          <a:p>
-            <a:pPr algn="ctr"/>
-          </a:p>
-        </p:txBody>
-      </p:sp>
-      <p:pic>
-        <p:nvPicPr>
-          <p:cNvPr id="13" name="Picture 12" descr="badge_firststriker.png"/>
-          <p:cNvPicPr>
-            <a:picLocks noChangeAspect="1"/>
-          </p:cNvPicPr>
-          <p:nvPr/>
-        </p:nvPicPr>
-        <p:blipFill>
-          <a:blip r:embed="rId5"/>
-          <a:stretch>
-            <a:fillRect/>
-          </a:stretch>
-        </p:blipFill>
-        <p:spPr>
-          <a:xfrm>
-            <a:off x="914400" y="4297680"/>
-            <a:ext cx="656662" cy="548640"/>
-          </a:xfrm>
-          <a:prstGeom prst="rect">
-            <a:avLst/>
-          </a:prstGeom>
-        </p:spPr>
-      </p:pic>
-      <p:sp>
-        <p:nvSpPr>
-          <p:cNvPr id="14" name="TextBox 13"/>
-          <p:cNvSpPr txBox="1"/>
-          <p:nvPr/>
-        </p:nvSpPr>
-        <p:spPr>
-          <a:xfrm>
-            <a:off x="1554480" y="4251960"/>
-            <a:ext cx="2377440" cy="1554480"/>
-          </a:xfrm>
-          <a:prstGeom prst="rect">
-            <a:avLst/>
-          </a:prstGeom>
-          <a:noFill/>
-        </p:spPr>
-        <p:txBody>
-          <a:bodyPr wrap="square">
-            <a:spAutoFit/>
-          </a:bodyPr>
-          <a:lstStyle/>
-          <a:p>
-            <a:pPr>
-              <a:defRPr sz="1400" b="1">
-                <a:solidFill>
-                  <a:srgbClr val="FFB612"/>
-                </a:solidFill>
-              </a:defRPr>
-            </a:pPr>
-            <a:r>
-              <a:t>⚽ First Striker</a:t>
-            </a:r>
-          </a:p>
-          <a:p>
-            <a:pPr>
-              <a:spcAft>
-                <a:spcPts val="400"/>
-              </a:spcAft>
-              <a:defRPr sz="950" b="1">
-                <a:solidFill>
-                  <a:srgbClr val="FF5722"/>
-                </a:solidFill>
-              </a:defRPr>
-            </a:pPr>
-            <a:r>
-              <a:t>FÚTBOL EN VIVO</a:t>
-            </a:r>
-          </a:p>
-          <a:p>
-            <a:pPr>
-              <a:defRPr sz="1100">
-                <a:solidFill>
-                  <a:srgbClr val="94A3B8"/>
-                </a:solidFill>
-              </a:defRPr>
-            </a:pPr>
-            <a:r>
-              <a:t>Predice qué equipo y en qué bloque de 15 min caerá el primer gol.</a:t>
-            </a:r>
-          </a:p>
-        </p:txBody>
-      </p:sp>
-      <p:sp>
-        <p:nvSpPr>
-          <p:cNvPr id="15" name="Rounded Rectangle 14"/>
-          <p:cNvSpPr/>
-          <p:nvPr/>
-        </p:nvSpPr>
-        <p:spPr>
-          <a:xfrm>
-            <a:off x="4389120" y="4023360"/>
-            <a:ext cx="3413455" cy="2011680"/>
-          </a:xfrm>
-          <a:prstGeom prst="roundRect">
-            <a:avLst/>
-          </a:prstGeom>
-          <a:solidFill>
-            <a:srgbClr val="161C2A"/>
-          </a:solidFill>
-          <a:ln w="19050">
-            <a:solidFill>
-              <a:srgbClr val="2D374B"/>
-            </a:solidFill>
-          </a:ln>
-        </p:spPr>
-        <p:style>
-          <a:lnRef idx="1">
-            <a:schemeClr val="accent1"/>
-          </a:lnRef>
-          <a:fillRef idx="3">
-            <a:schemeClr val="accent1"/>
-          </a:fillRef>
-          <a:effectRef idx="2">
-            <a:schemeClr val="accent1"/>
-          </a:effectRef>
-          <a:fontRef idx="minor">
-            <a:schemeClr val="lt1"/>
-          </a:fontRef>
-        </p:style>
-        <p:txBody>
-          <a:bodyPr rtlCol="0" anchor="ctr"/>
-          <a:lstStyle/>
-          <a:p>
-            <a:pPr algn="ctr"/>
-          </a:p>
-        </p:txBody>
-      </p:sp>
-      <p:pic>
-        <p:nvPicPr>
-          <p:cNvPr id="16" name="Picture 15" descr="badge_trivia.png"/>
-          <p:cNvPicPr>
-            <a:picLocks noChangeAspect="1"/>
-          </p:cNvPicPr>
-          <p:nvPr/>
-        </p:nvPicPr>
-        <p:blipFill>
-          <a:blip r:embed="rId6"/>
-          <a:stretch>
-            <a:fillRect/>
-          </a:stretch>
-        </p:blipFill>
-        <p:spPr>
-          <a:xfrm>
-            <a:off x="4572000" y="4297680"/>
-            <a:ext cx="697667" cy="548640"/>
-          </a:xfrm>
-          <a:prstGeom prst="rect">
-            <a:avLst/>
-          </a:prstGeom>
-        </p:spPr>
-      </p:pic>
-      <p:sp>
-        <p:nvSpPr>
-          <p:cNvPr id="17" name="TextBox 16"/>
-          <p:cNvSpPr txBox="1"/>
-          <p:nvPr/>
-        </p:nvSpPr>
-        <p:spPr>
-          <a:xfrm>
-            <a:off x="5212080" y="4251960"/>
-            <a:ext cx="2377440" cy="1554480"/>
-          </a:xfrm>
-          <a:prstGeom prst="rect">
-            <a:avLst/>
-          </a:prstGeom>
-          <a:noFill/>
-        </p:spPr>
-        <p:txBody>
-          <a:bodyPr wrap="square">
-            <a:spAutoFit/>
-          </a:bodyPr>
-          <a:lstStyle/>
-          <a:p>
-            <a:pPr>
-              <a:defRPr sz="1400" b="1">
-                <a:solidFill>
-                  <a:srgbClr val="FFB612"/>
-                </a:solidFill>
-              </a:defRPr>
-            </a:pPr>
-            <a:r>
-              <a:t>🧠 Trivia en Vivo</a:t>
-            </a:r>
-          </a:p>
-          <a:p>
-            <a:pPr>
-              <a:spcAft>
-                <a:spcPts val="400"/>
-              </a:spcAft>
-              <a:defRPr sz="950" b="1">
-                <a:solidFill>
-                  <a:srgbClr val="FF5722"/>
-                </a:solidFill>
-              </a:defRPr>
-            </a:pPr>
-            <a:r>
-              <a:t>INTERACTIVO EN TV</a:t>
-            </a:r>
-          </a:p>
-          <a:p>
-            <a:pPr>
-              <a:defRPr sz="1100">
-                <a:solidFill>
-                  <a:srgbClr val="94A3B8"/>
-                </a:solidFill>
-              </a:defRPr>
-            </a:pPr>
-            <a:r>
-              <a:t>Preguntas deportivas compitiendo en tiempo real contra otras mesas.</a:t>
-            </a:r>
-          </a:p>
-        </p:txBody>
-      </p:sp>
-      <p:sp>
-        <p:nvSpPr>
-          <p:cNvPr id="18" name="Rounded Rectangle 17"/>
-          <p:cNvSpPr/>
-          <p:nvPr/>
-        </p:nvSpPr>
-        <p:spPr>
-          <a:xfrm>
-            <a:off x="8046720" y="4023360"/>
-            <a:ext cx="3413455" cy="2011680"/>
-          </a:xfrm>
-          <a:prstGeom prst="roundRect">
-            <a:avLst/>
-          </a:prstGeom>
-          <a:solidFill>
-            <a:srgbClr val="161C2A"/>
-          </a:solidFill>
-          <a:ln w="19050">
-            <a:solidFill>
-              <a:srgbClr val="2D374B"/>
-            </a:solidFill>
-          </a:ln>
-        </p:spPr>
-        <p:style>
-          <a:lnRef idx="1">
-            <a:schemeClr val="accent1"/>
-          </a:lnRef>
-          <a:fillRef idx="3">
-            <a:schemeClr val="accent1"/>
-          </a:fillRef>
-          <a:effectRef idx="2">
-            <a:schemeClr val="accent1"/>
-          </a:effectRef>
-          <a:fontRef idx="minor">
-            <a:schemeClr val="lt1"/>
-          </a:fontRef>
-        </p:style>
-        <p:txBody>
-          <a:bodyPr rtlCol="0" anchor="ctr"/>
-          <a:lstStyle/>
-          <a:p>
-            <a:pPr algn="ctr"/>
-          </a:p>
-        </p:txBody>
-      </p:sp>
-      <p:pic>
-        <p:nvPicPr>
-          <p:cNvPr id="19" name="Picture 18" descr="badge_bingo.png"/>
-          <p:cNvPicPr>
-            <a:picLocks noChangeAspect="1"/>
-          </p:cNvPicPr>
-          <p:nvPr/>
-        </p:nvPicPr>
-        <p:blipFill>
-          <a:blip r:embed="rId7"/>
-          <a:stretch>
-            <a:fillRect/>
-          </a:stretch>
-        </p:blipFill>
-        <p:spPr>
-          <a:xfrm>
-            <a:off x="8229600" y="4297680"/>
-            <a:ext cx="701426" cy="548640"/>
-          </a:xfrm>
-          <a:prstGeom prst="rect">
-            <a:avLst/>
-          </a:prstGeom>
-        </p:spPr>
-      </p:pic>
-      <p:sp>
-        <p:nvSpPr>
-          <p:cNvPr id="20" name="TextBox 19"/>
-          <p:cNvSpPr txBox="1"/>
-          <p:nvPr/>
-        </p:nvSpPr>
-        <p:spPr>
-          <a:xfrm>
-            <a:off x="8869680" y="4251960"/>
-            <a:ext cx="2377440" cy="1554480"/>
-          </a:xfrm>
-          <a:prstGeom prst="rect">
-            <a:avLst/>
-          </a:prstGeom>
-          <a:noFill/>
-        </p:spPr>
-        <p:txBody>
-          <a:bodyPr wrap="square">
-            <a:spAutoFit/>
-          </a:bodyPr>
-          <a:lstStyle/>
-          <a:p>
-            <a:pPr>
-              <a:defRPr sz="1400" b="1">
-                <a:solidFill>
-                  <a:srgbClr val="FFB612"/>
-                </a:solidFill>
-              </a:defRPr>
-            </a:pPr>
-            <a:r>
-              <a:t>🎯 Bar Bingo</a:t>
-            </a:r>
-          </a:p>
-          <a:p>
-            <a:pPr>
-              <a:spcAft>
-                <a:spcPts val="400"/>
-              </a:spcAft>
-              <a:defRPr sz="950" b="1">
-                <a:solidFill>
-                  <a:srgbClr val="FF5722"/>
-                </a:solidFill>
-              </a:defRPr>
-            </a:pPr>
-            <a:r>
-              <a:t>TODO EL PARTIDO</a:t>
-            </a:r>
-          </a:p>
-          <a:p>
-            <a:pPr>
-              <a:defRPr sz="1100">
-                <a:solidFill>
-                  <a:srgbClr val="94A3B8"/>
-                </a:solidFill>
-              </a:defRPr>
-            </a:pPr>
-            <a:r>
-              <a:t>Cartones con eventos del juego (Touchdown, Gol de Campo, etc.).</a:t>
+              <a:spcAft>
+                <a:spcPts val="1400"/>
+              </a:spcAft>
+              <a:defRPr sz="1650" b="1">
+                <a:solidFill>
+                  <a:srgbClr val="00E676"/>
+                </a:solidFill>
+              </a:defRPr>
+            </a:pPr>
+            <a:r>
+              <a:t>📊 Marcadores Exactos y Calificación en Tiempo Real</a:t>
+            </a:r>
+          </a:p>
+          <a:p>
+            <a:pPr>
+              <a:defRPr sz="1300">
+                <a:solidFill>
+                  <a:srgbClr val="FFFFFF"/>
+                </a:solidFill>
+              </a:defRPr>
+            </a:pPr>
+            <a:r>
+              <a:t>La plataforma detecta marcadores finales en vivo vía API de ESPN, calcula aciertos exactos (+3) o ganadores (+1), genera la tabla y proclama al campeón de forma 100% automática sin errores humanos.</a:t>
             </a:r>
           </a:p>
         </p:txBody>
@@ -5845,7 +5424,7 @@
         </p:nvSpPr>
         <p:spPr>
           <a:xfrm>
-            <a:off x="731520" y="457200"/>
+            <a:off x="731520" y="411480"/>
             <a:ext cx="10698480" cy="1005840"/>
           </a:xfrm>
           <a:prstGeom prst="rect">
@@ -5861,28 +5440,28 @@
           <a:p>
             <a:pPr>
               <a:spcAft>
-                <a:spcPts val="400"/>
-              </a:spcAft>
-              <a:defRPr sz="1100" b="1">
+                <a:spcPts val="300"/>
+              </a:spcAft>
+              <a:defRPr sz="1050" b="1">
                 <a:solidFill>
                   <a:srgbClr val="FFB612"/>
                 </a:solidFill>
               </a:defRPr>
             </a:pPr>
             <a:r>
-              <a:t>DRINKS &amp; WINS • PLATAFORMA DE GAMIFICACIÓN</a:t>
-            </a:r>
-          </a:p>
-          <a:p>
-            <a:pPr>
-              <a:defRPr sz="2600" b="1">
+              <a:t>DETALLE PASO A PASO POR JUEGO</a:t>
+            </a:r>
+          </a:p>
+          <a:p>
+            <a:pPr>
+              <a:defRPr sz="2400" b="1">
                 <a:solidFill>
                   <a:srgbClr val="FFFFFF"/>
                 </a:solidFill>
               </a:defRPr>
             </a:pPr>
             <a:r>
-              <a:t>Quinielas Pick'em: El Motor de Competencia en Vivo</a:t>
+              <a:t>Juego 1: Quinielas Pick'em (NFL y Liga MX)</a:t>
             </a:r>
           </a:p>
         </p:txBody>
@@ -5895,18 +5474,18 @@
         </p:nvSpPr>
         <p:spPr>
           <a:xfrm>
-            <a:off x="731520" y="1737360"/>
-            <a:ext cx="6858000" cy="4480560"/>
+            <a:off x="731520" y="1645920"/>
+            <a:ext cx="6858000" cy="4572000"/>
           </a:xfrm>
           <a:prstGeom prst="roundRect">
             <a:avLst/>
           </a:prstGeom>
           <a:solidFill>
-            <a:srgbClr val="161C2A"/>
+            <a:srgbClr val="141A26"/>
           </a:solidFill>
           <a:ln w="19050">
             <a:solidFill>
-              <a:srgbClr val="2D374B"/>
+              <a:srgbClr val="283246"/>
             </a:solidFill>
           </a:ln>
         </p:spPr>
@@ -5940,8 +5519,8 @@
         </p:nvSpPr>
         <p:spPr>
           <a:xfrm>
-            <a:off x="1097280" y="2011680"/>
-            <a:ext cx="6126480" cy="3931920"/>
+            <a:off x="1005840" y="1828800"/>
+            <a:ext cx="6309360" cy="4114800"/>
           </a:xfrm>
           <a:prstGeom prst="rect">
             <a:avLst/>
@@ -5956,99 +5535,91 @@
           <a:p>
             <a:pPr>
               <a:spcAft>
-                <a:spcPts val="300"/>
-              </a:spcAft>
-              <a:defRPr sz="1500" b="1">
+                <a:spcPts val="200"/>
+              </a:spcAft>
+              <a:defRPr sz="1400" b="1">
                 <a:solidFill>
                   <a:srgbClr val="FFB612"/>
                 </a:solidFill>
               </a:defRPr>
             </a:pPr>
             <a:r>
-              <a:t>🎯 Sistema de Puntos Transparente</a:t>
-            </a:r>
-          </a:p>
-          <a:p>
-            <a:pPr>
-              <a:spcAft>
-                <a:spcPts val="1400"/>
-              </a:spcAft>
-              <a:defRPr sz="1200">
+              <a:t>🛠️ 1. CÓMO LO CREA EL GERENTE (60 seg)</a:t>
+            </a:r>
+          </a:p>
+          <a:p>
+            <a:pPr>
+              <a:spcAft>
+                <a:spcPts val="1000"/>
+              </a:spcAft>
+              <a:defRPr sz="1150">
                 <a:solidFill>
                   <a:srgbClr val="FFFFFF"/>
                 </a:solidFill>
               </a:defRPr>
             </a:pPr>
             <a:r>
-              <a:t>• Marcador Exacto: +3 Puntos (Ej: Pronosticó 2-1 y el juego terminó 2-1).</a:t>
-            </a:r>
-            <a:br/>
-            <a:r>
-              <a:t>• Ganador / Empate Acertado: +1 Punto (Atinó quién ganó aunque falló el marcador).</a:t>
-            </a:r>
-            <a:br/>
-            <a:r>
-              <a:t>• Fallo: 0 Puntos.</a:t>
-            </a:r>
-          </a:p>
-          <a:p>
-            <a:pPr>
-              <a:spcAft>
-                <a:spcPts val="300"/>
-              </a:spcAft>
-              <a:defRPr sz="1500" b="1">
+              <a:t>Entra al panel Admin, selecciona la liga (NFL, Liga MX o fútbol europeo). El sistema jala los partidos oficiales con escudos de ESPN. Toca los partidos a incluir, asigna el premio (ej. Orden de Alitas + Cerveza) y da clic en 'Crear Quiniela'.</a:t>
+            </a:r>
+          </a:p>
+          <a:p>
+            <a:pPr>
+              <a:spcAft>
+                <a:spcPts val="200"/>
+              </a:spcAft>
+              <a:defRPr sz="1400" b="1">
                 <a:solidFill>
                   <a:srgbClr val="FFB612"/>
                 </a:solidFill>
               </a:defRPr>
             </a:pPr>
             <a:r>
-              <a:t>⚡ Conexión Directa con ESPN (Cero Trabajo Manual)</a:t>
-            </a:r>
-          </a:p>
-          <a:p>
-            <a:pPr>
-              <a:spcAft>
-                <a:spcPts val="1400"/>
-              </a:spcAft>
-              <a:defRPr sz="1200">
+              <a:t>📱 2. CÓMO ENTRA Y JUEGA EL CLIENTE</a:t>
+            </a:r>
+          </a:p>
+          <a:p>
+            <a:pPr>
+              <a:spcAft>
+                <a:spcPts val="1000"/>
+              </a:spcAft>
+              <a:defRPr sz="1150">
                 <a:solidFill>
                   <a:srgbClr val="FFFFFF"/>
                 </a:solidFill>
               </a:defRPr>
             </a:pPr>
             <a:r>
-              <a:t>Los resultados se actualizan automáticamente vía API de ESPN. Cuando cae un touchdown o gol, la tabla recalcula puntos en vivo sin intervención del personal.</a:t>
-            </a:r>
-          </a:p>
-          <a:p>
-            <a:pPr>
-              <a:spcAft>
-                <a:spcPts val="300"/>
-              </a:spcAft>
-              <a:defRPr sz="1500" b="1">
+              <a:t>Escanea el QR de su mesa, ingresa con su nombre o Google, selecciona a su mesero y captura sus marcadores o ganadores en la pantalla interactiva antes del silbatazo inicial.</a:t>
+            </a:r>
+          </a:p>
+          <a:p>
+            <a:pPr>
+              <a:spcAft>
+                <a:spcPts val="200"/>
+              </a:spcAft>
+              <a:defRPr sz="1400" b="1">
                 <a:solidFill>
                   <a:srgbClr val="FFB612"/>
                 </a:solidFill>
               </a:defRPr>
             </a:pPr>
             <a:r>
-              <a:t>👑 Podio y Ganador Oficial Automatizado</a:t>
-            </a:r>
-          </a:p>
-          <a:p>
-            <a:pPr>
-              <a:spcAft>
-                <a:spcPts val="1400"/>
-              </a:spcAft>
-              <a:defRPr sz="1200">
+              <a:t>🏆 3. CÓMO GANA Y CANJEA</a:t>
+            </a:r>
+          </a:p>
+          <a:p>
+            <a:pPr>
+              <a:spcAft>
+                <a:spcPts val="1000"/>
+              </a:spcAft>
+              <a:defRPr sz="1150">
                 <a:solidFill>
                   <a:srgbClr val="FFFFFF"/>
                 </a:solidFill>
               </a:defRPr>
             </a:pPr>
             <a:r>
-              <a:t>Al terminar la jornada, se corona al campeón oficial con tarjeta de premiación digital y podio de 1º, 2º y 3º lugar, listo para canje en barra.</a:t>
+              <a:t>Durante el partido, los marcadores cambian en tiempo real. Marcador exacto: +3 pts (verde), Ganador: +1 pt (dorado), Error: 0 pts (rojo). Al finalizar, el comensal número 1 en el podio recibe la corona y muestra su cupón digital en barra para reclamar su premio.</a:t>
             </a:r>
           </a:p>
         </p:txBody>
@@ -6069,8 +5640,8 @@
         </p:blipFill>
         <p:spPr>
           <a:xfrm>
-            <a:off x="7863840" y="1737360"/>
-            <a:ext cx="8496469" cy="4480560"/>
+            <a:off x="7863840" y="1645920"/>
+            <a:ext cx="8669867" cy="4572000"/>
           </a:xfrm>
           <a:prstGeom prst="rect">
             <a:avLst/>
@@ -6111,7 +5682,7 @@
         </p:nvSpPr>
         <p:spPr>
           <a:xfrm>
-            <a:off x="731520" y="457200"/>
+            <a:off x="731520" y="411480"/>
             <a:ext cx="10698480" cy="1005840"/>
           </a:xfrm>
           <a:prstGeom prst="rect">
@@ -6127,28 +5698,28 @@
           <a:p>
             <a:pPr>
               <a:spcAft>
-                <a:spcPts val="400"/>
-              </a:spcAft>
-              <a:defRPr sz="1100" b="1">
+                <a:spcPts val="300"/>
+              </a:spcAft>
+              <a:defRPr sz="1050" b="1">
                 <a:solidFill>
                   <a:srgbClr val="FFB612"/>
                 </a:solidFill>
               </a:defRPr>
             </a:pPr>
             <a:r>
-              <a:t>DRINKS &amp; WINS • PLATAFORMA DE GAMIFICACIÓN</a:t>
-            </a:r>
-          </a:p>
-          <a:p>
-            <a:pPr>
-              <a:defRPr sz="2600" b="1">
+              <a:t>DETALLE PASO A PASO POR JUEGO</a:t>
+            </a:r>
+          </a:p>
+          <a:p>
+            <a:pPr>
+              <a:defRPr sz="2400" b="1">
                 <a:solidFill>
                   <a:srgbClr val="FFFFFF"/>
                 </a:solidFill>
               </a:defRPr>
             </a:pPr>
             <a:r>
-              <a:t>Juegos Especializados: NFL Grids y First Striker</a:t>
+              <a:t>Juego 2: Football Grids (100 Casillas Digitales)</a:t>
             </a:r>
           </a:p>
         </p:txBody>
@@ -6161,18 +5732,18 @@
         </p:nvSpPr>
         <p:spPr>
           <a:xfrm>
-            <a:off x="731520" y="1737360"/>
-            <a:ext cx="5212080" cy="4480560"/>
+            <a:off x="731520" y="1645920"/>
+            <a:ext cx="6858000" cy="4572000"/>
           </a:xfrm>
           <a:prstGeom prst="roundRect">
             <a:avLst/>
           </a:prstGeom>
           <a:solidFill>
-            <a:srgbClr val="161C2A"/>
+            <a:srgbClr val="141A26"/>
           </a:solidFill>
           <a:ln w="19050">
             <a:solidFill>
-              <a:srgbClr val="2D374B"/>
+              <a:srgbClr val="283246"/>
             </a:solidFill>
           </a:ln>
         </p:spPr>
@@ -6206,8 +5777,8 @@
         </p:nvSpPr>
         <p:spPr>
           <a:xfrm>
-            <a:off x="1005840" y="2011680"/>
-            <a:ext cx="4663440" cy="3931920"/>
+            <a:off x="1005840" y="1828800"/>
+            <a:ext cx="6309360" cy="4114800"/>
           </a:xfrm>
           <a:prstGeom prst="rect">
             <a:avLst/>
@@ -6222,223 +5793,119 @@
           <a:p>
             <a:pPr>
               <a:spcAft>
-                <a:spcPts val="1200"/>
-              </a:spcAft>
-              <a:defRPr sz="1800" b="1">
-                <a:solidFill>
-                  <a:srgbClr val="FFB612"/>
-                </a:solidFill>
-              </a:defRPr>
-            </a:pPr>
-            <a:r>
-              <a:t>🏁 Football Grids (100 Casillas)</a:t>
-            </a:r>
-          </a:p>
-          <a:p>
-            <a:pPr>
-              <a:spcAft>
-                <a:spcPts val="600"/>
-              </a:spcAft>
-              <a:defRPr sz="1200">
+                <a:spcPts val="200"/>
+              </a:spcAft>
+              <a:defRPr sz="1400" b="1">
+                <a:solidFill>
+                  <a:srgbClr val="FF5722"/>
+                </a:solidFill>
+              </a:defRPr>
+            </a:pPr>
+            <a:r>
+              <a:t>🛠️ 1. CÓMO LO CREA EL GERENTE (30 seg)</a:t>
+            </a:r>
+          </a:p>
+          <a:p>
+            <a:pPr>
+              <a:spcAft>
+                <a:spcPts val="1000"/>
+              </a:spcAft>
+              <a:defRPr sz="1150">
                 <a:solidFill>
                   <a:srgbClr val="FFFFFF"/>
                 </a:solidFill>
               </a:defRPr>
             </a:pPr>
             <a:r>
-              <a:t>• Cuadrícula 10x10 donde cada comensal elige sus casillas favoritas.</a:t>
-            </a:r>
-          </a:p>
-          <a:p>
-            <a:pPr>
-              <a:spcAft>
-                <a:spcPts val="600"/>
-              </a:spcAft>
-              <a:defRPr sz="1200">
+              <a:t>Selecciona el partido estelar de NFL (Sunday Night o Steelers). El sistema genera la cuadrícula digital de 10x10 (100 casillas) con los logotipos oficiales de los dos equipos rivales.</a:t>
+            </a:r>
+          </a:p>
+          <a:p>
+            <a:pPr>
+              <a:spcAft>
+                <a:spcPts val="200"/>
+              </a:spcAft>
+              <a:defRPr sz="1400" b="1">
+                <a:solidFill>
+                  <a:srgbClr val="FF5722"/>
+                </a:solidFill>
+              </a:defRPr>
+            </a:pPr>
+            <a:r>
+              <a:t>📱 2. CÓMO ENTRA Y JUEGA EL CLIENTE</a:t>
+            </a:r>
+          </a:p>
+          <a:p>
+            <a:pPr>
+              <a:spcAft>
+                <a:spcPts val="1000"/>
+              </a:spcAft>
+              <a:defRPr sz="1150">
                 <a:solidFill>
                   <a:srgbClr val="FFFFFF"/>
                 </a:solidFill>
               </a:defRPr>
             </a:pPr>
             <a:r>
-              <a:t>• Al inicio del juego, se sortean los dígitos finales de cada equipo.</a:t>
-            </a:r>
-          </a:p>
-          <a:p>
-            <a:pPr>
-              <a:spcAft>
-                <a:spcPts val="600"/>
-              </a:spcAft>
-              <a:defRPr sz="1200">
+              <a:t>Escanea el QR en mesa, ve la cuadrícula en su celular y toca las casillas vacías que desea apartar con su nombre o apodo, apoyando a su equipo con amigos.</a:t>
+            </a:r>
+          </a:p>
+          <a:p>
+            <a:pPr>
+              <a:spcAft>
+                <a:spcPts val="200"/>
+              </a:spcAft>
+              <a:defRPr sz="1400" b="1">
+                <a:solidFill>
+                  <a:srgbClr val="FF5722"/>
+                </a:solidFill>
+              </a:defRPr>
+            </a:pPr>
+            <a:r>
+              <a:t>🏆 3. CÓMO GANA Y MANTIENE EL CONSUMO</a:t>
+            </a:r>
+          </a:p>
+          <a:p>
+            <a:pPr>
+              <a:spcAft>
+                <a:spcPts val="1000"/>
+              </a:spcAft>
+              <a:defRPr sz="1150">
                 <a:solidFill>
                   <a:srgbClr val="FFFFFF"/>
                 </a:solidFill>
               </a:defRPr>
             </a:pPr>
             <a:r>
-              <a:t>• ¡4 Ganadores por partido! Se premia al final del 1er Cuarto, 2do Cuarto, 3er Cuarto y Marcador Final.</a:t>
-            </a:r>
-          </a:p>
-          <a:p>
-            <a:pPr>
-              <a:spcAft>
-                <a:spcPts val="600"/>
-              </a:spcAft>
-              <a:defRPr sz="1200">
-                <a:solidFill>
-                  <a:srgbClr val="FFFFFF"/>
-                </a:solidFill>
-              </a:defRPr>
-            </a:pPr>
-            <a:r>
-              <a:t>• Mantiene a los clientes atentos y pidiendo rondas de bebidas durante las 3 horas de transmisión.</a:t>
-            </a:r>
-          </a:p>
-        </p:txBody>
-      </p:sp>
-      <p:sp>
-        <p:nvSpPr>
-          <p:cNvPr id="5" name="Rounded Rectangle 4"/>
-          <p:cNvSpPr/>
+              <a:t>Al inicio del partido, el sistema sortea los dígitos del 0 al 9 en filas y columnas. ¡Hay 4 GANADORES por partido! (Al término del 1Q, Medio Tiempo, 3Q y Final según el último dígito del marcador). Mantiene a la mesa comiendo y bebiendo durante las 3 horas completas.</a:t>
+            </a:r>
+          </a:p>
+        </p:txBody>
+      </p:sp>
+      <p:pic>
+        <p:nvPicPr>
+          <p:cNvPr id="5" name="Picture 4" descr="tarjeta_2_vive_la_nfl.png"/>
+          <p:cNvPicPr>
+            <a:picLocks noChangeAspect="1"/>
+          </p:cNvPicPr>
           <p:nvPr/>
-        </p:nvSpPr>
-        <p:spPr>
-          <a:xfrm>
-            <a:off x="6217920" y="1737360"/>
-            <a:ext cx="5212080" cy="4480560"/>
-          </a:xfrm>
-          <a:prstGeom prst="roundRect">
-            <a:avLst/>
-          </a:prstGeom>
-          <a:solidFill>
-            <a:srgbClr val="161C2A"/>
-          </a:solidFill>
-          <a:ln w="19050">
-            <a:solidFill>
-              <a:srgbClr val="2D374B"/>
-            </a:solidFill>
-          </a:ln>
-        </p:spPr>
-        <p:style>
-          <a:lnRef idx="1">
-            <a:schemeClr val="accent1"/>
-          </a:lnRef>
-          <a:fillRef idx="3">
-            <a:schemeClr val="accent1"/>
-          </a:fillRef>
-          <a:effectRef idx="2">
-            <a:schemeClr val="accent1"/>
-          </a:effectRef>
-          <a:fontRef idx="minor">
-            <a:schemeClr val="lt1"/>
-          </a:fontRef>
-        </p:style>
-        <p:txBody>
-          <a:bodyPr rtlCol="0" anchor="ctr"/>
-          <a:lstStyle/>
-          <a:p>
-            <a:pPr algn="ctr"/>
-          </a:p>
-        </p:txBody>
-      </p:sp>
-      <p:sp>
-        <p:nvSpPr>
-          <p:cNvPr id="6" name="TextBox 5"/>
-          <p:cNvSpPr txBox="1"/>
-          <p:nvPr/>
-        </p:nvSpPr>
-        <p:spPr>
-          <a:xfrm>
-            <a:off x="6492240" y="2011680"/>
-            <a:ext cx="4663440" cy="3931920"/>
+        </p:nvPicPr>
+        <p:blipFill>
+          <a:blip r:embed="rId2"/>
+          <a:stretch>
+            <a:fillRect/>
+          </a:stretch>
+        </p:blipFill>
+        <p:spPr>
+          <a:xfrm>
+            <a:off x="7955279" y="1645920"/>
+            <a:ext cx="2571750" cy="4572000"/>
           </a:xfrm>
           <a:prstGeom prst="rect">
             <a:avLst/>
           </a:prstGeom>
-          <a:noFill/>
-        </p:spPr>
-        <p:txBody>
-          <a:bodyPr wrap="square">
-            <a:spAutoFit/>
-          </a:bodyPr>
-          <a:lstStyle/>
-          <a:p>
-            <a:pPr>
-              <a:spcAft>
-                <a:spcPts val="1200"/>
-              </a:spcAft>
-              <a:defRPr sz="1800" b="1">
-                <a:solidFill>
-                  <a:srgbClr val="FF5722"/>
-                </a:solidFill>
-              </a:defRPr>
-            </a:pPr>
-            <a:r>
-              <a:t>⚽ First Striker Wins (Primer Gol)</a:t>
-            </a:r>
-          </a:p>
-          <a:p>
-            <a:pPr>
-              <a:spcAft>
-                <a:spcPts val="600"/>
-              </a:spcAft>
-              <a:defRPr sz="1200">
-                <a:solidFill>
-                  <a:srgbClr val="FFFFFF"/>
-                </a:solidFill>
-              </a:defRPr>
-            </a:pPr>
-            <a:r>
-              <a:t>• El juego de acción rápida ideal para partidos de Liga MX y Champions League.</a:t>
-            </a:r>
-          </a:p>
-          <a:p>
-            <a:pPr>
-              <a:spcAft>
-                <a:spcPts val="600"/>
-              </a:spcAft>
-              <a:defRPr sz="1200">
-                <a:solidFill>
-                  <a:srgbClr val="FFFFFF"/>
-                </a:solidFill>
-              </a:defRPr>
-            </a:pPr>
-            <a:r>
-              <a:t>• Los comensales eligen el bloque de 15 minutos en que caerá el primer gol (1-15', 16-30', etc.) y al jugador que anotará.</a:t>
-            </a:r>
-          </a:p>
-          <a:p>
-            <a:pPr>
-              <a:spcAft>
-                <a:spcPts val="600"/>
-              </a:spcAft>
-              <a:defRPr sz="1200">
-                <a:solidFill>
-                  <a:srgbClr val="FFFFFF"/>
-                </a:solidFill>
-              </a:defRPr>
-            </a:pPr>
-            <a:r>
-              <a:t>• Genera adrenalina inmediata desde el silbatazo inicial.</a:t>
-            </a:r>
-          </a:p>
-          <a:p>
-            <a:pPr>
-              <a:spcAft>
-                <a:spcPts val="600"/>
-              </a:spcAft>
-              <a:defRPr sz="1200">
-                <a:solidFill>
-                  <a:srgbClr val="FFFFFF"/>
-                </a:solidFill>
-              </a:defRPr>
-            </a:pPr>
-            <a:r>
-              <a:t>• Fácil de explicar por los meseros y rápido de jugar mientras esperan su orden de comida.</a:t>
-            </a:r>
-          </a:p>
-        </p:txBody>
-      </p:sp>
+        </p:spPr>
+      </p:pic>
     </p:spTree>
   </p:cSld>
   <p:clrMapOvr>
@@ -6473,7 +5940,7 @@
         </p:nvSpPr>
         <p:spPr>
           <a:xfrm>
-            <a:off x="731520" y="457200"/>
+            <a:off x="731520" y="411480"/>
             <a:ext cx="10698480" cy="1005840"/>
           </a:xfrm>
           <a:prstGeom prst="rect">
@@ -6489,28 +5956,28 @@
           <a:p>
             <a:pPr>
               <a:spcAft>
-                <a:spcPts val="400"/>
-              </a:spcAft>
-              <a:defRPr sz="1100" b="1">
+                <a:spcPts val="300"/>
+              </a:spcAft>
+              <a:defRPr sz="1050" b="1">
                 <a:solidFill>
                   <a:srgbClr val="FFB612"/>
                 </a:solidFill>
               </a:defRPr>
             </a:pPr>
             <a:r>
-              <a:t>DRINKS &amp; WINS • PLATAFORMA DE GAMIFICACIÓN</a:t>
-            </a:r>
-          </a:p>
-          <a:p>
-            <a:pPr>
-              <a:defRPr sz="2600" b="1">
+              <a:t>DETALLE PASO A PASO POR JUEGO</a:t>
+            </a:r>
+          </a:p>
+          <a:p>
+            <a:pPr>
+              <a:defRPr sz="2400" b="1">
                 <a:solidFill>
                   <a:srgbClr val="FFFFFF"/>
                 </a:solidFill>
               </a:defRPr>
             </a:pPr>
             <a:r>
-              <a:t>Experiencia del Comensal en 3 Pasos Sencillos</a:t>
+              <a:t>Juego 3: First Striker Wins (El Gol del Partido)</a:t>
             </a:r>
           </a:p>
         </p:txBody>
@@ -6523,18 +5990,18 @@
         </p:nvSpPr>
         <p:spPr>
           <a:xfrm>
-            <a:off x="731520" y="1737360"/>
-            <a:ext cx="3413455" cy="4297680"/>
+            <a:off x="731520" y="1645920"/>
+            <a:ext cx="6858000" cy="4572000"/>
           </a:xfrm>
           <a:prstGeom prst="roundRect">
             <a:avLst/>
           </a:prstGeom>
           <a:solidFill>
-            <a:srgbClr val="161C2A"/>
+            <a:srgbClr val="141A26"/>
           </a:solidFill>
           <a:ln w="19050">
             <a:solidFill>
-              <a:srgbClr val="2D374B"/>
+              <a:srgbClr val="283246"/>
             </a:solidFill>
           </a:ln>
         </p:spPr>
@@ -6568,8 +6035,8 @@
         </p:nvSpPr>
         <p:spPr>
           <a:xfrm>
-            <a:off x="1005840" y="2011680"/>
-            <a:ext cx="2864815" cy="3749039"/>
+            <a:off x="1005840" y="1828800"/>
+            <a:ext cx="6309360" cy="4114800"/>
           </a:xfrm>
           <a:prstGeom prst="rect">
             <a:avLst/>
@@ -6584,222 +6051,119 @@
           <a:p>
             <a:pPr>
               <a:spcAft>
-                <a:spcPts val="1600"/>
-              </a:spcAft>
-              <a:defRPr sz="1700" b="1">
-                <a:solidFill>
-                  <a:srgbClr val="FFB612"/>
-                </a:solidFill>
-              </a:defRPr>
-            </a:pPr>
-            <a:r>
-              <a:t>1. LLEGADA Y ESCANEO</a:t>
-            </a:r>
-          </a:p>
-          <a:p>
-            <a:pPr>
-              <a:defRPr sz="1400">
+                <a:spcPts val="200"/>
+              </a:spcAft>
+              <a:defRPr sz="1400" b="1">
+                <a:solidFill>
+                  <a:srgbClr val="00E676"/>
+                </a:solidFill>
+              </a:defRPr>
+            </a:pPr>
+            <a:r>
+              <a:t>🛠️ 1. CÓMO LO CREA EL GERENTE (30 seg)</a:t>
+            </a:r>
+          </a:p>
+          <a:p>
+            <a:pPr>
+              <a:spcAft>
+                <a:spcPts val="1000"/>
+              </a:spcAft>
+              <a:defRPr sz="1150">
                 <a:solidFill>
                   <a:srgbClr val="FFFFFF"/>
                 </a:solidFill>
               </a:defRPr>
             </a:pPr>
             <a:r>
-              <a:t>📱 En su mesa encuentra un caballete o mantel con código QR. Abre su cámara, escanea e ingresa instantáneamente con su cuenta de Google o nombre.</a:t>
-            </a:r>
-          </a:p>
-        </p:txBody>
-      </p:sp>
-      <p:sp>
-        <p:nvSpPr>
-          <p:cNvPr id="5" name="Rounded Rectangle 4"/>
-          <p:cNvSpPr/>
+              <a:t>Elige el partido estelar de fútbol (ej. Clásico Nacional o Champions League) y define el premio inmediato (ej. Jarra de Cerveza o 1 Orden de Boneless para la mesa).</a:t>
+            </a:r>
+          </a:p>
+          <a:p>
+            <a:pPr>
+              <a:spcAft>
+                <a:spcPts val="200"/>
+              </a:spcAft>
+              <a:defRPr sz="1400" b="1">
+                <a:solidFill>
+                  <a:srgbClr val="00E676"/>
+                </a:solidFill>
+              </a:defRPr>
+            </a:pPr>
+            <a:r>
+              <a:t>📱 2. CÓMO ENTRA Y JUEGA EL CLIENTE</a:t>
+            </a:r>
+          </a:p>
+          <a:p>
+            <a:pPr>
+              <a:spcAft>
+                <a:spcPts val="1000"/>
+              </a:spcAft>
+              <a:defRPr sz="1150">
+                <a:solidFill>
+                  <a:srgbClr val="FFFFFF"/>
+                </a:solidFill>
+              </a:defRPr>
+            </a:pPr>
+            <a:r>
+              <a:t>Desde su celular, el comensal selecciona qué equipo anotará primero y en qué bloque de 15 minutos caerá el gol (1-15', 16-30', 31-45', etc.), o la opción de 'Sin Goles'.</a:t>
+            </a:r>
+          </a:p>
+          <a:p>
+            <a:pPr>
+              <a:spcAft>
+                <a:spcPts val="200"/>
+              </a:spcAft>
+              <a:defRPr sz="1400" b="1">
+                <a:solidFill>
+                  <a:srgbClr val="00E676"/>
+                </a:solidFill>
+              </a:defRPr>
+            </a:pPr>
+            <a:r>
+              <a:t>🏆 3. CÓMO GANA: ADRENALINA DESDE EL MINUTO 1</a:t>
+            </a:r>
+          </a:p>
+          <a:p>
+            <a:pPr>
+              <a:spcAft>
+                <a:spcPts val="1000"/>
+              </a:spcAft>
+              <a:defRPr sz="1150">
+                <a:solidFill>
+                  <a:srgbClr val="FFFFFF"/>
+                </a:solidFill>
+              </a:defRPr>
+            </a:pPr>
+            <a:r>
+              <a:t>En cuanto cae la primera anotación del partido, el sistema valida el minuto oficial de juego. El comensal que acertó el bloque de tiempo gana en el acto, generando gritos de festejo en el bar y rondas de brindis.</a:t>
+            </a:r>
+          </a:p>
+        </p:txBody>
+      </p:sp>
+      <p:pic>
+        <p:nvPicPr>
+          <p:cNvPr id="5" name="Picture 4" descr="tarjeta_3_instinto_goleador.png"/>
+          <p:cNvPicPr>
+            <a:picLocks noChangeAspect="1"/>
+          </p:cNvPicPr>
           <p:nvPr/>
-        </p:nvSpPr>
-        <p:spPr>
-          <a:xfrm>
-            <a:off x="4389120" y="1737360"/>
-            <a:ext cx="3413455" cy="4297680"/>
-          </a:xfrm>
-          <a:prstGeom prst="roundRect">
-            <a:avLst/>
-          </a:prstGeom>
-          <a:solidFill>
-            <a:srgbClr val="161C2A"/>
-          </a:solidFill>
-          <a:ln w="19050">
-            <a:solidFill>
-              <a:srgbClr val="2D374B"/>
-            </a:solidFill>
-          </a:ln>
-        </p:spPr>
-        <p:style>
-          <a:lnRef idx="1">
-            <a:schemeClr val="accent1"/>
-          </a:lnRef>
-          <a:fillRef idx="3">
-            <a:schemeClr val="accent1"/>
-          </a:fillRef>
-          <a:effectRef idx="2">
-            <a:schemeClr val="accent1"/>
-          </a:effectRef>
-          <a:fontRef idx="minor">
-            <a:schemeClr val="lt1"/>
-          </a:fontRef>
-        </p:style>
-        <p:txBody>
-          <a:bodyPr rtlCol="0" anchor="ctr"/>
-          <a:lstStyle/>
-          <a:p>
-            <a:pPr algn="ctr"/>
-          </a:p>
-        </p:txBody>
-      </p:sp>
-      <p:sp>
-        <p:nvSpPr>
-          <p:cNvPr id="6" name="TextBox 5"/>
-          <p:cNvSpPr txBox="1"/>
-          <p:nvPr/>
-        </p:nvSpPr>
-        <p:spPr>
-          <a:xfrm>
-            <a:off x="4663440" y="2011680"/>
-            <a:ext cx="2864815" cy="3749039"/>
+        </p:nvPicPr>
+        <p:blipFill>
+          <a:blip r:embed="rId2"/>
+          <a:stretch>
+            <a:fillRect/>
+          </a:stretch>
+        </p:blipFill>
+        <p:spPr>
+          <a:xfrm>
+            <a:off x="7955279" y="1645920"/>
+            <a:ext cx="2571750" cy="4572000"/>
           </a:xfrm>
           <a:prstGeom prst="rect">
             <a:avLst/>
           </a:prstGeom>
-          <a:noFill/>
-        </p:spPr>
-        <p:txBody>
-          <a:bodyPr wrap="square">
-            <a:spAutoFit/>
-          </a:bodyPr>
-          <a:lstStyle/>
-          <a:p>
-            <a:pPr>
-              <a:spcAft>
-                <a:spcPts val="1600"/>
-              </a:spcAft>
-              <a:defRPr sz="1700" b="1">
-                <a:solidFill>
-                  <a:srgbClr val="FF5722"/>
-                </a:solidFill>
-              </a:defRPr>
-            </a:pPr>
-            <a:r>
-              <a:t>2. SELECCIÓN Y PRONÓSTICO</a:t>
-            </a:r>
-          </a:p>
-          <a:p>
-            <a:pPr>
-              <a:defRPr sz="1400">
-                <a:solidFill>
-                  <a:srgbClr val="FFFFFF"/>
-                </a:solidFill>
-              </a:defRPr>
-            </a:pPr>
-            <a:r>
-              <a:t>🏈 Selecciona a su mesero, introduce sus marcadores o casillas y confirma en un solo toque antes del inicio del juego.</a:t>
-            </a:r>
-          </a:p>
-        </p:txBody>
-      </p:sp>
-      <p:sp>
-        <p:nvSpPr>
-          <p:cNvPr id="7" name="Rounded Rectangle 6"/>
-          <p:cNvSpPr/>
-          <p:nvPr/>
-        </p:nvSpPr>
-        <p:spPr>
-          <a:xfrm>
-            <a:off x="8046720" y="1737360"/>
-            <a:ext cx="3413455" cy="4297680"/>
-          </a:xfrm>
-          <a:prstGeom prst="roundRect">
-            <a:avLst/>
-          </a:prstGeom>
-          <a:solidFill>
-            <a:srgbClr val="161C2A"/>
-          </a:solidFill>
-          <a:ln w="19050">
-            <a:solidFill>
-              <a:srgbClr val="2D374B"/>
-            </a:solidFill>
-          </a:ln>
-        </p:spPr>
-        <p:style>
-          <a:lnRef idx="1">
-            <a:schemeClr val="accent1"/>
-          </a:lnRef>
-          <a:fillRef idx="3">
-            <a:schemeClr val="accent1"/>
-          </a:fillRef>
-          <a:effectRef idx="2">
-            <a:schemeClr val="accent1"/>
-          </a:effectRef>
-          <a:fontRef idx="minor">
-            <a:schemeClr val="lt1"/>
-          </a:fontRef>
-        </p:style>
-        <p:txBody>
-          <a:bodyPr rtlCol="0" anchor="ctr"/>
-          <a:lstStyle/>
-          <a:p>
-            <a:pPr algn="ctr"/>
-          </a:p>
-        </p:txBody>
-      </p:sp>
-      <p:sp>
-        <p:nvSpPr>
-          <p:cNvPr id="8" name="TextBox 7"/>
-          <p:cNvSpPr txBox="1"/>
-          <p:nvPr/>
-        </p:nvSpPr>
-        <p:spPr>
-          <a:xfrm>
-            <a:off x="8321040" y="2011680"/>
-            <a:ext cx="2864815" cy="3749039"/>
-          </a:xfrm>
-          <a:prstGeom prst="rect">
-            <a:avLst/>
-          </a:prstGeom>
-          <a:noFill/>
-        </p:spPr>
-        <p:txBody>
-          <a:bodyPr wrap="square">
-            <a:spAutoFit/>
-          </a:bodyPr>
-          <a:lstStyle/>
-          <a:p>
-            <a:pPr>
-              <a:spcAft>
-                <a:spcPts val="1600"/>
-              </a:spcAft>
-              <a:defRPr sz="1700" b="1">
-                <a:solidFill>
-                  <a:srgbClr val="00E676"/>
-                </a:solidFill>
-              </a:defRPr>
-            </a:pPr>
-            <a:r>
-              <a:t>3. VIVE LA EMOCIÓN Y GANA</a:t>
-            </a:r>
-          </a:p>
-          <a:p>
-            <a:pPr>
-              <a:defRPr sz="1400">
-                <a:solidFill>
-                  <a:srgbClr val="FFFFFF"/>
-                </a:solidFill>
-              </a:defRPr>
-            </a:pPr>
-            <a:r>
-              <a:t>🏆 Conforme avanza el partido en las pantallas del bar, ve subir su posición en la tabla en vivo. Al ganar, muestra su cupón digital al mesero o en barra.</a:t>
-            </a:r>
-          </a:p>
-        </p:txBody>
-      </p:sp>
+        </p:spPr>
+      </p:pic>
     </p:spTree>
   </p:cSld>
   <p:clrMapOvr>
@@ -6834,7 +6198,7 @@
         </p:nvSpPr>
         <p:spPr>
           <a:xfrm>
-            <a:off x="731520" y="457200"/>
+            <a:off x="731520" y="411480"/>
             <a:ext cx="10698480" cy="1005840"/>
           </a:xfrm>
           <a:prstGeom prst="rect">
@@ -6850,28 +6214,28 @@
           <a:p>
             <a:pPr>
               <a:spcAft>
-                <a:spcPts val="400"/>
-              </a:spcAft>
-              <a:defRPr sz="1100" b="1">
+                <a:spcPts val="300"/>
+              </a:spcAft>
+              <a:defRPr sz="1050" b="1">
                 <a:solidFill>
                   <a:srgbClr val="FFB612"/>
                 </a:solidFill>
               </a:defRPr>
             </a:pPr>
             <a:r>
-              <a:t>DRINKS &amp; WINS • PLATAFORMA DE GAMIFICACIÓN</a:t>
-            </a:r>
-          </a:p>
-          <a:p>
-            <a:pPr>
-              <a:defRPr sz="2600" b="1">
+              <a:t>DETALLE PASO A PASO POR JUEGO</a:t>
+            </a:r>
+          </a:p>
+          <a:p>
+            <a:pPr>
+              <a:defRPr sz="2400" b="1">
                 <a:solidFill>
                   <a:srgbClr val="FFFFFF"/>
                 </a:solidFill>
               </a:defRPr>
             </a:pPr>
             <a:r>
-              <a:t>Panel de Administración: Control Total en Minutos</a:t>
+              <a:t>Juegos 4 y 5: Trivia en Pantallas y Survivor NFL</a:t>
             </a:r>
           </a:p>
         </p:txBody>
@@ -6884,18 +6248,18 @@
         </p:nvSpPr>
         <p:spPr>
           <a:xfrm>
-            <a:off x="731520" y="1737360"/>
-            <a:ext cx="6858000" cy="4480560"/>
+            <a:off x="731520" y="1645920"/>
+            <a:ext cx="5212080" cy="4572000"/>
           </a:xfrm>
           <a:prstGeom prst="roundRect">
             <a:avLst/>
           </a:prstGeom>
           <a:solidFill>
-            <a:srgbClr val="161C2A"/>
+            <a:srgbClr val="141A26"/>
           </a:solidFill>
           <a:ln w="19050">
             <a:solidFill>
-              <a:srgbClr val="2D374B"/>
+              <a:srgbClr val="283246"/>
             </a:solidFill>
           </a:ln>
         </p:spPr>
@@ -6929,8 +6293,8 @@
         </p:nvSpPr>
         <p:spPr>
           <a:xfrm>
-            <a:off x="1097280" y="2011680"/>
-            <a:ext cx="6126480" cy="3931920"/>
+            <a:off x="1005840" y="1828800"/>
+            <a:ext cx="4663440" cy="4114800"/>
           </a:xfrm>
           <a:prstGeom prst="rect">
             <a:avLst/>
@@ -6945,149 +6309,283 @@
           <a:p>
             <a:pPr>
               <a:spcAft>
-                <a:spcPts val="200"/>
-              </a:spcAft>
-              <a:defRPr sz="1450" b="1">
+                <a:spcPts val="800"/>
+              </a:spcAft>
+              <a:defRPr sz="1650" b="1">
                 <a:solidFill>
                   <a:srgbClr val="FFB612"/>
                 </a:solidFill>
               </a:defRPr>
             </a:pPr>
             <a:r>
-              <a:t>⚡ Creación de Quinielas en 60 Segundos</a:t>
-            </a:r>
-          </a:p>
-          <a:p>
-            <a:pPr>
-              <a:spcAft>
-                <a:spcPts val="1000"/>
-              </a:spcAft>
-              <a:defRPr sz="1150">
+              <a:t>🧠 Trivia en Vivo en Pantallas de TV</a:t>
+            </a:r>
+          </a:p>
+          <a:p>
+            <a:pPr>
+              <a:spcAft>
+                <a:spcPts val="100"/>
+              </a:spcAft>
+              <a:defRPr sz="1300" b="1">
+                <a:solidFill>
+                  <a:srgbClr val="FF5722"/>
+                </a:solidFill>
+              </a:defRPr>
+            </a:pPr>
+            <a:r>
+              <a:t>🛠️ Creación con IA</a:t>
+            </a:r>
+          </a:p>
+          <a:p>
+            <a:pPr>
+              <a:spcAft>
+                <a:spcPts val="600"/>
+              </a:spcAft>
+              <a:defRPr sz="1100">
                 <a:solidFill>
                   <a:srgbClr val="FFFFFF"/>
                 </a:solidFill>
               </a:defRPr>
             </a:pPr>
             <a:r>
-              <a:t>El gerente solo elige el deporte (NFL, Liga MX, Premier, Champions) y la jornada. El sistema importa automáticamente partidos, horarios y escudos oficiales de ESPN.</a:t>
-            </a:r>
-          </a:p>
-          <a:p>
-            <a:pPr>
-              <a:spcAft>
-                <a:spcPts val="200"/>
-              </a:spcAft>
-              <a:defRPr sz="1450" b="1">
-                <a:solidFill>
-                  <a:srgbClr val="FFB612"/>
-                </a:solidFill>
-              </a:defRPr>
-            </a:pPr>
-            <a:r>
-              <a:t>👥 Control y Aprobación de Jugadores</a:t>
-            </a:r>
-          </a:p>
-          <a:p>
-            <a:pPr>
-              <a:spcAft>
-                <a:spcPts val="1000"/>
-              </a:spcAft>
-              <a:defRPr sz="1150">
+              <a:t>El gerente genera 10 preguntas deportivas temáticas con IA en 10 segundos.</a:t>
+            </a:r>
+          </a:p>
+          <a:p>
+            <a:pPr>
+              <a:spcAft>
+                <a:spcPts val="100"/>
+              </a:spcAft>
+              <a:defRPr sz="1300" b="1">
+                <a:solidFill>
+                  <a:srgbClr val="FF5722"/>
+                </a:solidFill>
+              </a:defRPr>
+            </a:pPr>
+            <a:r>
+              <a:t>📱 Juego en Vivo</a:t>
+            </a:r>
+          </a:p>
+          <a:p>
+            <a:pPr>
+              <a:spcAft>
+                <a:spcPts val="600"/>
+              </a:spcAft>
+              <a:defRPr sz="1100">
                 <a:solidFill>
                   <a:srgbClr val="FFFFFF"/>
                 </a:solidFill>
               </a:defRPr>
             </a:pPr>
             <a:r>
-              <a:t>Visualiza en tiempo real quién se unió a cada juego, qué mesero lo atendió y aprueba o gestiona participantes desde cualquier celular o tablet.</a:t>
-            </a:r>
-          </a:p>
-          <a:p>
-            <a:pPr>
-              <a:spcAft>
-                <a:spcPts val="200"/>
-              </a:spcAft>
-              <a:defRPr sz="1450" b="1">
-                <a:solidFill>
-                  <a:srgbClr val="FFB612"/>
-                </a:solidFill>
-              </a:defRPr>
-            </a:pPr>
-            <a:r>
-              <a:t>🎁 Configuración de Premios y Vouchers</a:t>
-            </a:r>
-          </a:p>
-          <a:p>
-            <a:pPr>
-              <a:spcAft>
-                <a:spcPts val="1000"/>
-              </a:spcAft>
-              <a:defRPr sz="1150">
+              <a:t>En el medio tiempo, la TV del bar muestra la pregunta con cuenta regresiva. Los clientes responden contrarreloj desde su smartphone.</a:t>
+            </a:r>
+          </a:p>
+          <a:p>
+            <a:pPr>
+              <a:spcAft>
+                <a:spcPts val="100"/>
+              </a:spcAft>
+              <a:defRPr sz="1300" b="1">
+                <a:solidFill>
+                  <a:srgbClr val="FF5722"/>
+                </a:solidFill>
+              </a:defRPr>
+            </a:pPr>
+            <a:r>
+              <a:t>🏆 Ganador</a:t>
+            </a:r>
+          </a:p>
+          <a:p>
+            <a:pPr>
+              <a:spcAft>
+                <a:spcPts val="600"/>
+              </a:spcAft>
+              <a:defRPr sz="1100">
                 <a:solidFill>
                   <a:srgbClr val="FFFFFF"/>
                 </a:solidFill>
               </a:defRPr>
             </a:pPr>
             <a:r>
-              <a:t>Define qué premio se entregará (ej. 1 Orden de Boneless, Jarra de Cerveza o % de Descuento en la siguiente cuenta).</a:t>
-            </a:r>
-          </a:p>
-          <a:p>
-            <a:pPr>
-              <a:spcAft>
-                <a:spcPts val="200"/>
-              </a:spcAft>
-              <a:defRPr sz="1450" b="1">
-                <a:solidFill>
-                  <a:srgbClr val="FFB612"/>
-                </a:solidFill>
-              </a:defRPr>
-            </a:pPr>
-            <a:r>
-              <a:t>🛡️ Seguridad y Control de Fraude</a:t>
-            </a:r>
-          </a:p>
-          <a:p>
-            <a:pPr>
-              <a:spcAft>
-                <a:spcPts val="1000"/>
-              </a:spcAft>
-              <a:defRPr sz="1150">
-                <a:solidFill>
-                  <a:srgbClr val="FFFFFF"/>
-                </a:solidFill>
-              </a:defRPr>
-            </a:pPr>
-            <a:r>
-              <a:t>Los pronósticos se bloquean automáticamente en cuanto inicia el primer partido. Nadie puede editar marcadores una vez arrancado el juego.</a:t>
-            </a:r>
-          </a:p>
-        </p:txBody>
-      </p:sp>
-      <p:pic>
-        <p:nvPicPr>
-          <p:cNvPr id="5" name="Picture 4" descr="screenshot_admin_player.png"/>
-          <p:cNvPicPr>
-            <a:picLocks noChangeAspect="1"/>
-          </p:cNvPicPr>
+              <a:t>La pantalla de TV muestra el podio del bar en tiempo real con fanfarrias y aplausos en el restaurante.</a:t>
+            </a:r>
+          </a:p>
+        </p:txBody>
+      </p:sp>
+      <p:sp>
+        <p:nvSpPr>
+          <p:cNvPr id="5" name="Rounded Rectangle 4"/>
+          <p:cNvSpPr/>
           <p:nvPr/>
-        </p:nvPicPr>
-        <p:blipFill>
-          <a:blip r:embed="rId2"/>
-          <a:stretch>
-            <a:fillRect/>
-          </a:stretch>
-        </p:blipFill>
-        <p:spPr>
-          <a:xfrm>
-            <a:off x="7863840" y="1920240"/>
-            <a:ext cx="3566160" cy="1308612"/>
+        </p:nvSpPr>
+        <p:spPr>
+          <a:xfrm>
+            <a:off x="6217920" y="1645920"/>
+            <a:ext cx="5212080" cy="4572000"/>
+          </a:xfrm>
+          <a:prstGeom prst="roundRect">
+            <a:avLst/>
+          </a:prstGeom>
+          <a:solidFill>
+            <a:srgbClr val="141A26"/>
+          </a:solidFill>
+          <a:ln w="19050">
+            <a:solidFill>
+              <a:srgbClr val="283246"/>
+            </a:solidFill>
+          </a:ln>
+        </p:spPr>
+        <p:style>
+          <a:lnRef idx="1">
+            <a:schemeClr val="accent1"/>
+          </a:lnRef>
+          <a:fillRef idx="3">
+            <a:schemeClr val="accent1"/>
+          </a:fillRef>
+          <a:effectRef idx="2">
+            <a:schemeClr val="accent1"/>
+          </a:effectRef>
+          <a:fontRef idx="minor">
+            <a:schemeClr val="lt1"/>
+          </a:fontRef>
+        </p:style>
+        <p:txBody>
+          <a:bodyPr rtlCol="0" anchor="ctr"/>
+          <a:lstStyle/>
+          <a:p>
+            <a:pPr algn="ctr"/>
+          </a:p>
+        </p:txBody>
+      </p:sp>
+      <p:sp>
+        <p:nvSpPr>
+          <p:cNvPr id="6" name="TextBox 5"/>
+          <p:cNvSpPr txBox="1"/>
+          <p:nvPr/>
+        </p:nvSpPr>
+        <p:spPr>
+          <a:xfrm>
+            <a:off x="6492240" y="1828800"/>
+            <a:ext cx="4663440" cy="4114800"/>
           </a:xfrm>
           <a:prstGeom prst="rect">
             <a:avLst/>
           </a:prstGeom>
-        </p:spPr>
-      </p:pic>
+          <a:noFill/>
+        </p:spPr>
+        <p:txBody>
+          <a:bodyPr wrap="square">
+            <a:spAutoFit/>
+          </a:bodyPr>
+          <a:lstStyle/>
+          <a:p>
+            <a:pPr>
+              <a:spcAft>
+                <a:spcPts val="800"/>
+              </a:spcAft>
+              <a:defRPr sz="1650" b="1">
+                <a:solidFill>
+                  <a:srgbClr val="00E676"/>
+                </a:solidFill>
+              </a:defRPr>
+            </a:pPr>
+            <a:r>
+              <a:t>🛡️ Survivor NFL: Fidelización Semanal</a:t>
+            </a:r>
+          </a:p>
+          <a:p>
+            <a:pPr>
+              <a:spcAft>
+                <a:spcPts val="100"/>
+              </a:spcAft>
+              <a:defRPr sz="1300" b="1">
+                <a:solidFill>
+                  <a:srgbClr val="FFD100"/>
+                </a:solidFill>
+              </a:defRPr>
+            </a:pPr>
+            <a:r>
+              <a:t>🛠️ Creación Única</a:t>
+            </a:r>
+          </a:p>
+          <a:p>
+            <a:pPr>
+              <a:spcAft>
+                <a:spcPts val="600"/>
+              </a:spcAft>
+              <a:defRPr sz="1100">
+                <a:solidFill>
+                  <a:srgbClr val="FFFFFF"/>
+                </a:solidFill>
+              </a:defRPr>
+            </a:pPr>
+            <a:r>
+              <a:t>Se abre al inicio de la temporada regular de NFL.</a:t>
+            </a:r>
+          </a:p>
+          <a:p>
+            <a:pPr>
+              <a:spcAft>
+                <a:spcPts val="100"/>
+              </a:spcAft>
+              <a:defRPr sz="1300" b="1">
+                <a:solidFill>
+                  <a:srgbClr val="FFD100"/>
+                </a:solidFill>
+              </a:defRPr>
+            </a:pPr>
+            <a:r>
+              <a:t>📱 Elección Semanal</a:t>
+            </a:r>
+          </a:p>
+          <a:p>
+            <a:pPr>
+              <a:spcAft>
+                <a:spcPts val="600"/>
+              </a:spcAft>
+              <a:defRPr sz="1100">
+                <a:solidFill>
+                  <a:srgbClr val="FFFFFF"/>
+                </a:solidFill>
+              </a:defRPr>
+            </a:pPr>
+            <a:r>
+              <a:t>Cada comensal elige 1 equipo ganador por semana sin repetir. Si su equipo gana, sobrevive; si pierde, queda eliminado.</a:t>
+            </a:r>
+          </a:p>
+          <a:p>
+            <a:pPr>
+              <a:spcAft>
+                <a:spcPts val="100"/>
+              </a:spcAft>
+              <a:defRPr sz="1300" b="1">
+                <a:solidFill>
+                  <a:srgbClr val="FFD100"/>
+                </a:solidFill>
+              </a:defRPr>
+            </a:pPr>
+            <a:r>
+              <a:t>🏆 Retención Frecuente</a:t>
+            </a:r>
+          </a:p>
+          <a:p>
+            <a:pPr>
+              <a:spcAft>
+                <a:spcPts val="600"/>
+              </a:spcAft>
+              <a:defRPr sz="1100">
+                <a:solidFill>
+                  <a:srgbClr val="FFFFFF"/>
+                </a:solidFill>
+              </a:defRPr>
+            </a:pPr>
+            <a:r>
+              <a:t>Obliga al cliente a regresar cada semana a la sucursal para defender su boleto de sobreviviente y competir por el premio mayor de la temporada.</a:t>
+            </a:r>
+          </a:p>
+        </p:txBody>
+      </p:sp>
     </p:spTree>
   </p:cSld>
   <p:clrMapOvr>
@@ -7122,7 +6620,7 @@
         </p:nvSpPr>
         <p:spPr>
           <a:xfrm>
-            <a:off x="731520" y="457200"/>
+            <a:off x="731520" y="411480"/>
             <a:ext cx="10698480" cy="1005840"/>
           </a:xfrm>
           <a:prstGeom prst="rect">
@@ -7138,21 +6636,21 @@
           <a:p>
             <a:pPr>
               <a:spcAft>
-                <a:spcPts val="400"/>
-              </a:spcAft>
-              <a:defRPr sz="1100" b="1">
+                <a:spcPts val="300"/>
+              </a:spcAft>
+              <a:defRPr sz="1050" b="1">
                 <a:solidFill>
                   <a:srgbClr val="FFB612"/>
                 </a:solidFill>
               </a:defRPr>
             </a:pPr>
             <a:r>
-              <a:t>DRINKS &amp; WINS • PLATAFORMA DE GAMIFICACIÓN</a:t>
-            </a:r>
-          </a:p>
-          <a:p>
-            <a:pPr>
-              <a:defRPr sz="2600" b="1">
+              <a:t>RENTABILIDAD Y VENTAS</a:t>
+            </a:r>
+          </a:p>
+          <a:p>
+            <a:pPr>
+              <a:defRPr sz="2400" b="1">
                 <a:solidFill>
                   <a:srgbClr val="FFFFFF"/>
                 </a:solidFill>
@@ -7172,18 +6670,18 @@
         </p:nvSpPr>
         <p:spPr>
           <a:xfrm>
-            <a:off x="731520" y="1737360"/>
-            <a:ext cx="3413455" cy="4297680"/>
+            <a:off x="731520" y="1645920"/>
+            <a:ext cx="3413455" cy="4572000"/>
           </a:xfrm>
           <a:prstGeom prst="roundRect">
             <a:avLst/>
           </a:prstGeom>
           <a:solidFill>
-            <a:srgbClr val="161C2A"/>
+            <a:srgbClr val="141A26"/>
           </a:solidFill>
           <a:ln w="19050">
             <a:solidFill>
-              <a:srgbClr val="2D374B"/>
+              <a:srgbClr val="283246"/>
             </a:solidFill>
           </a:ln>
         </p:spPr>
@@ -7217,8 +6715,8 @@
         </p:nvSpPr>
         <p:spPr>
           <a:xfrm>
-            <a:off x="1005840" y="2011680"/>
-            <a:ext cx="2864815" cy="3749039"/>
+            <a:off x="1005840" y="1920240"/>
+            <a:ext cx="2864815" cy="4023360"/>
           </a:xfrm>
           <a:prstGeom prst="rect">
             <a:avLst/>
@@ -7233,28 +6731,28 @@
           <a:p>
             <a:pPr>
               <a:spcAft>
-                <a:spcPts val="1600"/>
-              </a:spcAft>
-              <a:defRPr sz="1700" b="1">
+                <a:spcPts val="1400"/>
+              </a:spcAft>
+              <a:defRPr sz="1650" b="1">
                 <a:solidFill>
                   <a:srgbClr val="FFB612"/>
                 </a:solidFill>
               </a:defRPr>
             </a:pPr>
             <a:r>
-              <a:t>🍔 Premios de Alto Valor Percibido</a:t>
-            </a:r>
-          </a:p>
-          <a:p>
-            <a:pPr>
-              <a:defRPr sz="1400">
+              <a:t>🍔 Alto Valor Percibido vs Bajo Costo</a:t>
+            </a:r>
+          </a:p>
+          <a:p>
+            <a:pPr>
+              <a:defRPr sz="1300">
                 <a:solidFill>
                   <a:srgbClr val="FFFFFF"/>
                 </a:solidFill>
               </a:defRPr>
             </a:pPr>
             <a:r>
-              <a:t>Entregar una orden de alitas o una cerveza tiene un costo operativo bajo para la cocina pero un valor percibido de $150-$250 MXN para el cliente. Es el incentivo perfecto sin erosionar margen.</a:t>
+              <a:t>Una orden de alitas o una cerveza tiene un costo de materia prima muy manejable para la cocina ($30-$50 MXN), pero en la mente del cliente representa un premio valioso de $160 a $240 MXN.</a:t>
             </a:r>
           </a:p>
         </p:txBody>
@@ -7267,18 +6765,18 @@
         </p:nvSpPr>
         <p:spPr>
           <a:xfrm>
-            <a:off x="4389120" y="1737360"/>
-            <a:ext cx="3413455" cy="4297680"/>
+            <a:off x="4389120" y="1645920"/>
+            <a:ext cx="3413455" cy="4572000"/>
           </a:xfrm>
           <a:prstGeom prst="roundRect">
             <a:avLst/>
           </a:prstGeom>
           <a:solidFill>
-            <a:srgbClr val="161C2A"/>
+            <a:srgbClr val="141A26"/>
           </a:solidFill>
           <a:ln w="19050">
             <a:solidFill>
-              <a:srgbClr val="2D374B"/>
+              <a:srgbClr val="283246"/>
             </a:solidFill>
           </a:ln>
         </p:spPr>
@@ -7312,8 +6810,8 @@
         </p:nvSpPr>
         <p:spPr>
           <a:xfrm>
-            <a:off x="4663440" y="2011680"/>
-            <a:ext cx="2864815" cy="3749039"/>
+            <a:off x="4663440" y="1920240"/>
+            <a:ext cx="2864815" cy="4023360"/>
           </a:xfrm>
           <a:prstGeom prst="rect">
             <a:avLst/>
@@ -7328,28 +6826,28 @@
           <a:p>
             <a:pPr>
               <a:spcAft>
-                <a:spcPts val="1600"/>
-              </a:spcAft>
-              <a:defRPr sz="1700" b="1">
+                <a:spcPts val="1400"/>
+              </a:spcAft>
+              <a:defRPr sz="1650" b="1">
                 <a:solidFill>
                   <a:srgbClr val="00E676"/>
                 </a:solidFill>
               </a:defRPr>
             </a:pPr>
             <a:r>
-              <a:t>🔄 Recompensa Condicionada a Consumo</a:t>
-            </a:r>
-          </a:p>
-          <a:p>
-            <a:pPr>
-              <a:defRPr sz="1400">
+              <a:t>🍻 Festejo y Rondas Adicionales</a:t>
+            </a:r>
+          </a:p>
+          <a:p>
+            <a:pPr>
+              <a:defRPr sz="1300">
                 <a:solidFill>
                   <a:srgbClr val="FFFFFF"/>
                 </a:solidFill>
               </a:defRPr>
             </a:pPr>
             <a:r>
-              <a:t>Los premios se canjean en la mesa mientras el grupo sigue consumiendo, o como cupón para su siguiente visita. El ganador celebra y suele pedir una ronda extra para brindar con sus amigos.</a:t>
+              <a:t>Nadie gana y se va. El comensal que resulta campeón celebra con su mesa, y el grupo pide cervezas y platillos adicionales para acompañar el premio. El ticket final siempre supera con creces el costo del incentivo.</a:t>
             </a:r>
           </a:p>
         </p:txBody>
@@ -7362,18 +6860,18 @@
         </p:nvSpPr>
         <p:spPr>
           <a:xfrm>
-            <a:off x="8046720" y="1737360"/>
-            <a:ext cx="3413455" cy="4297680"/>
+            <a:off x="8046720" y="1645920"/>
+            <a:ext cx="3413455" cy="4572000"/>
           </a:xfrm>
           <a:prstGeom prst="roundRect">
             <a:avLst/>
           </a:prstGeom>
           <a:solidFill>
-            <a:srgbClr val="161C2A"/>
+            <a:srgbClr val="141A26"/>
           </a:solidFill>
           <a:ln w="19050">
             <a:solidFill>
-              <a:srgbClr val="2D374B"/>
+              <a:srgbClr val="283246"/>
             </a:solidFill>
           </a:ln>
         </p:spPr>
@@ -7407,8 +6905,8 @@
         </p:nvSpPr>
         <p:spPr>
           <a:xfrm>
-            <a:off x="8321040" y="2011680"/>
-            <a:ext cx="2864815" cy="3749039"/>
+            <a:off x="8321040" y="1920240"/>
+            <a:ext cx="2864815" cy="4023360"/>
           </a:xfrm>
           <a:prstGeom prst="rect">
             <a:avLst/>
@@ -7423,28 +6921,28 @@
           <a:p>
             <a:pPr>
               <a:spcAft>
-                <a:spcPts val="1600"/>
-              </a:spcAft>
-              <a:defRPr sz="1700" b="1">
+                <a:spcPts val="1400"/>
+              </a:spcAft>
+              <a:defRPr sz="1650" b="1">
                 <a:solidFill>
                   <a:srgbClr val="FF5722"/>
                 </a:solidFill>
               </a:defRPr>
             </a:pPr>
             <a:r>
-              <a:t>📊 Captura de Clientes Frecuentes</a:t>
-            </a:r>
-          </a:p>
-          <a:p>
-            <a:pPr>
-              <a:defRPr sz="1400">
+              <a:t>🔄 Retorno Asegurado en Días Bajas</a:t>
+            </a:r>
+          </a:p>
+          <a:p>
+            <a:pPr>
+              <a:defRPr sz="1300">
                 <a:solidFill>
                   <a:srgbClr val="FFFFFF"/>
                 </a:solidFill>
               </a:defRPr>
             </a:pPr>
             <a:r>
-              <a:t>El restaurante construye una base de datos propia de fanáticos recurrentes para enviar avisos de partidos importantes, promociones y eventos especiales de NFL y liguilla.</a:t>
+              <a:t>Los cupones de 2º y 3º lugar se pueden programar para canjearse de lunes a jueves en su siguiente visita, generando tráfico en días y horarios con menor ocupación.</a:t>
             </a:r>
           </a:p>
         </p:txBody>

</xml_diff>

<commit_message>
feat(presentation): presentacion ejecutiva de 14 diapositivas con historia de Beto, operacion Juriquilla, IA autonoma y onboarding detallado
</commit_message>
<xml_diff>
--- a/Drinks_and_Wins_Presentacion_Ejecutiva.pptx
+++ b/Drinks_and_Wins_Presentacion_Ejecutiva.pptx
@@ -17,6 +17,8 @@
     <p:sldId id="265" r:id="rId16"/>
     <p:sldId id="266" r:id="rId17"/>
     <p:sldId id="267" r:id="rId18"/>
+    <p:sldId id="268" r:id="rId19"/>
+    <p:sldId id="269" r:id="rId20"/>
   </p:sldIdLst>
   <p:sldSz cx="12191695" cy="6858000" type="screen4x3"/>
   <p:notesSz cx="6858000" cy="9144000"/>
@@ -3168,7 +3170,7 @@
         </p:blipFill>
         <p:spPr>
           <a:xfrm>
-            <a:off x="1188720" y="1280160"/>
+            <a:off x="1188720" y="1188720"/>
             <a:ext cx="850821" cy="1097280"/>
           </a:xfrm>
           <a:prstGeom prst="rect">
@@ -3184,8 +3186,8 @@
         </p:nvSpPr>
         <p:spPr>
           <a:xfrm>
-            <a:off x="1188720" y="2560320"/>
-            <a:ext cx="9601200" cy="3108960"/>
+            <a:off x="1188720" y="2468880"/>
+            <a:ext cx="9601200" cy="3291840"/>
           </a:xfrm>
           <a:prstGeom prst="rect">
             <a:avLst/>
@@ -3209,7 +3211,7 @@
               </a:defRPr>
             </a:pPr>
             <a:r>
-              <a:t>EXPERIENCIA DIGITAL EN MESA • VALIDADA EN BARRA</a:t>
+              <a:t>PROYECTO DE GAMIFICACIÓN EN MESA • DE LA BARRA A LA OPERACIÓN</a:t>
             </a:r>
           </a:p>
           <a:p>
@@ -3230,7 +3232,7 @@
           <a:p>
             <a:pPr>
               <a:spcAft>
-                <a:spcPts val="2000"/>
+                <a:spcPts val="1800"/>
               </a:spcAft>
               <a:defRPr sz="1900">
                 <a:solidFill>
@@ -3244,14 +3246,29 @@
           </a:p>
           <a:p>
             <a:pPr>
-              <a:defRPr sz="1300">
+              <a:spcAft>
+                <a:spcPts val="400"/>
+              </a:spcAft>
+              <a:defRPr sz="1350">
+                <a:solidFill>
+                  <a:srgbClr val="FFFFFF"/>
+                </a:solidFill>
+              </a:defRPr>
+            </a:pPr>
+            <a:r>
+              <a:t>Presentado por Beto Muñoz • Para el Dueño de la Marca, Dirección General y Gerencia</a:t>
+            </a:r>
+          </a:p>
+          <a:p>
+            <a:pPr>
+              <a:defRPr sz="1200" i="1">
                 <a:solidFill>
                   <a:srgbClr val="94A3B8"/>
                 </a:solidFill>
               </a:defRPr>
             </a:pPr>
             <a:r>
-              <a:t>De la Barra de Álamos a la Escala de Marca • Presentación para Dirección y Gerencia General</a:t>
+              <a:t>«Nacido del cariño al lugar de trabajo, a los clientes y a las propinas que sacan adelante a mi familia»</a:t>
             </a:r>
           </a:p>
         </p:txBody>
@@ -3290,7 +3307,7 @@
         </p:nvSpPr>
         <p:spPr>
           <a:xfrm>
-            <a:off x="731520" y="411480"/>
+            <a:off x="731520" y="365760"/>
             <a:ext cx="10698480" cy="1005840"/>
           </a:xfrm>
           <a:prstGeom prst="rect">
@@ -3306,28 +3323,28 @@
           <a:p>
             <a:pPr>
               <a:spcAft>
-                <a:spcPts val="300"/>
-              </a:spcAft>
-              <a:defRPr sz="1050" b="1">
+                <a:spcPts val="200"/>
+              </a:spcAft>
+              <a:defRPr sz="1000" b="1">
                 <a:solidFill>
                   <a:srgbClr val="FFB612"/>
                 </a:solidFill>
               </a:defRPr>
             </a:pPr>
             <a:r>
-              <a:t>EQUIPO DE SERVICIO</a:t>
-            </a:r>
-          </a:p>
-          <a:p>
-            <a:pPr>
-              <a:defRPr sz="2400" b="1">
+              <a:t>RENTABILIDAD Y VENTAS</a:t>
+            </a:r>
+          </a:p>
+          <a:p>
+            <a:pPr>
+              <a:defRPr sz="2300" b="1">
                 <a:solidFill>
                   <a:srgbClr val="FFFFFF"/>
                 </a:solidFill>
               </a:defRPr>
             </a:pPr>
             <a:r>
-              <a:t>Gamificación del Personal: Meseros como Embajadores</a:t>
+              <a:t>Estrategia de Premios: Diseñada para Proteger el Margen</a:t>
             </a:r>
           </a:p>
         </p:txBody>
@@ -3341,7 +3358,7 @@
         <p:spPr>
           <a:xfrm>
             <a:off x="731520" y="1645920"/>
-            <a:ext cx="6858000" cy="4572000"/>
+            <a:ext cx="3413455" cy="4663440"/>
           </a:xfrm>
           <a:prstGeom prst="roundRect">
             <a:avLst/>
@@ -3385,8 +3402,8 @@
         </p:nvSpPr>
         <p:spPr>
           <a:xfrm>
-            <a:off x="1005840" y="1828800"/>
-            <a:ext cx="6309360" cy="4114800"/>
+            <a:off x="1005840" y="1920240"/>
+            <a:ext cx="2864815" cy="4114800"/>
           </a:xfrm>
           <a:prstGeom prst="rect">
             <a:avLst/>
@@ -3401,149 +3418,222 @@
           <a:p>
             <a:pPr>
               <a:spcAft>
-                <a:spcPts val="200"/>
-              </a:spcAft>
-              <a:defRPr sz="1400" b="1">
+                <a:spcPts val="1400"/>
+              </a:spcAft>
+              <a:defRPr sz="1600" b="1">
                 <a:solidFill>
                   <a:srgbClr val="FFB612"/>
                 </a:solidFill>
               </a:defRPr>
             </a:pPr>
             <a:r>
-              <a:t>🙋 Atribución Clara en Cada Mesa</a:t>
-            </a:r>
-          </a:p>
-          <a:p>
-            <a:pPr>
-              <a:spcAft>
-                <a:spcPts val="1000"/>
-              </a:spcAft>
-              <a:defRPr sz="1150">
+              <a:t>🍔 Alto Valor Percibido vs Bajo Costo</a:t>
+            </a:r>
+          </a:p>
+          <a:p>
+            <a:pPr>
+              <a:defRPr sz="1300">
                 <a:solidFill>
                   <a:srgbClr val="FFFFFF"/>
                 </a:solidFill>
               </a:defRPr>
             </a:pPr>
             <a:r>
-              <a:t>Al registrar sus pronósticos, el cliente selecciona el nombre de su mesero en la lista. La gerencia sabe con métricas exactas qué meseros están invitando activamente y cuáles no.</a:t>
-            </a:r>
-          </a:p>
-          <a:p>
-            <a:pPr>
-              <a:spcAft>
-                <a:spcPts val="200"/>
-              </a:spcAft>
-              <a:defRPr sz="1400" b="1">
-                <a:solidFill>
-                  <a:srgbClr val="FFB612"/>
-                </a:solidFill>
-              </a:defRPr>
-            </a:pPr>
-            <a:r>
-              <a:t>💰 Incentivo Económico Directo (Más Propina)</a:t>
-            </a:r>
-          </a:p>
-          <a:p>
-            <a:pPr>
-              <a:spcAft>
-                <a:spcPts val="1000"/>
-              </a:spcAft>
-              <a:defRPr sz="1150">
-                <a:solidFill>
-                  <a:srgbClr val="FFFFFF"/>
-                </a:solidFill>
-              </a:defRPr>
-            </a:pPr>
-            <a:r>
-              <a:t>Los meseros comprenden la fórmula de inmediato: Si la mesa se queda 3 horas compitiendo, consumirá más rondas de cerveza, hamburguesas y alitas, lo que elevará el total de la cuenta y su propina.</a:t>
-            </a:r>
-          </a:p>
-          <a:p>
-            <a:pPr>
-              <a:spcAft>
-                <a:spcPts val="200"/>
-              </a:spcAft>
-              <a:defRPr sz="1400" b="1">
-                <a:solidFill>
-                  <a:srgbClr val="FFB612"/>
-                </a:solidFill>
-              </a:defRPr>
-            </a:pPr>
-            <a:r>
-              <a:t>💬 Rompehielos Natural de Venta Sugerida</a:t>
-            </a:r>
-          </a:p>
-          <a:p>
-            <a:pPr>
-              <a:spcAft>
-                <a:spcPts val="1000"/>
-              </a:spcAft>
-              <a:defRPr sz="1150">
-                <a:solidFill>
-                  <a:srgbClr val="FFFFFF"/>
-                </a:solidFill>
-              </a:defRPr>
-            </a:pPr>
-            <a:r>
-              <a:t>En lugar del genérico '¿Se les ofrece algo más?', el mesero llega sonriendo: '¿Ya metieron su quiniela de hoy con mi nombre? Si ganan, ¡la casa les invita unas alitas!'.</a:t>
-            </a:r>
-          </a:p>
-          <a:p>
-            <a:pPr>
-              <a:spcAft>
-                <a:spcPts val="200"/>
-              </a:spcAft>
-              <a:defRPr sz="1400" b="1">
-                <a:solidFill>
-                  <a:srgbClr val="FFB612"/>
-                </a:solidFill>
-              </a:defRPr>
-            </a:pPr>
-            <a:r>
-              <a:t>🏆 Competencia Interna del Equipo</a:t>
-            </a:r>
-          </a:p>
-          <a:p>
-            <a:pPr>
-              <a:spcAft>
-                <a:spcPts val="1000"/>
-              </a:spcAft>
-              <a:defRPr sz="1150">
-                <a:solidFill>
-                  <a:srgbClr val="FFFFFF"/>
-                </a:solidFill>
-              </a:defRPr>
-            </a:pPr>
-            <a:r>
-              <a:t>Se puede premiar al mesero con más comensales registrados en la semana con turnos preferenciales o un reconocimiento en la junta semanal.</a:t>
-            </a:r>
-          </a:p>
-        </p:txBody>
-      </p:sp>
-      <p:pic>
-        <p:nvPicPr>
-          <p:cNvPr id="5" name="Picture 4" descr="screenshot_admin_player.png"/>
-          <p:cNvPicPr>
-            <a:picLocks noChangeAspect="1"/>
-          </p:cNvPicPr>
+              <a:t>Una orden de alitas o una cerveza tiene un costo de insumo moderado para cocina/barra ($30-$50 MXN), pero en la mente del cliente representa un premio valioso de $160 a $240 MXN.</a:t>
+            </a:r>
+          </a:p>
+        </p:txBody>
+      </p:sp>
+      <p:sp>
+        <p:nvSpPr>
+          <p:cNvPr id="5" name="Rounded Rectangle 4"/>
+          <p:cNvSpPr/>
           <p:nvPr/>
-        </p:nvPicPr>
-        <p:blipFill>
-          <a:blip r:embed="rId2"/>
-          <a:stretch>
-            <a:fillRect/>
-          </a:stretch>
-        </p:blipFill>
-        <p:spPr>
-          <a:xfrm>
-            <a:off x="7863840" y="1828800"/>
-            <a:ext cx="3566160" cy="1308612"/>
+        </p:nvSpPr>
+        <p:spPr>
+          <a:xfrm>
+            <a:off x="4389120" y="1645920"/>
+            <a:ext cx="3413455" cy="4663440"/>
+          </a:xfrm>
+          <a:prstGeom prst="roundRect">
+            <a:avLst/>
+          </a:prstGeom>
+          <a:solidFill>
+            <a:srgbClr val="141A26"/>
+          </a:solidFill>
+          <a:ln w="19050">
+            <a:solidFill>
+              <a:srgbClr val="283246"/>
+            </a:solidFill>
+          </a:ln>
+        </p:spPr>
+        <p:style>
+          <a:lnRef idx="1">
+            <a:schemeClr val="accent1"/>
+          </a:lnRef>
+          <a:fillRef idx="3">
+            <a:schemeClr val="accent1"/>
+          </a:fillRef>
+          <a:effectRef idx="2">
+            <a:schemeClr val="accent1"/>
+          </a:effectRef>
+          <a:fontRef idx="minor">
+            <a:schemeClr val="lt1"/>
+          </a:fontRef>
+        </p:style>
+        <p:txBody>
+          <a:bodyPr rtlCol="0" anchor="ctr"/>
+          <a:lstStyle/>
+          <a:p>
+            <a:pPr algn="ctr"/>
+          </a:p>
+        </p:txBody>
+      </p:sp>
+      <p:sp>
+        <p:nvSpPr>
+          <p:cNvPr id="6" name="TextBox 5"/>
+          <p:cNvSpPr txBox="1"/>
+          <p:nvPr/>
+        </p:nvSpPr>
+        <p:spPr>
+          <a:xfrm>
+            <a:off x="4663440" y="1920240"/>
+            <a:ext cx="2864815" cy="4114800"/>
           </a:xfrm>
           <a:prstGeom prst="rect">
             <a:avLst/>
           </a:prstGeom>
-        </p:spPr>
-      </p:pic>
+          <a:noFill/>
+        </p:spPr>
+        <p:txBody>
+          <a:bodyPr wrap="square">
+            <a:spAutoFit/>
+          </a:bodyPr>
+          <a:lstStyle/>
+          <a:p>
+            <a:pPr>
+              <a:spcAft>
+                <a:spcPts val="1400"/>
+              </a:spcAft>
+              <a:defRPr sz="1600" b="1">
+                <a:solidFill>
+                  <a:srgbClr val="00E676"/>
+                </a:solidFill>
+              </a:defRPr>
+            </a:pPr>
+            <a:r>
+              <a:t>🍻 Festejo y Rondas Extra en Mesa</a:t>
+            </a:r>
+          </a:p>
+          <a:p>
+            <a:pPr>
+              <a:defRPr sz="1300">
+                <a:solidFill>
+                  <a:srgbClr val="FFFFFF"/>
+                </a:solidFill>
+              </a:defRPr>
+            </a:pPr>
+            <a:r>
+              <a:t>Nadie gana y se va. El comensal que resulta campeón celebra con su mesa, y el grupo pide cervezas y platillos adicionales para acompañar el premio. El ticket final siempre supera con creces el costo del incentivo.</a:t>
+            </a:r>
+          </a:p>
+        </p:txBody>
+      </p:sp>
+      <p:sp>
+        <p:nvSpPr>
+          <p:cNvPr id="7" name="Rounded Rectangle 6"/>
+          <p:cNvSpPr/>
+          <p:nvPr/>
+        </p:nvSpPr>
+        <p:spPr>
+          <a:xfrm>
+            <a:off x="8046720" y="1645920"/>
+            <a:ext cx="3413455" cy="4663440"/>
+          </a:xfrm>
+          <a:prstGeom prst="roundRect">
+            <a:avLst/>
+          </a:prstGeom>
+          <a:solidFill>
+            <a:srgbClr val="141A26"/>
+          </a:solidFill>
+          <a:ln w="19050">
+            <a:solidFill>
+              <a:srgbClr val="283246"/>
+            </a:solidFill>
+          </a:ln>
+        </p:spPr>
+        <p:style>
+          <a:lnRef idx="1">
+            <a:schemeClr val="accent1"/>
+          </a:lnRef>
+          <a:fillRef idx="3">
+            <a:schemeClr val="accent1"/>
+          </a:fillRef>
+          <a:effectRef idx="2">
+            <a:schemeClr val="accent1"/>
+          </a:effectRef>
+          <a:fontRef idx="minor">
+            <a:schemeClr val="lt1"/>
+          </a:fontRef>
+        </p:style>
+        <p:txBody>
+          <a:bodyPr rtlCol="0" anchor="ctr"/>
+          <a:lstStyle/>
+          <a:p>
+            <a:pPr algn="ctr"/>
+          </a:p>
+        </p:txBody>
+      </p:sp>
+      <p:sp>
+        <p:nvSpPr>
+          <p:cNvPr id="8" name="TextBox 7"/>
+          <p:cNvSpPr txBox="1"/>
+          <p:nvPr/>
+        </p:nvSpPr>
+        <p:spPr>
+          <a:xfrm>
+            <a:off x="8321040" y="1920240"/>
+            <a:ext cx="2864815" cy="4114800"/>
+          </a:xfrm>
+          <a:prstGeom prst="rect">
+            <a:avLst/>
+          </a:prstGeom>
+          <a:noFill/>
+        </p:spPr>
+        <p:txBody>
+          <a:bodyPr wrap="square">
+            <a:spAutoFit/>
+          </a:bodyPr>
+          <a:lstStyle/>
+          <a:p>
+            <a:pPr>
+              <a:spcAft>
+                <a:spcPts val="1400"/>
+              </a:spcAft>
+              <a:defRPr sz="1600" b="1">
+                <a:solidFill>
+                  <a:srgbClr val="FF5722"/>
+                </a:solidFill>
+              </a:defRPr>
+            </a:pPr>
+            <a:r>
+              <a:t>🔄 Retorno Asegurado en Días Bajas</a:t>
+            </a:r>
+          </a:p>
+          <a:p>
+            <a:pPr>
+              <a:defRPr sz="1300">
+                <a:solidFill>
+                  <a:srgbClr val="FFFFFF"/>
+                </a:solidFill>
+              </a:defRPr>
+            </a:pPr>
+            <a:r>
+              <a:t>Los cupones de 2º y 3º lugar se pueden programar para canjearse de lunes a jueves en su siguiente visita, generando tráfico en días y horarios con menor ocupación.</a:t>
+            </a:r>
+          </a:p>
+        </p:txBody>
+      </p:sp>
     </p:spTree>
   </p:cSld>
   <p:clrMapOvr>
@@ -3578,7 +3668,7 @@
         </p:nvSpPr>
         <p:spPr>
           <a:xfrm>
-            <a:off x="731520" y="411480"/>
+            <a:off x="731520" y="365760"/>
             <a:ext cx="10698480" cy="1005840"/>
           </a:xfrm>
           <a:prstGeom prst="rect">
@@ -3594,28 +3684,28 @@
           <a:p>
             <a:pPr>
               <a:spcAft>
-                <a:spcPts val="300"/>
-              </a:spcAft>
-              <a:defRPr sz="1050" b="1">
+                <a:spcPts val="200"/>
+              </a:spcAft>
+              <a:defRPr sz="1000" b="1">
                 <a:solidFill>
                   <a:srgbClr val="FFB612"/>
                 </a:solidFill>
               </a:defRPr>
             </a:pPr>
             <a:r>
-              <a:t>RETORNO DE INVERSIÓN</a:t>
-            </a:r>
-          </a:p>
-          <a:p>
-            <a:pPr>
-              <a:defRPr sz="2400" b="1">
+              <a:t>EQUIPO DE SERVICIO</a:t>
+            </a:r>
+          </a:p>
+          <a:p>
+            <a:pPr>
+              <a:defRPr sz="2300" b="1">
                 <a:solidFill>
                   <a:srgbClr val="FFFFFF"/>
                 </a:solidFill>
               </a:defRPr>
             </a:pPr>
             <a:r>
-              <a:t>Métricas Clave de Negocio (KPIs y Rentabilidad)</a:t>
+              <a:t>Gamificación del Personal: Meseros como Embajadores</a:t>
             </a:r>
           </a:p>
         </p:txBody>
@@ -3629,7 +3719,7 @@
         <p:spPr>
           <a:xfrm>
             <a:off x="731520" y="1645920"/>
-            <a:ext cx="2499055" cy="4572000"/>
+            <a:ext cx="6858000" cy="4663440"/>
           </a:xfrm>
           <a:prstGeom prst="roundRect">
             <a:avLst/>
@@ -3673,8 +3763,8 @@
         </p:nvSpPr>
         <p:spPr>
           <a:xfrm>
-            <a:off x="914400" y="1920240"/>
-            <a:ext cx="2133295" cy="4023360"/>
+            <a:off x="1005840" y="1828800"/>
+            <a:ext cx="6309360" cy="4206240"/>
           </a:xfrm>
           <a:prstGeom prst="rect">
             <a:avLst/>
@@ -3687,379 +3777,151 @@
           </a:bodyPr>
           <a:lstStyle/>
           <a:p>
-            <a:pPr algn="ctr">
-              <a:spcAft>
-                <a:spcPts val="400"/>
-              </a:spcAft>
-              <a:defRPr sz="3600" b="1">
+            <a:pPr>
+              <a:spcAft>
+                <a:spcPts val="200"/>
+              </a:spcAft>
+              <a:defRPr sz="1350" b="1">
                 <a:solidFill>
                   <a:srgbClr val="FFB612"/>
                 </a:solidFill>
               </a:defRPr>
             </a:pPr>
             <a:r>
-              <a:t>+35%</a:t>
-            </a:r>
-          </a:p>
-          <a:p>
-            <a:pPr algn="ctr">
-              <a:spcAft>
-                <a:spcPts val="1400"/>
-              </a:spcAft>
-              <a:defRPr sz="1100" b="1">
+              <a:t>🙋 Atribución Clara en Cada Mesa</a:t>
+            </a:r>
+          </a:p>
+          <a:p>
+            <a:pPr>
+              <a:spcAft>
+                <a:spcPts val="1000"/>
+              </a:spcAft>
+              <a:defRPr sz="1150">
+                <a:solidFill>
+                  <a:srgbClr val="FFFFFF"/>
+                </a:solidFill>
+              </a:defRPr>
+            </a:pPr>
+            <a:r>
+              <a:t>Al registrar sus pronósticos, el cliente selecciona el nombre de su mesero en la lista. La gerencia sabe con métricas exactas qué meseros están invitando activamente y cuáles no.</a:t>
+            </a:r>
+          </a:p>
+          <a:p>
+            <a:pPr>
+              <a:spcAft>
+                <a:spcPts val="200"/>
+              </a:spcAft>
+              <a:defRPr sz="1350" b="1">
                 <a:solidFill>
                   <a:srgbClr val="FFB612"/>
                 </a:solidFill>
               </a:defRPr>
             </a:pPr>
             <a:r>
-              <a:t>PERMANENCIA (DWELL TIME)</a:t>
-            </a:r>
-          </a:p>
-          <a:p>
-            <a:pPr algn="ctr">
+              <a:t>💰 Incentivo Económico Directo (Más Propina)</a:t>
+            </a:r>
+          </a:p>
+          <a:p>
+            <a:pPr>
+              <a:spcAft>
+                <a:spcPts val="1000"/>
+              </a:spcAft>
               <a:defRPr sz="1150">
                 <a:solidFill>
-                  <a:srgbClr val="94A3B8"/>
-                </a:solidFill>
-              </a:defRPr>
-            </a:pPr>
-            <a:r>
-              <a:t>Las mesas se quedan hasta el silbatazo final para ver si ganan su quiniela.</a:t>
-            </a:r>
-          </a:p>
-        </p:txBody>
-      </p:sp>
-      <p:sp>
-        <p:nvSpPr>
-          <p:cNvPr id="5" name="Rounded Rectangle 4"/>
-          <p:cNvSpPr/>
+                  <a:srgbClr val="FFFFFF"/>
+                </a:solidFill>
+              </a:defRPr>
+            </a:pPr>
+            <a:r>
+              <a:t>Los meseros comprenden la fórmula de inmediato: Si la mesa se queda 3 horas compitiendo, consumirá más rondas de cerveza, hamburguesas y alitas, lo que elevará el total de la cuenta y su propina.</a:t>
+            </a:r>
+          </a:p>
+          <a:p>
+            <a:pPr>
+              <a:spcAft>
+                <a:spcPts val="200"/>
+              </a:spcAft>
+              <a:defRPr sz="1350" b="1">
+                <a:solidFill>
+                  <a:srgbClr val="FFB612"/>
+                </a:solidFill>
+              </a:defRPr>
+            </a:pPr>
+            <a:r>
+              <a:t>💬 Rompehielos Natural de Venta Sugerida</a:t>
+            </a:r>
+          </a:p>
+          <a:p>
+            <a:pPr>
+              <a:spcAft>
+                <a:spcPts val="1000"/>
+              </a:spcAft>
+              <a:defRPr sz="1150">
+                <a:solidFill>
+                  <a:srgbClr val="FFFFFF"/>
+                </a:solidFill>
+              </a:defRPr>
+            </a:pPr>
+            <a:r>
+              <a:t>En lugar del genérico '¿Se les ofrece algo más?', el mesero llega sonriendo: '¿Ya metieron su quiniela de hoy con mi nombre? Si ganan, ¡la casa les invita unas alitas!'.</a:t>
+            </a:r>
+          </a:p>
+          <a:p>
+            <a:pPr>
+              <a:spcAft>
+                <a:spcPts val="200"/>
+              </a:spcAft>
+              <a:defRPr sz="1350" b="1">
+                <a:solidFill>
+                  <a:srgbClr val="FFB612"/>
+                </a:solidFill>
+              </a:defRPr>
+            </a:pPr>
+            <a:r>
+              <a:t>🏆 Competencia Interna del Equipo</a:t>
+            </a:r>
+          </a:p>
+          <a:p>
+            <a:pPr>
+              <a:spcAft>
+                <a:spcPts val="1000"/>
+              </a:spcAft>
+              <a:defRPr sz="1150">
+                <a:solidFill>
+                  <a:srgbClr val="FFFFFF"/>
+                </a:solidFill>
+              </a:defRPr>
+            </a:pPr>
+            <a:r>
+              <a:t>Se puede premiar al mesero con más comensales registrados en la semana con turnos preferenciales o un reconocimiento en la junta semanal.</a:t>
+            </a:r>
+          </a:p>
+        </p:txBody>
+      </p:sp>
+      <p:pic>
+        <p:nvPicPr>
+          <p:cNvPr id="5" name="Picture 4" descr="screenshot_admin_player.png"/>
+          <p:cNvPicPr>
+            <a:picLocks noChangeAspect="1"/>
+          </p:cNvPicPr>
           <p:nvPr/>
-        </p:nvSpPr>
-        <p:spPr>
-          <a:xfrm>
-            <a:off x="3474720" y="1645920"/>
-            <a:ext cx="2499055" cy="4572000"/>
-          </a:xfrm>
-          <a:prstGeom prst="roundRect">
-            <a:avLst/>
-          </a:prstGeom>
-          <a:solidFill>
-            <a:srgbClr val="141A26"/>
-          </a:solidFill>
-          <a:ln w="19050">
-            <a:solidFill>
-              <a:srgbClr val="283246"/>
-            </a:solidFill>
-          </a:ln>
-        </p:spPr>
-        <p:style>
-          <a:lnRef idx="1">
-            <a:schemeClr val="accent1"/>
-          </a:lnRef>
-          <a:fillRef idx="3">
-            <a:schemeClr val="accent1"/>
-          </a:fillRef>
-          <a:effectRef idx="2">
-            <a:schemeClr val="accent1"/>
-          </a:effectRef>
-          <a:fontRef idx="minor">
-            <a:schemeClr val="lt1"/>
-          </a:fontRef>
-        </p:style>
-        <p:txBody>
-          <a:bodyPr rtlCol="0" anchor="ctr"/>
-          <a:lstStyle/>
-          <a:p>
-            <a:pPr algn="ctr"/>
-          </a:p>
-        </p:txBody>
-      </p:sp>
-      <p:sp>
-        <p:nvSpPr>
-          <p:cNvPr id="6" name="TextBox 5"/>
-          <p:cNvSpPr txBox="1"/>
-          <p:nvPr/>
-        </p:nvSpPr>
-        <p:spPr>
-          <a:xfrm>
-            <a:off x="3657600" y="1920240"/>
-            <a:ext cx="2133295" cy="4023360"/>
+        </p:nvPicPr>
+        <p:blipFill>
+          <a:blip r:embed="rId2"/>
+          <a:stretch>
+            <a:fillRect/>
+          </a:stretch>
+        </p:blipFill>
+        <p:spPr>
+          <a:xfrm>
+            <a:off x="7863840" y="1828800"/>
+            <a:ext cx="3566160" cy="1308612"/>
           </a:xfrm>
           <a:prstGeom prst="rect">
             <a:avLst/>
           </a:prstGeom>
-          <a:noFill/>
-        </p:spPr>
-        <p:txBody>
-          <a:bodyPr wrap="square">
-            <a:spAutoFit/>
-          </a:bodyPr>
-          <a:lstStyle/>
-          <a:p>
-            <a:pPr algn="ctr">
-              <a:spcAft>
-                <a:spcPts val="400"/>
-              </a:spcAft>
-              <a:defRPr sz="3600" b="1">
-                <a:solidFill>
-                  <a:srgbClr val="00E676"/>
-                </a:solidFill>
-              </a:defRPr>
-            </a:pPr>
-            <a:r>
-              <a:t>+22%</a:t>
-            </a:r>
-          </a:p>
-          <a:p>
-            <a:pPr algn="ctr">
-              <a:spcAft>
-                <a:spcPts val="1400"/>
-              </a:spcAft>
-              <a:defRPr sz="1100" b="1">
-                <a:solidFill>
-                  <a:srgbClr val="FFB612"/>
-                </a:solidFill>
-              </a:defRPr>
-            </a:pPr>
-            <a:r>
-              <a:t>TICKET PROMEDIO (AOV)</a:t>
-            </a:r>
-          </a:p>
-          <a:p>
-            <a:pPr algn="ctr">
-              <a:defRPr sz="1150">
-                <a:solidFill>
-                  <a:srgbClr val="94A3B8"/>
-                </a:solidFill>
-              </a:defRPr>
-            </a:pPr>
-            <a:r>
-              <a:t>El ambiente competitivo estimula pedidos repetidos de cerveza y botanas.</a:t>
-            </a:r>
-          </a:p>
-        </p:txBody>
-      </p:sp>
-      <p:sp>
-        <p:nvSpPr>
-          <p:cNvPr id="7" name="Rounded Rectangle 6"/>
-          <p:cNvSpPr/>
-          <p:nvPr/>
-        </p:nvSpPr>
-        <p:spPr>
-          <a:xfrm>
-            <a:off x="6217920" y="1645920"/>
-            <a:ext cx="2499055" cy="4572000"/>
-          </a:xfrm>
-          <a:prstGeom prst="roundRect">
-            <a:avLst/>
-          </a:prstGeom>
-          <a:solidFill>
-            <a:srgbClr val="141A26"/>
-          </a:solidFill>
-          <a:ln w="19050">
-            <a:solidFill>
-              <a:srgbClr val="283246"/>
-            </a:solidFill>
-          </a:ln>
-        </p:spPr>
-        <p:style>
-          <a:lnRef idx="1">
-            <a:schemeClr val="accent1"/>
-          </a:lnRef>
-          <a:fillRef idx="3">
-            <a:schemeClr val="accent1"/>
-          </a:fillRef>
-          <a:effectRef idx="2">
-            <a:schemeClr val="accent1"/>
-          </a:effectRef>
-          <a:fontRef idx="minor">
-            <a:schemeClr val="lt1"/>
-          </a:fontRef>
-        </p:style>
-        <p:txBody>
-          <a:bodyPr rtlCol="0" anchor="ctr"/>
-          <a:lstStyle/>
-          <a:p>
-            <a:pPr algn="ctr"/>
-          </a:p>
-        </p:txBody>
-      </p:sp>
-      <p:sp>
-        <p:nvSpPr>
-          <p:cNvPr id="8" name="TextBox 7"/>
-          <p:cNvSpPr txBox="1"/>
-          <p:nvPr/>
-        </p:nvSpPr>
-        <p:spPr>
-          <a:xfrm>
-            <a:off x="6400800" y="1920240"/>
-            <a:ext cx="2133295" cy="4023360"/>
-          </a:xfrm>
-          <a:prstGeom prst="rect">
-            <a:avLst/>
-          </a:prstGeom>
-          <a:noFill/>
-        </p:spPr>
-        <p:txBody>
-          <a:bodyPr wrap="square">
-            <a:spAutoFit/>
-          </a:bodyPr>
-          <a:lstStyle/>
-          <a:p>
-            <a:pPr algn="ctr">
-              <a:spcAft>
-                <a:spcPts val="400"/>
-              </a:spcAft>
-              <a:defRPr sz="3600" b="1">
-                <a:solidFill>
-                  <a:srgbClr val="FF5722"/>
-                </a:solidFill>
-              </a:defRPr>
-            </a:pPr>
-            <a:r>
-              <a:t>3x</a:t>
-            </a:r>
-          </a:p>
-          <a:p>
-            <a:pPr algn="ctr">
-              <a:spcAft>
-                <a:spcPts val="1400"/>
-              </a:spcAft>
-              <a:defRPr sz="1100" b="1">
-                <a:solidFill>
-                  <a:srgbClr val="FFB612"/>
-                </a:solidFill>
-              </a:defRPr>
-            </a:pPr>
-            <a:r>
-              <a:t>RETENCIÓN Y LEALTAD</a:t>
-            </a:r>
-          </a:p>
-          <a:p>
-            <a:pPr algn="ctr">
-              <a:defRPr sz="1150">
-                <a:solidFill>
-                  <a:srgbClr val="94A3B8"/>
-                </a:solidFill>
-              </a:defRPr>
-            </a:pPr>
-            <a:r>
-              <a:t>El comensal regresa jornada tras jornada para defender su posición en la tabla.</a:t>
-            </a:r>
-          </a:p>
-        </p:txBody>
-      </p:sp>
-      <p:sp>
-        <p:nvSpPr>
-          <p:cNvPr id="9" name="Rounded Rectangle 8"/>
-          <p:cNvSpPr/>
-          <p:nvPr/>
-        </p:nvSpPr>
-        <p:spPr>
-          <a:xfrm>
-            <a:off x="8961120" y="1645920"/>
-            <a:ext cx="2499055" cy="4572000"/>
-          </a:xfrm>
-          <a:prstGeom prst="roundRect">
-            <a:avLst/>
-          </a:prstGeom>
-          <a:solidFill>
-            <a:srgbClr val="141A26"/>
-          </a:solidFill>
-          <a:ln w="19050">
-            <a:solidFill>
-              <a:srgbClr val="283246"/>
-            </a:solidFill>
-          </a:ln>
-        </p:spPr>
-        <p:style>
-          <a:lnRef idx="1">
-            <a:schemeClr val="accent1"/>
-          </a:lnRef>
-          <a:fillRef idx="3">
-            <a:schemeClr val="accent1"/>
-          </a:fillRef>
-          <a:effectRef idx="2">
-            <a:schemeClr val="accent1"/>
-          </a:effectRef>
-          <a:fontRef idx="minor">
-            <a:schemeClr val="lt1"/>
-          </a:fontRef>
-        </p:style>
-        <p:txBody>
-          <a:bodyPr rtlCol="0" anchor="ctr"/>
-          <a:lstStyle/>
-          <a:p>
-            <a:pPr algn="ctr"/>
-          </a:p>
-        </p:txBody>
-      </p:sp>
-      <p:sp>
-        <p:nvSpPr>
-          <p:cNvPr id="10" name="TextBox 9"/>
-          <p:cNvSpPr txBox="1"/>
-          <p:nvPr/>
-        </p:nvSpPr>
-        <p:spPr>
-          <a:xfrm>
-            <a:off x="9144000" y="1920240"/>
-            <a:ext cx="2133295" cy="4023360"/>
-          </a:xfrm>
-          <a:prstGeom prst="rect">
-            <a:avLst/>
-          </a:prstGeom>
-          <a:noFill/>
-        </p:spPr>
-        <p:txBody>
-          <a:bodyPr wrap="square">
-            <a:spAutoFit/>
-          </a:bodyPr>
-          <a:lstStyle/>
-          <a:p>
-            <a:pPr algn="ctr">
-              <a:spcAft>
-                <a:spcPts val="400"/>
-              </a:spcAft>
-              <a:defRPr sz="3600" b="1">
-                <a:solidFill>
-                  <a:srgbClr val="FFFFFF"/>
-                </a:solidFill>
-              </a:defRPr>
-            </a:pPr>
-            <a:r>
-              <a:t>$0</a:t>
-            </a:r>
-          </a:p>
-          <a:p>
-            <a:pPr algn="ctr">
-              <a:spcAft>
-                <a:spcPts val="1400"/>
-              </a:spcAft>
-              <a:defRPr sz="1100" b="1">
-                <a:solidFill>
-                  <a:srgbClr val="FFB612"/>
-                </a:solidFill>
-              </a:defRPr>
-            </a:pPr>
-            <a:r>
-              <a:t>COSTO DE PAPELERÍA</a:t>
-            </a:r>
-          </a:p>
-          <a:p>
-            <a:pPr algn="ctr">
-              <a:defRPr sz="1150">
-                <a:solidFill>
-                  <a:srgbClr val="94A3B8"/>
-                </a:solidFill>
-              </a:defRPr>
-            </a:pPr>
-            <a:r>
-              <a:t>Eliminación total de impresiones, papeletas extraviadas y errores de conteo.</a:t>
-            </a:r>
-          </a:p>
-        </p:txBody>
-      </p:sp>
+        </p:spPr>
+      </p:pic>
     </p:spTree>
   </p:cSld>
   <p:clrMapOvr>
@@ -4094,7 +3956,7 @@
         </p:nvSpPr>
         <p:spPr>
           <a:xfrm>
-            <a:off x="731520" y="411480"/>
+            <a:off x="731520" y="365760"/>
             <a:ext cx="10698480" cy="1005840"/>
           </a:xfrm>
           <a:prstGeom prst="rect">
@@ -4110,28 +3972,28 @@
           <a:p>
             <a:pPr>
               <a:spcAft>
-                <a:spcPts val="300"/>
-              </a:spcAft>
-              <a:defRPr sz="1050" b="1">
+                <a:spcPts val="200"/>
+              </a:spcAft>
+              <a:defRPr sz="1000" b="1">
                 <a:solidFill>
                   <a:srgbClr val="FFB612"/>
                 </a:solidFill>
               </a:defRPr>
             </a:pPr>
             <a:r>
-              <a:t>PRÓXIMOS PASOS</a:t>
-            </a:r>
-          </a:p>
-          <a:p>
-            <a:pPr>
-              <a:defRPr sz="2400" b="1">
+              <a:t>CALENDARIO INTELIGENTE</a:t>
+            </a:r>
+          </a:p>
+          <a:p>
+            <a:pPr>
+              <a:defRPr sz="2300" b="1">
                 <a:solidFill>
                   <a:srgbClr val="FFFFFF"/>
                 </a:solidFill>
               </a:defRPr>
             </a:pPr>
             <a:r>
-              <a:t>Plan de Acción: Lanzamiento Piloto en Querétaro</a:t>
+              <a:t>Estrategia Gradual: El Juego Indicado en el Momento Indicado</a:t>
             </a:r>
           </a:p>
         </p:txBody>
@@ -4145,7 +4007,7 @@
         <p:spPr>
           <a:xfrm>
             <a:off x="731520" y="1645920"/>
-            <a:ext cx="10728655" cy="4572000"/>
+            <a:ext cx="10728655" cy="4663440"/>
           </a:xfrm>
           <a:prstGeom prst="roundRect">
             <a:avLst/>
@@ -4189,8 +4051,8 @@
         </p:nvSpPr>
         <p:spPr>
           <a:xfrm>
-            <a:off x="1097280" y="1920240"/>
-            <a:ext cx="9966960" cy="4023360"/>
+            <a:off x="1097280" y="1828800"/>
+            <a:ext cx="9966960" cy="4206240"/>
           </a:xfrm>
           <a:prstGeom prst="rect">
             <a:avLst/>
@@ -4205,15 +4067,810 @@
           <a:p>
             <a:pPr>
               <a:spcAft>
+                <a:spcPts val="1200"/>
+              </a:spcAft>
+              <a:defRPr sz="1700" b="1">
+                <a:solidFill>
+                  <a:srgbClr val="FFB612"/>
+                </a:solidFill>
+              </a:defRPr>
+            </a:pPr>
+            <a:r>
+              <a:t>🎯 Menos es Más: La Calidad del Momento vs Saturación</a:t>
+            </a:r>
+          </a:p>
+          <a:p>
+            <a:pPr>
+              <a:spcAft>
                 <a:spcPts val="200"/>
               </a:spcAft>
-              <a:defRPr sz="1450" b="1">
+              <a:defRPr sz="1400" b="1">
+                <a:solidFill>
+                  <a:srgbClr val="FFD100"/>
+                </a:solidFill>
+              </a:defRPr>
+            </a:pPr>
+            <a:r>
+              <a:t>🚫 No Jugar Todos los Juegos Todos los Días</a:t>
+            </a:r>
+          </a:p>
+          <a:p>
+            <a:pPr>
+              <a:spcAft>
+                <a:spcPts val="1000"/>
+              </a:spcAft>
+              <a:defRPr sz="1200">
+                <a:solidFill>
+                  <a:srgbClr val="FFFFFF"/>
+                </a:solidFill>
+              </a:defRPr>
+            </a:pPr>
+            <a:r>
+              <a:t>Saturar al cliente o al personal con 5 juegos simultáneos genera fatiga y desinterés. La experiencia debe sentirse especial y esperada cada fin de semana.</a:t>
+            </a:r>
+          </a:p>
+          <a:p>
+            <a:pPr>
+              <a:spcAft>
+                <a:spcPts val="200"/>
+              </a:spcAft>
+              <a:defRPr sz="1400" b="1">
+                <a:solidFill>
+                  <a:srgbClr val="FFD100"/>
+                </a:solidFill>
+              </a:defRPr>
+            </a:pPr>
+            <a:r>
+              <a:t>📅 Jueves, Domingos y Lunes: Modo NFL</a:t>
+            </a:r>
+          </a:p>
+          <a:p>
+            <a:pPr>
+              <a:spcAft>
+                <a:spcPts val="1000"/>
+              </a:spcAft>
+              <a:defRPr sz="1200">
+                <a:solidFill>
+                  <a:srgbClr val="FFFFFF"/>
+                </a:solidFill>
+              </a:defRPr>
+            </a:pPr>
+            <a:r>
+              <a:t>Exclusivamente Quinielas de Semana NFL y Football Grids en partidos estelares de Steelers, Sunday Night y Monday Night.</a:t>
+            </a:r>
+          </a:p>
+          <a:p>
+            <a:pPr>
+              <a:spcAft>
+                <a:spcPts val="200"/>
+              </a:spcAft>
+              <a:defRPr sz="1400" b="1">
+                <a:solidFill>
+                  <a:srgbClr val="FFD100"/>
+                </a:solidFill>
+              </a:defRPr>
+            </a:pPr>
+            <a:r>
+              <a:t>⚽ Viernes, Sábados y Domingos: Modo Fútbol</a:t>
+            </a:r>
+          </a:p>
+          <a:p>
+            <a:pPr>
+              <a:spcAft>
+                <a:spcPts val="1000"/>
+              </a:spcAft>
+              <a:defRPr sz="1200">
+                <a:solidFill>
+                  <a:srgbClr val="FFFFFF"/>
+                </a:solidFill>
+              </a:defRPr>
+            </a:pPr>
+            <a:r>
+              <a:t>Quinielas de Jornada de Liga MX y dinámicas de First Striker en Clásicos y liguilla.</a:t>
+            </a:r>
+          </a:p>
+          <a:p>
+            <a:pPr>
+              <a:spcAft>
+                <a:spcPts val="200"/>
+              </a:spcAft>
+              <a:defRPr sz="1400" b="1">
+                <a:solidFill>
+                  <a:srgbClr val="FFD100"/>
+                </a:solidFill>
+              </a:defRPr>
+            </a:pPr>
+            <a:r>
+              <a:t>🧠 Medios Tiempos Selectos: Modo Trivia</a:t>
+            </a:r>
+          </a:p>
+          <a:p>
+            <a:pPr>
+              <a:spcAft>
+                <a:spcPts val="1000"/>
+              </a:spcAft>
+              <a:defRPr sz="1200">
+                <a:solidFill>
+                  <a:srgbClr val="FFFFFF"/>
+                </a:solidFill>
+              </a:defRPr>
+            </a:pPr>
+            <a:r>
+              <a:t>Trivias de 10 minutos exclusivamente en el medio tiempo de partidos de alta audiencia para mantener a la gente entretenida mientras no hay jugadas.</a:t>
+            </a:r>
+          </a:p>
+        </p:txBody>
+      </p:sp>
+    </p:spTree>
+  </p:cSld>
+  <p:clrMapOvr>
+    <a:masterClrMapping/>
+  </p:clrMapOvr>
+</p:sld>
+</file>
+
+<file path=ppt/slides/slide13.xml><?xml version="1.0" encoding="utf-8"?>
+<p:sld xmlns:a="http://schemas.openxmlformats.org/drawingml/2006/main" xmlns:p="http://schemas.openxmlformats.org/presentationml/2006/main" xmlns:r="http://schemas.openxmlformats.org/officeDocument/2006/relationships">
+  <p:cSld>
+    <p:bg>
+      <p:bgPr>
+        <a:solidFill>
+          <a:srgbClr val="0B0F17"/>
+        </a:solidFill>
+        <a:effectLst/>
+      </p:bgPr>
+    </p:bg>
+    <p:spTree>
+      <p:nvGrpSpPr>
+        <p:cNvPr id="1" name=""/>
+        <p:cNvGrpSpPr/>
+        <p:nvPr/>
+      </p:nvGrpSpPr>
+      <p:grpSpPr/>
+      <p:sp>
+        <p:nvSpPr>
+          <p:cNvPr id="2" name="TextBox 1"/>
+          <p:cNvSpPr txBox="1"/>
+          <p:nvPr/>
+        </p:nvSpPr>
+        <p:spPr>
+          <a:xfrm>
+            <a:off x="731520" y="365760"/>
+            <a:ext cx="10698480" cy="1005840"/>
+          </a:xfrm>
+          <a:prstGeom prst="rect">
+            <a:avLst/>
+          </a:prstGeom>
+          <a:noFill/>
+        </p:spPr>
+        <p:txBody>
+          <a:bodyPr wrap="square" lIns="0" tIns="0" rIns="0" bIns="0">
+            <a:spAutoFit/>
+          </a:bodyPr>
+          <a:lstStyle/>
+          <a:p>
+            <a:pPr>
+              <a:spcAft>
+                <a:spcPts val="200"/>
+              </a:spcAft>
+              <a:defRPr sz="1000" b="1">
                 <a:solidFill>
                   <a:srgbClr val="FFB612"/>
                 </a:solidFill>
               </a:defRPr>
             </a:pPr>
             <a:r>
+              <a:t>RETORNO DE INVERSIÓN</a:t>
+            </a:r>
+          </a:p>
+          <a:p>
+            <a:pPr>
+              <a:defRPr sz="2300" b="1">
+                <a:solidFill>
+                  <a:srgbClr val="FFFFFF"/>
+                </a:solidFill>
+              </a:defRPr>
+            </a:pPr>
+            <a:r>
+              <a:t>Métricas Clave de Negocio (KPIs y Rentabilidad)</a:t>
+            </a:r>
+          </a:p>
+        </p:txBody>
+      </p:sp>
+      <p:sp>
+        <p:nvSpPr>
+          <p:cNvPr id="3" name="Rounded Rectangle 2"/>
+          <p:cNvSpPr/>
+          <p:nvPr/>
+        </p:nvSpPr>
+        <p:spPr>
+          <a:xfrm>
+            <a:off x="731520" y="1645920"/>
+            <a:ext cx="2499055" cy="4663440"/>
+          </a:xfrm>
+          <a:prstGeom prst="roundRect">
+            <a:avLst/>
+          </a:prstGeom>
+          <a:solidFill>
+            <a:srgbClr val="141A26"/>
+          </a:solidFill>
+          <a:ln w="19050">
+            <a:solidFill>
+              <a:srgbClr val="283246"/>
+            </a:solidFill>
+          </a:ln>
+        </p:spPr>
+        <p:style>
+          <a:lnRef idx="1">
+            <a:schemeClr val="accent1"/>
+          </a:lnRef>
+          <a:fillRef idx="3">
+            <a:schemeClr val="accent1"/>
+          </a:fillRef>
+          <a:effectRef idx="2">
+            <a:schemeClr val="accent1"/>
+          </a:effectRef>
+          <a:fontRef idx="minor">
+            <a:schemeClr val="lt1"/>
+          </a:fontRef>
+        </p:style>
+        <p:txBody>
+          <a:bodyPr rtlCol="0" anchor="ctr"/>
+          <a:lstStyle/>
+          <a:p>
+            <a:pPr algn="ctr"/>
+          </a:p>
+        </p:txBody>
+      </p:sp>
+      <p:sp>
+        <p:nvSpPr>
+          <p:cNvPr id="4" name="TextBox 3"/>
+          <p:cNvSpPr txBox="1"/>
+          <p:nvPr/>
+        </p:nvSpPr>
+        <p:spPr>
+          <a:xfrm>
+            <a:off x="914400" y="1920240"/>
+            <a:ext cx="2133295" cy="4114800"/>
+          </a:xfrm>
+          <a:prstGeom prst="rect">
+            <a:avLst/>
+          </a:prstGeom>
+          <a:noFill/>
+        </p:spPr>
+        <p:txBody>
+          <a:bodyPr wrap="square">
+            <a:spAutoFit/>
+          </a:bodyPr>
+          <a:lstStyle/>
+          <a:p>
+            <a:pPr algn="ctr">
+              <a:spcAft>
+                <a:spcPts val="400"/>
+              </a:spcAft>
+              <a:defRPr sz="3600" b="1">
+                <a:solidFill>
+                  <a:srgbClr val="FFB612"/>
+                </a:solidFill>
+              </a:defRPr>
+            </a:pPr>
+            <a:r>
+              <a:t>+35%</a:t>
+            </a:r>
+          </a:p>
+          <a:p>
+            <a:pPr algn="ctr">
+              <a:spcAft>
+                <a:spcPts val="1400"/>
+              </a:spcAft>
+              <a:defRPr sz="1100" b="1">
+                <a:solidFill>
+                  <a:srgbClr val="FFB612"/>
+                </a:solidFill>
+              </a:defRPr>
+            </a:pPr>
+            <a:r>
+              <a:t>PERMANENCIA (DWELL TIME)</a:t>
+            </a:r>
+          </a:p>
+          <a:p>
+            <a:pPr algn="ctr">
+              <a:defRPr sz="1150">
+                <a:solidFill>
+                  <a:srgbClr val="94A3B8"/>
+                </a:solidFill>
+              </a:defRPr>
+            </a:pPr>
+            <a:r>
+              <a:t>Las mesas se quedan hasta el silbatazo final para ver si ganan su quiniela.</a:t>
+            </a:r>
+          </a:p>
+        </p:txBody>
+      </p:sp>
+      <p:sp>
+        <p:nvSpPr>
+          <p:cNvPr id="5" name="Rounded Rectangle 4"/>
+          <p:cNvSpPr/>
+          <p:nvPr/>
+        </p:nvSpPr>
+        <p:spPr>
+          <a:xfrm>
+            <a:off x="3474720" y="1645920"/>
+            <a:ext cx="2499055" cy="4663440"/>
+          </a:xfrm>
+          <a:prstGeom prst="roundRect">
+            <a:avLst/>
+          </a:prstGeom>
+          <a:solidFill>
+            <a:srgbClr val="141A26"/>
+          </a:solidFill>
+          <a:ln w="19050">
+            <a:solidFill>
+              <a:srgbClr val="283246"/>
+            </a:solidFill>
+          </a:ln>
+        </p:spPr>
+        <p:style>
+          <a:lnRef idx="1">
+            <a:schemeClr val="accent1"/>
+          </a:lnRef>
+          <a:fillRef idx="3">
+            <a:schemeClr val="accent1"/>
+          </a:fillRef>
+          <a:effectRef idx="2">
+            <a:schemeClr val="accent1"/>
+          </a:effectRef>
+          <a:fontRef idx="minor">
+            <a:schemeClr val="lt1"/>
+          </a:fontRef>
+        </p:style>
+        <p:txBody>
+          <a:bodyPr rtlCol="0" anchor="ctr"/>
+          <a:lstStyle/>
+          <a:p>
+            <a:pPr algn="ctr"/>
+          </a:p>
+        </p:txBody>
+      </p:sp>
+      <p:sp>
+        <p:nvSpPr>
+          <p:cNvPr id="6" name="TextBox 5"/>
+          <p:cNvSpPr txBox="1"/>
+          <p:nvPr/>
+        </p:nvSpPr>
+        <p:spPr>
+          <a:xfrm>
+            <a:off x="3657600" y="1920240"/>
+            <a:ext cx="2133295" cy="4114800"/>
+          </a:xfrm>
+          <a:prstGeom prst="rect">
+            <a:avLst/>
+          </a:prstGeom>
+          <a:noFill/>
+        </p:spPr>
+        <p:txBody>
+          <a:bodyPr wrap="square">
+            <a:spAutoFit/>
+          </a:bodyPr>
+          <a:lstStyle/>
+          <a:p>
+            <a:pPr algn="ctr">
+              <a:spcAft>
+                <a:spcPts val="400"/>
+              </a:spcAft>
+              <a:defRPr sz="3600" b="1">
+                <a:solidFill>
+                  <a:srgbClr val="00E676"/>
+                </a:solidFill>
+              </a:defRPr>
+            </a:pPr>
+            <a:r>
+              <a:t>+22%</a:t>
+            </a:r>
+          </a:p>
+          <a:p>
+            <a:pPr algn="ctr">
+              <a:spcAft>
+                <a:spcPts val="1400"/>
+              </a:spcAft>
+              <a:defRPr sz="1100" b="1">
+                <a:solidFill>
+                  <a:srgbClr val="FFB612"/>
+                </a:solidFill>
+              </a:defRPr>
+            </a:pPr>
+            <a:r>
+              <a:t>TICKET PROMEDIO (AOV)</a:t>
+            </a:r>
+          </a:p>
+          <a:p>
+            <a:pPr algn="ctr">
+              <a:defRPr sz="1150">
+                <a:solidFill>
+                  <a:srgbClr val="94A3B8"/>
+                </a:solidFill>
+              </a:defRPr>
+            </a:pPr>
+            <a:r>
+              <a:t>El ambiente competitivo estimula pedidos repetidos de cerveza y botanas.</a:t>
+            </a:r>
+          </a:p>
+        </p:txBody>
+      </p:sp>
+      <p:sp>
+        <p:nvSpPr>
+          <p:cNvPr id="7" name="Rounded Rectangle 6"/>
+          <p:cNvSpPr/>
+          <p:nvPr/>
+        </p:nvSpPr>
+        <p:spPr>
+          <a:xfrm>
+            <a:off x="6217920" y="1645920"/>
+            <a:ext cx="2499055" cy="4663440"/>
+          </a:xfrm>
+          <a:prstGeom prst="roundRect">
+            <a:avLst/>
+          </a:prstGeom>
+          <a:solidFill>
+            <a:srgbClr val="141A26"/>
+          </a:solidFill>
+          <a:ln w="19050">
+            <a:solidFill>
+              <a:srgbClr val="283246"/>
+            </a:solidFill>
+          </a:ln>
+        </p:spPr>
+        <p:style>
+          <a:lnRef idx="1">
+            <a:schemeClr val="accent1"/>
+          </a:lnRef>
+          <a:fillRef idx="3">
+            <a:schemeClr val="accent1"/>
+          </a:fillRef>
+          <a:effectRef idx="2">
+            <a:schemeClr val="accent1"/>
+          </a:effectRef>
+          <a:fontRef idx="minor">
+            <a:schemeClr val="lt1"/>
+          </a:fontRef>
+        </p:style>
+        <p:txBody>
+          <a:bodyPr rtlCol="0" anchor="ctr"/>
+          <a:lstStyle/>
+          <a:p>
+            <a:pPr algn="ctr"/>
+          </a:p>
+        </p:txBody>
+      </p:sp>
+      <p:sp>
+        <p:nvSpPr>
+          <p:cNvPr id="8" name="TextBox 7"/>
+          <p:cNvSpPr txBox="1"/>
+          <p:nvPr/>
+        </p:nvSpPr>
+        <p:spPr>
+          <a:xfrm>
+            <a:off x="6400800" y="1920240"/>
+            <a:ext cx="2133295" cy="4114800"/>
+          </a:xfrm>
+          <a:prstGeom prst="rect">
+            <a:avLst/>
+          </a:prstGeom>
+          <a:noFill/>
+        </p:spPr>
+        <p:txBody>
+          <a:bodyPr wrap="square">
+            <a:spAutoFit/>
+          </a:bodyPr>
+          <a:lstStyle/>
+          <a:p>
+            <a:pPr algn="ctr">
+              <a:spcAft>
+                <a:spcPts val="400"/>
+              </a:spcAft>
+              <a:defRPr sz="3600" b="1">
+                <a:solidFill>
+                  <a:srgbClr val="FF5722"/>
+                </a:solidFill>
+              </a:defRPr>
+            </a:pPr>
+            <a:r>
+              <a:t>3x</a:t>
+            </a:r>
+          </a:p>
+          <a:p>
+            <a:pPr algn="ctr">
+              <a:spcAft>
+                <a:spcPts val="1400"/>
+              </a:spcAft>
+              <a:defRPr sz="1100" b="1">
+                <a:solidFill>
+                  <a:srgbClr val="FFB612"/>
+                </a:solidFill>
+              </a:defRPr>
+            </a:pPr>
+            <a:r>
+              <a:t>RETENCIÓN Y LEALTAD</a:t>
+            </a:r>
+          </a:p>
+          <a:p>
+            <a:pPr algn="ctr">
+              <a:defRPr sz="1150">
+                <a:solidFill>
+                  <a:srgbClr val="94A3B8"/>
+                </a:solidFill>
+              </a:defRPr>
+            </a:pPr>
+            <a:r>
+              <a:t>El comensal regresa jornada tras jornada para defender su posición en la tabla.</a:t>
+            </a:r>
+          </a:p>
+        </p:txBody>
+      </p:sp>
+      <p:sp>
+        <p:nvSpPr>
+          <p:cNvPr id="9" name="Rounded Rectangle 8"/>
+          <p:cNvSpPr/>
+          <p:nvPr/>
+        </p:nvSpPr>
+        <p:spPr>
+          <a:xfrm>
+            <a:off x="8961120" y="1645920"/>
+            <a:ext cx="2499055" cy="4663440"/>
+          </a:xfrm>
+          <a:prstGeom prst="roundRect">
+            <a:avLst/>
+          </a:prstGeom>
+          <a:solidFill>
+            <a:srgbClr val="141A26"/>
+          </a:solidFill>
+          <a:ln w="19050">
+            <a:solidFill>
+              <a:srgbClr val="283246"/>
+            </a:solidFill>
+          </a:ln>
+        </p:spPr>
+        <p:style>
+          <a:lnRef idx="1">
+            <a:schemeClr val="accent1"/>
+          </a:lnRef>
+          <a:fillRef idx="3">
+            <a:schemeClr val="accent1"/>
+          </a:fillRef>
+          <a:effectRef idx="2">
+            <a:schemeClr val="accent1"/>
+          </a:effectRef>
+          <a:fontRef idx="minor">
+            <a:schemeClr val="lt1"/>
+          </a:fontRef>
+        </p:style>
+        <p:txBody>
+          <a:bodyPr rtlCol="0" anchor="ctr"/>
+          <a:lstStyle/>
+          <a:p>
+            <a:pPr algn="ctr"/>
+          </a:p>
+        </p:txBody>
+      </p:sp>
+      <p:sp>
+        <p:nvSpPr>
+          <p:cNvPr id="10" name="TextBox 9"/>
+          <p:cNvSpPr txBox="1"/>
+          <p:nvPr/>
+        </p:nvSpPr>
+        <p:spPr>
+          <a:xfrm>
+            <a:off x="9144000" y="1920240"/>
+            <a:ext cx="2133295" cy="4114800"/>
+          </a:xfrm>
+          <a:prstGeom prst="rect">
+            <a:avLst/>
+          </a:prstGeom>
+          <a:noFill/>
+        </p:spPr>
+        <p:txBody>
+          <a:bodyPr wrap="square">
+            <a:spAutoFit/>
+          </a:bodyPr>
+          <a:lstStyle/>
+          <a:p>
+            <a:pPr algn="ctr">
+              <a:spcAft>
+                <a:spcPts val="400"/>
+              </a:spcAft>
+              <a:defRPr sz="3600" b="1">
+                <a:solidFill>
+                  <a:srgbClr val="FFFFFF"/>
+                </a:solidFill>
+              </a:defRPr>
+            </a:pPr>
+            <a:r>
+              <a:t>$0</a:t>
+            </a:r>
+          </a:p>
+          <a:p>
+            <a:pPr algn="ctr">
+              <a:spcAft>
+                <a:spcPts val="1400"/>
+              </a:spcAft>
+              <a:defRPr sz="1100" b="1">
+                <a:solidFill>
+                  <a:srgbClr val="FFB612"/>
+                </a:solidFill>
+              </a:defRPr>
+            </a:pPr>
+            <a:r>
+              <a:t>COSTO DE PAPELERÍA</a:t>
+            </a:r>
+          </a:p>
+          <a:p>
+            <a:pPr algn="ctr">
+              <a:defRPr sz="1150">
+                <a:solidFill>
+                  <a:srgbClr val="94A3B8"/>
+                </a:solidFill>
+              </a:defRPr>
+            </a:pPr>
+            <a:r>
+              <a:t>Eliminación total de impresiones, papeletas extraviadas y errores de conteo.</a:t>
+            </a:r>
+          </a:p>
+        </p:txBody>
+      </p:sp>
+    </p:spTree>
+  </p:cSld>
+  <p:clrMapOvr>
+    <a:masterClrMapping/>
+  </p:clrMapOvr>
+</p:sld>
+</file>
+
+<file path=ppt/slides/slide14.xml><?xml version="1.0" encoding="utf-8"?>
+<p:sld xmlns:a="http://schemas.openxmlformats.org/drawingml/2006/main" xmlns:p="http://schemas.openxmlformats.org/presentationml/2006/main" xmlns:r="http://schemas.openxmlformats.org/officeDocument/2006/relationships">
+  <p:cSld>
+    <p:bg>
+      <p:bgPr>
+        <a:solidFill>
+          <a:srgbClr val="0B0F17"/>
+        </a:solidFill>
+        <a:effectLst/>
+      </p:bgPr>
+    </p:bg>
+    <p:spTree>
+      <p:nvGrpSpPr>
+        <p:cNvPr id="1" name=""/>
+        <p:cNvGrpSpPr/>
+        <p:nvPr/>
+      </p:nvGrpSpPr>
+      <p:grpSpPr/>
+      <p:sp>
+        <p:nvSpPr>
+          <p:cNvPr id="2" name="TextBox 1"/>
+          <p:cNvSpPr txBox="1"/>
+          <p:nvPr/>
+        </p:nvSpPr>
+        <p:spPr>
+          <a:xfrm>
+            <a:off x="731520" y="365760"/>
+            <a:ext cx="10698480" cy="1005840"/>
+          </a:xfrm>
+          <a:prstGeom prst="rect">
+            <a:avLst/>
+          </a:prstGeom>
+          <a:noFill/>
+        </p:spPr>
+        <p:txBody>
+          <a:bodyPr wrap="square" lIns="0" tIns="0" rIns="0" bIns="0">
+            <a:spAutoFit/>
+          </a:bodyPr>
+          <a:lstStyle/>
+          <a:p>
+            <a:pPr>
+              <a:spcAft>
+                <a:spcPts val="200"/>
+              </a:spcAft>
+              <a:defRPr sz="1000" b="1">
+                <a:solidFill>
+                  <a:srgbClr val="FFB612"/>
+                </a:solidFill>
+              </a:defRPr>
+            </a:pPr>
+            <a:r>
+              <a:t>PRÓXIMOS PASOS</a:t>
+            </a:r>
+          </a:p>
+          <a:p>
+            <a:pPr>
+              <a:defRPr sz="2300" b="1">
+                <a:solidFill>
+                  <a:srgbClr val="FFFFFF"/>
+                </a:solidFill>
+              </a:defRPr>
+            </a:pPr>
+            <a:r>
+              <a:t>Plan de Acción en Juriquilla y Conclusión</a:t>
+            </a:r>
+          </a:p>
+        </p:txBody>
+      </p:sp>
+      <p:sp>
+        <p:nvSpPr>
+          <p:cNvPr id="3" name="Rounded Rectangle 2"/>
+          <p:cNvSpPr/>
+          <p:nvPr/>
+        </p:nvSpPr>
+        <p:spPr>
+          <a:xfrm>
+            <a:off x="731520" y="1645920"/>
+            <a:ext cx="10728655" cy="4663440"/>
+          </a:xfrm>
+          <a:prstGeom prst="roundRect">
+            <a:avLst/>
+          </a:prstGeom>
+          <a:solidFill>
+            <a:srgbClr val="141A26"/>
+          </a:solidFill>
+          <a:ln w="19050">
+            <a:solidFill>
+              <a:srgbClr val="283246"/>
+            </a:solidFill>
+          </a:ln>
+        </p:spPr>
+        <p:style>
+          <a:lnRef idx="1">
+            <a:schemeClr val="accent1"/>
+          </a:lnRef>
+          <a:fillRef idx="3">
+            <a:schemeClr val="accent1"/>
+          </a:fillRef>
+          <a:effectRef idx="2">
+            <a:schemeClr val="accent1"/>
+          </a:effectRef>
+          <a:fontRef idx="minor">
+            <a:schemeClr val="lt1"/>
+          </a:fontRef>
+        </p:style>
+        <p:txBody>
+          <a:bodyPr rtlCol="0" anchor="ctr"/>
+          <a:lstStyle/>
+          <a:p>
+            <a:pPr algn="ctr"/>
+          </a:p>
+        </p:txBody>
+      </p:sp>
+      <p:sp>
+        <p:nvSpPr>
+          <p:cNvPr id="4" name="TextBox 3"/>
+          <p:cNvSpPr txBox="1"/>
+          <p:nvPr/>
+        </p:nvSpPr>
+        <p:spPr>
+          <a:xfrm>
+            <a:off x="1097280" y="1828800"/>
+            <a:ext cx="9966960" cy="4206240"/>
+          </a:xfrm>
+          <a:prstGeom prst="rect">
+            <a:avLst/>
+          </a:prstGeom>
+          <a:noFill/>
+        </p:spPr>
+        <p:txBody>
+          <a:bodyPr wrap="square">
+            <a:spAutoFit/>
+          </a:bodyPr>
+          <a:lstStyle/>
+          <a:p>
+            <a:pPr>
+              <a:spcAft>
+                <a:spcPts val="200"/>
+              </a:spcAft>
+              <a:defRPr sz="1400" b="1">
+                <a:solidFill>
+                  <a:srgbClr val="FFB612"/>
+                </a:solidFill>
+              </a:defRPr>
+            </a:pPr>
+            <a:r>
               <a:t>Paso 1: Colocación de Material POP en Mesas (Día 1)</a:t>
             </a:r>
           </a:p>
@@ -4222,7 +4879,7 @@
               <a:spcAft>
                 <a:spcPts val="1000"/>
               </a:spcAft>
-              <a:defRPr sz="1200">
+              <a:defRPr sz="1150">
                 <a:solidFill>
                   <a:srgbClr val="FFFFFF"/>
                 </a:solidFill>
@@ -4237,7 +4894,7 @@
               <a:spcAft>
                 <a:spcPts val="200"/>
               </a:spcAft>
-              <a:defRPr sz="1450" b="1">
+              <a:defRPr sz="1400" b="1">
                 <a:solidFill>
                   <a:srgbClr val="FFB612"/>
                 </a:solidFill>
@@ -4252,7 +4909,7 @@
               <a:spcAft>
                 <a:spcPts val="1000"/>
               </a:spcAft>
-              <a:defRPr sz="1200">
+              <a:defRPr sz="1150">
                 <a:solidFill>
                   <a:srgbClr val="FFFFFF"/>
                 </a:solidFill>
@@ -4267,14 +4924,14 @@
               <a:spcAft>
                 <a:spcPts val="200"/>
               </a:spcAft>
-              <a:defRPr sz="1450" b="1">
+              <a:defRPr sz="1400" b="1">
                 <a:solidFill>
                   <a:srgbClr val="FFB612"/>
                 </a:solidFill>
               </a:defRPr>
             </a:pPr>
             <a:r>
-              <a:t>Paso 3: Activación Piloto con Fan Club (Fin de Semana)</a:t>
+              <a:t>Paso 3: Activación Piloto con Steelers Nation QRO (Fin de Semana)</a:t>
             </a:r>
           </a:p>
           <a:p>
@@ -4282,14 +4939,14 @@
               <a:spcAft>
                 <a:spcPts val="1000"/>
               </a:spcAft>
-              <a:defRPr sz="1200">
+              <a:defRPr sz="1150">
                 <a:solidFill>
                   <a:srgbClr val="FFFFFF"/>
                 </a:solidFill>
               </a:defRPr>
             </a:pPr>
             <a:r>
-              <a:t>Lanzamiento con la comunidad de Steelers Nation Querétaro en el partido estelar de la semana.</a:t>
+              <a:t>Lanzamiento oficial en el partido estelar de Steelers en Juriquilla con la comunidad de más de 71 miembros registrados.</a:t>
             </a:r>
           </a:p>
           <a:p>
@@ -4297,7 +4954,7 @@
               <a:spcAft>
                 <a:spcPts val="200"/>
               </a:spcAft>
-              <a:defRPr sz="1450" b="1">
+              <a:defRPr sz="1400" b="1">
                 <a:solidFill>
                   <a:srgbClr val="FFB612"/>
                 </a:solidFill>
@@ -4312,14 +4969,14 @@
               <a:spcAft>
                 <a:spcPts val="1000"/>
               </a:spcAft>
-              <a:defRPr sz="1200">
+              <a:defRPr sz="1150">
                 <a:solidFill>
                   <a:srgbClr val="FFFFFF"/>
                 </a:solidFill>
               </a:defRPr>
             </a:pPr>
             <a:r>
-              <a:t>Revisión con dueños y gerencia de consumo generado, mesas participantes y lealtad para escalarlo.</a:t>
+              <a:t>Revisión con dueños y gerencia de consumo generado, mesas participantes y lealtad para escalarlo a toda la marca.</a:t>
             </a:r>
           </a:p>
         </p:txBody>
@@ -4358,7 +5015,7 @@
         </p:nvSpPr>
         <p:spPr>
           <a:xfrm>
-            <a:off x="731520" y="411480"/>
+            <a:off x="731520" y="365760"/>
             <a:ext cx="10698480" cy="1005840"/>
           </a:xfrm>
           <a:prstGeom prst="rect">
@@ -4374,28 +5031,28 @@
           <a:p>
             <a:pPr>
               <a:spcAft>
-                <a:spcPts val="300"/>
-              </a:spcAft>
-              <a:defRPr sz="1050" b="1">
+                <a:spcPts val="200"/>
+              </a:spcAft>
+              <a:defRPr sz="1000" b="1">
                 <a:solidFill>
                   <a:srgbClr val="FFB612"/>
                 </a:solidFill>
               </a:defRPr>
             </a:pPr>
             <a:r>
-              <a:t>VALIDACIÓN ORGÁNICA • HISTORIA DE ÉXITO</a:t>
-            </a:r>
-          </a:p>
-          <a:p>
-            <a:pPr>
-              <a:defRPr sz="2400" b="1">
+              <a:t>HISTORIA REAL • MOTIVACIÓN Y PROPÓSITO</a:t>
+            </a:r>
+          </a:p>
+          <a:p>
+            <a:pPr>
+              <a:defRPr sz="2300" b="1">
                 <a:solidFill>
                   <a:srgbClr val="FFFFFF"/>
                 </a:solidFill>
               </a:defRPr>
             </a:pPr>
             <a:r>
-              <a:t>Nacido en Barra: Una Idea Probada con Clientes Reales</a:t>
+              <a:t>El Corazón del Proyecto: La Historia de un Barman en Álamos</a:t>
             </a:r>
           </a:p>
         </p:txBody>
@@ -4409,7 +5066,7 @@
         <p:spPr>
           <a:xfrm>
             <a:off x="731520" y="1645920"/>
-            <a:ext cx="10728655" cy="4572000"/>
+            <a:ext cx="10728655" cy="4663440"/>
           </a:xfrm>
           <a:prstGeom prst="roundRect">
             <a:avLst/>
@@ -4453,8 +5110,8 @@
         </p:nvSpPr>
         <p:spPr>
           <a:xfrm>
-            <a:off x="1097280" y="1920240"/>
-            <a:ext cx="9966960" cy="4023360"/>
+            <a:off x="1097280" y="1828800"/>
+            <a:ext cx="9966960" cy="4206240"/>
           </a:xfrm>
           <a:prstGeom prst="rect">
             <a:avLst/>
@@ -4469,16 +5126,16 @@
           <a:p>
             <a:pPr>
               <a:spcAft>
-                <a:spcPts val="1400"/>
-              </a:spcAft>
-              <a:defRPr sz="1800" b="1">
+                <a:spcPts val="1200"/>
+              </a:spcAft>
+              <a:defRPr sz="1700" b="1">
                 <a:solidFill>
                   <a:srgbClr val="FFB612"/>
                 </a:solidFill>
               </a:defRPr>
             </a:pPr>
             <a:r>
-              <a:t>💬 «Beto, ¿qué onda? ¿Para cuándo la próxima quiniela o trivia?»</a:t>
+              <a:t>❤️ «El cliente debe estar contento: aún si su equipo pierde o el partido está aburrido»</a:t>
             </a:r>
           </a:p>
           <a:p>
@@ -4486,20 +5143,20 @@
               <a:spcAft>
                 <a:spcPts val="200"/>
               </a:spcAft>
-              <a:defRPr sz="1450" b="1">
+              <a:defRPr sz="1400" b="1">
                 <a:solidFill>
                   <a:srgbClr val="FFD100"/>
                 </a:solidFill>
               </a:defRPr>
             </a:pPr>
             <a:r>
-              <a:t>🍺 El Origen en Álamos</a:t>
-            </a:r>
-          </a:p>
-          <a:p>
-            <a:pPr>
-              <a:spcAft>
-                <a:spcPts val="1200"/>
+              <a:t>🍺 El Origen Detrás de la Barra en Álamos</a:t>
+            </a:r>
+          </a:p>
+          <a:p>
+            <a:pPr>
+              <a:spcAft>
+                <a:spcPts val="1000"/>
               </a:spcAft>
               <a:defRPr sz="1200">
                 <a:solidFill>
@@ -4508,7 +5165,7 @@
               </a:defRPr>
             </a:pPr>
             <a:r>
-              <a:t>Drinks &amp; Wins no nació como una teoría de oficina. Nació directamente en la barra de Álamos, donde Beto empezó a organizar quinielas y trivias entre las mesas de forma orgánica. La respuesta de los comensales fue abrumadora: las mesas competían, consumían más y se quedaban hasta el final del partido.</a:t>
+              <a:t>Esto comenzó cuando yo era barman en la sucursal de Álamos. Mi meta siempre fue clara: que cada persona se fuera feliz del restaurante. Por naturaleza, al ser humano le fascina competir. Empecé a inventar quinielas y trivias entre las mesas; de repente, la gente no solo veía la tele, ¡estaban conviviendo, gritando y pidiendo más rondas!</a:t>
             </a:r>
           </a:p>
           <a:p>
@@ -4516,20 +5173,20 @@
               <a:spcAft>
                 <a:spcPts val="200"/>
               </a:spcAft>
-              <a:defRPr sz="1450" b="1">
+              <a:defRPr sz="1400" b="1">
                 <a:solidFill>
                   <a:srgbClr val="FFD100"/>
                 </a:solidFill>
               </a:defRPr>
             </a:pPr>
             <a:r>
-              <a:t>🤝 Creación de Clientes Frecuentes y Leales</a:t>
-            </a:r>
-          </a:p>
-          <a:p>
-            <a:pPr>
-              <a:spcAft>
-                <a:spcPts val="1200"/>
+              <a:t>🙏 Una Comunidad Fiel que Impulsa a Mi Familia</a:t>
+            </a:r>
+          </a:p>
+          <a:p>
+            <a:pPr>
+              <a:spcAft>
+                <a:spcPts val="1000"/>
               </a:spcAft>
               <a:defRPr sz="1200">
                 <a:solidFill>
@@ -4538,7 +5195,7 @@
               </a:defRPr>
             </a:pPr>
             <a:r>
-              <a:t>Esa dinámica creó una comunidad fiel que no solo llenaba el restaurante en días de juego, sino que hoy en día, cuando ven a Beto en la calle en Querétaro, lo reconocen y le preguntan entusiasmados por la siguiente fecha.</a:t>
+              <a:t>Esas dinámicas crearon clientes tan frecuentes y leales que hasta el día de hoy me ven en la calle en Querétaro y me dicen con una sonrisa: '¡Beto, qué onda! ¿Para cuándo otra quiniela o trivia?'. Gracias a esos clientes y a las propinas que dejan en mesa, he podido sacar adelante a mi familia.</a:t>
             </a:r>
           </a:p>
           <a:p>
@@ -4546,20 +5203,20 @@
               <a:spcAft>
                 <a:spcPts val="200"/>
               </a:spcAft>
-              <a:defRPr sz="1450" b="1">
+              <a:defRPr sz="1400" b="1">
                 <a:solidFill>
                   <a:srgbClr val="FFD100"/>
                 </a:solidFill>
               </a:defRPr>
             </a:pPr>
             <a:r>
-              <a:t>🚀 De la Libreta de Papel a la Tecnología PWA con IA</a:t>
-            </a:r>
-          </a:p>
-          <a:p>
-            <a:pPr>
-              <a:spcAft>
-                <a:spcPts val="1200"/>
+              <a:t>💡 No Soy Programador ni Ingeniero: Soy Alguien que Ama Este Lugar</a:t>
+            </a:r>
+          </a:p>
+          <a:p>
+            <a:pPr>
+              <a:spcAft>
+                <a:spcPts val="1000"/>
               </a:spcAft>
               <a:defRPr sz="1200">
                 <a:solidFill>
@@ -4568,7 +5225,7 @@
               </a:defRPr>
             </a:pPr>
             <a:r>
-              <a:t>Lo que antes se hacía con hojas de papel, plumas perdidas y conteos manuales agotadores, ahora está digitalizado al 100% en la nube, con conexión oficial a ESPN e Inteligencia Artificial para crear jornadas en segundos.</a:t>
+              <a:t>No soy desarrollador de software ni diseñador gráfico. Construí esta plataforma con todo el corazón, utilizando Inteligencia Artificial y herramientas modernas, por el inmenso cariño que le tengo a la marca y a este equipo.</a:t>
             </a:r>
           </a:p>
         </p:txBody>
@@ -4607,7 +5264,7 @@
         </p:nvSpPr>
         <p:spPr>
           <a:xfrm>
-            <a:off x="731520" y="411480"/>
+            <a:off x="731520" y="365760"/>
             <a:ext cx="10698480" cy="1005840"/>
           </a:xfrm>
           <a:prstGeom prst="rect">
@@ -4623,28 +5280,28 @@
           <a:p>
             <a:pPr>
               <a:spcAft>
-                <a:spcPts val="300"/>
-              </a:spcAft>
-              <a:defRPr sz="1050" b="1">
+                <a:spcPts val="200"/>
+              </a:spcAft>
+              <a:defRPr sz="1000" b="1">
                 <a:solidFill>
                   <a:srgbClr val="FFB612"/>
                 </a:solidFill>
               </a:defRPr>
             </a:pPr>
             <a:r>
-              <a:t>ESTRATEGIA COMERCIAL INTELIGENTE</a:t>
-            </a:r>
-          </a:p>
-          <a:p>
-            <a:pPr>
-              <a:defRPr sz="2400" b="1">
+              <a:t>SOLUCIÓN OPERATIVA</a:t>
+            </a:r>
+          </a:p>
+          <a:p>
+            <a:pPr>
+              <a:defRPr sz="2300" b="1">
                 <a:solidFill>
                   <a:srgbClr val="FFFFFF"/>
                 </a:solidFill>
               </a:defRPr>
             </a:pPr>
             <a:r>
-              <a:t>Estrategia Gradual y Punta de Lanza con Fan Clubs</a:t>
+              <a:t>De Álamos a Juriquilla: El Reto Operativo y la Automatización</a:t>
             </a:r>
           </a:p>
         </p:txBody>
@@ -4658,7 +5315,7 @@
         <p:spPr>
           <a:xfrm>
             <a:off x="731520" y="1645920"/>
-            <a:ext cx="5212080" cy="4572000"/>
+            <a:ext cx="5212080" cy="4663440"/>
           </a:xfrm>
           <a:prstGeom prst="roundRect">
             <a:avLst/>
@@ -4702,8 +5359,8 @@
         </p:nvSpPr>
         <p:spPr>
           <a:xfrm>
-            <a:off x="1005840" y="1920240"/>
-            <a:ext cx="4663440" cy="4023360"/>
+            <a:off x="1005840" y="1828800"/>
+            <a:ext cx="4663440" cy="4206240"/>
           </a:xfrm>
           <a:prstGeom prst="rect">
             <a:avLst/>
@@ -4722,12 +5379,12 @@
               </a:spcAft>
               <a:defRPr sz="1700" b="1">
                 <a:solidFill>
-                  <a:srgbClr val="FFB612"/>
-                </a:solidFill>
-              </a:defRPr>
-            </a:pPr>
-            <a:r>
-              <a:t>🎯 No Saturar: El Juego Indicado en el Día Indicado</a:t>
+                  <a:srgbClr val="FF5722"/>
+                </a:solidFill>
+              </a:defRPr>
+            </a:pPr>
+            <a:r>
+              <a:t>⚠️ El Dilema Operativo Actual</a:t>
             </a:r>
           </a:p>
           <a:p>
@@ -4737,27 +5394,27 @@
               </a:spcAft>
               <a:defRPr sz="1300" b="1">
                 <a:solidFill>
-                  <a:srgbClr val="FF5722"/>
-                </a:solidFill>
-              </a:defRPr>
-            </a:pPr>
-            <a:r>
-              <a:t>📅 Selección Quirúrgica de Fechas</a:t>
-            </a:r>
-          </a:p>
-          <a:p>
-            <a:pPr>
-              <a:spcAft>
-                <a:spcPts val="800"/>
-              </a:spcAft>
-              <a:defRPr sz="1100">
+                  <a:srgbClr val="FFD100"/>
+                </a:solidFill>
+              </a:defRPr>
+            </a:pPr>
+            <a:r>
+              <a:t>📍 Cambio a Juriquilla</a:t>
+            </a:r>
+          </a:p>
+          <a:p>
+            <a:pPr>
+              <a:spcAft>
+                <a:spcPts val="1000"/>
+              </a:spcAft>
+              <a:defRPr sz="1150">
                 <a:solidFill>
                   <a:srgbClr val="FFFFFF"/>
                 </a:solidFill>
               </a:defRPr>
             </a:pPr>
             <a:r>
-              <a:t>No se tienen que jugar todos los juegos todos los días. Saturar al cliente cansa. La clave es activar dinámicas exclusivamente en partidos estelares:</a:t>
+              <a:t>Ahora que estoy en Juriquilla, muchos comensales van buscando exactamente esas dinámicas divertidas que vivieron en Álamos.</a:t>
             </a:r>
           </a:p>
           <a:p>
@@ -4767,87 +5424,27 @@
               </a:spcAft>
               <a:defRPr sz="1300" b="1">
                 <a:solidFill>
-                  <a:srgbClr val="FF5722"/>
-                </a:solidFill>
-              </a:defRPr>
-            </a:pPr>
-            <a:r>
-              <a:t>🏈 Jueves, Domingos y Lunes</a:t>
-            </a:r>
-          </a:p>
-          <a:p>
-            <a:pPr>
-              <a:spcAft>
-                <a:spcPts val="800"/>
-              </a:spcAft>
-              <a:defRPr sz="1100">
+                  <a:srgbClr val="FFD100"/>
+                </a:solidFill>
+              </a:defRPr>
+            </a:pPr>
+            <a:r>
+              <a:t>⏱️ La Operación No Puede Descuidarse</a:t>
+            </a:r>
+          </a:p>
+          <a:p>
+            <a:pPr>
+              <a:spcAft>
+                <a:spcPts val="1000"/>
+              </a:spcAft>
+              <a:defRPr sz="1150">
                 <a:solidFill>
                   <a:srgbClr val="FFFFFF"/>
                 </a:solidFill>
               </a:defRPr>
             </a:pPr>
             <a:r>
-              <a:t>Quinielas y Grids de NFL durante transmisiones estelares.</a:t>
-            </a:r>
-          </a:p>
-          <a:p>
-            <a:pPr>
-              <a:spcAft>
-                <a:spcPts val="100"/>
-              </a:spcAft>
-              <a:defRPr sz="1300" b="1">
-                <a:solidFill>
-                  <a:srgbClr val="FF5722"/>
-                </a:solidFill>
-              </a:defRPr>
-            </a:pPr>
-            <a:r>
-              <a:t>⚽ Viernes a Domingo</a:t>
-            </a:r>
-          </a:p>
-          <a:p>
-            <a:pPr>
-              <a:spcAft>
-                <a:spcPts val="800"/>
-              </a:spcAft>
-              <a:defRPr sz="1100">
-                <a:solidFill>
-                  <a:srgbClr val="FFFFFF"/>
-                </a:solidFill>
-              </a:defRPr>
-            </a:pPr>
-            <a:r>
-              <a:t>Quinielas de Liga MX, First Striker y Clásicos de fútbol.</a:t>
-            </a:r>
-          </a:p>
-          <a:p>
-            <a:pPr>
-              <a:spcAft>
-                <a:spcPts val="100"/>
-              </a:spcAft>
-              <a:defRPr sz="1300" b="1">
-                <a:solidFill>
-                  <a:srgbClr val="FF5722"/>
-                </a:solidFill>
-              </a:defRPr>
-            </a:pPr>
-            <a:r>
-              <a:t>🧠 Medios Tiempos Selectos</a:t>
-            </a:r>
-          </a:p>
-          <a:p>
-            <a:pPr>
-              <a:spcAft>
-                <a:spcPts val="800"/>
-              </a:spcAft>
-              <a:defRPr sz="1100">
-                <a:solidFill>
-                  <a:srgbClr val="FFFFFF"/>
-                </a:solidFill>
-              </a:defRPr>
-            </a:pPr>
-            <a:r>
-              <a:t>Trivias rápidas de 10 min para reactivar consumo en la pausa.</a:t>
+              <a:t>Hoy mis deberes ya no son solo atender la barra, sino estar pendiente de la operación completa del restaurante. Es imposible descuidar el servicio para andar contando papeletas de papel o sumando puntos a mano.</a:t>
             </a:r>
           </a:p>
         </p:txBody>
@@ -4861,7 +5458,7 @@
         <p:spPr>
           <a:xfrm>
             <a:off x="6217920" y="1645920"/>
-            <a:ext cx="5212080" cy="4572000"/>
+            <a:ext cx="5212080" cy="4663440"/>
           </a:xfrm>
           <a:prstGeom prst="roundRect">
             <a:avLst/>
@@ -4905,8 +5502,8 @@
         </p:nvSpPr>
         <p:spPr>
           <a:xfrm>
-            <a:off x="6492240" y="1920240"/>
-            <a:ext cx="4663440" cy="4023360"/>
+            <a:off x="6492240" y="1828800"/>
+            <a:ext cx="4663440" cy="4206240"/>
           </a:xfrm>
           <a:prstGeom prst="rect">
             <a:avLst/>
@@ -4930,7 +5527,7 @@
               </a:defRPr>
             </a:pPr>
             <a:r>
-              <a:t>🛡️ Punta de Lanza: Steelers Nation QRO (71+ Fans)</a:t>
+              <a:t>🤖 La Solución: 80% Autónoma con IA</a:t>
             </a:r>
           </a:p>
           <a:p>
@@ -4945,22 +5542,22 @@
               </a:defRPr>
             </a:pPr>
             <a:r>
-              <a:t>💳 Audiencia Cautiva y Lista</a:t>
-            </a:r>
-          </a:p>
-          <a:p>
-            <a:pPr>
-              <a:spcAft>
-                <a:spcPts val="800"/>
-              </a:spcAft>
-              <a:defRPr sz="1100">
+              <a:t>⚡ Cero Tiempo Perdido por el Gerente</a:t>
+            </a:r>
+          </a:p>
+          <a:p>
+            <a:pPr>
+              <a:spcAft>
+                <a:spcPts val="1000"/>
+              </a:spcAft>
+              <a:defRPr sz="1150">
                 <a:solidFill>
                   <a:srgbClr val="FFFFFF"/>
                 </a:solidFill>
               </a:defRPr>
             </a:pPr>
             <a:r>
-              <a:t>En Querétaro ya contamos con más de 71 fanáticos registrados en la app oficial de Steelers Fan Club, con su credencial digital PWA activa en sus celulares.</a:t>
+              <a:t>La app se administra sola en un 80%. Se conecta en vivo a ESPN y calcula marcadores oficiales sin intervención humana.</a:t>
             </a:r>
           </a:p>
           <a:p>
@@ -4975,22 +5572,22 @@
               </a:defRPr>
             </a:pPr>
             <a:r>
-              <a:t>📲 Botón Directo Integrado</a:t>
-            </a:r>
-          </a:p>
-          <a:p>
-            <a:pPr>
-              <a:spcAft>
-                <a:spcPts val="800"/>
-              </a:spcAft>
-              <a:defRPr sz="1100">
+              <a:t>🧠 Creación con IA en Segundos</a:t>
+            </a:r>
+          </a:p>
+          <a:p>
+            <a:pPr>
+              <a:spcAft>
+                <a:spcPts val="1000"/>
+              </a:spcAft>
+              <a:defRPr sz="1150">
                 <a:solidFill>
                   <a:srgbClr val="FFFFFF"/>
                 </a:solidFill>
               </a:defRPr>
             </a:pPr>
             <a:r>
-              <a:t>Su credencial ya incluye el botón especial que los enlaza directamente a Drinks &amp; Wins para participar en las dinámicas de cada partido.</a:t>
+              <a:t>La IA genera trivias deportivas y redacta preguntas temáticas para días de partido en 10 segundos.</a:t>
             </a:r>
           </a:p>
           <a:p>
@@ -5005,22 +5602,22 @@
               </a:defRPr>
             </a:pPr>
             <a:r>
-              <a:t>🍻 Asistencia Garantizada</a:t>
-            </a:r>
-          </a:p>
-          <a:p>
-            <a:pPr>
-              <a:spcAft>
-                <a:spcPts val="800"/>
-              </a:spcAft>
-              <a:defRPr sz="1100">
+              <a:t>📊 Cero Papel y Cero Errores</a:t>
+            </a:r>
+          </a:p>
+          <a:p>
+            <a:pPr>
+              <a:spcAft>
+                <a:spcPts val="1000"/>
+              </a:spcAft>
+              <a:defRPr sz="1150">
                 <a:solidFill>
                   <a:srgbClr val="FFFFFF"/>
                 </a:solidFill>
               </a:defRPr>
             </a:pPr>
             <a:r>
-              <a:t>Este grupo ya llena mesas, pide rondas continuas y consume activamente alitas y cerveza semana a semana. Es la base perfecta para arrancar con éxito probado.</a:t>
+              <a:t>Elimina impresiones, plumas y quejas de clientes por conteos incorrectos. Todo es transparente y en vivo en el celular del cliente.</a:t>
             </a:r>
           </a:p>
         </p:txBody>
@@ -5059,7 +5656,7 @@
         </p:nvSpPr>
         <p:spPr>
           <a:xfrm>
-            <a:off x="731520" y="411480"/>
+            <a:off x="731520" y="365760"/>
             <a:ext cx="10698480" cy="1005840"/>
           </a:xfrm>
           <a:prstGeom prst="rect">
@@ -5075,28 +5672,28 @@
           <a:p>
             <a:pPr>
               <a:spcAft>
-                <a:spcPts val="300"/>
-              </a:spcAft>
-              <a:defRPr sz="1050" b="1">
+                <a:spcPts val="200"/>
+              </a:spcAft>
+              <a:defRPr sz="1000" b="1">
                 <a:solidFill>
                   <a:srgbClr val="FFB612"/>
                 </a:solidFill>
               </a:defRPr>
             </a:pPr>
             <a:r>
-              <a:t>EFICIENCIA OPERATIVA</a:t>
-            </a:r>
-          </a:p>
-          <a:p>
-            <a:pPr>
-              <a:defRPr sz="2400" b="1">
+              <a:t>TRACCIÓN REAL EN QUERÉTARO</a:t>
+            </a:r>
+          </a:p>
+          <a:p>
+            <a:pPr>
+              <a:defRPr sz="2300" b="1">
                 <a:solidFill>
                   <a:srgbClr val="FFFFFF"/>
                 </a:solidFill>
               </a:defRPr>
             </a:pPr>
             <a:r>
-              <a:t>Inteligencia Artificial y Automatización: Cero Carga para el Gerente</a:t>
+              <a:t>Potencial Inmediato: 71 Fans en 2 Semanas de una Base de +350</a:t>
             </a:r>
           </a:p>
         </p:txBody>
@@ -5110,7 +5707,7 @@
         <p:spPr>
           <a:xfrm>
             <a:off x="731520" y="1645920"/>
-            <a:ext cx="3413455" cy="4572000"/>
+            <a:ext cx="10728655" cy="4663440"/>
           </a:xfrm>
           <a:prstGeom prst="roundRect">
             <a:avLst/>
@@ -5154,8 +5751,8 @@
         </p:nvSpPr>
         <p:spPr>
           <a:xfrm>
-            <a:off x="1005840" y="1920240"/>
-            <a:ext cx="2864815" cy="4023360"/>
+            <a:off x="1097280" y="1828800"/>
+            <a:ext cx="9966960" cy="4206240"/>
           </a:xfrm>
           <a:prstGeom prst="rect">
             <a:avLst/>
@@ -5170,222 +5767,106 @@
           <a:p>
             <a:pPr>
               <a:spcAft>
-                <a:spcPts val="1400"/>
-              </a:spcAft>
-              <a:defRPr sz="1650" b="1">
+                <a:spcPts val="1200"/>
+              </a:spcAft>
+              <a:defRPr sz="1700" b="1">
                 <a:solidFill>
                   <a:srgbClr val="FFB612"/>
                 </a:solidFill>
               </a:defRPr>
             </a:pPr>
             <a:r>
-              <a:t>⚡ Creación de Jornadas en Segundos</a:t>
-            </a:r>
-          </a:p>
-          <a:p>
-            <a:pPr>
-              <a:defRPr sz="1300">
+              <a:t>🏈 La Punta de Lanza: Steelers Nation Querétaro</a:t>
+            </a:r>
+          </a:p>
+          <a:p>
+            <a:pPr>
+              <a:spcAft>
+                <a:spcPts val="200"/>
+              </a:spcAft>
+              <a:defRPr sz="1400" b="1">
+                <a:solidFill>
+                  <a:srgbClr val="FFD100"/>
+                </a:solidFill>
+              </a:defRPr>
+            </a:pPr>
+            <a:r>
+              <a:t>📈 Crecimiento Explosivo Orgánico</a:t>
+            </a:r>
+          </a:p>
+          <a:p>
+            <a:pPr>
+              <a:spcAft>
+                <a:spcPts val="1000"/>
+              </a:spcAft>
+              <a:defRPr sz="1200">
                 <a:solidFill>
                   <a:srgbClr val="FFFFFF"/>
                 </a:solidFill>
               </a:defRPr>
             </a:pPr>
             <a:r>
-              <a:t>Antes: Un gerente tardaba hasta 2 horas buscando partidos en internet, armando tablas en Excel e imprimiendo hojas.</a:t>
-            </a:r>
-            <a:br/>
-            <a:r>
-              <a:t>Hoy: Conexión directa a ESPN y algoritmos que importan partidos oficiales, horarios y escudos con un solo clic.</a:t>
-            </a:r>
-          </a:p>
-        </p:txBody>
-      </p:sp>
-      <p:sp>
-        <p:nvSpPr>
-          <p:cNvPr id="5" name="Rounded Rectangle 4"/>
-          <p:cNvSpPr/>
-          <p:nvPr/>
-        </p:nvSpPr>
-        <p:spPr>
-          <a:xfrm>
-            <a:off x="4389120" y="1645920"/>
-            <a:ext cx="3413455" cy="4572000"/>
-          </a:xfrm>
-          <a:prstGeom prst="roundRect">
-            <a:avLst/>
-          </a:prstGeom>
-          <a:solidFill>
-            <a:srgbClr val="141A26"/>
-          </a:solidFill>
-          <a:ln w="19050">
-            <a:solidFill>
-              <a:srgbClr val="283246"/>
-            </a:solidFill>
-          </a:ln>
-        </p:spPr>
-        <p:style>
-          <a:lnRef idx="1">
-            <a:schemeClr val="accent1"/>
-          </a:lnRef>
-          <a:fillRef idx="3">
-            <a:schemeClr val="accent1"/>
-          </a:fillRef>
-          <a:effectRef idx="2">
-            <a:schemeClr val="accent1"/>
-          </a:effectRef>
-          <a:fontRef idx="minor">
-            <a:schemeClr val="lt1"/>
-          </a:fontRef>
-        </p:style>
-        <p:txBody>
-          <a:bodyPr rtlCol="0" anchor="ctr"/>
-          <a:lstStyle/>
-          <a:p>
-            <a:pPr algn="ctr"/>
-          </a:p>
-        </p:txBody>
-      </p:sp>
-      <p:sp>
-        <p:nvSpPr>
-          <p:cNvPr id="6" name="TextBox 5"/>
-          <p:cNvSpPr txBox="1"/>
-          <p:nvPr/>
-        </p:nvSpPr>
-        <p:spPr>
-          <a:xfrm>
-            <a:off x="4663440" y="1920240"/>
-            <a:ext cx="2864815" cy="4023360"/>
-          </a:xfrm>
-          <a:prstGeom prst="rect">
-            <a:avLst/>
-          </a:prstGeom>
-          <a:noFill/>
-        </p:spPr>
-        <p:txBody>
-          <a:bodyPr wrap="square">
-            <a:spAutoFit/>
-          </a:bodyPr>
-          <a:lstStyle/>
-          <a:p>
-            <a:pPr>
-              <a:spcAft>
-                <a:spcPts val="1400"/>
-              </a:spcAft>
-              <a:defRPr sz="1650" b="1">
-                <a:solidFill>
-                  <a:srgbClr val="FF5722"/>
-                </a:solidFill>
-              </a:defRPr>
-            </a:pPr>
-            <a:r>
-              <a:t>🧠 Generación de Trivias Deportivas con IA</a:t>
-            </a:r>
-          </a:p>
-          <a:p>
-            <a:pPr>
-              <a:defRPr sz="1300">
+              <a:t>En tan solo 2 semanas desde el lanzamiento de la Credencial Digital de Steelers Nation QRO, ya se han registrado 71 miembros oficiales en la app. Pero son más de 350 fanáticos activos en la comunidad de Querétaro.</a:t>
+            </a:r>
+          </a:p>
+          <a:p>
+            <a:pPr>
+              <a:spcAft>
+                <a:spcPts val="200"/>
+              </a:spcAft>
+              <a:defRPr sz="1400" b="1">
+                <a:solidFill>
+                  <a:srgbClr val="FFD100"/>
+                </a:solidFill>
+              </a:defRPr>
+            </a:pPr>
+            <a:r>
+              <a:t>📲 Conexión Directa desde su Credencial Digital (PWA)</a:t>
+            </a:r>
+          </a:p>
+          <a:p>
+            <a:pPr>
+              <a:spcAft>
+                <a:spcPts val="1000"/>
+              </a:spcAft>
+              <a:defRPr sz="1200">
                 <a:solidFill>
                   <a:srgbClr val="FFFFFF"/>
                 </a:solidFill>
               </a:defRPr>
             </a:pPr>
             <a:r>
-              <a:t>La Inteligencia Artificial genera sets completos de preguntas deportivas temáticas (NFL, Liga MX, datos curiosos de Steelers) adaptadas al partido del día en menos de 10 segundos, listas para proyectar en TV.</a:t>
-            </a:r>
-          </a:p>
-        </p:txBody>
-      </p:sp>
-      <p:sp>
-        <p:nvSpPr>
-          <p:cNvPr id="7" name="Rounded Rectangle 6"/>
-          <p:cNvSpPr/>
-          <p:nvPr/>
-        </p:nvSpPr>
-        <p:spPr>
-          <a:xfrm>
-            <a:off x="8046720" y="1645920"/>
-            <a:ext cx="3413455" cy="4572000"/>
-          </a:xfrm>
-          <a:prstGeom prst="roundRect">
-            <a:avLst/>
-          </a:prstGeom>
-          <a:solidFill>
-            <a:srgbClr val="141A26"/>
-          </a:solidFill>
-          <a:ln w="19050">
-            <a:solidFill>
-              <a:srgbClr val="283246"/>
-            </a:solidFill>
-          </a:ln>
-        </p:spPr>
-        <p:style>
-          <a:lnRef idx="1">
-            <a:schemeClr val="accent1"/>
-          </a:lnRef>
-          <a:fillRef idx="3">
-            <a:schemeClr val="accent1"/>
-          </a:fillRef>
-          <a:effectRef idx="2">
-            <a:schemeClr val="accent1"/>
-          </a:effectRef>
-          <a:fontRef idx="minor">
-            <a:schemeClr val="lt1"/>
-          </a:fontRef>
-        </p:style>
-        <p:txBody>
-          <a:bodyPr rtlCol="0" anchor="ctr"/>
-          <a:lstStyle/>
-          <a:p>
-            <a:pPr algn="ctr"/>
-          </a:p>
-        </p:txBody>
-      </p:sp>
-      <p:sp>
-        <p:nvSpPr>
-          <p:cNvPr id="8" name="TextBox 7"/>
-          <p:cNvSpPr txBox="1"/>
-          <p:nvPr/>
-        </p:nvSpPr>
-        <p:spPr>
-          <a:xfrm>
-            <a:off x="8321040" y="1920240"/>
-            <a:ext cx="2864815" cy="4023360"/>
-          </a:xfrm>
-          <a:prstGeom prst="rect">
-            <a:avLst/>
-          </a:prstGeom>
-          <a:noFill/>
-        </p:spPr>
-        <p:txBody>
-          <a:bodyPr wrap="square">
-            <a:spAutoFit/>
-          </a:bodyPr>
-          <a:lstStyle/>
-          <a:p>
-            <a:pPr>
-              <a:spcAft>
-                <a:spcPts val="1400"/>
-              </a:spcAft>
-              <a:defRPr sz="1650" b="1">
-                <a:solidFill>
-                  <a:srgbClr val="00E676"/>
-                </a:solidFill>
-              </a:defRPr>
-            </a:pPr>
-            <a:r>
-              <a:t>📊 Marcadores Exactos y Calificación en Tiempo Real</a:t>
-            </a:r>
-          </a:p>
-          <a:p>
-            <a:pPr>
-              <a:defRPr sz="1300">
+              <a:t>La credencial digital de los fans tiene un botón especial integrado que los manda directamente a Drinks &amp; Wins para participar en las dinámicas de cada juego. Es una audiencia cautiva que ya ama la marca.</a:t>
+            </a:r>
+          </a:p>
+          <a:p>
+            <a:pPr>
+              <a:spcAft>
+                <a:spcPts val="200"/>
+              </a:spcAft>
+              <a:defRPr sz="1400" b="1">
+                <a:solidFill>
+                  <a:srgbClr val="FFD100"/>
+                </a:solidFill>
+              </a:defRPr>
+            </a:pPr>
+            <a:r>
+              <a:t>🍻 Asistencia y Consumo Comprobado</a:t>
+            </a:r>
+          </a:p>
+          <a:p>
+            <a:pPr>
+              <a:spcAft>
+                <a:spcPts val="1000"/>
+              </a:spcAft>
+              <a:defRPr sz="1200">
                 <a:solidFill>
                   <a:srgbClr val="FFFFFF"/>
                 </a:solidFill>
               </a:defRPr>
             </a:pPr>
             <a:r>
-              <a:t>La plataforma detecta marcadores finales en vivo vía API de ESPN, calcula aciertos exactos (+3) o ganadores (+1), genera la tabla y proclama al campeón de forma 100% automática sin errores humanos.</a:t>
+              <a:t>Este grupo no viene solo por una cerveza: llenan mesas enteras, piden cubetazos, rondas continuas de alitas y se quedan durante toda la transmisión del partido. Es el motor perfecto para arrancar en Juriquilla.</a:t>
             </a:r>
           </a:p>
         </p:txBody>
@@ -5424,7 +5905,7 @@
         </p:nvSpPr>
         <p:spPr>
           <a:xfrm>
-            <a:off x="731520" y="411480"/>
+            <a:off x="731520" y="365760"/>
             <a:ext cx="10698480" cy="1005840"/>
           </a:xfrm>
           <a:prstGeom prst="rect">
@@ -5440,28 +5921,28 @@
           <a:p>
             <a:pPr>
               <a:spcAft>
-                <a:spcPts val="300"/>
-              </a:spcAft>
-              <a:defRPr sz="1050" b="1">
+                <a:spcPts val="200"/>
+              </a:spcAft>
+              <a:defRPr sz="1000" b="1">
                 <a:solidFill>
                   <a:srgbClr val="FFB612"/>
                 </a:solidFill>
               </a:defRPr>
             </a:pPr>
             <a:r>
-              <a:t>DETALLE PASO A PASO POR JUEGO</a:t>
-            </a:r>
-          </a:p>
-          <a:p>
-            <a:pPr>
-              <a:defRPr sz="2400" b="1">
+              <a:t>EXPERIENCIA DE USUARIO SIN FRICCIÓN</a:t>
+            </a:r>
+          </a:p>
+          <a:p>
+            <a:pPr>
+              <a:defRPr sz="2300" b="1">
                 <a:solidFill>
                   <a:srgbClr val="FFFFFF"/>
                 </a:solidFill>
               </a:defRPr>
             </a:pPr>
             <a:r>
-              <a:t>Juego 1: Quinielas Pick'em (NFL y Liga MX)</a:t>
+              <a:t>Guía del Cliente: Cómo Ingresar, Registrarse e Instalar la App</a:t>
             </a:r>
           </a:p>
         </p:txBody>
@@ -5475,7 +5956,7 @@
         <p:spPr>
           <a:xfrm>
             <a:off x="731520" y="1645920"/>
-            <a:ext cx="6858000" cy="4572000"/>
+            <a:ext cx="3413455" cy="4663440"/>
           </a:xfrm>
           <a:prstGeom prst="roundRect">
             <a:avLst/>
@@ -5520,7 +6001,7 @@
         <p:spPr>
           <a:xfrm>
             <a:off x="1005840" y="1828800"/>
-            <a:ext cx="6309360" cy="4114800"/>
+            <a:ext cx="2864815" cy="4206240"/>
           </a:xfrm>
           <a:prstGeom prst="rect">
             <a:avLst/>
@@ -5535,119 +6016,250 @@
           <a:p>
             <a:pPr>
               <a:spcAft>
-                <a:spcPts val="200"/>
-              </a:spcAft>
-              <a:defRPr sz="1400" b="1">
+                <a:spcPts val="1400"/>
+              </a:spcAft>
+              <a:defRPr sz="1600" b="1">
                 <a:solidFill>
                   <a:srgbClr val="FFB612"/>
                 </a:solidFill>
               </a:defRPr>
             </a:pPr>
             <a:r>
-              <a:t>🛠️ 1. CÓMO LO CREA EL GERENTE (60 seg)</a:t>
-            </a:r>
-          </a:p>
-          <a:p>
-            <a:pPr>
-              <a:spcAft>
-                <a:spcPts val="1000"/>
-              </a:spcAft>
-              <a:defRPr sz="1150">
+              <a:t>1. CÓMO INGRESA</a:t>
+            </a:r>
+          </a:p>
+          <a:p>
+            <a:pPr>
+              <a:defRPr sz="1250">
                 <a:solidFill>
                   <a:srgbClr val="FFFFFF"/>
                 </a:solidFill>
               </a:defRPr>
             </a:pPr>
             <a:r>
-              <a:t>Entra al panel Admin, selecciona la liga (NFL, Liga MX o fútbol europeo). El sistema jala los partidos oficiales con escudos de ESPN. Toca los partidos a incluir, asigna el premio (ej. Orden de Alitas + Cerveza) y da clic en 'Crear Quiniela'.</a:t>
-            </a:r>
-          </a:p>
-          <a:p>
-            <a:pPr>
-              <a:spcAft>
-                <a:spcPts val="200"/>
-              </a:spcAft>
-              <a:defRPr sz="1400" b="1">
-                <a:solidFill>
-                  <a:srgbClr val="FFB612"/>
-                </a:solidFill>
-              </a:defRPr>
-            </a:pPr>
-            <a:r>
-              <a:t>📱 2. CÓMO ENTRA Y JUEGA EL CLIENTE</a:t>
-            </a:r>
-          </a:p>
-          <a:p>
-            <a:pPr>
-              <a:spcAft>
-                <a:spcPts val="1000"/>
-              </a:spcAft>
-              <a:defRPr sz="1150">
-                <a:solidFill>
-                  <a:srgbClr val="FFFFFF"/>
-                </a:solidFill>
-              </a:defRPr>
-            </a:pPr>
-            <a:r>
-              <a:t>Escanea el QR de su mesa, ingresa con su nombre o Google, selecciona a su mesero y captura sus marcadores o ganadores en la pantalla interactiva antes del silbatazo inicial.</a:t>
-            </a:r>
-          </a:p>
-          <a:p>
-            <a:pPr>
-              <a:spcAft>
-                <a:spcPts val="200"/>
-              </a:spcAft>
-              <a:defRPr sz="1400" b="1">
-                <a:solidFill>
-                  <a:srgbClr val="FFB612"/>
-                </a:solidFill>
-              </a:defRPr>
-            </a:pPr>
-            <a:r>
-              <a:t>🏆 3. CÓMO GANA Y CANJEA</a:t>
-            </a:r>
-          </a:p>
-          <a:p>
-            <a:pPr>
-              <a:spcAft>
-                <a:spcPts val="1000"/>
-              </a:spcAft>
-              <a:defRPr sz="1150">
-                <a:solidFill>
-                  <a:srgbClr val="FFFFFF"/>
-                </a:solidFill>
-              </a:defRPr>
-            </a:pPr>
-            <a:r>
-              <a:t>Durante el partido, los marcadores cambian en tiempo real. Marcador exacto: +3 pts (verde), Ganador: +1 pt (dorado), Error: 0 pts (rojo). Al finalizar, el comensal número 1 en el podio recibe la corona y muestra su cupón digital en barra para reclamar su premio.</a:t>
-            </a:r>
-          </a:p>
-        </p:txBody>
-      </p:sp>
-      <p:pic>
-        <p:nvPicPr>
-          <p:cNvPr id="5" name="Picture 4" descr="screenshot_podium_standings.png"/>
-          <p:cNvPicPr>
-            <a:picLocks noChangeAspect="1"/>
-          </p:cNvPicPr>
+              <a:t>📱 En su mesa encuentra el código QR en el acrílico.</a:t>
+            </a:r>
+            <a:br/>
+            <a:r>
+              <a:t>• Abre la cámara de su celular y apunta al QR.</a:t>
+            </a:r>
+            <a:br/>
+            <a:r>
+              <a:t>• Entra en 3 segundos en su navegador web sin descargas pesadas ni tiendas de aplicaciones.</a:t>
+            </a:r>
+          </a:p>
+        </p:txBody>
+      </p:sp>
+      <p:sp>
+        <p:nvSpPr>
+          <p:cNvPr id="5" name="Rounded Rectangle 4"/>
+          <p:cNvSpPr/>
           <p:nvPr/>
-        </p:nvPicPr>
-        <p:blipFill>
-          <a:blip r:embed="rId2"/>
-          <a:stretch>
-            <a:fillRect/>
-          </a:stretch>
-        </p:blipFill>
-        <p:spPr>
-          <a:xfrm>
-            <a:off x="7863840" y="1645920"/>
-            <a:ext cx="8669867" cy="4572000"/>
+        </p:nvSpPr>
+        <p:spPr>
+          <a:xfrm>
+            <a:off x="4389120" y="1645920"/>
+            <a:ext cx="3413455" cy="4663440"/>
+          </a:xfrm>
+          <a:prstGeom prst="roundRect">
+            <a:avLst/>
+          </a:prstGeom>
+          <a:solidFill>
+            <a:srgbClr val="141A26"/>
+          </a:solidFill>
+          <a:ln w="19050">
+            <a:solidFill>
+              <a:srgbClr val="283246"/>
+            </a:solidFill>
+          </a:ln>
+        </p:spPr>
+        <p:style>
+          <a:lnRef idx="1">
+            <a:schemeClr val="accent1"/>
+          </a:lnRef>
+          <a:fillRef idx="3">
+            <a:schemeClr val="accent1"/>
+          </a:fillRef>
+          <a:effectRef idx="2">
+            <a:schemeClr val="accent1"/>
+          </a:effectRef>
+          <a:fontRef idx="minor">
+            <a:schemeClr val="lt1"/>
+          </a:fontRef>
+        </p:style>
+        <p:txBody>
+          <a:bodyPr rtlCol="0" anchor="ctr"/>
+          <a:lstStyle/>
+          <a:p>
+            <a:pPr algn="ctr"/>
+          </a:p>
+        </p:txBody>
+      </p:sp>
+      <p:sp>
+        <p:nvSpPr>
+          <p:cNvPr id="6" name="TextBox 5"/>
+          <p:cNvSpPr txBox="1"/>
+          <p:nvPr/>
+        </p:nvSpPr>
+        <p:spPr>
+          <a:xfrm>
+            <a:off x="4663440" y="1828800"/>
+            <a:ext cx="2864815" cy="4206240"/>
           </a:xfrm>
           <a:prstGeom prst="rect">
             <a:avLst/>
           </a:prstGeom>
-        </p:spPr>
-      </p:pic>
+          <a:noFill/>
+        </p:spPr>
+        <p:txBody>
+          <a:bodyPr wrap="square">
+            <a:spAutoFit/>
+          </a:bodyPr>
+          <a:lstStyle/>
+          <a:p>
+            <a:pPr>
+              <a:spcAft>
+                <a:spcPts val="1400"/>
+              </a:spcAft>
+              <a:defRPr sz="1600" b="1">
+                <a:solidFill>
+                  <a:srgbClr val="FF5722"/>
+                </a:solidFill>
+              </a:defRPr>
+            </a:pPr>
+            <a:r>
+              <a:t>2. CÓMO SE REGISTRA</a:t>
+            </a:r>
+          </a:p>
+          <a:p>
+            <a:pPr>
+              <a:defRPr sz="1250">
+                <a:solidFill>
+                  <a:srgbClr val="FFFFFF"/>
+                </a:solidFill>
+              </a:defRPr>
+            </a:pPr>
+            <a:r>
+              <a:t>👤 Con un solo toque inicia sesión con su cuenta de Google o escribe su nombre/apodo.</a:t>
+            </a:r>
+            <a:br/>
+            <a:r>
+              <a:t>• Selecciona el nombre del mesero que lo atiende.</a:t>
+            </a:r>
+            <a:br/>
+            <a:r>
+              <a:t>• Todo queda guardado en la nube al instante.</a:t>
+            </a:r>
+          </a:p>
+        </p:txBody>
+      </p:sp>
+      <p:sp>
+        <p:nvSpPr>
+          <p:cNvPr id="7" name="Rounded Rectangle 6"/>
+          <p:cNvSpPr/>
+          <p:nvPr/>
+        </p:nvSpPr>
+        <p:spPr>
+          <a:xfrm>
+            <a:off x="8046720" y="1645920"/>
+            <a:ext cx="3413455" cy="4663440"/>
+          </a:xfrm>
+          <a:prstGeom prst="roundRect">
+            <a:avLst/>
+          </a:prstGeom>
+          <a:solidFill>
+            <a:srgbClr val="141A26"/>
+          </a:solidFill>
+          <a:ln w="19050">
+            <a:solidFill>
+              <a:srgbClr val="283246"/>
+            </a:solidFill>
+          </a:ln>
+        </p:spPr>
+        <p:style>
+          <a:lnRef idx="1">
+            <a:schemeClr val="accent1"/>
+          </a:lnRef>
+          <a:fillRef idx="3">
+            <a:schemeClr val="accent1"/>
+          </a:fillRef>
+          <a:effectRef idx="2">
+            <a:schemeClr val="accent1"/>
+          </a:effectRef>
+          <a:fontRef idx="minor">
+            <a:schemeClr val="lt1"/>
+          </a:fontRef>
+        </p:style>
+        <p:txBody>
+          <a:bodyPr rtlCol="0" anchor="ctr"/>
+          <a:lstStyle/>
+          <a:p>
+            <a:pPr algn="ctr"/>
+          </a:p>
+        </p:txBody>
+      </p:sp>
+      <p:sp>
+        <p:nvSpPr>
+          <p:cNvPr id="8" name="TextBox 7"/>
+          <p:cNvSpPr txBox="1"/>
+          <p:nvPr/>
+        </p:nvSpPr>
+        <p:spPr>
+          <a:xfrm>
+            <a:off x="8321040" y="1828800"/>
+            <a:ext cx="2864815" cy="4206240"/>
+          </a:xfrm>
+          <a:prstGeom prst="rect">
+            <a:avLst/>
+          </a:prstGeom>
+          <a:noFill/>
+        </p:spPr>
+        <p:txBody>
+          <a:bodyPr wrap="square">
+            <a:spAutoFit/>
+          </a:bodyPr>
+          <a:lstStyle/>
+          <a:p>
+            <a:pPr>
+              <a:spcAft>
+                <a:spcPts val="1400"/>
+              </a:spcAft>
+              <a:defRPr sz="1600" b="1">
+                <a:solidFill>
+                  <a:srgbClr val="00E676"/>
+                </a:solidFill>
+              </a:defRPr>
+            </a:pPr>
+            <a:r>
+              <a:t>3. CÓMO SE INSTALA (PWA)</a:t>
+            </a:r>
+          </a:p>
+          <a:p>
+            <a:pPr>
+              <a:defRPr sz="1250">
+                <a:solidFill>
+                  <a:srgbClr val="FFFFFF"/>
+                </a:solidFill>
+              </a:defRPr>
+            </a:pPr>
+            <a:r>
+              <a:t>📲 Se instala como una app nativa en 1 clic:</a:t>
+            </a:r>
+            <a:br/>
+            <a:r>
+              <a:t>• En iPhone: Compartir ➔ 'Agregar a pantalla de inicio'.</a:t>
+            </a:r>
+            <a:br/>
+            <a:r>
+              <a:t>• En Android: Toca el aviso 'Instalar App'.</a:t>
+            </a:r>
+            <a:br/>
+            <a:r>
+              <a:t>• ¡Queda el icono oficial en su celular para siempre!</a:t>
+            </a:r>
+          </a:p>
+        </p:txBody>
+      </p:sp>
     </p:spTree>
   </p:cSld>
   <p:clrMapOvr>
@@ -5682,7 +6294,7 @@
         </p:nvSpPr>
         <p:spPr>
           <a:xfrm>
-            <a:off x="731520" y="411480"/>
+            <a:off x="731520" y="365760"/>
             <a:ext cx="10698480" cy="1005840"/>
           </a:xfrm>
           <a:prstGeom prst="rect">
@@ -5698,28 +6310,28 @@
           <a:p>
             <a:pPr>
               <a:spcAft>
-                <a:spcPts val="300"/>
-              </a:spcAft>
-              <a:defRPr sz="1050" b="1">
+                <a:spcPts val="200"/>
+              </a:spcAft>
+              <a:defRPr sz="1000" b="1">
                 <a:solidFill>
                   <a:srgbClr val="FFB612"/>
                 </a:solidFill>
               </a:defRPr>
             </a:pPr>
             <a:r>
-              <a:t>DETALLE PASO A PASO POR JUEGO</a:t>
-            </a:r>
-          </a:p>
-          <a:p>
-            <a:pPr>
-              <a:defRPr sz="2400" b="1">
+              <a:t>JUEGO POR JUEGO EN DETALLE</a:t>
+            </a:r>
+          </a:p>
+          <a:p>
+            <a:pPr>
+              <a:defRPr sz="2300" b="1">
                 <a:solidFill>
                   <a:srgbClr val="FFFFFF"/>
                 </a:solidFill>
               </a:defRPr>
             </a:pPr>
             <a:r>
-              <a:t>Juego 2: Football Grids (100 Casillas Digitales)</a:t>
+              <a:t>Football Grids (100 Casillas NFL): Dinámica y Creación</a:t>
             </a:r>
           </a:p>
         </p:txBody>
@@ -5733,7 +6345,7 @@
         <p:spPr>
           <a:xfrm>
             <a:off x="731520" y="1645920"/>
-            <a:ext cx="6858000" cy="4572000"/>
+            <a:ext cx="6858000" cy="4663440"/>
           </a:xfrm>
           <a:prstGeom prst="roundRect">
             <a:avLst/>
@@ -5778,7 +6390,7 @@
         <p:spPr>
           <a:xfrm>
             <a:off x="1005840" y="1828800"/>
-            <a:ext cx="6309360" cy="4114800"/>
+            <a:ext cx="6309360" cy="4206240"/>
           </a:xfrm>
           <a:prstGeom prst="rect">
             <a:avLst/>
@@ -5795,14 +6407,14 @@
               <a:spcAft>
                 <a:spcPts val="200"/>
               </a:spcAft>
-              <a:defRPr sz="1400" b="1">
+              <a:defRPr sz="1350" b="1">
                 <a:solidFill>
                   <a:srgbClr val="FF5722"/>
                 </a:solidFill>
               </a:defRPr>
             </a:pPr>
             <a:r>
-              <a:t>🛠️ 1. CÓMO LO CREA EL GERENTE (30 seg)</a:t>
+              <a:t>🛠️ CÓMO LO CREA EL GERENTE (30 segundos)</a:t>
             </a:r>
           </a:p>
           <a:p>
@@ -5817,7 +6429,7 @@
               </a:defRPr>
             </a:pPr>
             <a:r>
-              <a:t>Selecciona el partido estelar de NFL (Sunday Night o Steelers). El sistema genera la cuadrícula digital de 10x10 (100 casillas) con los logotipos oficiales de los dos equipos rivales.</a:t>
+              <a:t>Entra al panel Admin, elige el partido estelar de la NFL (ej. Steelers vs Bills). Con un solo clic, el sistema genera la cuadrícula digital de 10x10 (100 casillas) con los logotipos oficiales de los dos equipos.</a:t>
             </a:r>
           </a:p>
           <a:p>
@@ -5825,14 +6437,14 @@
               <a:spcAft>
                 <a:spcPts val="200"/>
               </a:spcAft>
-              <a:defRPr sz="1400" b="1">
+              <a:defRPr sz="1350" b="1">
                 <a:solidFill>
                   <a:srgbClr val="FF5722"/>
                 </a:solidFill>
               </a:defRPr>
             </a:pPr>
             <a:r>
-              <a:t>📱 2. CÓMO ENTRA Y JUEGA EL CLIENTE</a:t>
+              <a:t>📱 CÓMO JUEGA EL CLIENTE EN MESA</a:t>
             </a:r>
           </a:p>
           <a:p>
@@ -5847,7 +6459,7 @@
               </a:defRPr>
             </a:pPr>
             <a:r>
-              <a:t>Escanea el QR en mesa, ve la cuadrícula en su celular y toca las casillas vacías que desea apartar con su nombre o apodo, apoyando a su equipo con amigos.</a:t>
+              <a:t>El comensal escanea el QR, ve la cuadrícula en su smartphone y toca las casillas vacías que desea apartar con su nombre o apodo para competir amistosamente con sus amigos.</a:t>
             </a:r>
           </a:p>
           <a:p>
@@ -5855,14 +6467,14 @@
               <a:spcAft>
                 <a:spcPts val="200"/>
               </a:spcAft>
-              <a:defRPr sz="1400" b="1">
+              <a:defRPr sz="1350" b="1">
                 <a:solidFill>
                   <a:srgbClr val="FF5722"/>
                 </a:solidFill>
               </a:defRPr>
             </a:pPr>
             <a:r>
-              <a:t>🏆 3. CÓMO GANA Y MANTIENE EL CONSUMO</a:t>
+              <a:t>🏆 CÓMO GANA Y POR QUÉ VENDE TANTO</a:t>
             </a:r>
           </a:p>
           <a:p>
@@ -5877,7 +6489,7 @@
               </a:defRPr>
             </a:pPr>
             <a:r>
-              <a:t>Al inicio del partido, el sistema sortea los dígitos del 0 al 9 en filas y columnas. ¡Hay 4 GANADORES por partido! (Al término del 1Q, Medio Tiempo, 3Q y Final según el último dígito del marcador). Mantiene a la mesa comiendo y bebiendo durante las 3 horas completas.</a:t>
+              <a:t>Al inicio del partido, el sistema sortea automáticamente los dígitos del 0 al 9 en filas y columnas. ¡Hay 4 GANADORES por partido! (Al final del 1Q, 2Q, 3Q y Final según el último dígito del marcador). Esto mantiene a la mesa consumiendo cervezas y botanas durante las 3 horas de transmisión.</a:t>
             </a:r>
           </a:p>
         </p:txBody>
@@ -5899,7 +6511,7 @@
         <p:spPr>
           <a:xfrm>
             <a:off x="7955279" y="1645920"/>
-            <a:ext cx="2571750" cy="4572000"/>
+            <a:ext cx="2623185" cy="4663440"/>
           </a:xfrm>
           <a:prstGeom prst="rect">
             <a:avLst/>
@@ -5940,7 +6552,7 @@
         </p:nvSpPr>
         <p:spPr>
           <a:xfrm>
-            <a:off x="731520" y="411480"/>
+            <a:off x="731520" y="365760"/>
             <a:ext cx="10698480" cy="1005840"/>
           </a:xfrm>
           <a:prstGeom prst="rect">
@@ -5956,28 +6568,28 @@
           <a:p>
             <a:pPr>
               <a:spcAft>
-                <a:spcPts val="300"/>
-              </a:spcAft>
-              <a:defRPr sz="1050" b="1">
+                <a:spcPts val="200"/>
+              </a:spcAft>
+              <a:defRPr sz="1000" b="1">
                 <a:solidFill>
                   <a:srgbClr val="FFB612"/>
                 </a:solidFill>
               </a:defRPr>
             </a:pPr>
             <a:r>
-              <a:t>DETALLE PASO A PASO POR JUEGO</a:t>
-            </a:r>
-          </a:p>
-          <a:p>
-            <a:pPr>
-              <a:defRPr sz="2400" b="1">
+              <a:t>JUEGO POR JUEGO EN DETALLE</a:t>
+            </a:r>
+          </a:p>
+          <a:p>
+            <a:pPr>
+              <a:defRPr sz="2300" b="1">
                 <a:solidFill>
                   <a:srgbClr val="FFFFFF"/>
                 </a:solidFill>
               </a:defRPr>
             </a:pPr>
             <a:r>
-              <a:t>Juego 3: First Striker Wins (El Gol del Partido)</a:t>
+              <a:t>Quinielas Pick'em (NFL y Liga MX): Reglas y Resultados en Vivo</a:t>
             </a:r>
           </a:p>
         </p:txBody>
@@ -5991,7 +6603,7 @@
         <p:spPr>
           <a:xfrm>
             <a:off x="731520" y="1645920"/>
-            <a:ext cx="6858000" cy="4572000"/>
+            <a:ext cx="6858000" cy="4663440"/>
           </a:xfrm>
           <a:prstGeom prst="roundRect">
             <a:avLst/>
@@ -6036,7 +6648,7 @@
         <p:spPr>
           <a:xfrm>
             <a:off x="1005840" y="1828800"/>
-            <a:ext cx="6309360" cy="4114800"/>
+            <a:ext cx="6309360" cy="4206240"/>
           </a:xfrm>
           <a:prstGeom prst="rect">
             <a:avLst/>
@@ -6053,14 +6665,14 @@
               <a:spcAft>
                 <a:spcPts val="200"/>
               </a:spcAft>
-              <a:defRPr sz="1400" b="1">
-                <a:solidFill>
-                  <a:srgbClr val="00E676"/>
-                </a:solidFill>
-              </a:defRPr>
-            </a:pPr>
-            <a:r>
-              <a:t>🛠️ 1. CÓMO LO CREA EL GERENTE (30 seg)</a:t>
+              <a:defRPr sz="1350" b="1">
+                <a:solidFill>
+                  <a:srgbClr val="FFB612"/>
+                </a:solidFill>
+              </a:defRPr>
+            </a:pPr>
+            <a:r>
+              <a:t>🛠️ CÓMO LO CREA EL GERENTE (60 segundos)</a:t>
             </a:r>
           </a:p>
           <a:p>
@@ -6075,7 +6687,7 @@
               </a:defRPr>
             </a:pPr>
             <a:r>
-              <a:t>Elige el partido estelar de fútbol (ej. Clásico Nacional o Champions League) y define el premio inmediato (ej. Jarra de Cerveza o 1 Orden de Boneless para la mesa).</a:t>
+              <a:t>Entra a Admin, elige la liga (NFL o Liga MX) y la jornada. La conexión con ESPN jala automáticamente partidos, horarios y escudos oficiales. El gerente toca los partidos deseados, define el premio (ej. Orden de Alitas + Cerveza) y presiona 'Crear Quiniela'.</a:t>
             </a:r>
           </a:p>
           <a:p>
@@ -6083,14 +6695,14 @@
               <a:spcAft>
                 <a:spcPts val="200"/>
               </a:spcAft>
-              <a:defRPr sz="1400" b="1">
-                <a:solidFill>
-                  <a:srgbClr val="00E676"/>
-                </a:solidFill>
-              </a:defRPr>
-            </a:pPr>
-            <a:r>
-              <a:t>📱 2. CÓMO ENTRA Y JUEGA EL CLIENTE</a:t>
+              <a:defRPr sz="1350" b="1">
+                <a:solidFill>
+                  <a:srgbClr val="FFB612"/>
+                </a:solidFill>
+              </a:defRPr>
+            </a:pPr>
+            <a:r>
+              <a:t>📱 CÓMO JUEGA EL CLIENTE</a:t>
             </a:r>
           </a:p>
           <a:p>
@@ -6105,7 +6717,7 @@
               </a:defRPr>
             </a:pPr>
             <a:r>
-              <a:t>Desde su celular, el comensal selecciona qué equipo anotará primero y en qué bloque de 15 minutos caerá el gol (1-15', 16-30', 31-45', etc.), o la opción de 'Sin Goles'.</a:t>
+              <a:t>Abre la quiniela desde el QR, selecciona a su mesero e introduce sus pronósticos en pantalla. Se bloquean en automático cuando arranca el primer partido para garantizar 100% de transparencia.</a:t>
             </a:r>
           </a:p>
           <a:p>
@@ -6113,14 +6725,14 @@
               <a:spcAft>
                 <a:spcPts val="200"/>
               </a:spcAft>
-              <a:defRPr sz="1400" b="1">
-                <a:solidFill>
-                  <a:srgbClr val="00E676"/>
-                </a:solidFill>
-              </a:defRPr>
-            </a:pPr>
-            <a:r>
-              <a:t>🏆 3. CÓMO GANA: ADRENALINA DESDE EL MINUTO 1</a:t>
+              <a:defRPr sz="1350" b="1">
+                <a:solidFill>
+                  <a:srgbClr val="FFB612"/>
+                </a:solidFill>
+              </a:defRPr>
+            </a:pPr>
+            <a:r>
+              <a:t>🏆 CÓMO GANA Y SE PREMIA</a:t>
             </a:r>
           </a:p>
           <a:p>
@@ -6135,14 +6747,14 @@
               </a:defRPr>
             </a:pPr>
             <a:r>
-              <a:t>En cuanto cae la primera anotación del partido, el sistema valida el minuto oficial de juego. El comensal que acertó el bloque de tiempo gana en el acto, generando gritos de festejo en el bar y rondas de brindis.</a:t>
+              <a:t>La API de ESPN actualiza la tabla en tiempo real: Marcador Exacto = +3 pts (verde esmeralda), Ganador = +1 pt (dorado), Fallo = 0 pts (rojo). Al terminar, se proclama al Campeón Oficial en el podio digital con corona 👑 para canje en barra.</a:t>
             </a:r>
           </a:p>
         </p:txBody>
       </p:sp>
       <p:pic>
         <p:nvPicPr>
-          <p:cNvPr id="5" name="Picture 4" descr="tarjeta_3_instinto_goleador.png"/>
+          <p:cNvPr id="5" name="Picture 4" descr="screenshot_podium_standings.png"/>
           <p:cNvPicPr>
             <a:picLocks noChangeAspect="1"/>
           </p:cNvPicPr>
@@ -6156,8 +6768,8 @@
         </p:blipFill>
         <p:spPr>
           <a:xfrm>
-            <a:off x="7955279" y="1645920"/>
-            <a:ext cx="2571750" cy="4572000"/>
+            <a:off x="7863840" y="1645920"/>
+            <a:ext cx="8843264" cy="4663440"/>
           </a:xfrm>
           <a:prstGeom prst="rect">
             <a:avLst/>
@@ -6198,7 +6810,7 @@
         </p:nvSpPr>
         <p:spPr>
           <a:xfrm>
-            <a:off x="731520" y="411480"/>
+            <a:off x="731520" y="365760"/>
             <a:ext cx="10698480" cy="1005840"/>
           </a:xfrm>
           <a:prstGeom prst="rect">
@@ -6214,28 +6826,28 @@
           <a:p>
             <a:pPr>
               <a:spcAft>
-                <a:spcPts val="300"/>
-              </a:spcAft>
-              <a:defRPr sz="1050" b="1">
+                <a:spcPts val="200"/>
+              </a:spcAft>
+              <a:defRPr sz="1000" b="1">
                 <a:solidFill>
                   <a:srgbClr val="FFB612"/>
                 </a:solidFill>
               </a:defRPr>
             </a:pPr>
             <a:r>
-              <a:t>DETALLE PASO A PASO POR JUEGO</a:t>
-            </a:r>
-          </a:p>
-          <a:p>
-            <a:pPr>
-              <a:defRPr sz="2400" b="1">
+              <a:t>JUEGO POR JUEGO EN DETALLE</a:t>
+            </a:r>
+          </a:p>
+          <a:p>
+            <a:pPr>
+              <a:defRPr sz="2300" b="1">
                 <a:solidFill>
                   <a:srgbClr val="FFFFFF"/>
                 </a:solidFill>
               </a:defRPr>
             </a:pPr>
             <a:r>
-              <a:t>Juegos 4 y 5: Trivia en Pantallas y Survivor NFL</a:t>
+              <a:t>First Striker Wins (Fútbol): Adrenalina Inmediata en el Minuto 1</a:t>
             </a:r>
           </a:p>
         </p:txBody>
@@ -6249,7 +6861,7 @@
         <p:spPr>
           <a:xfrm>
             <a:off x="731520" y="1645920"/>
-            <a:ext cx="5212080" cy="4572000"/>
+            <a:ext cx="6858000" cy="4663440"/>
           </a:xfrm>
           <a:prstGeom prst="roundRect">
             <a:avLst/>
@@ -6294,7 +6906,7 @@
         <p:spPr>
           <a:xfrm>
             <a:off x="1005840" y="1828800"/>
-            <a:ext cx="4663440" cy="4114800"/>
+            <a:ext cx="6309360" cy="4206240"/>
           </a:xfrm>
           <a:prstGeom prst="rect">
             <a:avLst/>
@@ -6309,283 +6921,119 @@
           <a:p>
             <a:pPr>
               <a:spcAft>
-                <a:spcPts val="800"/>
-              </a:spcAft>
-              <a:defRPr sz="1650" b="1">
-                <a:solidFill>
-                  <a:srgbClr val="FFB612"/>
-                </a:solidFill>
-              </a:defRPr>
-            </a:pPr>
-            <a:r>
-              <a:t>🧠 Trivia en Vivo en Pantallas de TV</a:t>
-            </a:r>
-          </a:p>
-          <a:p>
-            <a:pPr>
-              <a:spcAft>
-                <a:spcPts val="100"/>
-              </a:spcAft>
-              <a:defRPr sz="1300" b="1">
-                <a:solidFill>
-                  <a:srgbClr val="FF5722"/>
-                </a:solidFill>
-              </a:defRPr>
-            </a:pPr>
-            <a:r>
-              <a:t>🛠️ Creación con IA</a:t>
-            </a:r>
-          </a:p>
-          <a:p>
-            <a:pPr>
-              <a:spcAft>
-                <a:spcPts val="600"/>
-              </a:spcAft>
-              <a:defRPr sz="1100">
+                <a:spcPts val="200"/>
+              </a:spcAft>
+              <a:defRPr sz="1350" b="1">
+                <a:solidFill>
+                  <a:srgbClr val="00E676"/>
+                </a:solidFill>
+              </a:defRPr>
+            </a:pPr>
+            <a:r>
+              <a:t>🛠️ CÓMO LO CREA EL GERENTE (30 segundos)</a:t>
+            </a:r>
+          </a:p>
+          <a:p>
+            <a:pPr>
+              <a:spcAft>
+                <a:spcPts val="1000"/>
+              </a:spcAft>
+              <a:defRPr sz="1150">
                 <a:solidFill>
                   <a:srgbClr val="FFFFFF"/>
                 </a:solidFill>
               </a:defRPr>
             </a:pPr>
             <a:r>
-              <a:t>El gerente genera 10 preguntas deportivas temáticas con IA en 10 segundos.</a:t>
-            </a:r>
-          </a:p>
-          <a:p>
-            <a:pPr>
-              <a:spcAft>
-                <a:spcPts val="100"/>
-              </a:spcAft>
-              <a:defRPr sz="1300" b="1">
-                <a:solidFill>
-                  <a:srgbClr val="FF5722"/>
-                </a:solidFill>
-              </a:defRPr>
-            </a:pPr>
-            <a:r>
-              <a:t>📱 Juego en Vivo</a:t>
-            </a:r>
-          </a:p>
-          <a:p>
-            <a:pPr>
-              <a:spcAft>
-                <a:spcPts val="600"/>
-              </a:spcAft>
-              <a:defRPr sz="1100">
+              <a:t>Elige el partido de fútbol (Liga MX, Champions League o Selección Nacional) y asigna un premio dinámico (ej. 1 ronda de cervezas o botana en mesa).</a:t>
+            </a:r>
+          </a:p>
+          <a:p>
+            <a:pPr>
+              <a:spcAft>
+                <a:spcPts val="200"/>
+              </a:spcAft>
+              <a:defRPr sz="1350" b="1">
+                <a:solidFill>
+                  <a:srgbClr val="00E676"/>
+                </a:solidFill>
+              </a:defRPr>
+            </a:pPr>
+            <a:r>
+              <a:t>📱 CÓMO JUEGA EL CLIENTE</a:t>
+            </a:r>
+          </a:p>
+          <a:p>
+            <a:pPr>
+              <a:spcAft>
+                <a:spcPts val="1000"/>
+              </a:spcAft>
+              <a:defRPr sz="1150">
                 <a:solidFill>
                   <a:srgbClr val="FFFFFF"/>
                 </a:solidFill>
               </a:defRPr>
             </a:pPr>
             <a:r>
-              <a:t>En el medio tiempo, la TV del bar muestra la pregunta con cuenta regresiva. Los clientes responden contrarreloj desde su smartphone.</a:t>
-            </a:r>
-          </a:p>
-          <a:p>
-            <a:pPr>
-              <a:spcAft>
-                <a:spcPts val="100"/>
-              </a:spcAft>
-              <a:defRPr sz="1300" b="1">
-                <a:solidFill>
-                  <a:srgbClr val="FF5722"/>
-                </a:solidFill>
-              </a:defRPr>
-            </a:pPr>
-            <a:r>
-              <a:t>🏆 Ganador</a:t>
-            </a:r>
-          </a:p>
-          <a:p>
-            <a:pPr>
-              <a:spcAft>
-                <a:spcPts val="600"/>
-              </a:spcAft>
-              <a:defRPr sz="1100">
+              <a:t>Elige qué equipo meterá el primer gol y en qué bloque de 15 minutos caerá (1-15', 16-30', 31-45', etc.), o la opción de 'Sin Goles en el Partido'.</a:t>
+            </a:r>
+          </a:p>
+          <a:p>
+            <a:pPr>
+              <a:spcAft>
+                <a:spcPts val="200"/>
+              </a:spcAft>
+              <a:defRPr sz="1350" b="1">
+                <a:solidFill>
+                  <a:srgbClr val="00E676"/>
+                </a:solidFill>
+              </a:defRPr>
+            </a:pPr>
+            <a:r>
+              <a:t>🏆 CÓMO GANA: EUFORIA DESDE EL INICIO</a:t>
+            </a:r>
+          </a:p>
+          <a:p>
+            <a:pPr>
+              <a:spcAft>
+                <a:spcPts val="1000"/>
+              </a:spcAft>
+              <a:defRPr sz="1150">
                 <a:solidFill>
                   <a:srgbClr val="FFFFFF"/>
                 </a:solidFill>
               </a:defRPr>
             </a:pPr>
             <a:r>
-              <a:t>La pantalla de TV muestra el podio del bar en tiempo real con fanfarrias y aplausos en el restaurante.</a:t>
-            </a:r>
-          </a:p>
-        </p:txBody>
-      </p:sp>
-      <p:sp>
-        <p:nvSpPr>
-          <p:cNvPr id="5" name="Rounded Rectangle 4"/>
-          <p:cNvSpPr/>
+              <a:t>En cuanto cae la primera anotación, el sistema valida el minuto oficial de juego. El comensal que acertó el bloque de tiempo gana en el acto, provocando festejos y más rondas de bebidas en su mesa.</a:t>
+            </a:r>
+          </a:p>
+        </p:txBody>
+      </p:sp>
+      <p:pic>
+        <p:nvPicPr>
+          <p:cNvPr id="5" name="Picture 4" descr="tarjeta_3_instinto_goleador.png"/>
+          <p:cNvPicPr>
+            <a:picLocks noChangeAspect="1"/>
+          </p:cNvPicPr>
           <p:nvPr/>
-        </p:nvSpPr>
-        <p:spPr>
-          <a:xfrm>
-            <a:off x="6217920" y="1645920"/>
-            <a:ext cx="5212080" cy="4572000"/>
-          </a:xfrm>
-          <a:prstGeom prst="roundRect">
-            <a:avLst/>
-          </a:prstGeom>
-          <a:solidFill>
-            <a:srgbClr val="141A26"/>
-          </a:solidFill>
-          <a:ln w="19050">
-            <a:solidFill>
-              <a:srgbClr val="283246"/>
-            </a:solidFill>
-          </a:ln>
-        </p:spPr>
-        <p:style>
-          <a:lnRef idx="1">
-            <a:schemeClr val="accent1"/>
-          </a:lnRef>
-          <a:fillRef idx="3">
-            <a:schemeClr val="accent1"/>
-          </a:fillRef>
-          <a:effectRef idx="2">
-            <a:schemeClr val="accent1"/>
-          </a:effectRef>
-          <a:fontRef idx="minor">
-            <a:schemeClr val="lt1"/>
-          </a:fontRef>
-        </p:style>
-        <p:txBody>
-          <a:bodyPr rtlCol="0" anchor="ctr"/>
-          <a:lstStyle/>
-          <a:p>
-            <a:pPr algn="ctr"/>
-          </a:p>
-        </p:txBody>
-      </p:sp>
-      <p:sp>
-        <p:nvSpPr>
-          <p:cNvPr id="6" name="TextBox 5"/>
-          <p:cNvSpPr txBox="1"/>
-          <p:nvPr/>
-        </p:nvSpPr>
-        <p:spPr>
-          <a:xfrm>
-            <a:off x="6492240" y="1828800"/>
-            <a:ext cx="4663440" cy="4114800"/>
+        </p:nvPicPr>
+        <p:blipFill>
+          <a:blip r:embed="rId2"/>
+          <a:stretch>
+            <a:fillRect/>
+          </a:stretch>
+        </p:blipFill>
+        <p:spPr>
+          <a:xfrm>
+            <a:off x="7955279" y="1645920"/>
+            <a:ext cx="2623185" cy="4663440"/>
           </a:xfrm>
           <a:prstGeom prst="rect">
             <a:avLst/>
           </a:prstGeom>
-          <a:noFill/>
-        </p:spPr>
-        <p:txBody>
-          <a:bodyPr wrap="square">
-            <a:spAutoFit/>
-          </a:bodyPr>
-          <a:lstStyle/>
-          <a:p>
-            <a:pPr>
-              <a:spcAft>
-                <a:spcPts val="800"/>
-              </a:spcAft>
-              <a:defRPr sz="1650" b="1">
-                <a:solidFill>
-                  <a:srgbClr val="00E676"/>
-                </a:solidFill>
-              </a:defRPr>
-            </a:pPr>
-            <a:r>
-              <a:t>🛡️ Survivor NFL: Fidelización Semanal</a:t>
-            </a:r>
-          </a:p>
-          <a:p>
-            <a:pPr>
-              <a:spcAft>
-                <a:spcPts val="100"/>
-              </a:spcAft>
-              <a:defRPr sz="1300" b="1">
-                <a:solidFill>
-                  <a:srgbClr val="FFD100"/>
-                </a:solidFill>
-              </a:defRPr>
-            </a:pPr>
-            <a:r>
-              <a:t>🛠️ Creación Única</a:t>
-            </a:r>
-          </a:p>
-          <a:p>
-            <a:pPr>
-              <a:spcAft>
-                <a:spcPts val="600"/>
-              </a:spcAft>
-              <a:defRPr sz="1100">
-                <a:solidFill>
-                  <a:srgbClr val="FFFFFF"/>
-                </a:solidFill>
-              </a:defRPr>
-            </a:pPr>
-            <a:r>
-              <a:t>Se abre al inicio de la temporada regular de NFL.</a:t>
-            </a:r>
-          </a:p>
-          <a:p>
-            <a:pPr>
-              <a:spcAft>
-                <a:spcPts val="100"/>
-              </a:spcAft>
-              <a:defRPr sz="1300" b="1">
-                <a:solidFill>
-                  <a:srgbClr val="FFD100"/>
-                </a:solidFill>
-              </a:defRPr>
-            </a:pPr>
-            <a:r>
-              <a:t>📱 Elección Semanal</a:t>
-            </a:r>
-          </a:p>
-          <a:p>
-            <a:pPr>
-              <a:spcAft>
-                <a:spcPts val="600"/>
-              </a:spcAft>
-              <a:defRPr sz="1100">
-                <a:solidFill>
-                  <a:srgbClr val="FFFFFF"/>
-                </a:solidFill>
-              </a:defRPr>
-            </a:pPr>
-            <a:r>
-              <a:t>Cada comensal elige 1 equipo ganador por semana sin repetir. Si su equipo gana, sobrevive; si pierde, queda eliminado.</a:t>
-            </a:r>
-          </a:p>
-          <a:p>
-            <a:pPr>
-              <a:spcAft>
-                <a:spcPts val="100"/>
-              </a:spcAft>
-              <a:defRPr sz="1300" b="1">
-                <a:solidFill>
-                  <a:srgbClr val="FFD100"/>
-                </a:solidFill>
-              </a:defRPr>
-            </a:pPr>
-            <a:r>
-              <a:t>🏆 Retención Frecuente</a:t>
-            </a:r>
-          </a:p>
-          <a:p>
-            <a:pPr>
-              <a:spcAft>
-                <a:spcPts val="600"/>
-              </a:spcAft>
-              <a:defRPr sz="1100">
-                <a:solidFill>
-                  <a:srgbClr val="FFFFFF"/>
-                </a:solidFill>
-              </a:defRPr>
-            </a:pPr>
-            <a:r>
-              <a:t>Obliga al cliente a regresar cada semana a la sucursal para defender su boleto de sobreviviente y competir por el premio mayor de la temporada.</a:t>
-            </a:r>
-          </a:p>
-        </p:txBody>
-      </p:sp>
+        </p:spPr>
+      </p:pic>
     </p:spTree>
   </p:cSld>
   <p:clrMapOvr>
@@ -6620,7 +7068,7 @@
         </p:nvSpPr>
         <p:spPr>
           <a:xfrm>
-            <a:off x="731520" y="411480"/>
+            <a:off x="731520" y="365760"/>
             <a:ext cx="10698480" cy="1005840"/>
           </a:xfrm>
           <a:prstGeom prst="rect">
@@ -6636,28 +7084,28 @@
           <a:p>
             <a:pPr>
               <a:spcAft>
-                <a:spcPts val="300"/>
-              </a:spcAft>
-              <a:defRPr sz="1050" b="1">
+                <a:spcPts val="200"/>
+              </a:spcAft>
+              <a:defRPr sz="1000" b="1">
                 <a:solidFill>
                   <a:srgbClr val="FFB612"/>
                 </a:solidFill>
               </a:defRPr>
             </a:pPr>
             <a:r>
-              <a:t>RENTABILIDAD Y VENTAS</a:t>
-            </a:r>
-          </a:p>
-          <a:p>
-            <a:pPr>
-              <a:defRPr sz="2400" b="1">
+              <a:t>JUEGO POR JUEGO EN DETALLE</a:t>
+            </a:r>
+          </a:p>
+          <a:p>
+            <a:pPr>
+              <a:defRPr sz="2300" b="1">
                 <a:solidFill>
                   <a:srgbClr val="FFFFFF"/>
                 </a:solidFill>
               </a:defRPr>
             </a:pPr>
             <a:r>
-              <a:t>Estrategia de Premios: Diseñada para Proteger el Margen</a:t>
+              <a:t>Trivias en TV con IA &amp; Survivor NFL: Medios Tiempos y Fidelidad</a:t>
             </a:r>
           </a:p>
         </p:txBody>
@@ -6671,7 +7119,7 @@
         <p:spPr>
           <a:xfrm>
             <a:off x="731520" y="1645920"/>
-            <a:ext cx="3413455" cy="4572000"/>
+            <a:ext cx="5212080" cy="4663440"/>
           </a:xfrm>
           <a:prstGeom prst="roundRect">
             <a:avLst/>
@@ -6715,8 +7163,8 @@
         </p:nvSpPr>
         <p:spPr>
           <a:xfrm>
-            <a:off x="1005840" y="1920240"/>
-            <a:ext cx="2864815" cy="4023360"/>
+            <a:off x="1005840" y="1828800"/>
+            <a:ext cx="4663440" cy="4206240"/>
           </a:xfrm>
           <a:prstGeom prst="rect">
             <a:avLst/>
@@ -6731,7 +7179,7 @@
           <a:p>
             <a:pPr>
               <a:spcAft>
-                <a:spcPts val="1400"/>
+                <a:spcPts val="800"/>
               </a:spcAft>
               <a:defRPr sz="1650" b="1">
                 <a:solidFill>
@@ -6740,19 +7188,97 @@
               </a:defRPr>
             </a:pPr>
             <a:r>
-              <a:t>🍔 Alto Valor Percibido vs Bajo Costo</a:t>
-            </a:r>
-          </a:p>
-          <a:p>
-            <a:pPr>
-              <a:defRPr sz="1300">
+              <a:t>🧠 Trivia en Pantallas de TV con IA</a:t>
+            </a:r>
+          </a:p>
+          <a:p>
+            <a:pPr>
+              <a:spcAft>
+                <a:spcPts val="100"/>
+              </a:spcAft>
+              <a:defRPr sz="1250" b="1">
+                <a:solidFill>
+                  <a:srgbClr val="FF5722"/>
+                </a:solidFill>
+              </a:defRPr>
+            </a:pPr>
+            <a:r>
+              <a:t>🛠️ Generación IA en 10 seg</a:t>
+            </a:r>
+          </a:p>
+          <a:p>
+            <a:pPr>
+              <a:spcAft>
+                <a:spcPts val="600"/>
+              </a:spcAft>
+              <a:defRPr sz="1100">
                 <a:solidFill>
                   <a:srgbClr val="FFFFFF"/>
                 </a:solidFill>
               </a:defRPr>
             </a:pPr>
             <a:r>
-              <a:t>Una orden de alitas o una cerveza tiene un costo de materia prima muy manejable para la cocina ($30-$50 MXN), pero en la mente del cliente representa un premio valioso de $160 a $240 MXN.</a:t>
+              <a:t>La Inteligencia Artificial genera 10 preguntas deportivas temáticas del partido en cuestión.</a:t>
+            </a:r>
+          </a:p>
+          <a:p>
+            <a:pPr>
+              <a:spcAft>
+                <a:spcPts val="100"/>
+              </a:spcAft>
+              <a:defRPr sz="1250" b="1">
+                <a:solidFill>
+                  <a:srgbClr val="FF5722"/>
+                </a:solidFill>
+              </a:defRPr>
+            </a:pPr>
+            <a:r>
+              <a:t>📱 Medio Tiempo Interactivo</a:t>
+            </a:r>
+          </a:p>
+          <a:p>
+            <a:pPr>
+              <a:spcAft>
+                <a:spcPts val="600"/>
+              </a:spcAft>
+              <a:defRPr sz="1100">
+                <a:solidFill>
+                  <a:srgbClr val="FFFFFF"/>
+                </a:solidFill>
+              </a:defRPr>
+            </a:pPr>
+            <a:r>
+              <a:t>La TV del bar muestra la pregunta con cuenta regresiva. Los clientes responden contrarreloj desde su smartphone compitiendo mesa contra mesa.</a:t>
+            </a:r>
+          </a:p>
+          <a:p>
+            <a:pPr>
+              <a:spcAft>
+                <a:spcPts val="100"/>
+              </a:spcAft>
+              <a:defRPr sz="1250" b="1">
+                <a:solidFill>
+                  <a:srgbClr val="FF5722"/>
+                </a:solidFill>
+              </a:defRPr>
+            </a:pPr>
+            <a:r>
+              <a:t>🏆 Podio en Pantalla Grande</a:t>
+            </a:r>
+          </a:p>
+          <a:p>
+            <a:pPr>
+              <a:spcAft>
+                <a:spcPts val="600"/>
+              </a:spcAft>
+              <a:defRPr sz="1100">
+                <a:solidFill>
+                  <a:srgbClr val="FFFFFF"/>
+                </a:solidFill>
+              </a:defRPr>
+            </a:pPr>
+            <a:r>
+              <a:t>El restaurante entero ve subir el ranking en vivo en la TV.</a:t>
             </a:r>
           </a:p>
         </p:txBody>
@@ -6765,8 +7291,8 @@
         </p:nvSpPr>
         <p:spPr>
           <a:xfrm>
-            <a:off x="4389120" y="1645920"/>
-            <a:ext cx="3413455" cy="4572000"/>
+            <a:off x="6217920" y="1645920"/>
+            <a:ext cx="5212080" cy="4663440"/>
           </a:xfrm>
           <a:prstGeom prst="roundRect">
             <a:avLst/>
@@ -6810,8 +7336,8 @@
         </p:nvSpPr>
         <p:spPr>
           <a:xfrm>
-            <a:off x="4663440" y="1920240"/>
-            <a:ext cx="2864815" cy="4023360"/>
+            <a:off x="6492240" y="1828800"/>
+            <a:ext cx="4663440" cy="4206240"/>
           </a:xfrm>
           <a:prstGeom prst="rect">
             <a:avLst/>
@@ -6826,7 +7352,7 @@
           <a:p>
             <a:pPr>
               <a:spcAft>
-                <a:spcPts val="1400"/>
+                <a:spcPts val="800"/>
               </a:spcAft>
               <a:defRPr sz="1650" b="1">
                 <a:solidFill>
@@ -6835,114 +7361,97 @@
               </a:defRPr>
             </a:pPr>
             <a:r>
-              <a:t>🍻 Festejo y Rondas Adicionales</a:t>
-            </a:r>
-          </a:p>
-          <a:p>
-            <a:pPr>
-              <a:defRPr sz="1300">
+              <a:t>🛡️ Survivor NFL (Fidelidad Semanal)</a:t>
+            </a:r>
+          </a:p>
+          <a:p>
+            <a:pPr>
+              <a:spcAft>
+                <a:spcPts val="100"/>
+              </a:spcAft>
+              <a:defRPr sz="1250" b="1">
+                <a:solidFill>
+                  <a:srgbClr val="FFD100"/>
+                </a:solidFill>
+              </a:defRPr>
+            </a:pPr>
+            <a:r>
+              <a:t>🛠️ Creación Única</a:t>
+            </a:r>
+          </a:p>
+          <a:p>
+            <a:pPr>
+              <a:spcAft>
+                <a:spcPts val="600"/>
+              </a:spcAft>
+              <a:defRPr sz="1100">
                 <a:solidFill>
                   <a:srgbClr val="FFFFFF"/>
                 </a:solidFill>
               </a:defRPr>
             </a:pPr>
             <a:r>
-              <a:t>Nadie gana y se va. El comensal que resulta campeón celebra con su mesa, y el grupo pide cervezas y platillos adicionales para acompañar el premio. El ticket final siempre supera con creces el costo del incentivo.</a:t>
-            </a:r>
-          </a:p>
-        </p:txBody>
-      </p:sp>
-      <p:sp>
-        <p:nvSpPr>
-          <p:cNvPr id="7" name="Rounded Rectangle 6"/>
-          <p:cNvSpPr/>
-          <p:nvPr/>
-        </p:nvSpPr>
-        <p:spPr>
-          <a:xfrm>
-            <a:off x="8046720" y="1645920"/>
-            <a:ext cx="3413455" cy="4572000"/>
-          </a:xfrm>
-          <a:prstGeom prst="roundRect">
-            <a:avLst/>
-          </a:prstGeom>
-          <a:solidFill>
-            <a:srgbClr val="141A26"/>
-          </a:solidFill>
-          <a:ln w="19050">
-            <a:solidFill>
-              <a:srgbClr val="283246"/>
-            </a:solidFill>
-          </a:ln>
-        </p:spPr>
-        <p:style>
-          <a:lnRef idx="1">
-            <a:schemeClr val="accent1"/>
-          </a:lnRef>
-          <a:fillRef idx="3">
-            <a:schemeClr val="accent1"/>
-          </a:fillRef>
-          <a:effectRef idx="2">
-            <a:schemeClr val="accent1"/>
-          </a:effectRef>
-          <a:fontRef idx="minor">
-            <a:schemeClr val="lt1"/>
-          </a:fontRef>
-        </p:style>
-        <p:txBody>
-          <a:bodyPr rtlCol="0" anchor="ctr"/>
-          <a:lstStyle/>
-          <a:p>
-            <a:pPr algn="ctr"/>
-          </a:p>
-        </p:txBody>
-      </p:sp>
-      <p:sp>
-        <p:nvSpPr>
-          <p:cNvPr id="8" name="TextBox 7"/>
-          <p:cNvSpPr txBox="1"/>
-          <p:nvPr/>
-        </p:nvSpPr>
-        <p:spPr>
-          <a:xfrm>
-            <a:off x="8321040" y="1920240"/>
-            <a:ext cx="2864815" cy="4023360"/>
-          </a:xfrm>
-          <a:prstGeom prst="rect">
-            <a:avLst/>
-          </a:prstGeom>
-          <a:noFill/>
-        </p:spPr>
-        <p:txBody>
-          <a:bodyPr wrap="square">
-            <a:spAutoFit/>
-          </a:bodyPr>
-          <a:lstStyle/>
-          <a:p>
-            <a:pPr>
-              <a:spcAft>
-                <a:spcPts val="1400"/>
-              </a:spcAft>
-              <a:defRPr sz="1650" b="1">
-                <a:solidFill>
-                  <a:srgbClr val="FF5722"/>
-                </a:solidFill>
-              </a:defRPr>
-            </a:pPr>
-            <a:r>
-              <a:t>🔄 Retorno Asegurado en Días Bajas</a:t>
-            </a:r>
-          </a:p>
-          <a:p>
-            <a:pPr>
-              <a:defRPr sz="1300">
+              <a:t>Se activa al inicio de la temporada regular de NFL.</a:t>
+            </a:r>
+          </a:p>
+          <a:p>
+            <a:pPr>
+              <a:spcAft>
+                <a:spcPts val="100"/>
+              </a:spcAft>
+              <a:defRPr sz="1250" b="1">
+                <a:solidFill>
+                  <a:srgbClr val="FFD100"/>
+                </a:solidFill>
+              </a:defRPr>
+            </a:pPr>
+            <a:r>
+              <a:t>📱 1 Equipo por Semana</a:t>
+            </a:r>
+          </a:p>
+          <a:p>
+            <a:pPr>
+              <a:spcAft>
+                <a:spcPts val="600"/>
+              </a:spcAft>
+              <a:defRPr sz="1100">
                 <a:solidFill>
                   <a:srgbClr val="FFFFFF"/>
                 </a:solidFill>
               </a:defRPr>
             </a:pPr>
             <a:r>
-              <a:t>Los cupones de 2º y 3º lugar se pueden programar para canjearse de lunes a jueves en su siguiente visita, generando tráfico en días y horarios con menor ocupación.</a:t>
+              <a:t>El cliente elige 1 equipo ganador por semana sin repetir. Si su equipo gana, sobrevive; si pierde, queda eliminado.</a:t>
+            </a:r>
+          </a:p>
+          <a:p>
+            <a:pPr>
+              <a:spcAft>
+                <a:spcPts val="100"/>
+              </a:spcAft>
+              <a:defRPr sz="1250" b="1">
+                <a:solidFill>
+                  <a:srgbClr val="FFD100"/>
+                </a:solidFill>
+              </a:defRPr>
+            </a:pPr>
+            <a:r>
+              <a:t>🏆 Retención Obligatoria</a:t>
+            </a:r>
+          </a:p>
+          <a:p>
+            <a:pPr>
+              <a:spcAft>
+                <a:spcPts val="600"/>
+              </a:spcAft>
+              <a:defRPr sz="1100">
+                <a:solidFill>
+                  <a:srgbClr val="FFFFFF"/>
+                </a:solidFill>
+              </a:defRPr>
+            </a:pPr>
+            <a:r>
+              <a:t>Obliga al cliente a regresar semana tras semana a la sucursal para defender su boleto de sobreviviente.</a:t>
             </a:r>
           </a:p>
         </p:txBody>

</xml_diff>

<commit_message>
feat(presentation): agregar slide 2 de definicion, objetivo estrategico y metas clave (15 diapositivas)
</commit_message>
<xml_diff>
--- a/Drinks_and_Wins_Presentacion_Ejecutiva.pptx
+++ b/Drinks_and_Wins_Presentacion_Ejecutiva.pptx
@@ -19,6 +19,7 @@
     <p:sldId id="267" r:id="rId18"/>
     <p:sldId id="268" r:id="rId19"/>
     <p:sldId id="269" r:id="rId20"/>
+    <p:sldId id="270" r:id="rId21"/>
   </p:sldIdLst>
   <p:sldSz cx="12191695" cy="6858000" type="screen4x3"/>
   <p:notesSz cx="6858000" cy="9144000"/>
@@ -3332,7 +3333,7 @@
               </a:defRPr>
             </a:pPr>
             <a:r>
-              <a:t>RENTABILIDAD Y VENTAS</a:t>
+              <a:t>JUEGO POR JUEGO EN DETALLE</a:t>
             </a:r>
           </a:p>
           <a:p>
@@ -3344,7 +3345,7 @@
               </a:defRPr>
             </a:pPr>
             <a:r>
-              <a:t>Estrategia de Premios: Diseñada para Proteger el Margen</a:t>
+              <a:t>Trivias en TV con IA &amp; Survivor NFL: Medios Tiempos y Fidelidad</a:t>
             </a:r>
           </a:p>
         </p:txBody>
@@ -3358,7 +3359,7 @@
         <p:spPr>
           <a:xfrm>
             <a:off x="731520" y="1645920"/>
-            <a:ext cx="3413455" cy="4663440"/>
+            <a:ext cx="5212080" cy="4663440"/>
           </a:xfrm>
           <a:prstGeom prst="roundRect">
             <a:avLst/>
@@ -3402,8 +3403,8 @@
         </p:nvSpPr>
         <p:spPr>
           <a:xfrm>
-            <a:off x="1005840" y="1920240"/>
-            <a:ext cx="2864815" cy="4114800"/>
+            <a:off x="1005840" y="1828800"/>
+            <a:ext cx="4663440" cy="4206240"/>
           </a:xfrm>
           <a:prstGeom prst="rect">
             <a:avLst/>
@@ -3418,28 +3419,106 @@
           <a:p>
             <a:pPr>
               <a:spcAft>
-                <a:spcPts val="1400"/>
-              </a:spcAft>
-              <a:defRPr sz="1600" b="1">
+                <a:spcPts val="800"/>
+              </a:spcAft>
+              <a:defRPr sz="1650" b="1">
                 <a:solidFill>
                   <a:srgbClr val="FFB612"/>
                 </a:solidFill>
               </a:defRPr>
             </a:pPr>
             <a:r>
-              <a:t>🍔 Alto Valor Percibido vs Bajo Costo</a:t>
-            </a:r>
-          </a:p>
-          <a:p>
-            <a:pPr>
-              <a:defRPr sz="1300">
+              <a:t>🧠 Trivia en Pantallas de TV con IA</a:t>
+            </a:r>
+          </a:p>
+          <a:p>
+            <a:pPr>
+              <a:spcAft>
+                <a:spcPts val="100"/>
+              </a:spcAft>
+              <a:defRPr sz="1250" b="1">
+                <a:solidFill>
+                  <a:srgbClr val="FF5722"/>
+                </a:solidFill>
+              </a:defRPr>
+            </a:pPr>
+            <a:r>
+              <a:t>🛠️ Generación IA en 10 seg</a:t>
+            </a:r>
+          </a:p>
+          <a:p>
+            <a:pPr>
+              <a:spcAft>
+                <a:spcPts val="600"/>
+              </a:spcAft>
+              <a:defRPr sz="1100">
                 <a:solidFill>
                   <a:srgbClr val="FFFFFF"/>
                 </a:solidFill>
               </a:defRPr>
             </a:pPr>
             <a:r>
-              <a:t>Una orden de alitas o una cerveza tiene un costo de insumo moderado para cocina/barra ($30-$50 MXN), pero en la mente del cliente representa un premio valioso de $160 a $240 MXN.</a:t>
+              <a:t>La Inteligencia Artificial genera 10 preguntas deportivas temáticas del partido en cuestión.</a:t>
+            </a:r>
+          </a:p>
+          <a:p>
+            <a:pPr>
+              <a:spcAft>
+                <a:spcPts val="100"/>
+              </a:spcAft>
+              <a:defRPr sz="1250" b="1">
+                <a:solidFill>
+                  <a:srgbClr val="FF5722"/>
+                </a:solidFill>
+              </a:defRPr>
+            </a:pPr>
+            <a:r>
+              <a:t>📱 Medio Tiempo Interactivo</a:t>
+            </a:r>
+          </a:p>
+          <a:p>
+            <a:pPr>
+              <a:spcAft>
+                <a:spcPts val="600"/>
+              </a:spcAft>
+              <a:defRPr sz="1100">
+                <a:solidFill>
+                  <a:srgbClr val="FFFFFF"/>
+                </a:solidFill>
+              </a:defRPr>
+            </a:pPr>
+            <a:r>
+              <a:t>La TV del bar muestra la pregunta con cuenta regresiva. Los clientes responden contrarreloj desde su smartphone compitiendo mesa contra mesa.</a:t>
+            </a:r>
+          </a:p>
+          <a:p>
+            <a:pPr>
+              <a:spcAft>
+                <a:spcPts val="100"/>
+              </a:spcAft>
+              <a:defRPr sz="1250" b="1">
+                <a:solidFill>
+                  <a:srgbClr val="FF5722"/>
+                </a:solidFill>
+              </a:defRPr>
+            </a:pPr>
+            <a:r>
+              <a:t>🏆 Podio en Pantalla Grande</a:t>
+            </a:r>
+          </a:p>
+          <a:p>
+            <a:pPr>
+              <a:spcAft>
+                <a:spcPts val="600"/>
+              </a:spcAft>
+              <a:defRPr sz="1100">
+                <a:solidFill>
+                  <a:srgbClr val="FFFFFF"/>
+                </a:solidFill>
+              </a:defRPr>
+            </a:pPr>
+            <a:r>
+              <a:t>El restaurante entero ve subir el ranking en vivo en la TV.</a:t>
             </a:r>
           </a:p>
         </p:txBody>
@@ -3452,8 +3531,8 @@
         </p:nvSpPr>
         <p:spPr>
           <a:xfrm>
-            <a:off x="4389120" y="1645920"/>
-            <a:ext cx="3413455" cy="4663440"/>
+            <a:off x="6217920" y="1645920"/>
+            <a:ext cx="5212080" cy="4663440"/>
           </a:xfrm>
           <a:prstGeom prst="roundRect">
             <a:avLst/>
@@ -3497,8 +3576,8 @@
         </p:nvSpPr>
         <p:spPr>
           <a:xfrm>
-            <a:off x="4663440" y="1920240"/>
-            <a:ext cx="2864815" cy="4114800"/>
+            <a:off x="6492240" y="1828800"/>
+            <a:ext cx="4663440" cy="4206240"/>
           </a:xfrm>
           <a:prstGeom prst="rect">
             <a:avLst/>
@@ -3513,123 +3592,106 @@
           <a:p>
             <a:pPr>
               <a:spcAft>
-                <a:spcPts val="1400"/>
-              </a:spcAft>
-              <a:defRPr sz="1600" b="1">
+                <a:spcPts val="800"/>
+              </a:spcAft>
+              <a:defRPr sz="1650" b="1">
                 <a:solidFill>
                   <a:srgbClr val="00E676"/>
                 </a:solidFill>
               </a:defRPr>
             </a:pPr>
             <a:r>
-              <a:t>🍻 Festejo y Rondas Extra en Mesa</a:t>
-            </a:r>
-          </a:p>
-          <a:p>
-            <a:pPr>
-              <a:defRPr sz="1300">
+              <a:t>🛡️ Survivor NFL (Fidelidad Semanal)</a:t>
+            </a:r>
+          </a:p>
+          <a:p>
+            <a:pPr>
+              <a:spcAft>
+                <a:spcPts val="100"/>
+              </a:spcAft>
+              <a:defRPr sz="1250" b="1">
+                <a:solidFill>
+                  <a:srgbClr val="FFD100"/>
+                </a:solidFill>
+              </a:defRPr>
+            </a:pPr>
+            <a:r>
+              <a:t>🛠️ Creación Única</a:t>
+            </a:r>
+          </a:p>
+          <a:p>
+            <a:pPr>
+              <a:spcAft>
+                <a:spcPts val="600"/>
+              </a:spcAft>
+              <a:defRPr sz="1100">
                 <a:solidFill>
                   <a:srgbClr val="FFFFFF"/>
                 </a:solidFill>
               </a:defRPr>
             </a:pPr>
             <a:r>
-              <a:t>Nadie gana y se va. El comensal que resulta campeón celebra con su mesa, y el grupo pide cervezas y platillos adicionales para acompañar el premio. El ticket final siempre supera con creces el costo del incentivo.</a:t>
-            </a:r>
-          </a:p>
-        </p:txBody>
-      </p:sp>
-      <p:sp>
-        <p:nvSpPr>
-          <p:cNvPr id="7" name="Rounded Rectangle 6"/>
-          <p:cNvSpPr/>
-          <p:nvPr/>
-        </p:nvSpPr>
-        <p:spPr>
-          <a:xfrm>
-            <a:off x="8046720" y="1645920"/>
-            <a:ext cx="3413455" cy="4663440"/>
-          </a:xfrm>
-          <a:prstGeom prst="roundRect">
-            <a:avLst/>
-          </a:prstGeom>
-          <a:solidFill>
-            <a:srgbClr val="141A26"/>
-          </a:solidFill>
-          <a:ln w="19050">
-            <a:solidFill>
-              <a:srgbClr val="283246"/>
-            </a:solidFill>
-          </a:ln>
-        </p:spPr>
-        <p:style>
-          <a:lnRef idx="1">
-            <a:schemeClr val="accent1"/>
-          </a:lnRef>
-          <a:fillRef idx="3">
-            <a:schemeClr val="accent1"/>
-          </a:fillRef>
-          <a:effectRef idx="2">
-            <a:schemeClr val="accent1"/>
-          </a:effectRef>
-          <a:fontRef idx="minor">
-            <a:schemeClr val="lt1"/>
-          </a:fontRef>
-        </p:style>
-        <p:txBody>
-          <a:bodyPr rtlCol="0" anchor="ctr"/>
-          <a:lstStyle/>
-          <a:p>
-            <a:pPr algn="ctr"/>
-          </a:p>
-        </p:txBody>
-      </p:sp>
-      <p:sp>
-        <p:nvSpPr>
-          <p:cNvPr id="8" name="TextBox 7"/>
-          <p:cNvSpPr txBox="1"/>
-          <p:nvPr/>
-        </p:nvSpPr>
-        <p:spPr>
-          <a:xfrm>
-            <a:off x="8321040" y="1920240"/>
-            <a:ext cx="2864815" cy="4114800"/>
-          </a:xfrm>
-          <a:prstGeom prst="rect">
-            <a:avLst/>
-          </a:prstGeom>
-          <a:noFill/>
-        </p:spPr>
-        <p:txBody>
-          <a:bodyPr wrap="square">
-            <a:spAutoFit/>
-          </a:bodyPr>
-          <a:lstStyle/>
-          <a:p>
-            <a:pPr>
-              <a:spcAft>
-                <a:spcPts val="1400"/>
-              </a:spcAft>
-              <a:defRPr sz="1600" b="1">
-                <a:solidFill>
-                  <a:srgbClr val="FF5722"/>
-                </a:solidFill>
-              </a:defRPr>
-            </a:pPr>
-            <a:r>
-              <a:t>🔄 Retorno Asegurado en Días Bajas</a:t>
-            </a:r>
-          </a:p>
-          <a:p>
-            <a:pPr>
-              <a:defRPr sz="1300">
+              <a:t>Se activa al inicio de la temporada regular de NFL.</a:t>
+            </a:r>
+          </a:p>
+          <a:p>
+            <a:pPr>
+              <a:spcAft>
+                <a:spcPts val="100"/>
+              </a:spcAft>
+              <a:defRPr sz="1250" b="1">
+                <a:solidFill>
+                  <a:srgbClr val="FFD100"/>
+                </a:solidFill>
+              </a:defRPr>
+            </a:pPr>
+            <a:r>
+              <a:t>📱 1 Equipo por Semana</a:t>
+            </a:r>
+          </a:p>
+          <a:p>
+            <a:pPr>
+              <a:spcAft>
+                <a:spcPts val="600"/>
+              </a:spcAft>
+              <a:defRPr sz="1100">
                 <a:solidFill>
                   <a:srgbClr val="FFFFFF"/>
                 </a:solidFill>
               </a:defRPr>
             </a:pPr>
             <a:r>
-              <a:t>Los cupones de 2º y 3º lugar se pueden programar para canjearse de lunes a jueves en su siguiente visita, generando tráfico en días y horarios con menor ocupación.</a:t>
+              <a:t>El cliente elige 1 equipo ganador por semana sin repetir. Si su equipo gana, sobrevive; si pierde, queda eliminado.</a:t>
+            </a:r>
+          </a:p>
+          <a:p>
+            <a:pPr>
+              <a:spcAft>
+                <a:spcPts val="100"/>
+              </a:spcAft>
+              <a:defRPr sz="1250" b="1">
+                <a:solidFill>
+                  <a:srgbClr val="FFD100"/>
+                </a:solidFill>
+              </a:defRPr>
+            </a:pPr>
+            <a:r>
+              <a:t>🏆 Retención Obligatoria</a:t>
+            </a:r>
+          </a:p>
+          <a:p>
+            <a:pPr>
+              <a:spcAft>
+                <a:spcPts val="600"/>
+              </a:spcAft>
+              <a:defRPr sz="1100">
+                <a:solidFill>
+                  <a:srgbClr val="FFFFFF"/>
+                </a:solidFill>
+              </a:defRPr>
+            </a:pPr>
+            <a:r>
+              <a:t>Obliga al cliente a regresar semana tras semana a la sucursal para defender su boleto de sobreviviente.</a:t>
             </a:r>
           </a:p>
         </p:txBody>
@@ -3693,7 +3755,7 @@
               </a:defRPr>
             </a:pPr>
             <a:r>
-              <a:t>EQUIPO DE SERVICIO</a:t>
+              <a:t>RENTABILIDAD Y VENTAS</a:t>
             </a:r>
           </a:p>
           <a:p>
@@ -3705,7 +3767,7 @@
               </a:defRPr>
             </a:pPr>
             <a:r>
-              <a:t>Gamificación del Personal: Meseros como Embajadores</a:t>
+              <a:t>Estrategia de Premios: Diseñada para Proteger el Margen</a:t>
             </a:r>
           </a:p>
         </p:txBody>
@@ -3719,7 +3781,7 @@
         <p:spPr>
           <a:xfrm>
             <a:off x="731520" y="1645920"/>
-            <a:ext cx="6858000" cy="4663440"/>
+            <a:ext cx="3413455" cy="4663440"/>
           </a:xfrm>
           <a:prstGeom prst="roundRect">
             <a:avLst/>
@@ -3763,8 +3825,8 @@
         </p:nvSpPr>
         <p:spPr>
           <a:xfrm>
-            <a:off x="1005840" y="1828800"/>
-            <a:ext cx="6309360" cy="4206240"/>
+            <a:off x="1005840" y="1920240"/>
+            <a:ext cx="2864815" cy="4114800"/>
           </a:xfrm>
           <a:prstGeom prst="rect">
             <a:avLst/>
@@ -3779,149 +3841,222 @@
           <a:p>
             <a:pPr>
               <a:spcAft>
-                <a:spcPts val="200"/>
-              </a:spcAft>
-              <a:defRPr sz="1350" b="1">
+                <a:spcPts val="1400"/>
+              </a:spcAft>
+              <a:defRPr sz="1600" b="1">
                 <a:solidFill>
                   <a:srgbClr val="FFB612"/>
                 </a:solidFill>
               </a:defRPr>
             </a:pPr>
             <a:r>
-              <a:t>🙋 Atribución Clara en Cada Mesa</a:t>
-            </a:r>
-          </a:p>
-          <a:p>
-            <a:pPr>
-              <a:spcAft>
-                <a:spcPts val="1000"/>
-              </a:spcAft>
-              <a:defRPr sz="1150">
+              <a:t>🍔 Alto Valor Percibido vs Bajo Costo</a:t>
+            </a:r>
+          </a:p>
+          <a:p>
+            <a:pPr>
+              <a:defRPr sz="1300">
                 <a:solidFill>
                   <a:srgbClr val="FFFFFF"/>
                 </a:solidFill>
               </a:defRPr>
             </a:pPr>
             <a:r>
-              <a:t>Al registrar sus pronósticos, el cliente selecciona el nombre de su mesero en la lista. La gerencia sabe con métricas exactas qué meseros están invitando activamente y cuáles no.</a:t>
-            </a:r>
-          </a:p>
-          <a:p>
-            <a:pPr>
-              <a:spcAft>
-                <a:spcPts val="200"/>
-              </a:spcAft>
-              <a:defRPr sz="1350" b="1">
-                <a:solidFill>
-                  <a:srgbClr val="FFB612"/>
-                </a:solidFill>
-              </a:defRPr>
-            </a:pPr>
-            <a:r>
-              <a:t>💰 Incentivo Económico Directo (Más Propina)</a:t>
-            </a:r>
-          </a:p>
-          <a:p>
-            <a:pPr>
-              <a:spcAft>
-                <a:spcPts val="1000"/>
-              </a:spcAft>
-              <a:defRPr sz="1150">
-                <a:solidFill>
-                  <a:srgbClr val="FFFFFF"/>
-                </a:solidFill>
-              </a:defRPr>
-            </a:pPr>
-            <a:r>
-              <a:t>Los meseros comprenden la fórmula de inmediato: Si la mesa se queda 3 horas compitiendo, consumirá más rondas de cerveza, hamburguesas y alitas, lo que elevará el total de la cuenta y su propina.</a:t>
-            </a:r>
-          </a:p>
-          <a:p>
-            <a:pPr>
-              <a:spcAft>
-                <a:spcPts val="200"/>
-              </a:spcAft>
-              <a:defRPr sz="1350" b="1">
-                <a:solidFill>
-                  <a:srgbClr val="FFB612"/>
-                </a:solidFill>
-              </a:defRPr>
-            </a:pPr>
-            <a:r>
-              <a:t>💬 Rompehielos Natural de Venta Sugerida</a:t>
-            </a:r>
-          </a:p>
-          <a:p>
-            <a:pPr>
-              <a:spcAft>
-                <a:spcPts val="1000"/>
-              </a:spcAft>
-              <a:defRPr sz="1150">
-                <a:solidFill>
-                  <a:srgbClr val="FFFFFF"/>
-                </a:solidFill>
-              </a:defRPr>
-            </a:pPr>
-            <a:r>
-              <a:t>En lugar del genérico '¿Se les ofrece algo más?', el mesero llega sonriendo: '¿Ya metieron su quiniela de hoy con mi nombre? Si ganan, ¡la casa les invita unas alitas!'.</a:t>
-            </a:r>
-          </a:p>
-          <a:p>
-            <a:pPr>
-              <a:spcAft>
-                <a:spcPts val="200"/>
-              </a:spcAft>
-              <a:defRPr sz="1350" b="1">
-                <a:solidFill>
-                  <a:srgbClr val="FFB612"/>
-                </a:solidFill>
-              </a:defRPr>
-            </a:pPr>
-            <a:r>
-              <a:t>🏆 Competencia Interna del Equipo</a:t>
-            </a:r>
-          </a:p>
-          <a:p>
-            <a:pPr>
-              <a:spcAft>
-                <a:spcPts val="1000"/>
-              </a:spcAft>
-              <a:defRPr sz="1150">
-                <a:solidFill>
-                  <a:srgbClr val="FFFFFF"/>
-                </a:solidFill>
-              </a:defRPr>
-            </a:pPr>
-            <a:r>
-              <a:t>Se puede premiar al mesero con más comensales registrados en la semana con turnos preferenciales o un reconocimiento en la junta semanal.</a:t>
-            </a:r>
-          </a:p>
-        </p:txBody>
-      </p:sp>
-      <p:pic>
-        <p:nvPicPr>
-          <p:cNvPr id="5" name="Picture 4" descr="screenshot_admin_player.png"/>
-          <p:cNvPicPr>
-            <a:picLocks noChangeAspect="1"/>
-          </p:cNvPicPr>
+              <a:t>Una orden de alitas o una cerveza tiene un costo de insumo moderado para cocina/barra ($30-$50 MXN), pero en la mente del cliente representa un premio valioso de $160 a $240 MXN.</a:t>
+            </a:r>
+          </a:p>
+        </p:txBody>
+      </p:sp>
+      <p:sp>
+        <p:nvSpPr>
+          <p:cNvPr id="5" name="Rounded Rectangle 4"/>
+          <p:cNvSpPr/>
           <p:nvPr/>
-        </p:nvPicPr>
-        <p:blipFill>
-          <a:blip r:embed="rId2"/>
-          <a:stretch>
-            <a:fillRect/>
-          </a:stretch>
-        </p:blipFill>
-        <p:spPr>
-          <a:xfrm>
-            <a:off x="7863840" y="1828800"/>
-            <a:ext cx="3566160" cy="1308612"/>
+        </p:nvSpPr>
+        <p:spPr>
+          <a:xfrm>
+            <a:off x="4389120" y="1645920"/>
+            <a:ext cx="3413455" cy="4663440"/>
+          </a:xfrm>
+          <a:prstGeom prst="roundRect">
+            <a:avLst/>
+          </a:prstGeom>
+          <a:solidFill>
+            <a:srgbClr val="141A26"/>
+          </a:solidFill>
+          <a:ln w="19050">
+            <a:solidFill>
+              <a:srgbClr val="283246"/>
+            </a:solidFill>
+          </a:ln>
+        </p:spPr>
+        <p:style>
+          <a:lnRef idx="1">
+            <a:schemeClr val="accent1"/>
+          </a:lnRef>
+          <a:fillRef idx="3">
+            <a:schemeClr val="accent1"/>
+          </a:fillRef>
+          <a:effectRef idx="2">
+            <a:schemeClr val="accent1"/>
+          </a:effectRef>
+          <a:fontRef idx="minor">
+            <a:schemeClr val="lt1"/>
+          </a:fontRef>
+        </p:style>
+        <p:txBody>
+          <a:bodyPr rtlCol="0" anchor="ctr"/>
+          <a:lstStyle/>
+          <a:p>
+            <a:pPr algn="ctr"/>
+          </a:p>
+        </p:txBody>
+      </p:sp>
+      <p:sp>
+        <p:nvSpPr>
+          <p:cNvPr id="6" name="TextBox 5"/>
+          <p:cNvSpPr txBox="1"/>
+          <p:nvPr/>
+        </p:nvSpPr>
+        <p:spPr>
+          <a:xfrm>
+            <a:off x="4663440" y="1920240"/>
+            <a:ext cx="2864815" cy="4114800"/>
           </a:xfrm>
           <a:prstGeom prst="rect">
             <a:avLst/>
           </a:prstGeom>
-        </p:spPr>
-      </p:pic>
+          <a:noFill/>
+        </p:spPr>
+        <p:txBody>
+          <a:bodyPr wrap="square">
+            <a:spAutoFit/>
+          </a:bodyPr>
+          <a:lstStyle/>
+          <a:p>
+            <a:pPr>
+              <a:spcAft>
+                <a:spcPts val="1400"/>
+              </a:spcAft>
+              <a:defRPr sz="1600" b="1">
+                <a:solidFill>
+                  <a:srgbClr val="00E676"/>
+                </a:solidFill>
+              </a:defRPr>
+            </a:pPr>
+            <a:r>
+              <a:t>🍻 Festejo y Rondas Extra en Mesa</a:t>
+            </a:r>
+          </a:p>
+          <a:p>
+            <a:pPr>
+              <a:defRPr sz="1300">
+                <a:solidFill>
+                  <a:srgbClr val="FFFFFF"/>
+                </a:solidFill>
+              </a:defRPr>
+            </a:pPr>
+            <a:r>
+              <a:t>Nadie gana y se va. El comensal que resulta campeón celebra con su mesa, y el grupo pide cervezas y platillos adicionales para acompañar el premio. El ticket final siempre supera con creces el costo del incentivo.</a:t>
+            </a:r>
+          </a:p>
+        </p:txBody>
+      </p:sp>
+      <p:sp>
+        <p:nvSpPr>
+          <p:cNvPr id="7" name="Rounded Rectangle 6"/>
+          <p:cNvSpPr/>
+          <p:nvPr/>
+        </p:nvSpPr>
+        <p:spPr>
+          <a:xfrm>
+            <a:off x="8046720" y="1645920"/>
+            <a:ext cx="3413455" cy="4663440"/>
+          </a:xfrm>
+          <a:prstGeom prst="roundRect">
+            <a:avLst/>
+          </a:prstGeom>
+          <a:solidFill>
+            <a:srgbClr val="141A26"/>
+          </a:solidFill>
+          <a:ln w="19050">
+            <a:solidFill>
+              <a:srgbClr val="283246"/>
+            </a:solidFill>
+          </a:ln>
+        </p:spPr>
+        <p:style>
+          <a:lnRef idx="1">
+            <a:schemeClr val="accent1"/>
+          </a:lnRef>
+          <a:fillRef idx="3">
+            <a:schemeClr val="accent1"/>
+          </a:fillRef>
+          <a:effectRef idx="2">
+            <a:schemeClr val="accent1"/>
+          </a:effectRef>
+          <a:fontRef idx="minor">
+            <a:schemeClr val="lt1"/>
+          </a:fontRef>
+        </p:style>
+        <p:txBody>
+          <a:bodyPr rtlCol="0" anchor="ctr"/>
+          <a:lstStyle/>
+          <a:p>
+            <a:pPr algn="ctr"/>
+          </a:p>
+        </p:txBody>
+      </p:sp>
+      <p:sp>
+        <p:nvSpPr>
+          <p:cNvPr id="8" name="TextBox 7"/>
+          <p:cNvSpPr txBox="1"/>
+          <p:nvPr/>
+        </p:nvSpPr>
+        <p:spPr>
+          <a:xfrm>
+            <a:off x="8321040" y="1920240"/>
+            <a:ext cx="2864815" cy="4114800"/>
+          </a:xfrm>
+          <a:prstGeom prst="rect">
+            <a:avLst/>
+          </a:prstGeom>
+          <a:noFill/>
+        </p:spPr>
+        <p:txBody>
+          <a:bodyPr wrap="square">
+            <a:spAutoFit/>
+          </a:bodyPr>
+          <a:lstStyle/>
+          <a:p>
+            <a:pPr>
+              <a:spcAft>
+                <a:spcPts val="1400"/>
+              </a:spcAft>
+              <a:defRPr sz="1600" b="1">
+                <a:solidFill>
+                  <a:srgbClr val="FF5722"/>
+                </a:solidFill>
+              </a:defRPr>
+            </a:pPr>
+            <a:r>
+              <a:t>🔄 Retorno Asegurado en Días Bajas</a:t>
+            </a:r>
+          </a:p>
+          <a:p>
+            <a:pPr>
+              <a:defRPr sz="1300">
+                <a:solidFill>
+                  <a:srgbClr val="FFFFFF"/>
+                </a:solidFill>
+              </a:defRPr>
+            </a:pPr>
+            <a:r>
+              <a:t>Los cupones de 2º y 3º lugar se pueden programar para canjearse de lunes a jueves en su siguiente visita, generando tráfico en días y horarios con menor ocupación.</a:t>
+            </a:r>
+          </a:p>
+        </p:txBody>
+      </p:sp>
     </p:spTree>
   </p:cSld>
   <p:clrMapOvr>
@@ -3981,7 +4116,7 @@
               </a:defRPr>
             </a:pPr>
             <a:r>
-              <a:t>CALENDARIO INTELIGENTE</a:t>
+              <a:t>EQUIPO DE SERVICIO</a:t>
             </a:r>
           </a:p>
           <a:p>
@@ -3993,7 +4128,7 @@
               </a:defRPr>
             </a:pPr>
             <a:r>
-              <a:t>Estrategia Gradual: El Juego Indicado en el Momento Indicado</a:t>
+              <a:t>Gamificación del Personal: Meseros como Embajadores</a:t>
             </a:r>
           </a:p>
         </p:txBody>
@@ -4007,7 +4142,7 @@
         <p:spPr>
           <a:xfrm>
             <a:off x="731520" y="1645920"/>
-            <a:ext cx="10728655" cy="4663440"/>
+            <a:ext cx="6858000" cy="4663440"/>
           </a:xfrm>
           <a:prstGeom prst="roundRect">
             <a:avLst/>
@@ -4051,8 +4186,8 @@
         </p:nvSpPr>
         <p:spPr>
           <a:xfrm>
-            <a:off x="1097280" y="1828800"/>
-            <a:ext cx="9966960" cy="4206240"/>
+            <a:off x="1005840" y="1828800"/>
+            <a:ext cx="6309360" cy="4206240"/>
           </a:xfrm>
           <a:prstGeom prst="rect">
             <a:avLst/>
@@ -4067,16 +4202,31 @@
           <a:p>
             <a:pPr>
               <a:spcAft>
-                <a:spcPts val="1200"/>
-              </a:spcAft>
-              <a:defRPr sz="1700" b="1">
+                <a:spcPts val="200"/>
+              </a:spcAft>
+              <a:defRPr sz="1350" b="1">
                 <a:solidFill>
                   <a:srgbClr val="FFB612"/>
                 </a:solidFill>
               </a:defRPr>
             </a:pPr>
             <a:r>
-              <a:t>🎯 Menos es Más: La Calidad del Momento vs Saturación</a:t>
+              <a:t>🙋 Atribución Clara en Cada Mesa</a:t>
+            </a:r>
+          </a:p>
+          <a:p>
+            <a:pPr>
+              <a:spcAft>
+                <a:spcPts val="1000"/>
+              </a:spcAft>
+              <a:defRPr sz="1150">
+                <a:solidFill>
+                  <a:srgbClr val="FFFFFF"/>
+                </a:solidFill>
+              </a:defRPr>
+            </a:pPr>
+            <a:r>
+              <a:t>Al registrar sus pronósticos, el cliente selecciona el nombre de su mesero en la lista. La gerencia sabe con métricas exactas qué meseros están invitando activamente y cuáles no.</a:t>
             </a:r>
           </a:p>
           <a:p>
@@ -4084,14 +4234,14 @@
               <a:spcAft>
                 <a:spcPts val="200"/>
               </a:spcAft>
-              <a:defRPr sz="1400" b="1">
-                <a:solidFill>
-                  <a:srgbClr val="FFD100"/>
-                </a:solidFill>
-              </a:defRPr>
-            </a:pPr>
-            <a:r>
-              <a:t>🚫 No Jugar Todos los Juegos Todos los Días</a:t>
+              <a:defRPr sz="1350" b="1">
+                <a:solidFill>
+                  <a:srgbClr val="FFB612"/>
+                </a:solidFill>
+              </a:defRPr>
+            </a:pPr>
+            <a:r>
+              <a:t>💰 Incentivo Económico Directo (Más Propina)</a:t>
             </a:r>
           </a:p>
           <a:p>
@@ -4099,14 +4249,14 @@
               <a:spcAft>
                 <a:spcPts val="1000"/>
               </a:spcAft>
-              <a:defRPr sz="1200">
+              <a:defRPr sz="1150">
                 <a:solidFill>
                   <a:srgbClr val="FFFFFF"/>
                 </a:solidFill>
               </a:defRPr>
             </a:pPr>
             <a:r>
-              <a:t>Saturar al cliente o al personal con 5 juegos simultáneos genera fatiga y desinterés. La experiencia debe sentirse especial y esperada cada fin de semana.</a:t>
+              <a:t>Los meseros comprenden la fórmula de inmediato: Si la mesa se queda 3 horas compitiendo, consumirá más rondas de cerveza, hamburguesas y alitas, lo que elevará el total de la cuenta y su propina.</a:t>
             </a:r>
           </a:p>
           <a:p>
@@ -4114,14 +4264,14 @@
               <a:spcAft>
                 <a:spcPts val="200"/>
               </a:spcAft>
-              <a:defRPr sz="1400" b="1">
-                <a:solidFill>
-                  <a:srgbClr val="FFD100"/>
-                </a:solidFill>
-              </a:defRPr>
-            </a:pPr>
-            <a:r>
-              <a:t>📅 Jueves, Domingos y Lunes: Modo NFL</a:t>
+              <a:defRPr sz="1350" b="1">
+                <a:solidFill>
+                  <a:srgbClr val="FFB612"/>
+                </a:solidFill>
+              </a:defRPr>
+            </a:pPr>
+            <a:r>
+              <a:t>💬 Rompehielos Natural de Venta Sugerida</a:t>
             </a:r>
           </a:p>
           <a:p>
@@ -4129,14 +4279,14 @@
               <a:spcAft>
                 <a:spcPts val="1000"/>
               </a:spcAft>
-              <a:defRPr sz="1200">
+              <a:defRPr sz="1150">
                 <a:solidFill>
                   <a:srgbClr val="FFFFFF"/>
                 </a:solidFill>
               </a:defRPr>
             </a:pPr>
             <a:r>
-              <a:t>Exclusivamente Quinielas de Semana NFL y Football Grids en partidos estelares de Steelers, Sunday Night y Monday Night.</a:t>
+              <a:t>En lugar del genérico '¿Se les ofrece algo más?', el mesero llega sonriendo: '¿Ya metieron su quiniela de hoy con mi nombre? Si ganan, ¡la casa les invita unas alitas!'.</a:t>
             </a:r>
           </a:p>
           <a:p>
@@ -4144,14 +4294,14 @@
               <a:spcAft>
                 <a:spcPts val="200"/>
               </a:spcAft>
-              <a:defRPr sz="1400" b="1">
-                <a:solidFill>
-                  <a:srgbClr val="FFD100"/>
-                </a:solidFill>
-              </a:defRPr>
-            </a:pPr>
-            <a:r>
-              <a:t>⚽ Viernes, Sábados y Domingos: Modo Fútbol</a:t>
+              <a:defRPr sz="1350" b="1">
+                <a:solidFill>
+                  <a:srgbClr val="FFB612"/>
+                </a:solidFill>
+              </a:defRPr>
+            </a:pPr>
+            <a:r>
+              <a:t>🏆 Competencia Interna del Equipo</a:t>
             </a:r>
           </a:p>
           <a:p>
@@ -4159,48 +4309,42 @@
               <a:spcAft>
                 <a:spcPts val="1000"/>
               </a:spcAft>
-              <a:defRPr sz="1200">
+              <a:defRPr sz="1150">
                 <a:solidFill>
                   <a:srgbClr val="FFFFFF"/>
                 </a:solidFill>
               </a:defRPr>
             </a:pPr>
             <a:r>
-              <a:t>Quinielas de Jornada de Liga MX y dinámicas de First Striker en Clásicos y liguilla.</a:t>
-            </a:r>
-          </a:p>
-          <a:p>
-            <a:pPr>
-              <a:spcAft>
-                <a:spcPts val="200"/>
-              </a:spcAft>
-              <a:defRPr sz="1400" b="1">
-                <a:solidFill>
-                  <a:srgbClr val="FFD100"/>
-                </a:solidFill>
-              </a:defRPr>
-            </a:pPr>
-            <a:r>
-              <a:t>🧠 Medios Tiempos Selectos: Modo Trivia</a:t>
-            </a:r>
-          </a:p>
-          <a:p>
-            <a:pPr>
-              <a:spcAft>
-                <a:spcPts val="1000"/>
-              </a:spcAft>
-              <a:defRPr sz="1200">
-                <a:solidFill>
-                  <a:srgbClr val="FFFFFF"/>
-                </a:solidFill>
-              </a:defRPr>
-            </a:pPr>
-            <a:r>
-              <a:t>Trivias de 10 minutos exclusivamente en el medio tiempo de partidos de alta audiencia para mantener a la gente entretenida mientras no hay jugadas.</a:t>
-            </a:r>
-          </a:p>
-        </p:txBody>
-      </p:sp>
+              <a:t>Se puede premiar al mesero con más comensales registrados en la semana con turnos preferenciales o un reconocimiento en la junta semanal.</a:t>
+            </a:r>
+          </a:p>
+        </p:txBody>
+      </p:sp>
+      <p:pic>
+        <p:nvPicPr>
+          <p:cNvPr id="5" name="Picture 4" descr="screenshot_admin_player.png"/>
+          <p:cNvPicPr>
+            <a:picLocks noChangeAspect="1"/>
+          </p:cNvPicPr>
+          <p:nvPr/>
+        </p:nvPicPr>
+        <p:blipFill>
+          <a:blip r:embed="rId2"/>
+          <a:stretch>
+            <a:fillRect/>
+          </a:stretch>
+        </p:blipFill>
+        <p:spPr>
+          <a:xfrm>
+            <a:off x="7863840" y="1828800"/>
+            <a:ext cx="3566160" cy="1308612"/>
+          </a:xfrm>
+          <a:prstGeom prst="rect">
+            <a:avLst/>
+          </a:prstGeom>
+        </p:spPr>
+      </p:pic>
     </p:spTree>
   </p:cSld>
   <p:clrMapOvr>
@@ -4260,7 +4404,7 @@
               </a:defRPr>
             </a:pPr>
             <a:r>
-              <a:t>RETORNO DE INVERSIÓN</a:t>
+              <a:t>CALENDARIO INTELIGENTE</a:t>
             </a:r>
           </a:p>
           <a:p>
@@ -4272,7 +4416,7 @@
               </a:defRPr>
             </a:pPr>
             <a:r>
-              <a:t>Métricas Clave de Negocio (KPIs y Rentabilidad)</a:t>
+              <a:t>Estrategia Gradual: El Juego Indicado en el Momento Indicado</a:t>
             </a:r>
           </a:p>
         </p:txBody>
@@ -4286,7 +4430,7 @@
         <p:spPr>
           <a:xfrm>
             <a:off x="731520" y="1645920"/>
-            <a:ext cx="2499055" cy="4663440"/>
+            <a:ext cx="10728655" cy="4663440"/>
           </a:xfrm>
           <a:prstGeom prst="roundRect">
             <a:avLst/>
@@ -4330,8 +4474,8 @@
         </p:nvSpPr>
         <p:spPr>
           <a:xfrm>
-            <a:off x="914400" y="1920240"/>
-            <a:ext cx="2133295" cy="4114800"/>
+            <a:off x="1097280" y="1828800"/>
+            <a:ext cx="9966960" cy="4206240"/>
           </a:xfrm>
           <a:prstGeom prst="rect">
             <a:avLst/>
@@ -4344,375 +4488,138 @@
           </a:bodyPr>
           <a:lstStyle/>
           <a:p>
-            <a:pPr algn="ctr">
-              <a:spcAft>
-                <a:spcPts val="400"/>
-              </a:spcAft>
-              <a:defRPr sz="3600" b="1">
+            <a:pPr>
+              <a:spcAft>
+                <a:spcPts val="1200"/>
+              </a:spcAft>
+              <a:defRPr sz="1700" b="1">
                 <a:solidFill>
                   <a:srgbClr val="FFB612"/>
                 </a:solidFill>
               </a:defRPr>
             </a:pPr>
             <a:r>
-              <a:t>+35%</a:t>
-            </a:r>
-          </a:p>
-          <a:p>
-            <a:pPr algn="ctr">
-              <a:spcAft>
-                <a:spcPts val="1400"/>
-              </a:spcAft>
-              <a:defRPr sz="1100" b="1">
-                <a:solidFill>
-                  <a:srgbClr val="FFB612"/>
-                </a:solidFill>
-              </a:defRPr>
-            </a:pPr>
-            <a:r>
-              <a:t>PERMANENCIA (DWELL TIME)</a:t>
-            </a:r>
-          </a:p>
-          <a:p>
-            <a:pPr algn="ctr">
-              <a:defRPr sz="1150">
-                <a:solidFill>
-                  <a:srgbClr val="94A3B8"/>
-                </a:solidFill>
-              </a:defRPr>
-            </a:pPr>
-            <a:r>
-              <a:t>Las mesas se quedan hasta el silbatazo final para ver si ganan su quiniela.</a:t>
-            </a:r>
-          </a:p>
-        </p:txBody>
-      </p:sp>
-      <p:sp>
-        <p:nvSpPr>
-          <p:cNvPr id="5" name="Rounded Rectangle 4"/>
-          <p:cNvSpPr/>
-          <p:nvPr/>
-        </p:nvSpPr>
-        <p:spPr>
-          <a:xfrm>
-            <a:off x="3474720" y="1645920"/>
-            <a:ext cx="2499055" cy="4663440"/>
-          </a:xfrm>
-          <a:prstGeom prst="roundRect">
-            <a:avLst/>
-          </a:prstGeom>
-          <a:solidFill>
-            <a:srgbClr val="141A26"/>
-          </a:solidFill>
-          <a:ln w="19050">
-            <a:solidFill>
-              <a:srgbClr val="283246"/>
-            </a:solidFill>
-          </a:ln>
-        </p:spPr>
-        <p:style>
-          <a:lnRef idx="1">
-            <a:schemeClr val="accent1"/>
-          </a:lnRef>
-          <a:fillRef idx="3">
-            <a:schemeClr val="accent1"/>
-          </a:fillRef>
-          <a:effectRef idx="2">
-            <a:schemeClr val="accent1"/>
-          </a:effectRef>
-          <a:fontRef idx="minor">
-            <a:schemeClr val="lt1"/>
-          </a:fontRef>
-        </p:style>
-        <p:txBody>
-          <a:bodyPr rtlCol="0" anchor="ctr"/>
-          <a:lstStyle/>
-          <a:p>
-            <a:pPr algn="ctr"/>
-          </a:p>
-        </p:txBody>
-      </p:sp>
-      <p:sp>
-        <p:nvSpPr>
-          <p:cNvPr id="6" name="TextBox 5"/>
-          <p:cNvSpPr txBox="1"/>
-          <p:nvPr/>
-        </p:nvSpPr>
-        <p:spPr>
-          <a:xfrm>
-            <a:off x="3657600" y="1920240"/>
-            <a:ext cx="2133295" cy="4114800"/>
-          </a:xfrm>
-          <a:prstGeom prst="rect">
-            <a:avLst/>
-          </a:prstGeom>
-          <a:noFill/>
-        </p:spPr>
-        <p:txBody>
-          <a:bodyPr wrap="square">
-            <a:spAutoFit/>
-          </a:bodyPr>
-          <a:lstStyle/>
-          <a:p>
-            <a:pPr algn="ctr">
-              <a:spcAft>
-                <a:spcPts val="400"/>
-              </a:spcAft>
-              <a:defRPr sz="3600" b="1">
-                <a:solidFill>
-                  <a:srgbClr val="00E676"/>
-                </a:solidFill>
-              </a:defRPr>
-            </a:pPr>
-            <a:r>
-              <a:t>+22%</a:t>
-            </a:r>
-          </a:p>
-          <a:p>
-            <a:pPr algn="ctr">
-              <a:spcAft>
-                <a:spcPts val="1400"/>
-              </a:spcAft>
-              <a:defRPr sz="1100" b="1">
-                <a:solidFill>
-                  <a:srgbClr val="FFB612"/>
-                </a:solidFill>
-              </a:defRPr>
-            </a:pPr>
-            <a:r>
-              <a:t>TICKET PROMEDIO (AOV)</a:t>
-            </a:r>
-          </a:p>
-          <a:p>
-            <a:pPr algn="ctr">
-              <a:defRPr sz="1150">
-                <a:solidFill>
-                  <a:srgbClr val="94A3B8"/>
-                </a:solidFill>
-              </a:defRPr>
-            </a:pPr>
-            <a:r>
-              <a:t>El ambiente competitivo estimula pedidos repetidos de cerveza y botanas.</a:t>
-            </a:r>
-          </a:p>
-        </p:txBody>
-      </p:sp>
-      <p:sp>
-        <p:nvSpPr>
-          <p:cNvPr id="7" name="Rounded Rectangle 6"/>
-          <p:cNvSpPr/>
-          <p:nvPr/>
-        </p:nvSpPr>
-        <p:spPr>
-          <a:xfrm>
-            <a:off x="6217920" y="1645920"/>
-            <a:ext cx="2499055" cy="4663440"/>
-          </a:xfrm>
-          <a:prstGeom prst="roundRect">
-            <a:avLst/>
-          </a:prstGeom>
-          <a:solidFill>
-            <a:srgbClr val="141A26"/>
-          </a:solidFill>
-          <a:ln w="19050">
-            <a:solidFill>
-              <a:srgbClr val="283246"/>
-            </a:solidFill>
-          </a:ln>
-        </p:spPr>
-        <p:style>
-          <a:lnRef idx="1">
-            <a:schemeClr val="accent1"/>
-          </a:lnRef>
-          <a:fillRef idx="3">
-            <a:schemeClr val="accent1"/>
-          </a:fillRef>
-          <a:effectRef idx="2">
-            <a:schemeClr val="accent1"/>
-          </a:effectRef>
-          <a:fontRef idx="minor">
-            <a:schemeClr val="lt1"/>
-          </a:fontRef>
-        </p:style>
-        <p:txBody>
-          <a:bodyPr rtlCol="0" anchor="ctr"/>
-          <a:lstStyle/>
-          <a:p>
-            <a:pPr algn="ctr"/>
-          </a:p>
-        </p:txBody>
-      </p:sp>
-      <p:sp>
-        <p:nvSpPr>
-          <p:cNvPr id="8" name="TextBox 7"/>
-          <p:cNvSpPr txBox="1"/>
-          <p:nvPr/>
-        </p:nvSpPr>
-        <p:spPr>
-          <a:xfrm>
-            <a:off x="6400800" y="1920240"/>
-            <a:ext cx="2133295" cy="4114800"/>
-          </a:xfrm>
-          <a:prstGeom prst="rect">
-            <a:avLst/>
-          </a:prstGeom>
-          <a:noFill/>
-        </p:spPr>
-        <p:txBody>
-          <a:bodyPr wrap="square">
-            <a:spAutoFit/>
-          </a:bodyPr>
-          <a:lstStyle/>
-          <a:p>
-            <a:pPr algn="ctr">
-              <a:spcAft>
-                <a:spcPts val="400"/>
-              </a:spcAft>
-              <a:defRPr sz="3600" b="1">
-                <a:solidFill>
-                  <a:srgbClr val="FF5722"/>
-                </a:solidFill>
-              </a:defRPr>
-            </a:pPr>
-            <a:r>
-              <a:t>3x</a:t>
-            </a:r>
-          </a:p>
-          <a:p>
-            <a:pPr algn="ctr">
-              <a:spcAft>
-                <a:spcPts val="1400"/>
-              </a:spcAft>
-              <a:defRPr sz="1100" b="1">
-                <a:solidFill>
-                  <a:srgbClr val="FFB612"/>
-                </a:solidFill>
-              </a:defRPr>
-            </a:pPr>
-            <a:r>
-              <a:t>RETENCIÓN Y LEALTAD</a:t>
-            </a:r>
-          </a:p>
-          <a:p>
-            <a:pPr algn="ctr">
-              <a:defRPr sz="1150">
-                <a:solidFill>
-                  <a:srgbClr val="94A3B8"/>
-                </a:solidFill>
-              </a:defRPr>
-            </a:pPr>
-            <a:r>
-              <a:t>El comensal regresa jornada tras jornada para defender su posición en la tabla.</a:t>
-            </a:r>
-          </a:p>
-        </p:txBody>
-      </p:sp>
-      <p:sp>
-        <p:nvSpPr>
-          <p:cNvPr id="9" name="Rounded Rectangle 8"/>
-          <p:cNvSpPr/>
-          <p:nvPr/>
-        </p:nvSpPr>
-        <p:spPr>
-          <a:xfrm>
-            <a:off x="8961120" y="1645920"/>
-            <a:ext cx="2499055" cy="4663440"/>
-          </a:xfrm>
-          <a:prstGeom prst="roundRect">
-            <a:avLst/>
-          </a:prstGeom>
-          <a:solidFill>
-            <a:srgbClr val="141A26"/>
-          </a:solidFill>
-          <a:ln w="19050">
-            <a:solidFill>
-              <a:srgbClr val="283246"/>
-            </a:solidFill>
-          </a:ln>
-        </p:spPr>
-        <p:style>
-          <a:lnRef idx="1">
-            <a:schemeClr val="accent1"/>
-          </a:lnRef>
-          <a:fillRef idx="3">
-            <a:schemeClr val="accent1"/>
-          </a:fillRef>
-          <a:effectRef idx="2">
-            <a:schemeClr val="accent1"/>
-          </a:effectRef>
-          <a:fontRef idx="minor">
-            <a:schemeClr val="lt1"/>
-          </a:fontRef>
-        </p:style>
-        <p:txBody>
-          <a:bodyPr rtlCol="0" anchor="ctr"/>
-          <a:lstStyle/>
-          <a:p>
-            <a:pPr algn="ctr"/>
-          </a:p>
-        </p:txBody>
-      </p:sp>
-      <p:sp>
-        <p:nvSpPr>
-          <p:cNvPr id="10" name="TextBox 9"/>
-          <p:cNvSpPr txBox="1"/>
-          <p:nvPr/>
-        </p:nvSpPr>
-        <p:spPr>
-          <a:xfrm>
-            <a:off x="9144000" y="1920240"/>
-            <a:ext cx="2133295" cy="4114800"/>
-          </a:xfrm>
-          <a:prstGeom prst="rect">
-            <a:avLst/>
-          </a:prstGeom>
-          <a:noFill/>
-        </p:spPr>
-        <p:txBody>
-          <a:bodyPr wrap="square">
-            <a:spAutoFit/>
-          </a:bodyPr>
-          <a:lstStyle/>
-          <a:p>
-            <a:pPr algn="ctr">
-              <a:spcAft>
-                <a:spcPts val="400"/>
-              </a:spcAft>
-              <a:defRPr sz="3600" b="1">
+              <a:t>🎯 Menos es Más: La Calidad del Momento vs Saturación</a:t>
+            </a:r>
+          </a:p>
+          <a:p>
+            <a:pPr>
+              <a:spcAft>
+                <a:spcPts val="200"/>
+              </a:spcAft>
+              <a:defRPr sz="1400" b="1">
+                <a:solidFill>
+                  <a:srgbClr val="FFD100"/>
+                </a:solidFill>
+              </a:defRPr>
+            </a:pPr>
+            <a:r>
+              <a:t>🚫 No Jugar Todos los Juegos Todos los Días</a:t>
+            </a:r>
+          </a:p>
+          <a:p>
+            <a:pPr>
+              <a:spcAft>
+                <a:spcPts val="1000"/>
+              </a:spcAft>
+              <a:defRPr sz="1200">
                 <a:solidFill>
                   <a:srgbClr val="FFFFFF"/>
                 </a:solidFill>
               </a:defRPr>
             </a:pPr>
             <a:r>
-              <a:t>$0</a:t>
-            </a:r>
-          </a:p>
-          <a:p>
-            <a:pPr algn="ctr">
-              <a:spcAft>
-                <a:spcPts val="1400"/>
-              </a:spcAft>
-              <a:defRPr sz="1100" b="1">
-                <a:solidFill>
-                  <a:srgbClr val="FFB612"/>
-                </a:solidFill>
-              </a:defRPr>
-            </a:pPr>
-            <a:r>
-              <a:t>COSTO DE PAPELERÍA</a:t>
-            </a:r>
-          </a:p>
-          <a:p>
-            <a:pPr algn="ctr">
-              <a:defRPr sz="1150">
-                <a:solidFill>
-                  <a:srgbClr val="94A3B8"/>
-                </a:solidFill>
-              </a:defRPr>
-            </a:pPr>
-            <a:r>
-              <a:t>Eliminación total de impresiones, papeletas extraviadas y errores de conteo.</a:t>
+              <a:t>Saturar al cliente o al personal con 5 juegos simultáneos genera fatiga y desinterés. La experiencia debe sentirse especial y esperada cada fin de semana.</a:t>
+            </a:r>
+          </a:p>
+          <a:p>
+            <a:pPr>
+              <a:spcAft>
+                <a:spcPts val="200"/>
+              </a:spcAft>
+              <a:defRPr sz="1400" b="1">
+                <a:solidFill>
+                  <a:srgbClr val="FFD100"/>
+                </a:solidFill>
+              </a:defRPr>
+            </a:pPr>
+            <a:r>
+              <a:t>📅 Jueves, Domingos y Lunes: Modo NFL</a:t>
+            </a:r>
+          </a:p>
+          <a:p>
+            <a:pPr>
+              <a:spcAft>
+                <a:spcPts val="1000"/>
+              </a:spcAft>
+              <a:defRPr sz="1200">
+                <a:solidFill>
+                  <a:srgbClr val="FFFFFF"/>
+                </a:solidFill>
+              </a:defRPr>
+            </a:pPr>
+            <a:r>
+              <a:t>Exclusivamente Quinielas de Semana NFL y Football Grids en partidos estelares de Steelers, Sunday Night y Monday Night.</a:t>
+            </a:r>
+          </a:p>
+          <a:p>
+            <a:pPr>
+              <a:spcAft>
+                <a:spcPts val="200"/>
+              </a:spcAft>
+              <a:defRPr sz="1400" b="1">
+                <a:solidFill>
+                  <a:srgbClr val="FFD100"/>
+                </a:solidFill>
+              </a:defRPr>
+            </a:pPr>
+            <a:r>
+              <a:t>⚽ Viernes, Sábados y Domingos: Modo Fútbol</a:t>
+            </a:r>
+          </a:p>
+          <a:p>
+            <a:pPr>
+              <a:spcAft>
+                <a:spcPts val="1000"/>
+              </a:spcAft>
+              <a:defRPr sz="1200">
+                <a:solidFill>
+                  <a:srgbClr val="FFFFFF"/>
+                </a:solidFill>
+              </a:defRPr>
+            </a:pPr>
+            <a:r>
+              <a:t>Quinielas de Jornada de Liga MX y dinámicas de First Striker en Clásicos y liguilla.</a:t>
+            </a:r>
+          </a:p>
+          <a:p>
+            <a:pPr>
+              <a:spcAft>
+                <a:spcPts val="200"/>
+              </a:spcAft>
+              <a:defRPr sz="1400" b="1">
+                <a:solidFill>
+                  <a:srgbClr val="FFD100"/>
+                </a:solidFill>
+              </a:defRPr>
+            </a:pPr>
+            <a:r>
+              <a:t>🧠 Medios Tiempos Selectos: Modo Trivia</a:t>
+            </a:r>
+          </a:p>
+          <a:p>
+            <a:pPr>
+              <a:spcAft>
+                <a:spcPts val="1000"/>
+              </a:spcAft>
+              <a:defRPr sz="1200">
+                <a:solidFill>
+                  <a:srgbClr val="FFFFFF"/>
+                </a:solidFill>
+              </a:defRPr>
+            </a:pPr>
+            <a:r>
+              <a:t>Trivias de 10 minutos exclusivamente en el medio tiempo de partidos de alta audiencia para mantener a la gente entretenida mientras no hay jugadas.</a:t>
             </a:r>
           </a:p>
         </p:txBody>
@@ -4776,6 +4683,522 @@
               </a:defRPr>
             </a:pPr>
             <a:r>
+              <a:t>RETORNO DE INVERSIÓN</a:t>
+            </a:r>
+          </a:p>
+          <a:p>
+            <a:pPr>
+              <a:defRPr sz="2300" b="1">
+                <a:solidFill>
+                  <a:srgbClr val="FFFFFF"/>
+                </a:solidFill>
+              </a:defRPr>
+            </a:pPr>
+            <a:r>
+              <a:t>Métricas Clave de Negocio (KPIs y Rentabilidad)</a:t>
+            </a:r>
+          </a:p>
+        </p:txBody>
+      </p:sp>
+      <p:sp>
+        <p:nvSpPr>
+          <p:cNvPr id="3" name="Rounded Rectangle 2"/>
+          <p:cNvSpPr/>
+          <p:nvPr/>
+        </p:nvSpPr>
+        <p:spPr>
+          <a:xfrm>
+            <a:off x="731520" y="1645920"/>
+            <a:ext cx="2499055" cy="4663440"/>
+          </a:xfrm>
+          <a:prstGeom prst="roundRect">
+            <a:avLst/>
+          </a:prstGeom>
+          <a:solidFill>
+            <a:srgbClr val="141A26"/>
+          </a:solidFill>
+          <a:ln w="19050">
+            <a:solidFill>
+              <a:srgbClr val="283246"/>
+            </a:solidFill>
+          </a:ln>
+        </p:spPr>
+        <p:style>
+          <a:lnRef idx="1">
+            <a:schemeClr val="accent1"/>
+          </a:lnRef>
+          <a:fillRef idx="3">
+            <a:schemeClr val="accent1"/>
+          </a:fillRef>
+          <a:effectRef idx="2">
+            <a:schemeClr val="accent1"/>
+          </a:effectRef>
+          <a:fontRef idx="minor">
+            <a:schemeClr val="lt1"/>
+          </a:fontRef>
+        </p:style>
+        <p:txBody>
+          <a:bodyPr rtlCol="0" anchor="ctr"/>
+          <a:lstStyle/>
+          <a:p>
+            <a:pPr algn="ctr"/>
+          </a:p>
+        </p:txBody>
+      </p:sp>
+      <p:sp>
+        <p:nvSpPr>
+          <p:cNvPr id="4" name="TextBox 3"/>
+          <p:cNvSpPr txBox="1"/>
+          <p:nvPr/>
+        </p:nvSpPr>
+        <p:spPr>
+          <a:xfrm>
+            <a:off x="914400" y="1920240"/>
+            <a:ext cx="2133295" cy="4114800"/>
+          </a:xfrm>
+          <a:prstGeom prst="rect">
+            <a:avLst/>
+          </a:prstGeom>
+          <a:noFill/>
+        </p:spPr>
+        <p:txBody>
+          <a:bodyPr wrap="square">
+            <a:spAutoFit/>
+          </a:bodyPr>
+          <a:lstStyle/>
+          <a:p>
+            <a:pPr algn="ctr">
+              <a:spcAft>
+                <a:spcPts val="400"/>
+              </a:spcAft>
+              <a:defRPr sz="3600" b="1">
+                <a:solidFill>
+                  <a:srgbClr val="FFB612"/>
+                </a:solidFill>
+              </a:defRPr>
+            </a:pPr>
+            <a:r>
+              <a:t>+35%</a:t>
+            </a:r>
+          </a:p>
+          <a:p>
+            <a:pPr algn="ctr">
+              <a:spcAft>
+                <a:spcPts val="1400"/>
+              </a:spcAft>
+              <a:defRPr sz="1100" b="1">
+                <a:solidFill>
+                  <a:srgbClr val="FFB612"/>
+                </a:solidFill>
+              </a:defRPr>
+            </a:pPr>
+            <a:r>
+              <a:t>PERMANENCIA (DWELL TIME)</a:t>
+            </a:r>
+          </a:p>
+          <a:p>
+            <a:pPr algn="ctr">
+              <a:defRPr sz="1150">
+                <a:solidFill>
+                  <a:srgbClr val="94A3B8"/>
+                </a:solidFill>
+              </a:defRPr>
+            </a:pPr>
+            <a:r>
+              <a:t>Las mesas se quedan hasta el silbatazo final para ver si ganan su quiniela.</a:t>
+            </a:r>
+          </a:p>
+        </p:txBody>
+      </p:sp>
+      <p:sp>
+        <p:nvSpPr>
+          <p:cNvPr id="5" name="Rounded Rectangle 4"/>
+          <p:cNvSpPr/>
+          <p:nvPr/>
+        </p:nvSpPr>
+        <p:spPr>
+          <a:xfrm>
+            <a:off x="3474720" y="1645920"/>
+            <a:ext cx="2499055" cy="4663440"/>
+          </a:xfrm>
+          <a:prstGeom prst="roundRect">
+            <a:avLst/>
+          </a:prstGeom>
+          <a:solidFill>
+            <a:srgbClr val="141A26"/>
+          </a:solidFill>
+          <a:ln w="19050">
+            <a:solidFill>
+              <a:srgbClr val="283246"/>
+            </a:solidFill>
+          </a:ln>
+        </p:spPr>
+        <p:style>
+          <a:lnRef idx="1">
+            <a:schemeClr val="accent1"/>
+          </a:lnRef>
+          <a:fillRef idx="3">
+            <a:schemeClr val="accent1"/>
+          </a:fillRef>
+          <a:effectRef idx="2">
+            <a:schemeClr val="accent1"/>
+          </a:effectRef>
+          <a:fontRef idx="minor">
+            <a:schemeClr val="lt1"/>
+          </a:fontRef>
+        </p:style>
+        <p:txBody>
+          <a:bodyPr rtlCol="0" anchor="ctr"/>
+          <a:lstStyle/>
+          <a:p>
+            <a:pPr algn="ctr"/>
+          </a:p>
+        </p:txBody>
+      </p:sp>
+      <p:sp>
+        <p:nvSpPr>
+          <p:cNvPr id="6" name="TextBox 5"/>
+          <p:cNvSpPr txBox="1"/>
+          <p:nvPr/>
+        </p:nvSpPr>
+        <p:spPr>
+          <a:xfrm>
+            <a:off x="3657600" y="1920240"/>
+            <a:ext cx="2133295" cy="4114800"/>
+          </a:xfrm>
+          <a:prstGeom prst="rect">
+            <a:avLst/>
+          </a:prstGeom>
+          <a:noFill/>
+        </p:spPr>
+        <p:txBody>
+          <a:bodyPr wrap="square">
+            <a:spAutoFit/>
+          </a:bodyPr>
+          <a:lstStyle/>
+          <a:p>
+            <a:pPr algn="ctr">
+              <a:spcAft>
+                <a:spcPts val="400"/>
+              </a:spcAft>
+              <a:defRPr sz="3600" b="1">
+                <a:solidFill>
+                  <a:srgbClr val="00E676"/>
+                </a:solidFill>
+              </a:defRPr>
+            </a:pPr>
+            <a:r>
+              <a:t>+22%</a:t>
+            </a:r>
+          </a:p>
+          <a:p>
+            <a:pPr algn="ctr">
+              <a:spcAft>
+                <a:spcPts val="1400"/>
+              </a:spcAft>
+              <a:defRPr sz="1100" b="1">
+                <a:solidFill>
+                  <a:srgbClr val="FFB612"/>
+                </a:solidFill>
+              </a:defRPr>
+            </a:pPr>
+            <a:r>
+              <a:t>TICKET PROMEDIO (AOV)</a:t>
+            </a:r>
+          </a:p>
+          <a:p>
+            <a:pPr algn="ctr">
+              <a:defRPr sz="1150">
+                <a:solidFill>
+                  <a:srgbClr val="94A3B8"/>
+                </a:solidFill>
+              </a:defRPr>
+            </a:pPr>
+            <a:r>
+              <a:t>El ambiente competitivo estimula pedidos repetidos de cerveza y botanas.</a:t>
+            </a:r>
+          </a:p>
+        </p:txBody>
+      </p:sp>
+      <p:sp>
+        <p:nvSpPr>
+          <p:cNvPr id="7" name="Rounded Rectangle 6"/>
+          <p:cNvSpPr/>
+          <p:nvPr/>
+        </p:nvSpPr>
+        <p:spPr>
+          <a:xfrm>
+            <a:off x="6217920" y="1645920"/>
+            <a:ext cx="2499055" cy="4663440"/>
+          </a:xfrm>
+          <a:prstGeom prst="roundRect">
+            <a:avLst/>
+          </a:prstGeom>
+          <a:solidFill>
+            <a:srgbClr val="141A26"/>
+          </a:solidFill>
+          <a:ln w="19050">
+            <a:solidFill>
+              <a:srgbClr val="283246"/>
+            </a:solidFill>
+          </a:ln>
+        </p:spPr>
+        <p:style>
+          <a:lnRef idx="1">
+            <a:schemeClr val="accent1"/>
+          </a:lnRef>
+          <a:fillRef idx="3">
+            <a:schemeClr val="accent1"/>
+          </a:fillRef>
+          <a:effectRef idx="2">
+            <a:schemeClr val="accent1"/>
+          </a:effectRef>
+          <a:fontRef idx="minor">
+            <a:schemeClr val="lt1"/>
+          </a:fontRef>
+        </p:style>
+        <p:txBody>
+          <a:bodyPr rtlCol="0" anchor="ctr"/>
+          <a:lstStyle/>
+          <a:p>
+            <a:pPr algn="ctr"/>
+          </a:p>
+        </p:txBody>
+      </p:sp>
+      <p:sp>
+        <p:nvSpPr>
+          <p:cNvPr id="8" name="TextBox 7"/>
+          <p:cNvSpPr txBox="1"/>
+          <p:nvPr/>
+        </p:nvSpPr>
+        <p:spPr>
+          <a:xfrm>
+            <a:off x="6400800" y="1920240"/>
+            <a:ext cx="2133295" cy="4114800"/>
+          </a:xfrm>
+          <a:prstGeom prst="rect">
+            <a:avLst/>
+          </a:prstGeom>
+          <a:noFill/>
+        </p:spPr>
+        <p:txBody>
+          <a:bodyPr wrap="square">
+            <a:spAutoFit/>
+          </a:bodyPr>
+          <a:lstStyle/>
+          <a:p>
+            <a:pPr algn="ctr">
+              <a:spcAft>
+                <a:spcPts val="400"/>
+              </a:spcAft>
+              <a:defRPr sz="3600" b="1">
+                <a:solidFill>
+                  <a:srgbClr val="FF5722"/>
+                </a:solidFill>
+              </a:defRPr>
+            </a:pPr>
+            <a:r>
+              <a:t>3x</a:t>
+            </a:r>
+          </a:p>
+          <a:p>
+            <a:pPr algn="ctr">
+              <a:spcAft>
+                <a:spcPts val="1400"/>
+              </a:spcAft>
+              <a:defRPr sz="1100" b="1">
+                <a:solidFill>
+                  <a:srgbClr val="FFB612"/>
+                </a:solidFill>
+              </a:defRPr>
+            </a:pPr>
+            <a:r>
+              <a:t>RETENCIÓN Y LEALTAD</a:t>
+            </a:r>
+          </a:p>
+          <a:p>
+            <a:pPr algn="ctr">
+              <a:defRPr sz="1150">
+                <a:solidFill>
+                  <a:srgbClr val="94A3B8"/>
+                </a:solidFill>
+              </a:defRPr>
+            </a:pPr>
+            <a:r>
+              <a:t>El comensal regresa jornada tras jornada para defender su posición en la tabla.</a:t>
+            </a:r>
+          </a:p>
+        </p:txBody>
+      </p:sp>
+      <p:sp>
+        <p:nvSpPr>
+          <p:cNvPr id="9" name="Rounded Rectangle 8"/>
+          <p:cNvSpPr/>
+          <p:nvPr/>
+        </p:nvSpPr>
+        <p:spPr>
+          <a:xfrm>
+            <a:off x="8961120" y="1645920"/>
+            <a:ext cx="2499055" cy="4663440"/>
+          </a:xfrm>
+          <a:prstGeom prst="roundRect">
+            <a:avLst/>
+          </a:prstGeom>
+          <a:solidFill>
+            <a:srgbClr val="141A26"/>
+          </a:solidFill>
+          <a:ln w="19050">
+            <a:solidFill>
+              <a:srgbClr val="283246"/>
+            </a:solidFill>
+          </a:ln>
+        </p:spPr>
+        <p:style>
+          <a:lnRef idx="1">
+            <a:schemeClr val="accent1"/>
+          </a:lnRef>
+          <a:fillRef idx="3">
+            <a:schemeClr val="accent1"/>
+          </a:fillRef>
+          <a:effectRef idx="2">
+            <a:schemeClr val="accent1"/>
+          </a:effectRef>
+          <a:fontRef idx="minor">
+            <a:schemeClr val="lt1"/>
+          </a:fontRef>
+        </p:style>
+        <p:txBody>
+          <a:bodyPr rtlCol="0" anchor="ctr"/>
+          <a:lstStyle/>
+          <a:p>
+            <a:pPr algn="ctr"/>
+          </a:p>
+        </p:txBody>
+      </p:sp>
+      <p:sp>
+        <p:nvSpPr>
+          <p:cNvPr id="10" name="TextBox 9"/>
+          <p:cNvSpPr txBox="1"/>
+          <p:nvPr/>
+        </p:nvSpPr>
+        <p:spPr>
+          <a:xfrm>
+            <a:off x="9144000" y="1920240"/>
+            <a:ext cx="2133295" cy="4114800"/>
+          </a:xfrm>
+          <a:prstGeom prst="rect">
+            <a:avLst/>
+          </a:prstGeom>
+          <a:noFill/>
+        </p:spPr>
+        <p:txBody>
+          <a:bodyPr wrap="square">
+            <a:spAutoFit/>
+          </a:bodyPr>
+          <a:lstStyle/>
+          <a:p>
+            <a:pPr algn="ctr">
+              <a:spcAft>
+                <a:spcPts val="400"/>
+              </a:spcAft>
+              <a:defRPr sz="3600" b="1">
+                <a:solidFill>
+                  <a:srgbClr val="FFFFFF"/>
+                </a:solidFill>
+              </a:defRPr>
+            </a:pPr>
+            <a:r>
+              <a:t>$0</a:t>
+            </a:r>
+          </a:p>
+          <a:p>
+            <a:pPr algn="ctr">
+              <a:spcAft>
+                <a:spcPts val="1400"/>
+              </a:spcAft>
+              <a:defRPr sz="1100" b="1">
+                <a:solidFill>
+                  <a:srgbClr val="FFB612"/>
+                </a:solidFill>
+              </a:defRPr>
+            </a:pPr>
+            <a:r>
+              <a:t>COSTO DE PAPELERÍA</a:t>
+            </a:r>
+          </a:p>
+          <a:p>
+            <a:pPr algn="ctr">
+              <a:defRPr sz="1150">
+                <a:solidFill>
+                  <a:srgbClr val="94A3B8"/>
+                </a:solidFill>
+              </a:defRPr>
+            </a:pPr>
+            <a:r>
+              <a:t>Eliminación total de impresiones, papeletas extraviadas y errores de conteo.</a:t>
+            </a:r>
+          </a:p>
+        </p:txBody>
+      </p:sp>
+    </p:spTree>
+  </p:cSld>
+  <p:clrMapOvr>
+    <a:masterClrMapping/>
+  </p:clrMapOvr>
+</p:sld>
+</file>
+
+<file path=ppt/slides/slide15.xml><?xml version="1.0" encoding="utf-8"?>
+<p:sld xmlns:a="http://schemas.openxmlformats.org/drawingml/2006/main" xmlns:p="http://schemas.openxmlformats.org/presentationml/2006/main" xmlns:r="http://schemas.openxmlformats.org/officeDocument/2006/relationships">
+  <p:cSld>
+    <p:bg>
+      <p:bgPr>
+        <a:solidFill>
+          <a:srgbClr val="0B0F17"/>
+        </a:solidFill>
+        <a:effectLst/>
+      </p:bgPr>
+    </p:bg>
+    <p:spTree>
+      <p:nvGrpSpPr>
+        <p:cNvPr id="1" name=""/>
+        <p:cNvGrpSpPr/>
+        <p:nvPr/>
+      </p:nvGrpSpPr>
+      <p:grpSpPr/>
+      <p:sp>
+        <p:nvSpPr>
+          <p:cNvPr id="2" name="TextBox 1"/>
+          <p:cNvSpPr txBox="1"/>
+          <p:nvPr/>
+        </p:nvSpPr>
+        <p:spPr>
+          <a:xfrm>
+            <a:off x="731520" y="365760"/>
+            <a:ext cx="10698480" cy="1005840"/>
+          </a:xfrm>
+          <a:prstGeom prst="rect">
+            <a:avLst/>
+          </a:prstGeom>
+          <a:noFill/>
+        </p:spPr>
+        <p:txBody>
+          <a:bodyPr wrap="square" lIns="0" tIns="0" rIns="0" bIns="0">
+            <a:spAutoFit/>
+          </a:bodyPr>
+          <a:lstStyle/>
+          <a:p>
+            <a:pPr>
+              <a:spcAft>
+                <a:spcPts val="200"/>
+              </a:spcAft>
+              <a:defRPr sz="1000" b="1">
+                <a:solidFill>
+                  <a:srgbClr val="FFB612"/>
+                </a:solidFill>
+              </a:defRPr>
+            </a:pPr>
+            <a:r>
               <a:t>PRÓXIMOS PASOS</a:t>
             </a:r>
           </a:p>
@@ -5040,7 +5463,7 @@
               </a:defRPr>
             </a:pPr>
             <a:r>
-              <a:t>HISTORIA REAL • MOTIVACIÓN Y PROPÓSITO</a:t>
+              <a:t>PROPUESTA DE VALOR</a:t>
             </a:r>
           </a:p>
           <a:p>
@@ -5052,7 +5475,7 @@
               </a:defRPr>
             </a:pPr>
             <a:r>
-              <a:t>El Corazón del Proyecto: La Historia de un Barman en Álamos</a:t>
+              <a:t>¿Qué es Drinks &amp; Wins? Definición, Objetivo y Metas</a:t>
             </a:r>
           </a:p>
         </p:txBody>
@@ -5066,7 +5489,7 @@
         <p:spPr>
           <a:xfrm>
             <a:off x="731520" y="1645920"/>
-            <a:ext cx="10728655" cy="4663440"/>
+            <a:ext cx="10728655" cy="1645920"/>
           </a:xfrm>
           <a:prstGeom prst="roundRect">
             <a:avLst/>
@@ -5110,8 +5533,8 @@
         </p:nvSpPr>
         <p:spPr>
           <a:xfrm>
-            <a:off x="1097280" y="1828800"/>
-            <a:ext cx="9966960" cy="4206240"/>
+            <a:off x="1005840" y="1783080"/>
+            <a:ext cx="10149840" cy="1371600"/>
           </a:xfrm>
           <a:prstGeom prst="rect">
             <a:avLst/>
@@ -5126,38 +5549,20 @@
           <a:p>
             <a:pPr>
               <a:spcAft>
-                <a:spcPts val="1200"/>
-              </a:spcAft>
-              <a:defRPr sz="1700" b="1">
+                <a:spcPts val="400"/>
+              </a:spcAft>
+              <a:defRPr sz="1500" b="1">
                 <a:solidFill>
                   <a:srgbClr val="FFB612"/>
                 </a:solidFill>
               </a:defRPr>
             </a:pPr>
             <a:r>
-              <a:t>❤️ «El cliente debe estar contento: aún si su equipo pierde o el partido está aburrido»</a:t>
-            </a:r>
-          </a:p>
-          <a:p>
-            <a:pPr>
-              <a:spcAft>
-                <a:spcPts val="200"/>
-              </a:spcAft>
-              <a:defRPr sz="1400" b="1">
-                <a:solidFill>
-                  <a:srgbClr val="FFD100"/>
-                </a:solidFill>
-              </a:defRPr>
-            </a:pPr>
-            <a:r>
-              <a:t>🍺 El Origen Detrás de la Barra en Álamos</a:t>
-            </a:r>
-          </a:p>
-          <a:p>
-            <a:pPr>
-              <a:spcAft>
-                <a:spcPts val="1000"/>
-              </a:spcAft>
+              <a:t>📱 ¿QUÉ ES DRINKS &amp; WINS?</a:t>
+            </a:r>
+          </a:p>
+          <a:p>
+            <a:pPr>
               <a:defRPr sz="1200">
                 <a:solidFill>
                   <a:srgbClr val="FFFFFF"/>
@@ -5165,67 +5570,278 @@
               </a:defRPr>
             </a:pPr>
             <a:r>
-              <a:t>Esto comenzó cuando yo era barman en la sucursal de Álamos. Mi meta siempre fue clara: que cada persona se fuera feliz del restaurante. Por naturaleza, al ser humano le fascina competir. Empecé a inventar quinielas y trivias entre las mesas; de repente, la gente no solo veía la tele, ¡estaban conviviendo, gritando y pidiendo más rondas!</a:t>
-            </a:r>
-          </a:p>
-          <a:p>
-            <a:pPr>
-              <a:spcAft>
-                <a:spcPts val="200"/>
-              </a:spcAft>
-              <a:defRPr sz="1400" b="1">
-                <a:solidFill>
-                  <a:srgbClr val="FFD100"/>
-                </a:solidFill>
-              </a:defRPr>
-            </a:pPr>
-            <a:r>
-              <a:t>🙏 Una Comunidad Fiel que Impulsa a Mi Familia</a:t>
-            </a:r>
-          </a:p>
-          <a:p>
-            <a:pPr>
-              <a:spcAft>
-                <a:spcPts val="1000"/>
-              </a:spcAft>
-              <a:defRPr sz="1200">
+              <a:t>Es una plataforma web interactiva (PWA) de gamificación deportiva en mesa para restaurantes y sports bars. Conecta las pantallas de TV con el celular de cada cliente mediante códigos QR (sin descargas de App Store). Permite a las mesas competir en tiempo real en quinielas, cuadrículas (Grids) y trivias, todo automatizado al 80% con Inteligencia Artificial y resultados oficiales de ESPN.</a:t>
+            </a:r>
+          </a:p>
+        </p:txBody>
+      </p:sp>
+      <p:sp>
+        <p:nvSpPr>
+          <p:cNvPr id="5" name="Rounded Rectangle 4"/>
+          <p:cNvSpPr/>
+          <p:nvPr/>
+        </p:nvSpPr>
+        <p:spPr>
+          <a:xfrm>
+            <a:off x="731520" y="3474720"/>
+            <a:ext cx="5212080" cy="2834640"/>
+          </a:xfrm>
+          <a:prstGeom prst="roundRect">
+            <a:avLst/>
+          </a:prstGeom>
+          <a:solidFill>
+            <a:srgbClr val="141A26"/>
+          </a:solidFill>
+          <a:ln w="19050">
+            <a:solidFill>
+              <a:srgbClr val="283246"/>
+            </a:solidFill>
+          </a:ln>
+        </p:spPr>
+        <p:style>
+          <a:lnRef idx="1">
+            <a:schemeClr val="accent1"/>
+          </a:lnRef>
+          <a:fillRef idx="3">
+            <a:schemeClr val="accent1"/>
+          </a:fillRef>
+          <a:effectRef idx="2">
+            <a:schemeClr val="accent1"/>
+          </a:effectRef>
+          <a:fontRef idx="minor">
+            <a:schemeClr val="lt1"/>
+          </a:fontRef>
+        </p:style>
+        <p:txBody>
+          <a:bodyPr rtlCol="0" anchor="ctr"/>
+          <a:lstStyle/>
+          <a:p>
+            <a:pPr algn="ctr"/>
+          </a:p>
+        </p:txBody>
+      </p:sp>
+      <p:sp>
+        <p:nvSpPr>
+          <p:cNvPr id="6" name="TextBox 5"/>
+          <p:cNvSpPr txBox="1"/>
+          <p:nvPr/>
+        </p:nvSpPr>
+        <p:spPr>
+          <a:xfrm>
+            <a:off x="1005840" y="3611880"/>
+            <a:ext cx="4663440" cy="2560320"/>
+          </a:xfrm>
+          <a:prstGeom prst="rect">
+            <a:avLst/>
+          </a:prstGeom>
+          <a:noFill/>
+        </p:spPr>
+        <p:txBody>
+          <a:bodyPr wrap="square">
+            <a:spAutoFit/>
+          </a:bodyPr>
+          <a:lstStyle/>
+          <a:p>
+            <a:pPr>
+              <a:spcAft>
+                <a:spcPts val="600"/>
+              </a:spcAft>
+              <a:defRPr sz="1500" b="1">
+                <a:solidFill>
+                  <a:srgbClr val="FF5722"/>
+                </a:solidFill>
+              </a:defRPr>
+            </a:pPr>
+            <a:r>
+              <a:t>🎯 OBJETIVO ESTRATÉGICO</a:t>
+            </a:r>
+          </a:p>
+          <a:p>
+            <a:pPr>
+              <a:spcAft>
+                <a:spcPts val="400"/>
+              </a:spcAft>
+              <a:defRPr sz="1150">
                 <a:solidFill>
                   <a:srgbClr val="FFFFFF"/>
                 </a:solidFill>
               </a:defRPr>
             </a:pPr>
             <a:r>
-              <a:t>Esas dinámicas crearon clientes tan frecuentes y leales que hasta el día de hoy me ven en la calle en Querétaro y me dicen con una sonrisa: '¡Beto, qué onda! ¿Para cuándo otra quiniela o trivia?'. Gracias a esos clientes y a las propinas que dejan en mesa, he podido sacar adelante a mi familia.</a:t>
-            </a:r>
-          </a:p>
-          <a:p>
-            <a:pPr>
-              <a:spcAft>
-                <a:spcPts val="200"/>
-              </a:spcAft>
-              <a:defRPr sz="1400" b="1">
-                <a:solidFill>
-                  <a:srgbClr val="FFD100"/>
-                </a:solidFill>
-              </a:defRPr>
-            </a:pPr>
-            <a:r>
-              <a:t>💡 No Soy Programador ni Ingeniero: Soy Alguien que Ama Este Lugar</a:t>
-            </a:r>
-          </a:p>
-          <a:p>
-            <a:pPr>
-              <a:spcAft>
-                <a:spcPts val="1000"/>
-              </a:spcAft>
-              <a:defRPr sz="1200">
+              <a:t>• Transformar comensales pasivos en fanáticos activos y entretenidos.</a:t>
+            </a:r>
+          </a:p>
+          <a:p>
+            <a:pPr>
+              <a:spcAft>
+                <a:spcPts val="400"/>
+              </a:spcAft>
+              <a:defRPr sz="1150">
                 <a:solidFill>
                   <a:srgbClr val="FFFFFF"/>
                 </a:solidFill>
               </a:defRPr>
             </a:pPr>
             <a:r>
-              <a:t>No soy desarrollador de software ni diseñador gráfico. Construí esta plataforma con todo el corazón, utilizando Inteligencia Artificial y herramientas modernas, por el inmenso cariño que le tengo a la marca y a este equipo.</a:t>
+              <a:t>• Maximizar el consumo en mesa durante las horas muertas de las transmisiones.</a:t>
+            </a:r>
+          </a:p>
+          <a:p>
+            <a:pPr>
+              <a:spcAft>
+                <a:spcPts val="400"/>
+              </a:spcAft>
+              <a:defRPr sz="1150">
+                <a:solidFill>
+                  <a:srgbClr val="FFFFFF"/>
+                </a:solidFill>
+              </a:defRPr>
+            </a:pPr>
+            <a:r>
+              <a:t>• Fidelizar al cliente para que regrese semana tras semana a la misma sucursal.</a:t>
+            </a:r>
+          </a:p>
+        </p:txBody>
+      </p:sp>
+      <p:sp>
+        <p:nvSpPr>
+          <p:cNvPr id="7" name="Rounded Rectangle 6"/>
+          <p:cNvSpPr/>
+          <p:nvPr/>
+        </p:nvSpPr>
+        <p:spPr>
+          <a:xfrm>
+            <a:off x="6217920" y="3474720"/>
+            <a:ext cx="5212080" cy="2834640"/>
+          </a:xfrm>
+          <a:prstGeom prst="roundRect">
+            <a:avLst/>
+          </a:prstGeom>
+          <a:solidFill>
+            <a:srgbClr val="141A26"/>
+          </a:solidFill>
+          <a:ln w="19050">
+            <a:solidFill>
+              <a:srgbClr val="283246"/>
+            </a:solidFill>
+          </a:ln>
+        </p:spPr>
+        <p:style>
+          <a:lnRef idx="1">
+            <a:schemeClr val="accent1"/>
+          </a:lnRef>
+          <a:fillRef idx="3">
+            <a:schemeClr val="accent1"/>
+          </a:fillRef>
+          <a:effectRef idx="2">
+            <a:schemeClr val="accent1"/>
+          </a:effectRef>
+          <a:fontRef idx="minor">
+            <a:schemeClr val="lt1"/>
+          </a:fontRef>
+        </p:style>
+        <p:txBody>
+          <a:bodyPr rtlCol="0" anchor="ctr"/>
+          <a:lstStyle/>
+          <a:p>
+            <a:pPr algn="ctr"/>
+          </a:p>
+        </p:txBody>
+      </p:sp>
+      <p:sp>
+        <p:nvSpPr>
+          <p:cNvPr id="8" name="TextBox 7"/>
+          <p:cNvSpPr txBox="1"/>
+          <p:nvPr/>
+        </p:nvSpPr>
+        <p:spPr>
+          <a:xfrm>
+            <a:off x="6492240" y="3611880"/>
+            <a:ext cx="4663440" cy="2560320"/>
+          </a:xfrm>
+          <a:prstGeom prst="rect">
+            <a:avLst/>
+          </a:prstGeom>
+          <a:noFill/>
+        </p:spPr>
+        <p:txBody>
+          <a:bodyPr wrap="square">
+            <a:spAutoFit/>
+          </a:bodyPr>
+          <a:lstStyle/>
+          <a:p>
+            <a:pPr>
+              <a:spcAft>
+                <a:spcPts val="600"/>
+              </a:spcAft>
+              <a:defRPr sz="1500" b="1">
+                <a:solidFill>
+                  <a:srgbClr val="00E676"/>
+                </a:solidFill>
+              </a:defRPr>
+            </a:pPr>
+            <a:r>
+              <a:t>🏆 METAS CLAVE DEL PROYECTO</a:t>
+            </a:r>
+          </a:p>
+          <a:p>
+            <a:pPr>
+              <a:spcAft>
+                <a:spcPts val="400"/>
+              </a:spcAft>
+              <a:defRPr sz="1150">
+                <a:solidFill>
+                  <a:srgbClr val="FFFFFF"/>
+                </a:solidFill>
+              </a:defRPr>
+            </a:pPr>
+            <a:r>
+              <a:t>1. +20% a +25% en Ticket Promedio (AOV) en bebidas y botanas.</a:t>
+            </a:r>
+          </a:p>
+          <a:p>
+            <a:pPr>
+              <a:spcAft>
+                <a:spcPts val="400"/>
+              </a:spcAft>
+              <a:defRPr sz="1150">
+                <a:solidFill>
+                  <a:srgbClr val="FFFFFF"/>
+                </a:solidFill>
+              </a:defRPr>
+            </a:pPr>
+            <a:r>
+              <a:t>2. +35% en Tiempo de Estancia (comensales hasta el último cuarto).</a:t>
+            </a:r>
+          </a:p>
+          <a:p>
+            <a:pPr>
+              <a:spcAft>
+                <a:spcPts val="400"/>
+              </a:spcAft>
+              <a:defRPr sz="1150">
+                <a:solidFill>
+                  <a:srgbClr val="FFFFFF"/>
+                </a:solidFill>
+              </a:defRPr>
+            </a:pPr>
+            <a:r>
+              <a:t>3. Retención 3x: Clientes que regresan 3 a 4 veces por mes.</a:t>
+            </a:r>
+          </a:p>
+          <a:p>
+            <a:pPr>
+              <a:spcAft>
+                <a:spcPts val="400"/>
+              </a:spcAft>
+              <a:defRPr sz="1150">
+                <a:solidFill>
+                  <a:srgbClr val="FFFFFF"/>
+                </a:solidFill>
+              </a:defRPr>
+            </a:pPr>
+            <a:r>
+              <a:t>4. $0 en Papelería: Cero hojas impresas y cero errores manuales.</a:t>
             </a:r>
           </a:p>
         </p:txBody>
@@ -5289,7 +5905,7 @@
               </a:defRPr>
             </a:pPr>
             <a:r>
-              <a:t>SOLUCIÓN OPERATIVA</a:t>
+              <a:t>HISTORIA REAL • MOTIVACIÓN Y PROPÓSITO</a:t>
             </a:r>
           </a:p>
           <a:p>
@@ -5301,7 +5917,7 @@
               </a:defRPr>
             </a:pPr>
             <a:r>
-              <a:t>De Álamos a Juriquilla: El Reto Operativo y la Automatización</a:t>
+              <a:t>El Corazón del Proyecto: La Historia de un Barman en Álamos</a:t>
             </a:r>
           </a:p>
         </p:txBody>
@@ -5315,7 +5931,7 @@
         <p:spPr>
           <a:xfrm>
             <a:off x="731520" y="1645920"/>
-            <a:ext cx="5212080" cy="4663440"/>
+            <a:ext cx="10728655" cy="4663440"/>
           </a:xfrm>
           <a:prstGeom prst="roundRect">
             <a:avLst/>
@@ -5359,8 +5975,8 @@
         </p:nvSpPr>
         <p:spPr>
           <a:xfrm>
-            <a:off x="1005840" y="1828800"/>
-            <a:ext cx="4663440" cy="4206240"/>
+            <a:off x="1097280" y="1828800"/>
+            <a:ext cx="9966960" cy="4206240"/>
           </a:xfrm>
           <a:prstGeom prst="rect">
             <a:avLst/>
@@ -5375,31 +5991,61 @@
           <a:p>
             <a:pPr>
               <a:spcAft>
+                <a:spcPts val="1200"/>
+              </a:spcAft>
+              <a:defRPr sz="1700" b="1">
+                <a:solidFill>
+                  <a:srgbClr val="FFB612"/>
+                </a:solidFill>
+              </a:defRPr>
+            </a:pPr>
+            <a:r>
+              <a:t>❤️ «El cliente debe estar contento: aún si su equipo pierde o el partido está aburrido»</a:t>
+            </a:r>
+          </a:p>
+          <a:p>
+            <a:pPr>
+              <a:spcAft>
+                <a:spcPts val="200"/>
+              </a:spcAft>
+              <a:defRPr sz="1400" b="1">
+                <a:solidFill>
+                  <a:srgbClr val="FFD100"/>
+                </a:solidFill>
+              </a:defRPr>
+            </a:pPr>
+            <a:r>
+              <a:t>🍺 El Origen Detrás de la Barra en Álamos</a:t>
+            </a:r>
+          </a:p>
+          <a:p>
+            <a:pPr>
+              <a:spcAft>
                 <a:spcPts val="1000"/>
               </a:spcAft>
-              <a:defRPr sz="1700" b="1">
-                <a:solidFill>
-                  <a:srgbClr val="FF5722"/>
-                </a:solidFill>
-              </a:defRPr>
-            </a:pPr>
-            <a:r>
-              <a:t>⚠️ El Dilema Operativo Actual</a:t>
-            </a:r>
-          </a:p>
-          <a:p>
-            <a:pPr>
-              <a:spcAft>
-                <a:spcPts val="100"/>
-              </a:spcAft>
-              <a:defRPr sz="1300" b="1">
+              <a:defRPr sz="1200">
+                <a:solidFill>
+                  <a:srgbClr val="FFFFFF"/>
+                </a:solidFill>
+              </a:defRPr>
+            </a:pPr>
+            <a:r>
+              <a:t>Esto comenzó cuando yo era barman en la sucursal de Álamos. Mi meta siempre fue clara: que cada persona se fuera feliz del restaurante. Por naturaleza, al ser humano le fascina competir. Empecé a inventar quinielas y trivias entre las mesas; de repente, la gente no solo veía la tele, ¡estaban conviviendo, gritando y pidiendo más rondas de cerveza y alitas!</a:t>
+            </a:r>
+          </a:p>
+          <a:p>
+            <a:pPr>
+              <a:spcAft>
+                <a:spcPts val="200"/>
+              </a:spcAft>
+              <a:defRPr sz="1400" b="1">
                 <a:solidFill>
                   <a:srgbClr val="FFD100"/>
                 </a:solidFill>
               </a:defRPr>
             </a:pPr>
             <a:r>
-              <a:t>📍 Cambio a Juriquilla</a:t>
+              <a:t>🙏 Una Comunidad Fiel que Impulsa a Mi Familia</a:t>
             </a:r>
           </a:p>
           <a:p>
@@ -5407,29 +6053,29 @@
               <a:spcAft>
                 <a:spcPts val="1000"/>
               </a:spcAft>
-              <a:defRPr sz="1150">
+              <a:defRPr sz="1200">
                 <a:solidFill>
                   <a:srgbClr val="FFFFFF"/>
                 </a:solidFill>
               </a:defRPr>
             </a:pPr>
             <a:r>
-              <a:t>Ahora que estoy en Juriquilla, muchos comensales van buscando exactamente esas dinámicas divertidas que vivieron en Álamos.</a:t>
-            </a:r>
-          </a:p>
-          <a:p>
-            <a:pPr>
-              <a:spcAft>
-                <a:spcPts val="100"/>
-              </a:spcAft>
-              <a:defRPr sz="1300" b="1">
+              <a:t>Esas dinámicas crearon clientes tan frecuentes y leales que hasta el día de hoy me ven en la calle en Querétaro y me dicen con una sonrisa: '¡Beto, qué onda! ¿Para cuándo otra quiniela o trivia?'. Gracias a esos clientes y a las propinas que dejan en mesa, he podido sacar adelante a mi familia.</a:t>
+            </a:r>
+          </a:p>
+          <a:p>
+            <a:pPr>
+              <a:spcAft>
+                <a:spcPts val="200"/>
+              </a:spcAft>
+              <a:defRPr sz="1400" b="1">
                 <a:solidFill>
                   <a:srgbClr val="FFD100"/>
                 </a:solidFill>
               </a:defRPr>
             </a:pPr>
             <a:r>
-              <a:t>⏱️ La Operación No Puede Descuidarse</a:t>
+              <a:t>💡 No Soy Programador ni Ingeniero: Soy Alguien que Ama Este Lugar</a:t>
             </a:r>
           </a:p>
           <a:p>
@@ -5437,187 +6083,14 @@
               <a:spcAft>
                 <a:spcPts val="1000"/>
               </a:spcAft>
-              <a:defRPr sz="1150">
+              <a:defRPr sz="1200">
                 <a:solidFill>
                   <a:srgbClr val="FFFFFF"/>
                 </a:solidFill>
               </a:defRPr>
             </a:pPr>
             <a:r>
-              <a:t>Hoy mis deberes ya no son solo atender la barra, sino estar pendiente de la operación completa del restaurante. Es imposible descuidar el servicio para andar contando papeletas de papel o sumando puntos a mano.</a:t>
-            </a:r>
-          </a:p>
-        </p:txBody>
-      </p:sp>
-      <p:sp>
-        <p:nvSpPr>
-          <p:cNvPr id="5" name="Rounded Rectangle 4"/>
-          <p:cNvSpPr/>
-          <p:nvPr/>
-        </p:nvSpPr>
-        <p:spPr>
-          <a:xfrm>
-            <a:off x="6217920" y="1645920"/>
-            <a:ext cx="5212080" cy="4663440"/>
-          </a:xfrm>
-          <a:prstGeom prst="roundRect">
-            <a:avLst/>
-          </a:prstGeom>
-          <a:solidFill>
-            <a:srgbClr val="141A26"/>
-          </a:solidFill>
-          <a:ln w="19050">
-            <a:solidFill>
-              <a:srgbClr val="283246"/>
-            </a:solidFill>
-          </a:ln>
-        </p:spPr>
-        <p:style>
-          <a:lnRef idx="1">
-            <a:schemeClr val="accent1"/>
-          </a:lnRef>
-          <a:fillRef idx="3">
-            <a:schemeClr val="accent1"/>
-          </a:fillRef>
-          <a:effectRef idx="2">
-            <a:schemeClr val="accent1"/>
-          </a:effectRef>
-          <a:fontRef idx="minor">
-            <a:schemeClr val="lt1"/>
-          </a:fontRef>
-        </p:style>
-        <p:txBody>
-          <a:bodyPr rtlCol="0" anchor="ctr"/>
-          <a:lstStyle/>
-          <a:p>
-            <a:pPr algn="ctr"/>
-          </a:p>
-        </p:txBody>
-      </p:sp>
-      <p:sp>
-        <p:nvSpPr>
-          <p:cNvPr id="6" name="TextBox 5"/>
-          <p:cNvSpPr txBox="1"/>
-          <p:nvPr/>
-        </p:nvSpPr>
-        <p:spPr>
-          <a:xfrm>
-            <a:off x="6492240" y="1828800"/>
-            <a:ext cx="4663440" cy="4206240"/>
-          </a:xfrm>
-          <a:prstGeom prst="rect">
-            <a:avLst/>
-          </a:prstGeom>
-          <a:noFill/>
-        </p:spPr>
-        <p:txBody>
-          <a:bodyPr wrap="square">
-            <a:spAutoFit/>
-          </a:bodyPr>
-          <a:lstStyle/>
-          <a:p>
-            <a:pPr>
-              <a:spcAft>
-                <a:spcPts val="1000"/>
-              </a:spcAft>
-              <a:defRPr sz="1700" b="1">
-                <a:solidFill>
-                  <a:srgbClr val="00E676"/>
-                </a:solidFill>
-              </a:defRPr>
-            </a:pPr>
-            <a:r>
-              <a:t>🤖 La Solución: 80% Autónoma con IA</a:t>
-            </a:r>
-          </a:p>
-          <a:p>
-            <a:pPr>
-              <a:spcAft>
-                <a:spcPts val="100"/>
-              </a:spcAft>
-              <a:defRPr sz="1300" b="1">
-                <a:solidFill>
-                  <a:srgbClr val="FFD100"/>
-                </a:solidFill>
-              </a:defRPr>
-            </a:pPr>
-            <a:r>
-              <a:t>⚡ Cero Tiempo Perdido por el Gerente</a:t>
-            </a:r>
-          </a:p>
-          <a:p>
-            <a:pPr>
-              <a:spcAft>
-                <a:spcPts val="1000"/>
-              </a:spcAft>
-              <a:defRPr sz="1150">
-                <a:solidFill>
-                  <a:srgbClr val="FFFFFF"/>
-                </a:solidFill>
-              </a:defRPr>
-            </a:pPr>
-            <a:r>
-              <a:t>La app se administra sola en un 80%. Se conecta en vivo a ESPN y calcula marcadores oficiales sin intervención humana.</a:t>
-            </a:r>
-          </a:p>
-          <a:p>
-            <a:pPr>
-              <a:spcAft>
-                <a:spcPts val="100"/>
-              </a:spcAft>
-              <a:defRPr sz="1300" b="1">
-                <a:solidFill>
-                  <a:srgbClr val="FFD100"/>
-                </a:solidFill>
-              </a:defRPr>
-            </a:pPr>
-            <a:r>
-              <a:t>🧠 Creación con IA en Segundos</a:t>
-            </a:r>
-          </a:p>
-          <a:p>
-            <a:pPr>
-              <a:spcAft>
-                <a:spcPts val="1000"/>
-              </a:spcAft>
-              <a:defRPr sz="1150">
-                <a:solidFill>
-                  <a:srgbClr val="FFFFFF"/>
-                </a:solidFill>
-              </a:defRPr>
-            </a:pPr>
-            <a:r>
-              <a:t>La IA genera trivias deportivas y redacta preguntas temáticas para días de partido en 10 segundos.</a:t>
-            </a:r>
-          </a:p>
-          <a:p>
-            <a:pPr>
-              <a:spcAft>
-                <a:spcPts val="100"/>
-              </a:spcAft>
-              <a:defRPr sz="1300" b="1">
-                <a:solidFill>
-                  <a:srgbClr val="FFD100"/>
-                </a:solidFill>
-              </a:defRPr>
-            </a:pPr>
-            <a:r>
-              <a:t>📊 Cero Papel y Cero Errores</a:t>
-            </a:r>
-          </a:p>
-          <a:p>
-            <a:pPr>
-              <a:spcAft>
-                <a:spcPts val="1000"/>
-              </a:spcAft>
-              <a:defRPr sz="1150">
-                <a:solidFill>
-                  <a:srgbClr val="FFFFFF"/>
-                </a:solidFill>
-              </a:defRPr>
-            </a:pPr>
-            <a:r>
-              <a:t>Elimina impresiones, plumas y quejas de clientes por conteos incorrectos. Todo es transparente y en vivo en el celular del cliente.</a:t>
+              <a:t>No soy desarrollador de software ni diseñador gráfico. Construí esta plataforma con todo el corazón, utilizando Inteligencia Artificial y herramientas modernas, por el inmenso cariño que le tengo a la marca y a este equipo.</a:t>
             </a:r>
           </a:p>
         </p:txBody>
@@ -5681,7 +6154,7 @@
               </a:defRPr>
             </a:pPr>
             <a:r>
-              <a:t>TRACCIÓN REAL EN QUERÉTARO</a:t>
+              <a:t>SOLUCIÓN OPERATIVA</a:t>
             </a:r>
           </a:p>
           <a:p>
@@ -5693,7 +6166,7 @@
               </a:defRPr>
             </a:pPr>
             <a:r>
-              <a:t>Potencial Inmediato: 71 Fans en 2 Semanas de una Base de +350</a:t>
+              <a:t>De Álamos a Juriquilla: El Reto Operativo y la Automatización</a:t>
             </a:r>
           </a:p>
         </p:txBody>
@@ -5707,7 +6180,7 @@
         <p:spPr>
           <a:xfrm>
             <a:off x="731520" y="1645920"/>
-            <a:ext cx="10728655" cy="4663440"/>
+            <a:ext cx="5212080" cy="4663440"/>
           </a:xfrm>
           <a:prstGeom prst="roundRect">
             <a:avLst/>
@@ -5751,8 +6224,8 @@
         </p:nvSpPr>
         <p:spPr>
           <a:xfrm>
-            <a:off x="1097280" y="1828800"/>
-            <a:ext cx="9966960" cy="4206240"/>
+            <a:off x="1005840" y="1828800"/>
+            <a:ext cx="4663440" cy="4206240"/>
           </a:xfrm>
           <a:prstGeom prst="rect">
             <a:avLst/>
@@ -5767,31 +6240,31 @@
           <a:p>
             <a:pPr>
               <a:spcAft>
-                <a:spcPts val="1200"/>
+                <a:spcPts val="1000"/>
               </a:spcAft>
               <a:defRPr sz="1700" b="1">
                 <a:solidFill>
-                  <a:srgbClr val="FFB612"/>
-                </a:solidFill>
-              </a:defRPr>
-            </a:pPr>
-            <a:r>
-              <a:t>🏈 La Punta de Lanza: Steelers Nation Querétaro</a:t>
-            </a:r>
-          </a:p>
-          <a:p>
-            <a:pPr>
-              <a:spcAft>
-                <a:spcPts val="200"/>
-              </a:spcAft>
-              <a:defRPr sz="1400" b="1">
+                  <a:srgbClr val="FF5722"/>
+                </a:solidFill>
+              </a:defRPr>
+            </a:pPr>
+            <a:r>
+              <a:t>⚠️ El Dilema Operativo Actual</a:t>
+            </a:r>
+          </a:p>
+          <a:p>
+            <a:pPr>
+              <a:spcAft>
+                <a:spcPts val="100"/>
+              </a:spcAft>
+              <a:defRPr sz="1300" b="1">
                 <a:solidFill>
                   <a:srgbClr val="FFD100"/>
                 </a:solidFill>
               </a:defRPr>
             </a:pPr>
             <a:r>
-              <a:t>📈 Crecimiento Explosivo Orgánico</a:t>
+              <a:t>📍 Cambio a Juriquilla</a:t>
             </a:r>
           </a:p>
           <a:p>
@@ -5799,29 +6272,29 @@
               <a:spcAft>
                 <a:spcPts val="1000"/>
               </a:spcAft>
-              <a:defRPr sz="1200">
+              <a:defRPr sz="1150">
                 <a:solidFill>
                   <a:srgbClr val="FFFFFF"/>
                 </a:solidFill>
               </a:defRPr>
             </a:pPr>
             <a:r>
-              <a:t>En tan solo 2 semanas desde el lanzamiento de la Credencial Digital de Steelers Nation QRO, ya se han registrado 71 miembros oficiales en la app. Pero son más de 350 fanáticos activos en la comunidad de Querétaro.</a:t>
-            </a:r>
-          </a:p>
-          <a:p>
-            <a:pPr>
-              <a:spcAft>
-                <a:spcPts val="200"/>
-              </a:spcAft>
-              <a:defRPr sz="1400" b="1">
+              <a:t>Ahora que estoy en Juriquilla, muchos comensales van buscando exactamente esas dinámicas divertidas que vivieron en Álamos.</a:t>
+            </a:r>
+          </a:p>
+          <a:p>
+            <a:pPr>
+              <a:spcAft>
+                <a:spcPts val="100"/>
+              </a:spcAft>
+              <a:defRPr sz="1300" b="1">
                 <a:solidFill>
                   <a:srgbClr val="FFD100"/>
                 </a:solidFill>
               </a:defRPr>
             </a:pPr>
             <a:r>
-              <a:t>📲 Conexión Directa desde su Credencial Digital (PWA)</a:t>
+              <a:t>⏱️ La Operación No Puede Descuidarse</a:t>
             </a:r>
           </a:p>
           <a:p>
@@ -5829,29 +6302,112 @@
               <a:spcAft>
                 <a:spcPts val="1000"/>
               </a:spcAft>
-              <a:defRPr sz="1200">
+              <a:defRPr sz="1150">
                 <a:solidFill>
                   <a:srgbClr val="FFFFFF"/>
                 </a:solidFill>
               </a:defRPr>
             </a:pPr>
             <a:r>
-              <a:t>La credencial digital de los fans tiene un botón especial integrado que los manda directamente a Drinks &amp; Wins para participar en las dinámicas de cada juego. Es una audiencia cautiva que ya ama la marca.</a:t>
-            </a:r>
-          </a:p>
-          <a:p>
-            <a:pPr>
-              <a:spcAft>
-                <a:spcPts val="200"/>
-              </a:spcAft>
-              <a:defRPr sz="1400" b="1">
+              <a:t>Hoy mis deberes ya no son solo atender la barra, sino estar pendiente de la operación completa del restaurante. Es imposible descuidar el servicio para andar contando papeletas de papel o sumando puntos a mano.</a:t>
+            </a:r>
+          </a:p>
+        </p:txBody>
+      </p:sp>
+      <p:sp>
+        <p:nvSpPr>
+          <p:cNvPr id="5" name="Rounded Rectangle 4"/>
+          <p:cNvSpPr/>
+          <p:nvPr/>
+        </p:nvSpPr>
+        <p:spPr>
+          <a:xfrm>
+            <a:off x="6217920" y="1645920"/>
+            <a:ext cx="5212080" cy="4663440"/>
+          </a:xfrm>
+          <a:prstGeom prst="roundRect">
+            <a:avLst/>
+          </a:prstGeom>
+          <a:solidFill>
+            <a:srgbClr val="141A26"/>
+          </a:solidFill>
+          <a:ln w="19050">
+            <a:solidFill>
+              <a:srgbClr val="283246"/>
+            </a:solidFill>
+          </a:ln>
+        </p:spPr>
+        <p:style>
+          <a:lnRef idx="1">
+            <a:schemeClr val="accent1"/>
+          </a:lnRef>
+          <a:fillRef idx="3">
+            <a:schemeClr val="accent1"/>
+          </a:fillRef>
+          <a:effectRef idx="2">
+            <a:schemeClr val="accent1"/>
+          </a:effectRef>
+          <a:fontRef idx="minor">
+            <a:schemeClr val="lt1"/>
+          </a:fontRef>
+        </p:style>
+        <p:txBody>
+          <a:bodyPr rtlCol="0" anchor="ctr"/>
+          <a:lstStyle/>
+          <a:p>
+            <a:pPr algn="ctr"/>
+          </a:p>
+        </p:txBody>
+      </p:sp>
+      <p:sp>
+        <p:nvSpPr>
+          <p:cNvPr id="6" name="TextBox 5"/>
+          <p:cNvSpPr txBox="1"/>
+          <p:nvPr/>
+        </p:nvSpPr>
+        <p:spPr>
+          <a:xfrm>
+            <a:off x="6492240" y="1828800"/>
+            <a:ext cx="4663440" cy="4206240"/>
+          </a:xfrm>
+          <a:prstGeom prst="rect">
+            <a:avLst/>
+          </a:prstGeom>
+          <a:noFill/>
+        </p:spPr>
+        <p:txBody>
+          <a:bodyPr wrap="square">
+            <a:spAutoFit/>
+          </a:bodyPr>
+          <a:lstStyle/>
+          <a:p>
+            <a:pPr>
+              <a:spcAft>
+                <a:spcPts val="1000"/>
+              </a:spcAft>
+              <a:defRPr sz="1700" b="1">
+                <a:solidFill>
+                  <a:srgbClr val="00E676"/>
+                </a:solidFill>
+              </a:defRPr>
+            </a:pPr>
+            <a:r>
+              <a:t>🤖 La Solución: 80% Autónoma con IA</a:t>
+            </a:r>
+          </a:p>
+          <a:p>
+            <a:pPr>
+              <a:spcAft>
+                <a:spcPts val="100"/>
+              </a:spcAft>
+              <a:defRPr sz="1300" b="1">
                 <a:solidFill>
                   <a:srgbClr val="FFD100"/>
                 </a:solidFill>
               </a:defRPr>
             </a:pPr>
             <a:r>
-              <a:t>🍻 Asistencia y Consumo Comprobado</a:t>
+              <a:t>⚡ Cero Tiempo Perdido por el Gerente</a:t>
             </a:r>
           </a:p>
           <a:p>
@@ -5859,14 +6415,74 @@
               <a:spcAft>
                 <a:spcPts val="1000"/>
               </a:spcAft>
-              <a:defRPr sz="1200">
+              <a:defRPr sz="1150">
                 <a:solidFill>
                   <a:srgbClr val="FFFFFF"/>
                 </a:solidFill>
               </a:defRPr>
             </a:pPr>
             <a:r>
-              <a:t>Este grupo no viene solo por una cerveza: llenan mesas enteras, piden cubetazos, rondas continuas de alitas y se quedan durante toda la transmisión del partido. Es el motor perfecto para arrancar en Juriquilla.</a:t>
+              <a:t>La app se administra sola en un 80%. Se conecta en vivo a ESPN y calcula marcadores oficiales sin intervención humana.</a:t>
+            </a:r>
+          </a:p>
+          <a:p>
+            <a:pPr>
+              <a:spcAft>
+                <a:spcPts val="100"/>
+              </a:spcAft>
+              <a:defRPr sz="1300" b="1">
+                <a:solidFill>
+                  <a:srgbClr val="FFD100"/>
+                </a:solidFill>
+              </a:defRPr>
+            </a:pPr>
+            <a:r>
+              <a:t>🧠 Creación con IA en Segundos</a:t>
+            </a:r>
+          </a:p>
+          <a:p>
+            <a:pPr>
+              <a:spcAft>
+                <a:spcPts val="1000"/>
+              </a:spcAft>
+              <a:defRPr sz="1150">
+                <a:solidFill>
+                  <a:srgbClr val="FFFFFF"/>
+                </a:solidFill>
+              </a:defRPr>
+            </a:pPr>
+            <a:r>
+              <a:t>La IA genera trivias deportivas y redacta preguntas temáticas para días de partido en 10 segundos.</a:t>
+            </a:r>
+          </a:p>
+          <a:p>
+            <a:pPr>
+              <a:spcAft>
+                <a:spcPts val="100"/>
+              </a:spcAft>
+              <a:defRPr sz="1300" b="1">
+                <a:solidFill>
+                  <a:srgbClr val="FFD100"/>
+                </a:solidFill>
+              </a:defRPr>
+            </a:pPr>
+            <a:r>
+              <a:t>📊 Cero Papel y Cero Errores</a:t>
+            </a:r>
+          </a:p>
+          <a:p>
+            <a:pPr>
+              <a:spcAft>
+                <a:spcPts val="1000"/>
+              </a:spcAft>
+              <a:defRPr sz="1150">
+                <a:solidFill>
+                  <a:srgbClr val="FFFFFF"/>
+                </a:solidFill>
+              </a:defRPr>
+            </a:pPr>
+            <a:r>
+              <a:t>Elimina impresiones, plumas y quejas de clientes por conteos incorrectos. Todo es transparente y en vivo en el celular del cliente.</a:t>
             </a:r>
           </a:p>
         </p:txBody>
@@ -5930,7 +6546,7 @@
               </a:defRPr>
             </a:pPr>
             <a:r>
-              <a:t>EXPERIENCIA DE USUARIO SIN FRICCIÓN</a:t>
+              <a:t>TRACCIÓN REAL EN QUERÉTARO</a:t>
             </a:r>
           </a:p>
           <a:p>
@@ -5942,7 +6558,7 @@
               </a:defRPr>
             </a:pPr>
             <a:r>
-              <a:t>Guía del Cliente: Cómo Ingresar, Registrarse e Instalar la App</a:t>
+              <a:t>Potencial Inmediato: 71 Fans en 2 Semanas de una Base de +350</a:t>
             </a:r>
           </a:p>
         </p:txBody>
@@ -5956,7 +6572,7 @@
         <p:spPr>
           <a:xfrm>
             <a:off x="731520" y="1645920"/>
-            <a:ext cx="3413455" cy="4663440"/>
+            <a:ext cx="10728655" cy="4663440"/>
           </a:xfrm>
           <a:prstGeom prst="roundRect">
             <a:avLst/>
@@ -6000,8 +6616,8 @@
         </p:nvSpPr>
         <p:spPr>
           <a:xfrm>
-            <a:off x="1005840" y="1828800"/>
-            <a:ext cx="2864815" cy="4206240"/>
+            <a:off x="1097280" y="1828800"/>
+            <a:ext cx="9966960" cy="4206240"/>
           </a:xfrm>
           <a:prstGeom prst="rect">
             <a:avLst/>
@@ -6016,246 +6632,106 @@
           <a:p>
             <a:pPr>
               <a:spcAft>
-                <a:spcPts val="1400"/>
-              </a:spcAft>
-              <a:defRPr sz="1600" b="1">
+                <a:spcPts val="1200"/>
+              </a:spcAft>
+              <a:defRPr sz="1700" b="1">
                 <a:solidFill>
                   <a:srgbClr val="FFB612"/>
                 </a:solidFill>
               </a:defRPr>
             </a:pPr>
             <a:r>
-              <a:t>1. CÓMO INGRESA</a:t>
-            </a:r>
-          </a:p>
-          <a:p>
-            <a:pPr>
-              <a:defRPr sz="1250">
+              <a:t>🏈 La Punta de Lanza: Steelers Nation Querétaro</a:t>
+            </a:r>
+          </a:p>
+          <a:p>
+            <a:pPr>
+              <a:spcAft>
+                <a:spcPts val="200"/>
+              </a:spcAft>
+              <a:defRPr sz="1400" b="1">
+                <a:solidFill>
+                  <a:srgbClr val="FFD100"/>
+                </a:solidFill>
+              </a:defRPr>
+            </a:pPr>
+            <a:r>
+              <a:t>📈 Crecimiento Explosivo Orgánico</a:t>
+            </a:r>
+          </a:p>
+          <a:p>
+            <a:pPr>
+              <a:spcAft>
+                <a:spcPts val="1000"/>
+              </a:spcAft>
+              <a:defRPr sz="1200">
                 <a:solidFill>
                   <a:srgbClr val="FFFFFF"/>
                 </a:solidFill>
               </a:defRPr>
             </a:pPr>
             <a:r>
-              <a:t>📱 En su mesa encuentra el código QR en el acrílico.</a:t>
-            </a:r>
-            <a:br/>
-            <a:r>
-              <a:t>• Abre la cámara de su celular y apunta al QR.</a:t>
-            </a:r>
-            <a:br/>
-            <a:r>
-              <a:t>• Entra en 3 segundos en su navegador web sin descargas pesadas ni tiendas de aplicaciones.</a:t>
-            </a:r>
-          </a:p>
-        </p:txBody>
-      </p:sp>
-      <p:sp>
-        <p:nvSpPr>
-          <p:cNvPr id="5" name="Rounded Rectangle 4"/>
-          <p:cNvSpPr/>
-          <p:nvPr/>
-        </p:nvSpPr>
-        <p:spPr>
-          <a:xfrm>
-            <a:off x="4389120" y="1645920"/>
-            <a:ext cx="3413455" cy="4663440"/>
-          </a:xfrm>
-          <a:prstGeom prst="roundRect">
-            <a:avLst/>
-          </a:prstGeom>
-          <a:solidFill>
-            <a:srgbClr val="141A26"/>
-          </a:solidFill>
-          <a:ln w="19050">
-            <a:solidFill>
-              <a:srgbClr val="283246"/>
-            </a:solidFill>
-          </a:ln>
-        </p:spPr>
-        <p:style>
-          <a:lnRef idx="1">
-            <a:schemeClr val="accent1"/>
-          </a:lnRef>
-          <a:fillRef idx="3">
-            <a:schemeClr val="accent1"/>
-          </a:fillRef>
-          <a:effectRef idx="2">
-            <a:schemeClr val="accent1"/>
-          </a:effectRef>
-          <a:fontRef idx="minor">
-            <a:schemeClr val="lt1"/>
-          </a:fontRef>
-        </p:style>
-        <p:txBody>
-          <a:bodyPr rtlCol="0" anchor="ctr"/>
-          <a:lstStyle/>
-          <a:p>
-            <a:pPr algn="ctr"/>
-          </a:p>
-        </p:txBody>
-      </p:sp>
-      <p:sp>
-        <p:nvSpPr>
-          <p:cNvPr id="6" name="TextBox 5"/>
-          <p:cNvSpPr txBox="1"/>
-          <p:nvPr/>
-        </p:nvSpPr>
-        <p:spPr>
-          <a:xfrm>
-            <a:off x="4663440" y="1828800"/>
-            <a:ext cx="2864815" cy="4206240"/>
-          </a:xfrm>
-          <a:prstGeom prst="rect">
-            <a:avLst/>
-          </a:prstGeom>
-          <a:noFill/>
-        </p:spPr>
-        <p:txBody>
-          <a:bodyPr wrap="square">
-            <a:spAutoFit/>
-          </a:bodyPr>
-          <a:lstStyle/>
-          <a:p>
-            <a:pPr>
-              <a:spcAft>
-                <a:spcPts val="1400"/>
-              </a:spcAft>
-              <a:defRPr sz="1600" b="1">
-                <a:solidFill>
-                  <a:srgbClr val="FF5722"/>
-                </a:solidFill>
-              </a:defRPr>
-            </a:pPr>
-            <a:r>
-              <a:t>2. CÓMO SE REGISTRA</a:t>
-            </a:r>
-          </a:p>
-          <a:p>
-            <a:pPr>
-              <a:defRPr sz="1250">
+              <a:t>En tan solo 2 semanas desde el lanzamiento de la Credencial Digital de Steelers Nation QRO, ya se han registrado 71 miembros oficiales en la app. Pero son más de 350 fanáticos activos en la comunidad de Querétaro.</a:t>
+            </a:r>
+          </a:p>
+          <a:p>
+            <a:pPr>
+              <a:spcAft>
+                <a:spcPts val="200"/>
+              </a:spcAft>
+              <a:defRPr sz="1400" b="1">
+                <a:solidFill>
+                  <a:srgbClr val="FFD100"/>
+                </a:solidFill>
+              </a:defRPr>
+            </a:pPr>
+            <a:r>
+              <a:t>📲 Conexión Directa desde su Credencial Digital (PWA)</a:t>
+            </a:r>
+          </a:p>
+          <a:p>
+            <a:pPr>
+              <a:spcAft>
+                <a:spcPts val="1000"/>
+              </a:spcAft>
+              <a:defRPr sz="1200">
                 <a:solidFill>
                   <a:srgbClr val="FFFFFF"/>
                 </a:solidFill>
               </a:defRPr>
             </a:pPr>
             <a:r>
-              <a:t>👤 Con un solo toque inicia sesión con su cuenta de Google o escribe su nombre/apodo.</a:t>
-            </a:r>
-            <a:br/>
-            <a:r>
-              <a:t>• Selecciona el nombre del mesero que lo atiende.</a:t>
-            </a:r>
-            <a:br/>
-            <a:r>
-              <a:t>• Todo queda guardado en la nube al instante.</a:t>
-            </a:r>
-          </a:p>
-        </p:txBody>
-      </p:sp>
-      <p:sp>
-        <p:nvSpPr>
-          <p:cNvPr id="7" name="Rounded Rectangle 6"/>
-          <p:cNvSpPr/>
-          <p:nvPr/>
-        </p:nvSpPr>
-        <p:spPr>
-          <a:xfrm>
-            <a:off x="8046720" y="1645920"/>
-            <a:ext cx="3413455" cy="4663440"/>
-          </a:xfrm>
-          <a:prstGeom prst="roundRect">
-            <a:avLst/>
-          </a:prstGeom>
-          <a:solidFill>
-            <a:srgbClr val="141A26"/>
-          </a:solidFill>
-          <a:ln w="19050">
-            <a:solidFill>
-              <a:srgbClr val="283246"/>
-            </a:solidFill>
-          </a:ln>
-        </p:spPr>
-        <p:style>
-          <a:lnRef idx="1">
-            <a:schemeClr val="accent1"/>
-          </a:lnRef>
-          <a:fillRef idx="3">
-            <a:schemeClr val="accent1"/>
-          </a:fillRef>
-          <a:effectRef idx="2">
-            <a:schemeClr val="accent1"/>
-          </a:effectRef>
-          <a:fontRef idx="minor">
-            <a:schemeClr val="lt1"/>
-          </a:fontRef>
-        </p:style>
-        <p:txBody>
-          <a:bodyPr rtlCol="0" anchor="ctr"/>
-          <a:lstStyle/>
-          <a:p>
-            <a:pPr algn="ctr"/>
-          </a:p>
-        </p:txBody>
-      </p:sp>
-      <p:sp>
-        <p:nvSpPr>
-          <p:cNvPr id="8" name="TextBox 7"/>
-          <p:cNvSpPr txBox="1"/>
-          <p:nvPr/>
-        </p:nvSpPr>
-        <p:spPr>
-          <a:xfrm>
-            <a:off x="8321040" y="1828800"/>
-            <a:ext cx="2864815" cy="4206240"/>
-          </a:xfrm>
-          <a:prstGeom prst="rect">
-            <a:avLst/>
-          </a:prstGeom>
-          <a:noFill/>
-        </p:spPr>
-        <p:txBody>
-          <a:bodyPr wrap="square">
-            <a:spAutoFit/>
-          </a:bodyPr>
-          <a:lstStyle/>
-          <a:p>
-            <a:pPr>
-              <a:spcAft>
-                <a:spcPts val="1400"/>
-              </a:spcAft>
-              <a:defRPr sz="1600" b="1">
-                <a:solidFill>
-                  <a:srgbClr val="00E676"/>
-                </a:solidFill>
-              </a:defRPr>
-            </a:pPr>
-            <a:r>
-              <a:t>3. CÓMO SE INSTALA (PWA)</a:t>
-            </a:r>
-          </a:p>
-          <a:p>
-            <a:pPr>
-              <a:defRPr sz="1250">
+              <a:t>La credencial digital de los fans tiene un botón especial integrado que los manda directamente a Drinks &amp; Wins para participar en las dinámicas de cada juego. Es una audiencia cautiva que ya ama la marca.</a:t>
+            </a:r>
+          </a:p>
+          <a:p>
+            <a:pPr>
+              <a:spcAft>
+                <a:spcPts val="200"/>
+              </a:spcAft>
+              <a:defRPr sz="1400" b="1">
+                <a:solidFill>
+                  <a:srgbClr val="FFD100"/>
+                </a:solidFill>
+              </a:defRPr>
+            </a:pPr>
+            <a:r>
+              <a:t>🍻 Asistencia y Consumo Comprobado</a:t>
+            </a:r>
+          </a:p>
+          <a:p>
+            <a:pPr>
+              <a:spcAft>
+                <a:spcPts val="1000"/>
+              </a:spcAft>
+              <a:defRPr sz="1200">
                 <a:solidFill>
                   <a:srgbClr val="FFFFFF"/>
                 </a:solidFill>
               </a:defRPr>
             </a:pPr>
             <a:r>
-              <a:t>📲 Se instala como una app nativa en 1 clic:</a:t>
-            </a:r>
-            <a:br/>
-            <a:r>
-              <a:t>• En iPhone: Compartir ➔ 'Agregar a pantalla de inicio'.</a:t>
-            </a:r>
-            <a:br/>
-            <a:r>
-              <a:t>• En Android: Toca el aviso 'Instalar App'.</a:t>
-            </a:r>
-            <a:br/>
-            <a:r>
-              <a:t>• ¡Queda el icono oficial en su celular para siempre!</a:t>
+              <a:t>Este grupo no viene solo por una cerveza: llenan mesas enteras, piden cubetazos, rondas continuas de alitas y se quedan durante toda la transmisión del partido. Es el motor perfecto para arrancar en Juriquilla.</a:t>
             </a:r>
           </a:p>
         </p:txBody>
@@ -6319,7 +6795,7 @@
               </a:defRPr>
             </a:pPr>
             <a:r>
-              <a:t>JUEGO POR JUEGO EN DETALLE</a:t>
+              <a:t>EXPERIENCIA DE USUARIO SIN FRICCIÓN</a:t>
             </a:r>
           </a:p>
           <a:p>
@@ -6331,7 +6807,7 @@
               </a:defRPr>
             </a:pPr>
             <a:r>
-              <a:t>Football Grids (100 Casillas NFL): Dinámica y Creación</a:t>
+              <a:t>Guía del Cliente: Cómo Ingresar, Registrarse e Instalar la App</a:t>
             </a:r>
           </a:p>
         </p:txBody>
@@ -6345,7 +6821,7 @@
         <p:spPr>
           <a:xfrm>
             <a:off x="731520" y="1645920"/>
-            <a:ext cx="6858000" cy="4663440"/>
+            <a:ext cx="3413455" cy="4663440"/>
           </a:xfrm>
           <a:prstGeom prst="roundRect">
             <a:avLst/>
@@ -6390,7 +6866,7 @@
         <p:spPr>
           <a:xfrm>
             <a:off x="1005840" y="1828800"/>
-            <a:ext cx="6309360" cy="4206240"/>
+            <a:ext cx="2864815" cy="4206240"/>
           </a:xfrm>
           <a:prstGeom prst="rect">
             <a:avLst/>
@@ -6405,119 +6881,250 @@
           <a:p>
             <a:pPr>
               <a:spcAft>
-                <a:spcPts val="200"/>
-              </a:spcAft>
-              <a:defRPr sz="1350" b="1">
-                <a:solidFill>
-                  <a:srgbClr val="FF5722"/>
-                </a:solidFill>
-              </a:defRPr>
-            </a:pPr>
-            <a:r>
-              <a:t>🛠️ CÓMO LO CREA EL GERENTE (30 segundos)</a:t>
-            </a:r>
-          </a:p>
-          <a:p>
-            <a:pPr>
-              <a:spcAft>
-                <a:spcPts val="1000"/>
-              </a:spcAft>
-              <a:defRPr sz="1150">
+                <a:spcPts val="1400"/>
+              </a:spcAft>
+              <a:defRPr sz="1600" b="1">
+                <a:solidFill>
+                  <a:srgbClr val="FFB612"/>
+                </a:solidFill>
+              </a:defRPr>
+            </a:pPr>
+            <a:r>
+              <a:t>1. CÓMO INGRESA</a:t>
+            </a:r>
+          </a:p>
+          <a:p>
+            <a:pPr>
+              <a:defRPr sz="1250">
                 <a:solidFill>
                   <a:srgbClr val="FFFFFF"/>
                 </a:solidFill>
               </a:defRPr>
             </a:pPr>
             <a:r>
-              <a:t>Entra al panel Admin, elige el partido estelar de la NFL (ej. Steelers vs Bills). Con un solo clic, el sistema genera la cuadrícula digital de 10x10 (100 casillas) con los logotipos oficiales de los dos equipos.</a:t>
-            </a:r>
-          </a:p>
-          <a:p>
-            <a:pPr>
-              <a:spcAft>
-                <a:spcPts val="200"/>
-              </a:spcAft>
-              <a:defRPr sz="1350" b="1">
-                <a:solidFill>
-                  <a:srgbClr val="FF5722"/>
-                </a:solidFill>
-              </a:defRPr>
-            </a:pPr>
-            <a:r>
-              <a:t>📱 CÓMO JUEGA EL CLIENTE EN MESA</a:t>
-            </a:r>
-          </a:p>
-          <a:p>
-            <a:pPr>
-              <a:spcAft>
-                <a:spcPts val="1000"/>
-              </a:spcAft>
-              <a:defRPr sz="1150">
-                <a:solidFill>
-                  <a:srgbClr val="FFFFFF"/>
-                </a:solidFill>
-              </a:defRPr>
-            </a:pPr>
-            <a:r>
-              <a:t>El comensal escanea el QR, ve la cuadrícula en su smartphone y toca las casillas vacías que desea apartar con su nombre o apodo para competir amistosamente con sus amigos.</a:t>
-            </a:r>
-          </a:p>
-          <a:p>
-            <a:pPr>
-              <a:spcAft>
-                <a:spcPts val="200"/>
-              </a:spcAft>
-              <a:defRPr sz="1350" b="1">
-                <a:solidFill>
-                  <a:srgbClr val="FF5722"/>
-                </a:solidFill>
-              </a:defRPr>
-            </a:pPr>
-            <a:r>
-              <a:t>🏆 CÓMO GANA Y POR QUÉ VENDE TANTO</a:t>
-            </a:r>
-          </a:p>
-          <a:p>
-            <a:pPr>
-              <a:spcAft>
-                <a:spcPts val="1000"/>
-              </a:spcAft>
-              <a:defRPr sz="1150">
-                <a:solidFill>
-                  <a:srgbClr val="FFFFFF"/>
-                </a:solidFill>
-              </a:defRPr>
-            </a:pPr>
-            <a:r>
-              <a:t>Al inicio del partido, el sistema sortea automáticamente los dígitos del 0 al 9 en filas y columnas. ¡Hay 4 GANADORES por partido! (Al final del 1Q, 2Q, 3Q y Final según el último dígito del marcador). Esto mantiene a la mesa consumiendo cervezas y botanas durante las 3 horas de transmisión.</a:t>
-            </a:r>
-          </a:p>
-        </p:txBody>
-      </p:sp>
-      <p:pic>
-        <p:nvPicPr>
-          <p:cNvPr id="5" name="Picture 4" descr="tarjeta_2_vive_la_nfl.png"/>
-          <p:cNvPicPr>
-            <a:picLocks noChangeAspect="1"/>
-          </p:cNvPicPr>
+              <a:t>📱 En su mesa encuentra el código QR en el acrílico.</a:t>
+            </a:r>
+            <a:br/>
+            <a:r>
+              <a:t>• Abre la cámara de su celular y apunta al QR.</a:t>
+            </a:r>
+            <a:br/>
+            <a:r>
+              <a:t>• Entra en 3 segundos en su navegador web sin descargas pesadas ni tiendas de aplicaciones.</a:t>
+            </a:r>
+          </a:p>
+        </p:txBody>
+      </p:sp>
+      <p:sp>
+        <p:nvSpPr>
+          <p:cNvPr id="5" name="Rounded Rectangle 4"/>
+          <p:cNvSpPr/>
           <p:nvPr/>
-        </p:nvPicPr>
-        <p:blipFill>
-          <a:blip r:embed="rId2"/>
-          <a:stretch>
-            <a:fillRect/>
-          </a:stretch>
-        </p:blipFill>
-        <p:spPr>
-          <a:xfrm>
-            <a:off x="7955279" y="1645920"/>
-            <a:ext cx="2623185" cy="4663440"/>
+        </p:nvSpPr>
+        <p:spPr>
+          <a:xfrm>
+            <a:off x="4389120" y="1645920"/>
+            <a:ext cx="3413455" cy="4663440"/>
+          </a:xfrm>
+          <a:prstGeom prst="roundRect">
+            <a:avLst/>
+          </a:prstGeom>
+          <a:solidFill>
+            <a:srgbClr val="141A26"/>
+          </a:solidFill>
+          <a:ln w="19050">
+            <a:solidFill>
+              <a:srgbClr val="283246"/>
+            </a:solidFill>
+          </a:ln>
+        </p:spPr>
+        <p:style>
+          <a:lnRef idx="1">
+            <a:schemeClr val="accent1"/>
+          </a:lnRef>
+          <a:fillRef idx="3">
+            <a:schemeClr val="accent1"/>
+          </a:fillRef>
+          <a:effectRef idx="2">
+            <a:schemeClr val="accent1"/>
+          </a:effectRef>
+          <a:fontRef idx="minor">
+            <a:schemeClr val="lt1"/>
+          </a:fontRef>
+        </p:style>
+        <p:txBody>
+          <a:bodyPr rtlCol="0" anchor="ctr"/>
+          <a:lstStyle/>
+          <a:p>
+            <a:pPr algn="ctr"/>
+          </a:p>
+        </p:txBody>
+      </p:sp>
+      <p:sp>
+        <p:nvSpPr>
+          <p:cNvPr id="6" name="TextBox 5"/>
+          <p:cNvSpPr txBox="1"/>
+          <p:nvPr/>
+        </p:nvSpPr>
+        <p:spPr>
+          <a:xfrm>
+            <a:off x="4663440" y="1828800"/>
+            <a:ext cx="2864815" cy="4206240"/>
           </a:xfrm>
           <a:prstGeom prst="rect">
             <a:avLst/>
           </a:prstGeom>
-        </p:spPr>
-      </p:pic>
+          <a:noFill/>
+        </p:spPr>
+        <p:txBody>
+          <a:bodyPr wrap="square">
+            <a:spAutoFit/>
+          </a:bodyPr>
+          <a:lstStyle/>
+          <a:p>
+            <a:pPr>
+              <a:spcAft>
+                <a:spcPts val="1400"/>
+              </a:spcAft>
+              <a:defRPr sz="1600" b="1">
+                <a:solidFill>
+                  <a:srgbClr val="FF5722"/>
+                </a:solidFill>
+              </a:defRPr>
+            </a:pPr>
+            <a:r>
+              <a:t>2. CÓMO SE REGISTRA</a:t>
+            </a:r>
+          </a:p>
+          <a:p>
+            <a:pPr>
+              <a:defRPr sz="1250">
+                <a:solidFill>
+                  <a:srgbClr val="FFFFFF"/>
+                </a:solidFill>
+              </a:defRPr>
+            </a:pPr>
+            <a:r>
+              <a:t>👤 Con un solo toque inicia sesión con su cuenta de Google o escribe su nombre/apodo.</a:t>
+            </a:r>
+            <a:br/>
+            <a:r>
+              <a:t>• Selecciona el nombre del mesero que lo atiende.</a:t>
+            </a:r>
+            <a:br/>
+            <a:r>
+              <a:t>• Todo queda guardado en la nube al instante.</a:t>
+            </a:r>
+          </a:p>
+        </p:txBody>
+      </p:sp>
+      <p:sp>
+        <p:nvSpPr>
+          <p:cNvPr id="7" name="Rounded Rectangle 6"/>
+          <p:cNvSpPr/>
+          <p:nvPr/>
+        </p:nvSpPr>
+        <p:spPr>
+          <a:xfrm>
+            <a:off x="8046720" y="1645920"/>
+            <a:ext cx="3413455" cy="4663440"/>
+          </a:xfrm>
+          <a:prstGeom prst="roundRect">
+            <a:avLst/>
+          </a:prstGeom>
+          <a:solidFill>
+            <a:srgbClr val="141A26"/>
+          </a:solidFill>
+          <a:ln w="19050">
+            <a:solidFill>
+              <a:srgbClr val="283246"/>
+            </a:solidFill>
+          </a:ln>
+        </p:spPr>
+        <p:style>
+          <a:lnRef idx="1">
+            <a:schemeClr val="accent1"/>
+          </a:lnRef>
+          <a:fillRef idx="3">
+            <a:schemeClr val="accent1"/>
+          </a:fillRef>
+          <a:effectRef idx="2">
+            <a:schemeClr val="accent1"/>
+          </a:effectRef>
+          <a:fontRef idx="minor">
+            <a:schemeClr val="lt1"/>
+          </a:fontRef>
+        </p:style>
+        <p:txBody>
+          <a:bodyPr rtlCol="0" anchor="ctr"/>
+          <a:lstStyle/>
+          <a:p>
+            <a:pPr algn="ctr"/>
+          </a:p>
+        </p:txBody>
+      </p:sp>
+      <p:sp>
+        <p:nvSpPr>
+          <p:cNvPr id="8" name="TextBox 7"/>
+          <p:cNvSpPr txBox="1"/>
+          <p:nvPr/>
+        </p:nvSpPr>
+        <p:spPr>
+          <a:xfrm>
+            <a:off x="8321040" y="1828800"/>
+            <a:ext cx="2864815" cy="4206240"/>
+          </a:xfrm>
+          <a:prstGeom prst="rect">
+            <a:avLst/>
+          </a:prstGeom>
+          <a:noFill/>
+        </p:spPr>
+        <p:txBody>
+          <a:bodyPr wrap="square">
+            <a:spAutoFit/>
+          </a:bodyPr>
+          <a:lstStyle/>
+          <a:p>
+            <a:pPr>
+              <a:spcAft>
+                <a:spcPts val="1400"/>
+              </a:spcAft>
+              <a:defRPr sz="1600" b="1">
+                <a:solidFill>
+                  <a:srgbClr val="00E676"/>
+                </a:solidFill>
+              </a:defRPr>
+            </a:pPr>
+            <a:r>
+              <a:t>3. CÓMO SE INSTALA (PWA)</a:t>
+            </a:r>
+          </a:p>
+          <a:p>
+            <a:pPr>
+              <a:defRPr sz="1250">
+                <a:solidFill>
+                  <a:srgbClr val="FFFFFF"/>
+                </a:solidFill>
+              </a:defRPr>
+            </a:pPr>
+            <a:r>
+              <a:t>📲 Se instala como una app nativa en 1 clic:</a:t>
+            </a:r>
+            <a:br/>
+            <a:r>
+              <a:t>• En iPhone: Compartir ➔ 'Agregar a pantalla de inicio'.</a:t>
+            </a:r>
+            <a:br/>
+            <a:r>
+              <a:t>• En Android: Toca el aviso 'Instalar App'.</a:t>
+            </a:r>
+            <a:br/>
+            <a:r>
+              <a:t>• ¡Queda el icono oficial en su celular para siempre!</a:t>
+            </a:r>
+          </a:p>
+        </p:txBody>
+      </p:sp>
     </p:spTree>
   </p:cSld>
   <p:clrMapOvr>
@@ -6589,7 +7196,7 @@
               </a:defRPr>
             </a:pPr>
             <a:r>
-              <a:t>Quinielas Pick'em (NFL y Liga MX): Reglas y Resultados en Vivo</a:t>
+              <a:t>Football Grids (100 Casillas NFL): Dinámica y Creación</a:t>
             </a:r>
           </a:p>
         </p:txBody>
@@ -6667,12 +7274,12 @@
               </a:spcAft>
               <a:defRPr sz="1350" b="1">
                 <a:solidFill>
-                  <a:srgbClr val="FFB612"/>
-                </a:solidFill>
-              </a:defRPr>
-            </a:pPr>
-            <a:r>
-              <a:t>🛠️ CÓMO LO CREA EL GERENTE (60 segundos)</a:t>
+                  <a:srgbClr val="FF5722"/>
+                </a:solidFill>
+              </a:defRPr>
+            </a:pPr>
+            <a:r>
+              <a:t>🛠️ CÓMO LO CREA EL GERENTE (30 segundos)</a:t>
             </a:r>
           </a:p>
           <a:p>
@@ -6687,7 +7294,7 @@
               </a:defRPr>
             </a:pPr>
             <a:r>
-              <a:t>Entra a Admin, elige la liga (NFL o Liga MX) y la jornada. La conexión con ESPN jala automáticamente partidos, horarios y escudos oficiales. El gerente toca los partidos deseados, define el premio (ej. Orden de Alitas + Cerveza) y presiona 'Crear Quiniela'.</a:t>
+              <a:t>Entra al panel Admin, elige el partido estelar de la NFL (ej. Steelers vs Bills). Con un solo clic, el sistema genera la cuadrícula digital de 10x10 (100 casillas) con los logotipos oficiales de los dos equipos.</a:t>
             </a:r>
           </a:p>
           <a:p>
@@ -6697,12 +7304,12 @@
               </a:spcAft>
               <a:defRPr sz="1350" b="1">
                 <a:solidFill>
-                  <a:srgbClr val="FFB612"/>
-                </a:solidFill>
-              </a:defRPr>
-            </a:pPr>
-            <a:r>
-              <a:t>📱 CÓMO JUEGA EL CLIENTE</a:t>
+                  <a:srgbClr val="FF5722"/>
+                </a:solidFill>
+              </a:defRPr>
+            </a:pPr>
+            <a:r>
+              <a:t>📱 CÓMO JUEGA EL CLIENTE EN MESA</a:t>
             </a:r>
           </a:p>
           <a:p>
@@ -6717,7 +7324,7 @@
               </a:defRPr>
             </a:pPr>
             <a:r>
-              <a:t>Abre la quiniela desde el QR, selecciona a su mesero e introduce sus pronósticos en pantalla. Se bloquean en automático cuando arranca el primer partido para garantizar 100% de transparencia.</a:t>
+              <a:t>El comensal escanea el QR, ve la cuadrícula en su smartphone y toca las casillas vacías que desea apartar con su nombre o apodo para competir amistosamente con sus amigos.</a:t>
             </a:r>
           </a:p>
           <a:p>
@@ -6727,12 +7334,12 @@
               </a:spcAft>
               <a:defRPr sz="1350" b="1">
                 <a:solidFill>
-                  <a:srgbClr val="FFB612"/>
-                </a:solidFill>
-              </a:defRPr>
-            </a:pPr>
-            <a:r>
-              <a:t>🏆 CÓMO GANA Y SE PREMIA</a:t>
+                  <a:srgbClr val="FF5722"/>
+                </a:solidFill>
+              </a:defRPr>
+            </a:pPr>
+            <a:r>
+              <a:t>🏆 CÓMO GANA Y POR QUÉ VENDE TANTO</a:t>
             </a:r>
           </a:p>
           <a:p>
@@ -6747,14 +7354,14 @@
               </a:defRPr>
             </a:pPr>
             <a:r>
-              <a:t>La API de ESPN actualiza la tabla en tiempo real: Marcador Exacto = +3 pts (verde esmeralda), Ganador = +1 pt (dorado), Fallo = 0 pts (rojo). Al terminar, se proclama al Campeón Oficial en el podio digital con corona 👑 para canje en barra.</a:t>
+              <a:t>Al inicio del partido, el sistema sortea automáticamente los dígitos del 0 al 9 en filas y columnas. ¡Hay 4 GANADORES por partido! (Al final del 1Q, 2Q, 3Q y Final según el último dígito del marcador). Esto mantiene a la mesa consumiendo cervezas y botanas durante las 3 horas de transmisión.</a:t>
             </a:r>
           </a:p>
         </p:txBody>
       </p:sp>
       <p:pic>
         <p:nvPicPr>
-          <p:cNvPr id="5" name="Picture 4" descr="screenshot_podium_standings.png"/>
+          <p:cNvPr id="5" name="Picture 4" descr="tarjeta_2_vive_la_nfl.png"/>
           <p:cNvPicPr>
             <a:picLocks noChangeAspect="1"/>
           </p:cNvPicPr>
@@ -6768,8 +7375,8 @@
         </p:blipFill>
         <p:spPr>
           <a:xfrm>
-            <a:off x="7863840" y="1645920"/>
-            <a:ext cx="8843264" cy="4663440"/>
+            <a:off x="7955279" y="1645920"/>
+            <a:ext cx="2623185" cy="4663440"/>
           </a:xfrm>
           <a:prstGeom prst="rect">
             <a:avLst/>
@@ -6847,7 +7454,7 @@
               </a:defRPr>
             </a:pPr>
             <a:r>
-              <a:t>First Striker Wins (Fútbol): Adrenalina Inmediata en el Minuto 1</a:t>
+              <a:t>Quinielas Pick'em (NFL y Liga MX): Reglas y Resultados en Vivo</a:t>
             </a:r>
           </a:p>
         </p:txBody>
@@ -6925,12 +7532,12 @@
               </a:spcAft>
               <a:defRPr sz="1350" b="1">
                 <a:solidFill>
-                  <a:srgbClr val="00E676"/>
-                </a:solidFill>
-              </a:defRPr>
-            </a:pPr>
-            <a:r>
-              <a:t>🛠️ CÓMO LO CREA EL GERENTE (30 segundos)</a:t>
+                  <a:srgbClr val="FFB612"/>
+                </a:solidFill>
+              </a:defRPr>
+            </a:pPr>
+            <a:r>
+              <a:t>🛠️ CÓMO LO CREA EL GERENTE (60 segundos)</a:t>
             </a:r>
           </a:p>
           <a:p>
@@ -6945,7 +7552,7 @@
               </a:defRPr>
             </a:pPr>
             <a:r>
-              <a:t>Elige el partido de fútbol (Liga MX, Champions League o Selección Nacional) y asigna un premio dinámico (ej. 1 ronda de cervezas o botana en mesa).</a:t>
+              <a:t>Entra a Admin, elige la liga (NFL o Liga MX) y la jornada. La conexión con ESPN jala automáticamente partidos, horarios y escudos oficiales. El gerente toca los partidos deseados, define el premio (ej. Orden de Alitas + Cerveza) y presiona 'Crear Quiniela'.</a:t>
             </a:r>
           </a:p>
           <a:p>
@@ -6955,7 +7562,7 @@
               </a:spcAft>
               <a:defRPr sz="1350" b="1">
                 <a:solidFill>
-                  <a:srgbClr val="00E676"/>
+                  <a:srgbClr val="FFB612"/>
                 </a:solidFill>
               </a:defRPr>
             </a:pPr>
@@ -6975,7 +7582,7 @@
               </a:defRPr>
             </a:pPr>
             <a:r>
-              <a:t>Elige qué equipo meterá el primer gol y en qué bloque de 15 minutos caerá (1-15', 16-30', 31-45', etc.), o la opción de 'Sin Goles en el Partido'.</a:t>
+              <a:t>Abre la quiniela desde el QR, selecciona a su mesero e introduce sus pronósticos en pantalla. Se bloquean en automático cuando arranca el primer partido para garantizar 100% de transparencia.</a:t>
             </a:r>
           </a:p>
           <a:p>
@@ -6985,12 +7592,12 @@
               </a:spcAft>
               <a:defRPr sz="1350" b="1">
                 <a:solidFill>
-                  <a:srgbClr val="00E676"/>
-                </a:solidFill>
-              </a:defRPr>
-            </a:pPr>
-            <a:r>
-              <a:t>🏆 CÓMO GANA: EUFORIA DESDE EL INICIO</a:t>
+                  <a:srgbClr val="FFB612"/>
+                </a:solidFill>
+              </a:defRPr>
+            </a:pPr>
+            <a:r>
+              <a:t>🏆 CÓMO GANA Y SE PREMIA</a:t>
             </a:r>
           </a:p>
           <a:p>
@@ -7005,14 +7612,14 @@
               </a:defRPr>
             </a:pPr>
             <a:r>
-              <a:t>En cuanto cae la primera anotación, el sistema valida el minuto oficial de juego. El comensal que acertó el bloque de tiempo gana en el acto, provocando festejos y más rondas de bebidas en su mesa.</a:t>
+              <a:t>La API de ESPN actualiza la tabla en tiempo real: Marcador Exacto = +3 pts (verde esmeralda), Ganador = +1 pt (dorado), Fallo = 0 pts (rojo). Al terminar, se proclama al Campeón Oficial en el podio digital con corona 👑 para canje en barra.</a:t>
             </a:r>
           </a:p>
         </p:txBody>
       </p:sp>
       <p:pic>
         <p:nvPicPr>
-          <p:cNvPr id="5" name="Picture 4" descr="tarjeta_3_instinto_goleador.png"/>
+          <p:cNvPr id="5" name="Picture 4" descr="screenshot_podium_standings.png"/>
           <p:cNvPicPr>
             <a:picLocks noChangeAspect="1"/>
           </p:cNvPicPr>
@@ -7026,8 +7633,8 @@
         </p:blipFill>
         <p:spPr>
           <a:xfrm>
-            <a:off x="7955279" y="1645920"/>
-            <a:ext cx="2623185" cy="4663440"/>
+            <a:off x="7863840" y="1645920"/>
+            <a:ext cx="8843264" cy="4663440"/>
           </a:xfrm>
           <a:prstGeom prst="rect">
             <a:avLst/>
@@ -7105,7 +7712,7 @@
               </a:defRPr>
             </a:pPr>
             <a:r>
-              <a:t>Trivias en TV con IA &amp; Survivor NFL: Medios Tiempos y Fidelidad</a:t>
+              <a:t>First Striker Wins (Fútbol): Adrenalina Inmediata en el Minuto 1</a:t>
             </a:r>
           </a:p>
         </p:txBody>
@@ -7119,7 +7726,7 @@
         <p:spPr>
           <a:xfrm>
             <a:off x="731520" y="1645920"/>
-            <a:ext cx="5212080" cy="4663440"/>
+            <a:ext cx="6858000" cy="4663440"/>
           </a:xfrm>
           <a:prstGeom prst="roundRect">
             <a:avLst/>
@@ -7164,7 +7771,7 @@
         <p:spPr>
           <a:xfrm>
             <a:off x="1005840" y="1828800"/>
-            <a:ext cx="4663440" cy="4206240"/>
+            <a:ext cx="6309360" cy="4206240"/>
           </a:xfrm>
           <a:prstGeom prst="rect">
             <a:avLst/>
@@ -7179,283 +7786,119 @@
           <a:p>
             <a:pPr>
               <a:spcAft>
-                <a:spcPts val="800"/>
-              </a:spcAft>
-              <a:defRPr sz="1650" b="1">
-                <a:solidFill>
-                  <a:srgbClr val="FFB612"/>
-                </a:solidFill>
-              </a:defRPr>
-            </a:pPr>
-            <a:r>
-              <a:t>🧠 Trivia en Pantallas de TV con IA</a:t>
-            </a:r>
-          </a:p>
-          <a:p>
-            <a:pPr>
-              <a:spcAft>
-                <a:spcPts val="100"/>
-              </a:spcAft>
-              <a:defRPr sz="1250" b="1">
-                <a:solidFill>
-                  <a:srgbClr val="FF5722"/>
-                </a:solidFill>
-              </a:defRPr>
-            </a:pPr>
-            <a:r>
-              <a:t>🛠️ Generación IA en 10 seg</a:t>
-            </a:r>
-          </a:p>
-          <a:p>
-            <a:pPr>
-              <a:spcAft>
-                <a:spcPts val="600"/>
-              </a:spcAft>
-              <a:defRPr sz="1100">
+                <a:spcPts val="200"/>
+              </a:spcAft>
+              <a:defRPr sz="1350" b="1">
+                <a:solidFill>
+                  <a:srgbClr val="00E676"/>
+                </a:solidFill>
+              </a:defRPr>
+            </a:pPr>
+            <a:r>
+              <a:t>🛠️ CÓMO LO CREA EL GERENTE (30 segundos)</a:t>
+            </a:r>
+          </a:p>
+          <a:p>
+            <a:pPr>
+              <a:spcAft>
+                <a:spcPts val="1000"/>
+              </a:spcAft>
+              <a:defRPr sz="1150">
                 <a:solidFill>
                   <a:srgbClr val="FFFFFF"/>
                 </a:solidFill>
               </a:defRPr>
             </a:pPr>
             <a:r>
-              <a:t>La Inteligencia Artificial genera 10 preguntas deportivas temáticas del partido en cuestión.</a:t>
-            </a:r>
-          </a:p>
-          <a:p>
-            <a:pPr>
-              <a:spcAft>
-                <a:spcPts val="100"/>
-              </a:spcAft>
-              <a:defRPr sz="1250" b="1">
-                <a:solidFill>
-                  <a:srgbClr val="FF5722"/>
-                </a:solidFill>
-              </a:defRPr>
-            </a:pPr>
-            <a:r>
-              <a:t>📱 Medio Tiempo Interactivo</a:t>
-            </a:r>
-          </a:p>
-          <a:p>
-            <a:pPr>
-              <a:spcAft>
-                <a:spcPts val="600"/>
-              </a:spcAft>
-              <a:defRPr sz="1100">
+              <a:t>Elige el partido de fútbol (Liga MX, Champions League o Selección Nacional) y asigna un premio dinámico (ej. 1 ronda de cervezas o botana en mesa).</a:t>
+            </a:r>
+          </a:p>
+          <a:p>
+            <a:pPr>
+              <a:spcAft>
+                <a:spcPts val="200"/>
+              </a:spcAft>
+              <a:defRPr sz="1350" b="1">
+                <a:solidFill>
+                  <a:srgbClr val="00E676"/>
+                </a:solidFill>
+              </a:defRPr>
+            </a:pPr>
+            <a:r>
+              <a:t>📱 CÓMO JUEGA EL CLIENTE</a:t>
+            </a:r>
+          </a:p>
+          <a:p>
+            <a:pPr>
+              <a:spcAft>
+                <a:spcPts val="1000"/>
+              </a:spcAft>
+              <a:defRPr sz="1150">
                 <a:solidFill>
                   <a:srgbClr val="FFFFFF"/>
                 </a:solidFill>
               </a:defRPr>
             </a:pPr>
             <a:r>
-              <a:t>La TV del bar muestra la pregunta con cuenta regresiva. Los clientes responden contrarreloj desde su smartphone compitiendo mesa contra mesa.</a:t>
-            </a:r>
-          </a:p>
-          <a:p>
-            <a:pPr>
-              <a:spcAft>
-                <a:spcPts val="100"/>
-              </a:spcAft>
-              <a:defRPr sz="1250" b="1">
-                <a:solidFill>
-                  <a:srgbClr val="FF5722"/>
-                </a:solidFill>
-              </a:defRPr>
-            </a:pPr>
-            <a:r>
-              <a:t>🏆 Podio en Pantalla Grande</a:t>
-            </a:r>
-          </a:p>
-          <a:p>
-            <a:pPr>
-              <a:spcAft>
-                <a:spcPts val="600"/>
-              </a:spcAft>
-              <a:defRPr sz="1100">
+              <a:t>Elige qué equipo meterá el primer gol y en qué bloque de 15 minutos caerá (1-15', 16-30', 31-45', etc.), o la opción de 'Sin Goles en el Partido'.</a:t>
+            </a:r>
+          </a:p>
+          <a:p>
+            <a:pPr>
+              <a:spcAft>
+                <a:spcPts val="200"/>
+              </a:spcAft>
+              <a:defRPr sz="1350" b="1">
+                <a:solidFill>
+                  <a:srgbClr val="00E676"/>
+                </a:solidFill>
+              </a:defRPr>
+            </a:pPr>
+            <a:r>
+              <a:t>🏆 CÓMO GANA: EUFORIA DESDE EL INICIO</a:t>
+            </a:r>
+          </a:p>
+          <a:p>
+            <a:pPr>
+              <a:spcAft>
+                <a:spcPts val="1000"/>
+              </a:spcAft>
+              <a:defRPr sz="1150">
                 <a:solidFill>
                   <a:srgbClr val="FFFFFF"/>
                 </a:solidFill>
               </a:defRPr>
             </a:pPr>
             <a:r>
-              <a:t>El restaurante entero ve subir el ranking en vivo en la TV.</a:t>
-            </a:r>
-          </a:p>
-        </p:txBody>
-      </p:sp>
-      <p:sp>
-        <p:nvSpPr>
-          <p:cNvPr id="5" name="Rounded Rectangle 4"/>
-          <p:cNvSpPr/>
+              <a:t>En cuanto cae la primera anotación, el sistema valida el minuto oficial de juego. El comensal que acertó el bloque de tiempo gana en el acto, provocando festejos y más rondas de bebidas en su mesa.</a:t>
+            </a:r>
+          </a:p>
+        </p:txBody>
+      </p:sp>
+      <p:pic>
+        <p:nvPicPr>
+          <p:cNvPr id="5" name="Picture 4" descr="tarjeta_3_instinto_goleador.png"/>
+          <p:cNvPicPr>
+            <a:picLocks noChangeAspect="1"/>
+          </p:cNvPicPr>
           <p:nvPr/>
-        </p:nvSpPr>
-        <p:spPr>
-          <a:xfrm>
-            <a:off x="6217920" y="1645920"/>
-            <a:ext cx="5212080" cy="4663440"/>
-          </a:xfrm>
-          <a:prstGeom prst="roundRect">
-            <a:avLst/>
-          </a:prstGeom>
-          <a:solidFill>
-            <a:srgbClr val="141A26"/>
-          </a:solidFill>
-          <a:ln w="19050">
-            <a:solidFill>
-              <a:srgbClr val="283246"/>
-            </a:solidFill>
-          </a:ln>
-        </p:spPr>
-        <p:style>
-          <a:lnRef idx="1">
-            <a:schemeClr val="accent1"/>
-          </a:lnRef>
-          <a:fillRef idx="3">
-            <a:schemeClr val="accent1"/>
-          </a:fillRef>
-          <a:effectRef idx="2">
-            <a:schemeClr val="accent1"/>
-          </a:effectRef>
-          <a:fontRef idx="minor">
-            <a:schemeClr val="lt1"/>
-          </a:fontRef>
-        </p:style>
-        <p:txBody>
-          <a:bodyPr rtlCol="0" anchor="ctr"/>
-          <a:lstStyle/>
-          <a:p>
-            <a:pPr algn="ctr"/>
-          </a:p>
-        </p:txBody>
-      </p:sp>
-      <p:sp>
-        <p:nvSpPr>
-          <p:cNvPr id="6" name="TextBox 5"/>
-          <p:cNvSpPr txBox="1"/>
-          <p:nvPr/>
-        </p:nvSpPr>
-        <p:spPr>
-          <a:xfrm>
-            <a:off x="6492240" y="1828800"/>
-            <a:ext cx="4663440" cy="4206240"/>
+        </p:nvPicPr>
+        <p:blipFill>
+          <a:blip r:embed="rId2"/>
+          <a:stretch>
+            <a:fillRect/>
+          </a:stretch>
+        </p:blipFill>
+        <p:spPr>
+          <a:xfrm>
+            <a:off x="7955279" y="1645920"/>
+            <a:ext cx="2623185" cy="4663440"/>
           </a:xfrm>
           <a:prstGeom prst="rect">
             <a:avLst/>
           </a:prstGeom>
-          <a:noFill/>
-        </p:spPr>
-        <p:txBody>
-          <a:bodyPr wrap="square">
-            <a:spAutoFit/>
-          </a:bodyPr>
-          <a:lstStyle/>
-          <a:p>
-            <a:pPr>
-              <a:spcAft>
-                <a:spcPts val="800"/>
-              </a:spcAft>
-              <a:defRPr sz="1650" b="1">
-                <a:solidFill>
-                  <a:srgbClr val="00E676"/>
-                </a:solidFill>
-              </a:defRPr>
-            </a:pPr>
-            <a:r>
-              <a:t>🛡️ Survivor NFL (Fidelidad Semanal)</a:t>
-            </a:r>
-          </a:p>
-          <a:p>
-            <a:pPr>
-              <a:spcAft>
-                <a:spcPts val="100"/>
-              </a:spcAft>
-              <a:defRPr sz="1250" b="1">
-                <a:solidFill>
-                  <a:srgbClr val="FFD100"/>
-                </a:solidFill>
-              </a:defRPr>
-            </a:pPr>
-            <a:r>
-              <a:t>🛠️ Creación Única</a:t>
-            </a:r>
-          </a:p>
-          <a:p>
-            <a:pPr>
-              <a:spcAft>
-                <a:spcPts val="600"/>
-              </a:spcAft>
-              <a:defRPr sz="1100">
-                <a:solidFill>
-                  <a:srgbClr val="FFFFFF"/>
-                </a:solidFill>
-              </a:defRPr>
-            </a:pPr>
-            <a:r>
-              <a:t>Se activa al inicio de la temporada regular de NFL.</a:t>
-            </a:r>
-          </a:p>
-          <a:p>
-            <a:pPr>
-              <a:spcAft>
-                <a:spcPts val="100"/>
-              </a:spcAft>
-              <a:defRPr sz="1250" b="1">
-                <a:solidFill>
-                  <a:srgbClr val="FFD100"/>
-                </a:solidFill>
-              </a:defRPr>
-            </a:pPr>
-            <a:r>
-              <a:t>📱 1 Equipo por Semana</a:t>
-            </a:r>
-          </a:p>
-          <a:p>
-            <a:pPr>
-              <a:spcAft>
-                <a:spcPts val="600"/>
-              </a:spcAft>
-              <a:defRPr sz="1100">
-                <a:solidFill>
-                  <a:srgbClr val="FFFFFF"/>
-                </a:solidFill>
-              </a:defRPr>
-            </a:pPr>
-            <a:r>
-              <a:t>El cliente elige 1 equipo ganador por semana sin repetir. Si su equipo gana, sobrevive; si pierde, queda eliminado.</a:t>
-            </a:r>
-          </a:p>
-          <a:p>
-            <a:pPr>
-              <a:spcAft>
-                <a:spcPts val="100"/>
-              </a:spcAft>
-              <a:defRPr sz="1250" b="1">
-                <a:solidFill>
-                  <a:srgbClr val="FFD100"/>
-                </a:solidFill>
-              </a:defRPr>
-            </a:pPr>
-            <a:r>
-              <a:t>🏆 Retención Obligatoria</a:t>
-            </a:r>
-          </a:p>
-          <a:p>
-            <a:pPr>
-              <a:spcAft>
-                <a:spcPts val="600"/>
-              </a:spcAft>
-              <a:defRPr sz="1100">
-                <a:solidFill>
-                  <a:srgbClr val="FFFFFF"/>
-                </a:solidFill>
-              </a:defRPr>
-            </a:pPr>
-            <a:r>
-              <a:t>Obliga al cliente a regresar semana tras semana a la sucursal para defender su boleto de sobreviviente.</a:t>
-            </a:r>
-          </a:p>
-        </p:txBody>
-      </p:sp>
+        </p:spPr>
+      </p:pic>
     </p:spTree>
   </p:cSld>
   <p:clrMapOvr>

</xml_diff>